<commit_message>
Etapa Miami: remove speakers, adiciona datas e tira elementos com cara de IA
Co-Authored-By: Claude Opus 5.5 <noreply@anthropic.com>
Claude-Session: https://claude.ai/code/session_01ETjDEHo1Y5Ziwi4pumEH8K
</commit_message>
<xml_diff>
--- a/entregas/Formacao-Internacional-Etapa-Miami.pptx
+++ b/entregas/Formacao-Internacional-Etapa-Miami.pptx
@@ -13,10 +13,9 @@
     <p:sldId id="261" r:id="rId7"/>
     <p:sldId id="262" r:id="rId8"/>
     <p:sldId id="263" r:id="rId9"/>
-    <p:sldId id="264" r:id="rId10"/>
   </p:sldIdLst>
   <p:notesMasterIdLst>
-    <p:notesMasterId r:id="rId11"/>
+    <p:notesMasterId r:id="rId10"/>
   </p:notesMasterIdLst>
   <p:sldSz cx="12192000" cy="6858000"/>
   <p:notesSz cx="6858000" cy="12192000"/>
@@ -115,29 +114,28 @@
   <p:extLst>
     <p:ext uri="{521415D9-36F7-43E2-AB2F-B90AF26B5E84}">
       <p14:sectionLst xmlns:p14="http://schemas.microsoft.com/office/powerpoint/2010/main">
-        <p14:section name="Abertura" id="{18db23bf-b575-e0d9-8825-af3155b99cfc}">
+        <p14:section name="Abertura" id="{b160e7dc-cd48-cb2c-5a16-905423bd9aa7}">
           <p14:sldIdLst>
             <p14:sldId id="256"/>
             <p14:sldId id="257"/>
           </p14:sldIdLst>
         </p14:section>
-        <p14:section name="A etapa" id="{e7a46f68-b52f-b69f-d9fa-03a1fce96690}">
+        <p14:section name="A etapa" id="{76c40604-99ed-093e-03c5-4d20405c16f7}">
           <p14:sldIdLst>
             <p14:sldId id="258"/>
             <p14:sldId id="259"/>
             <p14:sldId id="260"/>
           </p14:sldIdLst>
         </p14:section>
-        <p14:section name="Pessoas" id="{8a1d7c1e-3a83-56c0-7d02-850ed7a5a442}">
+        <p14:section name="Pessoas" id="{e6121930-c77f-6edc-8ca1-16f82258da45}">
           <p14:sldIdLst>
             <p14:sldId id="261"/>
             <p14:sldId id="262"/>
-            <p14:sldId id="263"/>
           </p14:sldIdLst>
         </p14:section>
-        <p14:section name="Inscrição" id="{93583069-0c84-0e9c-3370-f9b3f0ff11fe}">
+        <p14:section name="Inscrição" id="{8261533c-e3db-f8a1-f887-647b99963fd5}">
           <p14:sldIdLst>
-            <p14:sldId id="264"/>
+            <p14:sldId id="263"/>
           </p14:sldIdLst>
         </p14:section>
       </p14:sectionLst>
@@ -1072,7 +1070,7 @@
           <a:p>
             <a:r>
               <a:rPr lang="en-US" dirty="0"/>
-              <a:t/>
+              <a:t>Confirme que a aluna autorizou o uso do relato antes de divulgar este material fora da turma.</a:t>
             </a:r>
             <a:endParaRPr lang="en-US" dirty="0"/>
           </a:p>
@@ -1160,7 +1158,7 @@
           <a:p>
             <a:r>
               <a:rPr lang="en-US" dirty="0"/>
-              <a:t>Confirme que a aluna autorizou o uso do relato antes de divulgar este material fora da turma.</a:t>
+              <a:t>Troque o número de WhatsApp pelo número real da equipe.</a:t>
             </a:r>
             <a:endParaRPr lang="en-US" dirty="0"/>
           </a:p>
@@ -1184,94 +1182,6 @@
             <a:fld id="{F7021451-1387-4CA6-816F-3879F97B5CBC}" type="slidenum">
               <a:rPr lang="en-US"/>
               <a:t>8</a:t>
-            </a:fld>
-            <a:endParaRPr lang="en-US"/>
-          </a:p>
-        </p:txBody>
-      </p:sp>
-    </p:spTree>
-    <p:extLst>
-      <p:ext uri="{BB962C8B-B14F-4D97-AF65-F5344CB8AC3E}">
-        <p14:creationId xmlns:p14="http://schemas.microsoft.com/office/powerpoint/2010/main" val="1024086991"/>
-      </p:ext>
-    </p:extLst>
-  </p:cSld>
-  <p:clrMapOvr>
-    <a:masterClrMapping/>
-  </p:clrMapOvr>
-</p:notes>
-</file>
-
-<file path=ppt/notesSlides/notesSlide9.xml><?xml version="1.0" encoding="utf-8"?>
-<p:notes xmlns:a="http://schemas.openxmlformats.org/drawingml/2006/main" xmlns:r="http://schemas.openxmlformats.org/officeDocument/2006/relationships" xmlns:p="http://schemas.openxmlformats.org/presentationml/2006/main">
-  <p:cSld>
-    <p:spTree>
-      <p:nvGrpSpPr>
-        <p:cNvPr id="1" name=""/>
-        <p:cNvGrpSpPr/>
-        <p:nvPr/>
-      </p:nvGrpSpPr>
-      <p:grpSpPr>
-        <a:xfrm>
-          <a:off x="0" y="0"/>
-          <a:ext cx="0" cy="0"/>
-          <a:chOff x="0" y="0"/>
-          <a:chExt cx="0" cy="0"/>
-        </a:xfrm>
-      </p:grpSpPr>
-      <p:sp>
-        <p:nvSpPr>
-          <p:cNvPr id="2" name="Slide Image Placeholder 1"/>
-          <p:cNvSpPr>
-            <a:spLocks noGrp="1" noRot="1" noChangeAspect="1"/>
-          </p:cNvSpPr>
-          <p:nvPr>
-            <p:ph type="sldImg"/>
-          </p:nvPr>
-        </p:nvSpPr>
-        <p:spPr/>
-      </p:sp>
-      <p:sp>
-        <p:nvSpPr>
-          <p:cNvPr id="3" name="Notes Placeholder 2"/>
-          <p:cNvSpPr>
-            <a:spLocks noGrp="1"/>
-          </p:cNvSpPr>
-          <p:nvPr>
-            <p:ph type="body" idx="1"/>
-          </p:nvPr>
-        </p:nvSpPr>
-        <p:spPr/>
-        <p:txBody>
-          <a:bodyPr/>
-          <a:lstStyle/>
-          <a:p>
-            <a:r>
-              <a:rPr lang="en-US" dirty="0"/>
-              <a:t>Troque o número de WhatsApp pelo número real da equipe.</a:t>
-            </a:r>
-            <a:endParaRPr lang="en-US" dirty="0"/>
-          </a:p>
-        </p:txBody>
-      </p:sp>
-      <p:sp>
-        <p:nvSpPr>
-          <p:cNvPr id="4" name="Slide Number Placeholder 3"/>
-          <p:cNvSpPr>
-            <a:spLocks noGrp="1"/>
-          </p:cNvSpPr>
-          <p:nvPr>
-            <p:ph type="sldNum" sz="quarter" idx="10"/>
-          </p:nvPr>
-        </p:nvSpPr>
-        <p:spPr/>
-        <p:txBody>
-          <a:bodyPr/>
-          <a:lstStyle/>
-          <a:p>
-            <a:fld id="{F7021451-1387-4CA6-816F-3879F97B5CBC}" type="slidenum">
-              <a:rPr lang="en-US"/>
-              <a:t>9</a:t>
             </a:fld>
             <a:endParaRPr lang="en-US"/>
           </a:p>
@@ -1426,42 +1336,6 @@
               <a:t>TÍTULO</a:t>
             </a:r>
             <a:endParaRPr lang="en-US" sz="3200" dirty="0"/>
-          </a:p>
-        </p:txBody>
-      </p:sp>
-      <p:sp>
-        <p:nvSpPr>
-          <p:cNvPr id="3" name="Text 0"/>
-          <p:cNvSpPr/>
-          <p:nvPr/>
-        </p:nvSpPr>
-        <p:spPr>
-          <a:xfrm>
-            <a:off x="640080" y="6355080"/>
-            <a:ext cx="6858000" cy="274320"/>
-          </a:xfrm>
-          <a:prstGeom prst="rect">
-            <a:avLst/>
-          </a:prstGeom>
-          <a:noFill/>
-          <a:ln/>
-        </p:spPr>
-        <p:txBody>
-          <a:bodyPr wrap="square" lIns="0" tIns="0" rIns="0" bIns="0" rtlCol="0" anchor="ctr"/>
-          <a:lstStyle/>
-          <a:p>
-            <a:pPr indent="0" marL="0">
-              <a:buNone/>
-            </a:pPr>
-            <a:r>
-              <a:rPr lang="en-US" sz="900" spc="400" kern="0" dirty="0">
-                <a:solidFill>
-                  <a:schemeClr val="tx2"/>
-                </a:solidFill>
-              </a:rPr>
-              <a:t>PROGRAMA DE FORMAÇÃO INTERNACIONAL  ·  ETAPA DE MIAMI</a:t>
-            </a:r>
-            <a:endParaRPr lang="en-US" sz="900" dirty="0"/>
           </a:p>
         </p:txBody>
       </p:sp>
@@ -1861,7 +1735,7 @@
       </p:grpSpPr>
       <p:pic>
         <p:nvPicPr>
-          <p:cNvPr id="2" name="Foto Miami" descr="Prédios de Miami vistos da rua">    </p:cNvPr>
+          <p:cNvPr id="2" name="Foto laboratório" descr="Dra. Rosana em laboratório de anatomia, ao lado de uma mesa de specimen">    </p:cNvPr>
           <p:cNvPicPr>
             <a:picLocks noChangeAspect="1"/>
           </p:cNvPicPr>
@@ -1899,7 +1773,7 @@
           </a:prstGeom>
           <a:solidFill>
             <a:schemeClr val="tx1">
-              <a:alpha val="55000"/>
+              <a:alpha val="20000"/>
             </a:schemeClr>
           </a:solidFill>
           <a:ln w="12700">
@@ -1928,8 +1802,8 @@
         </p:blipFill>
         <p:spPr>
           <a:xfrm>
-            <a:off x="5120640" y="228600"/>
-            <a:ext cx="4206240" cy="2807208"/>
+            <a:off x="5852160" y="91440"/>
+            <a:ext cx="3108960" cy="2075688"/>
           </a:xfrm>
           <a:prstGeom prst="rect">
             <a:avLst/>
@@ -1945,7 +1819,7 @@
         <p:spPr>
           <a:xfrm>
             <a:off x="640080" y="1417320"/>
-            <a:ext cx="6400800" cy="274320"/>
+            <a:ext cx="5120640" cy="274320"/>
           </a:xfrm>
           <a:prstGeom prst="rect">
             <a:avLst/>
@@ -1961,7 +1835,7 @@
               <a:buNone/>
             </a:pPr>
             <a:r>
-              <a:rPr lang="en-US" sz="1200" spc="400" kern="0" dirty="0">
+              <a:rPr lang="en-US" sz="1200" spc="300" kern="0" dirty="0">
                 <a:solidFill>
                   <a:schemeClr val="accent4"/>
                 </a:solidFill>
@@ -1997,9 +1871,9 @@
               <a:buNone/>
             </a:pPr>
             <a:r>
-              <a:rPr lang="en-US" sz="3000" i="1" dirty="0">
-                <a:solidFill>
-                  <a:schemeClr val="accent1"/>
+              <a:rPr lang="en-US" sz="2800" spc="600" kern="0" dirty="0">
+                <a:solidFill>
+                  <a:schemeClr val="accent6"/>
                 </a:solidFill>
                 <a:latin typeface="Georgia" pitchFamily="34" charset="0"/>
                 <a:ea typeface="Georgia" pitchFamily="34" charset="-122"/>
@@ -2007,7 +1881,7 @@
               </a:rPr>
               <a:t>Etapa de</a:t>
             </a:r>
-            <a:endParaRPr lang="en-US" sz="3000" dirty="0"/>
+            <a:endParaRPr lang="en-US" sz="2800" dirty="0"/>
           </a:p>
         </p:txBody>
       </p:sp>
@@ -2058,7 +1932,7 @@
         </p:nvSpPr>
         <p:spPr>
           <a:xfrm>
-            <a:off x="640080" y="4297680"/>
+            <a:off x="640080" y="4160520"/>
             <a:ext cx="5120640" cy="822960"/>
           </a:xfrm>
           <a:prstGeom prst="rect">
@@ -2086,9 +1960,48 @@
           </a:p>
         </p:txBody>
       </p:sp>
+      <p:sp>
+        <p:nvSpPr>
+          <p:cNvPr id="9" name="Data"/>
+          <p:cNvSpPr txBox="1"/>
+          <p:nvPr/>
+        </p:nvSpPr>
+        <p:spPr>
+          <a:xfrm>
+            <a:off x="640080" y="4937760"/>
+            <a:ext cx="5943600" cy="411480"/>
+          </a:xfrm>
+          <a:prstGeom prst="rect">
+            <a:avLst/>
+          </a:prstGeom>
+          <a:noFill/>
+          <a:ln/>
+        </p:spPr>
+        <p:txBody>
+          <a:bodyPr wrap="square" lIns="0" tIns="0" rIns="0" bIns="0" rtlCol="0" anchor="ctr"/>
+          <a:lstStyle/>
+          <a:p>
+            <a:pPr indent="0" marL="0">
+              <a:buNone/>
+            </a:pPr>
+            <a:r>
+              <a:rPr lang="en-US" sz="2000" dirty="0">
+                <a:solidFill>
+                  <a:schemeClr val="bg1"/>
+                </a:solidFill>
+                <a:latin typeface="Georgia" pitchFamily="34" charset="0"/>
+                <a:ea typeface="Georgia" pitchFamily="34" charset="-122"/>
+                <a:cs typeface="Georgia" pitchFamily="34" charset="-120"/>
+              </a:rPr>
+              <a:t>19, 20 e 21 de maio de 2027</a:t>
+            </a:r>
+            <a:endParaRPr lang="en-US" sz="2000" dirty="0"/>
+          </a:p>
+        </p:txBody>
+      </p:sp>
       <p:pic>
         <p:nvPicPr>
-          <p:cNvPr id="9" name="Logo" descr="Logo Dra. Rosana Vecchi Caldas">    </p:cNvPr>
+          <p:cNvPr id="10" name="Logo" descr="Logo Dra. Rosana Vecchi Caldas">    </p:cNvPr>
           <p:cNvPicPr>
             <a:picLocks noChangeAspect="1"/>
           </p:cNvPicPr>
@@ -2246,7 +2159,7 @@
       </p:grpSpPr>
       <p:pic>
         <p:nvPicPr>
-          <p:cNvPr id="2" name="Foto laboratório" descr="Dra. Rosana em laboratório de anatomia, ao lado de uma mesa de specimen">    </p:cNvPr>
+          <p:cNvPr id="2" name="Foto Miami" descr="Prédios de Miami vistos da rua">    </p:cNvPr>
           <p:cNvPicPr>
             <a:picLocks noChangeAspect="1"/>
           </p:cNvPicPr>
@@ -2270,43 +2183,7 @@
       </p:pic>
       <p:sp>
         <p:nvSpPr>
-          <p:cNvPr id="3" name="Rótulo"/>
-          <p:cNvSpPr txBox="1"/>
-          <p:nvPr/>
-        </p:nvSpPr>
-        <p:spPr>
-          <a:xfrm>
-            <a:off x="640080" y="502920"/>
-            <a:ext cx="6035040" cy="274320"/>
-          </a:xfrm>
-          <a:prstGeom prst="rect">
-            <a:avLst/>
-          </a:prstGeom>
-          <a:noFill/>
-          <a:ln/>
-        </p:spPr>
-        <p:txBody>
-          <a:bodyPr wrap="square" lIns="0" tIns="0" rIns="0" bIns="0" rtlCol="0" anchor="ctr"/>
-          <a:lstStyle/>
-          <a:p>
-            <a:pPr indent="0" marL="0">
-              <a:buNone/>
-            </a:pPr>
-            <a:r>
-              <a:rPr lang="en-US" sz="1100" b="1" spc="600" kern="0" dirty="0">
-                <a:solidFill>
-                  <a:schemeClr val="accent1"/>
-                </a:solidFill>
-              </a:rPr>
-              <a:t>A ETAPA</a:t>
-            </a:r>
-            <a:endParaRPr lang="en-US" sz="1100" dirty="0"/>
-          </a:p>
-        </p:txBody>
-      </p:sp>
-      <p:sp>
-        <p:nvSpPr>
-          <p:cNvPr id="4" name="Text 0"/>
+          <p:cNvPr id="3" name="Text 0"/>
           <p:cNvSpPr/>
           <p:nvPr>
             <p:ph idx="100" type="title" hasCustomPrompt="1"/>
@@ -2347,14 +2224,14 @@
       </p:sp>
       <p:sp>
         <p:nvSpPr>
-          <p:cNvPr id="5" name="Texto Miami"/>
+          <p:cNvPr id="4" name="Texto Miami"/>
           <p:cNvSpPr txBox="1"/>
           <p:nvPr/>
         </p:nvSpPr>
         <p:spPr>
           <a:xfrm>
             <a:off x="640080" y="1920240"/>
-            <a:ext cx="5760720" cy="1463040"/>
+            <a:ext cx="5760720" cy="1371600"/>
           </a:xfrm>
           <a:prstGeom prst="rect">
             <a:avLst/>
@@ -2375,7 +2252,7 @@
                   <a:schemeClr val="accent4"/>
                 </a:solidFill>
               </a:rPr>
-              <a:t>Nos Estados Unidos, laboratórios privados de anatomia oferecem estrutura para treinamento hands-on em specimen, a peça anatômica real. Em Miami, o conteúdo científico vira prática supervisionada.</a:t>
+              <a:t>Nos Estados Unidos, laboratórios privados de anatomia oferecem estrutura para treinamento hands-on em specimen, a peça anatômica real. Em Miami, o conteúdo científico vira prática.</a:t>
             </a:r>
             <a:endParaRPr lang="en-US" sz="1700" dirty="0"/>
           </a:p>
@@ -2383,14 +2260,90 @@
       </p:sp>
       <p:sp>
         <p:nvSpPr>
-          <p:cNvPr id="6" name="Número 1"/>
+          <p:cNvPr id="5" name="Lista Miami"/>
           <p:cNvSpPr txBox="1"/>
           <p:nvPr/>
         </p:nvSpPr>
         <p:spPr>
           <a:xfrm>
-            <a:off x="640080" y="3703320"/>
-            <a:ext cx="2560320" cy="1143000"/>
+            <a:off x="640080" y="3520440"/>
+            <a:ext cx="5760720" cy="1463040"/>
+          </a:xfrm>
+          <a:prstGeom prst="rect">
+            <a:avLst/>
+          </a:prstGeom>
+          <a:noFill/>
+          <a:ln/>
+        </p:spPr>
+        <p:txBody>
+          <a:bodyPr wrap="square" lIns="0" tIns="0" rIns="0" bIns="0" rtlCol="0" anchor="t"/>
+          <a:lstStyle/>
+          <a:p>
+            <a:pPr marL="342900" indent="-342900">
+              <a:spcAft>
+                <a:spcPts val="1000"/>
+              </a:spcAft>
+              <a:buSzPct val="100000"/>
+              <a:buChar char="•"/>
+            </a:pPr>
+            <a:r>
+              <a:rPr lang="en-US" sz="1700" dirty="0">
+                <a:solidFill>
+                  <a:schemeClr val="bg1"/>
+                </a:solidFill>
+              </a:rPr>
+              <a:t>Imersão de 3 dias com prática real</a:t>
+            </a:r>
+            <a:endParaRPr lang="en-US" sz="1700" dirty="0"/>
+          </a:p>
+          <a:p>
+            <a:pPr marL="342900" indent="-342900">
+              <a:spcAft>
+                <a:spcPts val="1000"/>
+              </a:spcAft>
+              <a:buSzPct val="100000"/>
+              <a:buChar char="•"/>
+            </a:pPr>
+            <a:r>
+              <a:rPr lang="en-US" sz="1700" dirty="0">
+                <a:solidFill>
+                  <a:schemeClr val="bg1"/>
+                </a:solidFill>
+              </a:rPr>
+              <a:t>Laboratórios privados preparados para hands-on avançado</a:t>
+            </a:r>
+            <a:endParaRPr lang="en-US" sz="1700" dirty="0"/>
+          </a:p>
+          <a:p>
+            <a:pPr marL="342900" indent="-342900">
+              <a:spcAft>
+                <a:spcPts val="1000"/>
+              </a:spcAft>
+              <a:buSzPct val="100000"/>
+              <a:buChar char="•"/>
+            </a:pPr>
+            <a:r>
+              <a:rPr lang="en-US" sz="1700" dirty="0">
+                <a:solidFill>
+                  <a:schemeClr val="bg1"/>
+                </a:solidFill>
+              </a:rPr>
+              <a:t>Anatomia aplicada direto na peça anatômica</a:t>
+            </a:r>
+            <a:endParaRPr lang="en-US" sz="1700" dirty="0"/>
+          </a:p>
+        </p:txBody>
+      </p:sp>
+      <p:sp>
+        <p:nvSpPr>
+          <p:cNvPr id="6" name="Data"/>
+          <p:cNvSpPr txBox="1"/>
+          <p:nvPr/>
+        </p:nvSpPr>
+        <p:spPr>
+          <a:xfrm>
+            <a:off x="640080" y="5349240"/>
+            <a:ext cx="5760720" cy="411480"/>
           </a:xfrm>
           <a:prstGeom prst="rect">
             <a:avLst/>
@@ -2406,128 +2359,17 @@
               <a:buNone/>
             </a:pPr>
             <a:r>
-              <a:rPr lang="en-US" sz="8000" dirty="0">
-                <a:solidFill>
-                  <a:schemeClr val="accent1"/>
+              <a:rPr lang="en-US" sz="2000" dirty="0">
+                <a:solidFill>
+                  <a:schemeClr val="bg1"/>
                 </a:solidFill>
                 <a:latin typeface="Georgia" pitchFamily="34" charset="0"/>
                 <a:ea typeface="Georgia" pitchFamily="34" charset="-122"/>
                 <a:cs typeface="Georgia" pitchFamily="34" charset="-120"/>
               </a:rPr>
-              <a:t>3</a:t>
-            </a:r>
-            <a:endParaRPr lang="en-US" sz="8000" dirty="0"/>
-          </a:p>
-        </p:txBody>
-      </p:sp>
-      <p:sp>
-        <p:nvSpPr>
-          <p:cNvPr id="7" name="Legenda 1"/>
-          <p:cNvSpPr txBox="1"/>
-          <p:nvPr/>
-        </p:nvSpPr>
-        <p:spPr>
-          <a:xfrm>
-            <a:off x="640080" y="4892040"/>
-            <a:ext cx="2560320" cy="320040"/>
-          </a:xfrm>
-          <a:prstGeom prst="rect">
-            <a:avLst/>
-          </a:prstGeom>
-          <a:noFill/>
-          <a:ln/>
-        </p:spPr>
-        <p:txBody>
-          <a:bodyPr wrap="square" lIns="0" tIns="0" rIns="0" bIns="0" rtlCol="0" anchor="ctr"/>
-          <a:lstStyle/>
-          <a:p>
-            <a:pPr indent="0" marL="0">
-              <a:buNone/>
-            </a:pPr>
-            <a:r>
-              <a:rPr lang="en-US" sz="1200" spc="400" kern="0" dirty="0">
-                <a:solidFill>
-                  <a:schemeClr val="bg1"/>
-                </a:solidFill>
-              </a:rPr>
-              <a:t>DIAS DE IMERSÃO</a:t>
-            </a:r>
-            <a:endParaRPr lang="en-US" sz="1200" dirty="0"/>
-          </a:p>
-        </p:txBody>
-      </p:sp>
-      <p:sp>
-        <p:nvSpPr>
-          <p:cNvPr id="8" name="Número 2"/>
-          <p:cNvSpPr txBox="1"/>
-          <p:nvPr/>
-        </p:nvSpPr>
-        <p:spPr>
-          <a:xfrm>
-            <a:off x="3566160" y="3703320"/>
-            <a:ext cx="2560320" cy="1143000"/>
-          </a:xfrm>
-          <a:prstGeom prst="rect">
-            <a:avLst/>
-          </a:prstGeom>
-          <a:noFill/>
-          <a:ln/>
-        </p:spPr>
-        <p:txBody>
-          <a:bodyPr wrap="square" lIns="0" tIns="0" rIns="0" bIns="0" rtlCol="0" anchor="ctr"/>
-          <a:lstStyle/>
-          <a:p>
-            <a:pPr indent="0" marL="0">
-              <a:buNone/>
-            </a:pPr>
-            <a:r>
-              <a:rPr lang="en-US" sz="8000" dirty="0">
-                <a:solidFill>
-                  <a:schemeClr val="accent1"/>
-                </a:solidFill>
-                <a:latin typeface="Georgia" pitchFamily="34" charset="0"/>
-                <a:ea typeface="Georgia" pitchFamily="34" charset="-122"/>
-                <a:cs typeface="Georgia" pitchFamily="34" charset="-120"/>
-              </a:rPr>
-              <a:t>5</a:t>
-            </a:r>
-            <a:endParaRPr lang="en-US" sz="8000" dirty="0"/>
-          </a:p>
-        </p:txBody>
-      </p:sp>
-      <p:sp>
-        <p:nvSpPr>
-          <p:cNvPr id="9" name="Legenda 2"/>
-          <p:cNvSpPr txBox="1"/>
-          <p:nvPr/>
-        </p:nvSpPr>
-        <p:spPr>
-          <a:xfrm>
-            <a:off x="3566160" y="4892040"/>
-            <a:ext cx="2560320" cy="320040"/>
-          </a:xfrm>
-          <a:prstGeom prst="rect">
-            <a:avLst/>
-          </a:prstGeom>
-          <a:noFill/>
-          <a:ln/>
-        </p:spPr>
-        <p:txBody>
-          <a:bodyPr wrap="square" lIns="0" tIns="0" rIns="0" bIns="0" rtlCol="0" anchor="ctr"/>
-          <a:lstStyle/>
-          <a:p>
-            <a:pPr indent="0" marL="0">
-              <a:buNone/>
-            </a:pPr>
-            <a:r>
-              <a:rPr lang="en-US" sz="1200" spc="400" kern="0" dirty="0">
-                <a:solidFill>
-                  <a:schemeClr val="bg1"/>
-                </a:solidFill>
-              </a:rPr>
-              <a:t>MÓDULOS PRÁTICOS</a:t>
-            </a:r>
-            <a:endParaRPr lang="en-US" sz="1200" dirty="0"/>
+              <a:t>19, 20 e 21 de maio de 2027</a:t>
+            </a:r>
+            <a:endParaRPr lang="en-US" sz="2000" dirty="0"/>
           </a:p>
         </p:txBody>
       </p:sp>
@@ -2604,69 +2446,9 @@
           <a:chExt cx="0" cy="0"/>
         </a:xfrm>
       </p:grpSpPr>
-      <p:pic>
-        <p:nvPicPr>
-          <p:cNvPr id="2" name="Ilustração anatômica" descr="Ilustração anatômica de cabeça e pescoço com músculos, artérias e veias">    </p:cNvPr>
-          <p:cNvPicPr>
-            <a:picLocks noChangeAspect="1"/>
-          </p:cNvPicPr>
-          <p:nvPr/>
-        </p:nvPicPr>
-        <p:blipFill>
-          <a:blip r:embed="rId1"/>
-          <a:stretch>
-            <a:fillRect/>
-          </a:stretch>
-        </p:blipFill>
-        <p:spPr>
-          <a:xfrm>
-            <a:off x="7598664" y="0"/>
-            <a:ext cx="4594860" cy="6858000"/>
-          </a:xfrm>
-          <a:prstGeom prst="rect">
-            <a:avLst/>
-          </a:prstGeom>
-        </p:spPr>
-      </p:pic>
-      <p:sp>
-        <p:nvSpPr>
-          <p:cNvPr id="3" name="Rótulo"/>
-          <p:cNvSpPr txBox="1"/>
-          <p:nvPr/>
-        </p:nvSpPr>
-        <p:spPr>
-          <a:xfrm>
-            <a:off x="640080" y="502920"/>
-            <a:ext cx="6035040" cy="274320"/>
-          </a:xfrm>
-          <a:prstGeom prst="rect">
-            <a:avLst/>
-          </a:prstGeom>
-          <a:noFill/>
-          <a:ln/>
-        </p:spPr>
-        <p:txBody>
-          <a:bodyPr wrap="square" lIns="0" tIns="0" rIns="0" bIns="0" rtlCol="0" anchor="ctr"/>
-          <a:lstStyle/>
-          <a:p>
-            <a:pPr indent="0" marL="0">
-              <a:buNone/>
-            </a:pPr>
-            <a:r>
-              <a:rPr lang="en-US" sz="1100" b="1" spc="600" kern="0" dirty="0">
-                <a:solidFill>
-                  <a:schemeClr val="accent1"/>
-                </a:solidFill>
-              </a:rPr>
-              <a:t>ANATOMIA APLICADA E HANDS-ON</a:t>
-            </a:r>
-            <a:endParaRPr lang="en-US" sz="1100" dirty="0"/>
-          </a:p>
-        </p:txBody>
-      </p:sp>
-      <p:sp>
-        <p:nvSpPr>
-          <p:cNvPr id="4" name="Text 0"/>
+      <p:sp>
+        <p:nvSpPr>
+          <p:cNvPr id="2" name="Text 0"/>
           <p:cNvSpPr/>
           <p:nvPr>
             <p:ph idx="100" type="title" hasCustomPrompt="1"/>
@@ -2707,14 +2489,14 @@
       </p:sp>
       <p:sp>
         <p:nvSpPr>
-          <p:cNvPr id="5" name="Módulo 1 número"/>
+          <p:cNvPr id="3" name="Subtítulo"/>
           <p:cNvSpPr txBox="1"/>
           <p:nvPr/>
         </p:nvSpPr>
         <p:spPr>
           <a:xfrm>
-            <a:off x="640080" y="1965960"/>
-            <a:ext cx="731520" cy="548640"/>
+            <a:off x="640080" y="1463040"/>
+            <a:ext cx="6400800" cy="365760"/>
           </a:xfrm>
           <a:prstGeom prst="rect">
             <a:avLst/>
@@ -2730,30 +2512,27 @@
               <a:buNone/>
             </a:pPr>
             <a:r>
-              <a:rPr lang="en-US" sz="2600" dirty="0">
-                <a:solidFill>
-                  <a:schemeClr val="accent1"/>
-                </a:solidFill>
-                <a:latin typeface="Georgia" pitchFamily="34" charset="0"/>
-                <a:ea typeface="Georgia" pitchFamily="34" charset="-122"/>
-                <a:cs typeface="Georgia" pitchFamily="34" charset="-120"/>
-              </a:rPr>
-              <a:t>01</a:t>
-            </a:r>
-            <a:endParaRPr lang="en-US" sz="2600" dirty="0"/>
-          </a:p>
-        </p:txBody>
-      </p:sp>
-      <p:sp>
-        <p:nvSpPr>
-          <p:cNvPr id="6" name="Módulo 1"/>
+              <a:rPr lang="en-US" sz="1700" dirty="0">
+                <a:solidFill>
+                  <a:schemeClr val="accent4"/>
+                </a:solidFill>
+              </a:rPr>
+              <a:t>Anatomia aplicada e hands-on</a:t>
+            </a:r>
+            <a:endParaRPr lang="en-US" sz="1700" dirty="0"/>
+          </a:p>
+        </p:txBody>
+      </p:sp>
+      <p:sp>
+        <p:nvSpPr>
+          <p:cNvPr id="4" name="Módulo 1"/>
           <p:cNvSpPr txBox="1"/>
           <p:nvPr/>
         </p:nvSpPr>
         <p:spPr>
           <a:xfrm>
-            <a:off x="1463040" y="1965960"/>
-            <a:ext cx="5669280" cy="548640"/>
+            <a:off x="640080" y="2377440"/>
+            <a:ext cx="10881360" cy="548640"/>
           </a:xfrm>
           <a:prstGeom prst="rect">
             <a:avLst/>
@@ -2769,27 +2548,50 @@
               <a:buNone/>
             </a:pPr>
             <a:r>
-              <a:rPr lang="en-US" sz="1600" dirty="0">
+              <a:rPr lang="en-US" sz="2000" dirty="0">
                 <a:solidFill>
                   <a:schemeClr val="bg1"/>
                 </a:solidFill>
               </a:rPr>
               <a:t>Anatomia avançada de cabeça e pescoço aplicada a injetáveis</a:t>
             </a:r>
-            <a:endParaRPr lang="en-US" sz="1600" dirty="0"/>
-          </a:p>
-        </p:txBody>
-      </p:sp>
-      <p:sp>
-        <p:nvSpPr>
-          <p:cNvPr id="7" name="Módulo 2 número"/>
+            <a:endParaRPr lang="en-US" sz="2000" dirty="0"/>
+          </a:p>
+        </p:txBody>
+      </p:sp>
+      <p:sp>
+        <p:nvSpPr>
+          <p:cNvPr id="5" name="Divisória 1"/>
+          <p:cNvSpPr/>
+          <p:nvPr/>
+        </p:nvSpPr>
+        <p:spPr>
+          <a:xfrm>
+            <a:off x="640080" y="3090672"/>
+            <a:ext cx="10881360" cy="0"/>
+          </a:xfrm>
+          <a:prstGeom prst="line">
+            <a:avLst/>
+          </a:prstGeom>
+          <a:noFill/>
+          <a:ln w="9525">
+            <a:solidFill>
+              <a:schemeClr val="accent5"/>
+            </a:solidFill>
+            <a:prstDash val="solid"/>
+          </a:ln>
+        </p:spPr>
+      </p:sp>
+      <p:sp>
+        <p:nvSpPr>
+          <p:cNvPr id="6" name="Módulo 2"/>
           <p:cNvSpPr txBox="1"/>
           <p:nvPr/>
         </p:nvSpPr>
         <p:spPr>
           <a:xfrm>
-            <a:off x="640080" y="2752344"/>
-            <a:ext cx="731520" cy="548640"/>
+            <a:off x="640080" y="3246120"/>
+            <a:ext cx="10881360" cy="548640"/>
           </a:xfrm>
           <a:prstGeom prst="rect">
             <a:avLst/>
@@ -2805,30 +2607,50 @@
               <a:buNone/>
             </a:pPr>
             <a:r>
-              <a:rPr lang="en-US" sz="2600" dirty="0">
-                <a:solidFill>
-                  <a:schemeClr val="accent1"/>
-                </a:solidFill>
-                <a:latin typeface="Georgia" pitchFamily="34" charset="0"/>
-                <a:ea typeface="Georgia" pitchFamily="34" charset="-122"/>
-                <a:cs typeface="Georgia" pitchFamily="34" charset="-120"/>
-              </a:rPr>
-              <a:t>02</a:t>
-            </a:r>
-            <a:endParaRPr lang="en-US" sz="2600" dirty="0"/>
-          </a:p>
-        </p:txBody>
-      </p:sp>
-      <p:sp>
-        <p:nvSpPr>
-          <p:cNvPr id="8" name="Módulo 2"/>
+              <a:rPr lang="en-US" sz="2000" dirty="0">
+                <a:solidFill>
+                  <a:schemeClr val="bg1"/>
+                </a:solidFill>
+              </a:rPr>
+              <a:t>Anatomia avançada de cabeça e pescoço aplicada a fios faciais</a:t>
+            </a:r>
+            <a:endParaRPr lang="en-US" sz="2000" dirty="0"/>
+          </a:p>
+        </p:txBody>
+      </p:sp>
+      <p:sp>
+        <p:nvSpPr>
+          <p:cNvPr id="7" name="Divisória 2"/>
+          <p:cNvSpPr/>
+          <p:nvPr/>
+        </p:nvSpPr>
+        <p:spPr>
+          <a:xfrm>
+            <a:off x="640080" y="3959352"/>
+            <a:ext cx="10881360" cy="0"/>
+          </a:xfrm>
+          <a:prstGeom prst="line">
+            <a:avLst/>
+          </a:prstGeom>
+          <a:noFill/>
+          <a:ln w="9525">
+            <a:solidFill>
+              <a:schemeClr val="accent5"/>
+            </a:solidFill>
+            <a:prstDash val="solid"/>
+          </a:ln>
+        </p:spPr>
+      </p:sp>
+      <p:sp>
+        <p:nvSpPr>
+          <p:cNvPr id="8" name="Módulo 3"/>
           <p:cNvSpPr txBox="1"/>
           <p:nvPr/>
         </p:nvSpPr>
         <p:spPr>
           <a:xfrm>
-            <a:off x="1463040" y="2752344"/>
-            <a:ext cx="5669280" cy="548640"/>
+            <a:off x="640080" y="4114800"/>
+            <a:ext cx="10881360" cy="548640"/>
           </a:xfrm>
           <a:prstGeom prst="rect">
             <a:avLst/>
@@ -2844,27 +2666,50 @@
               <a:buNone/>
             </a:pPr>
             <a:r>
-              <a:rPr lang="en-US" sz="1600" dirty="0">
+              <a:rPr lang="en-US" sz="2000" dirty="0">
                 <a:solidFill>
                   <a:schemeClr val="bg1"/>
                 </a:solidFill>
               </a:rPr>
-              <a:t>Anatomia avançada de cabeça e pescoço aplicada a fios faciais</a:t>
-            </a:r>
-            <a:endParaRPr lang="en-US" sz="1600" dirty="0"/>
-          </a:p>
-        </p:txBody>
-      </p:sp>
-      <p:sp>
-        <p:nvSpPr>
-          <p:cNvPr id="9" name="Módulo 3 número"/>
+              <a:t>Bioestimuladores faciais e corporais: fundamentos, indicações e limites</a:t>
+            </a:r>
+            <a:endParaRPr lang="en-US" sz="2000" dirty="0"/>
+          </a:p>
+        </p:txBody>
+      </p:sp>
+      <p:sp>
+        <p:nvSpPr>
+          <p:cNvPr id="9" name="Divisória 3"/>
+          <p:cNvSpPr/>
+          <p:nvPr/>
+        </p:nvSpPr>
+        <p:spPr>
+          <a:xfrm>
+            <a:off x="640080" y="4828032"/>
+            <a:ext cx="10881360" cy="0"/>
+          </a:xfrm>
+          <a:prstGeom prst="line">
+            <a:avLst/>
+          </a:prstGeom>
+          <a:noFill/>
+          <a:ln w="9525">
+            <a:solidFill>
+              <a:schemeClr val="accent5"/>
+            </a:solidFill>
+            <a:prstDash val="solid"/>
+          </a:ln>
+        </p:spPr>
+      </p:sp>
+      <p:sp>
+        <p:nvSpPr>
+          <p:cNvPr id="10" name="Módulo 4"/>
           <p:cNvSpPr txBox="1"/>
           <p:nvPr/>
         </p:nvSpPr>
         <p:spPr>
           <a:xfrm>
-            <a:off x="640080" y="3538728"/>
-            <a:ext cx="731520" cy="548640"/>
+            <a:off x="640080" y="4983480"/>
+            <a:ext cx="10881360" cy="548640"/>
           </a:xfrm>
           <a:prstGeom prst="rect">
             <a:avLst/>
@@ -2880,30 +2725,50 @@
               <a:buNone/>
             </a:pPr>
             <a:r>
-              <a:rPr lang="en-US" sz="2600" dirty="0">
-                <a:solidFill>
-                  <a:schemeClr val="accent1"/>
-                </a:solidFill>
-                <a:latin typeface="Georgia" pitchFamily="34" charset="0"/>
-                <a:ea typeface="Georgia" pitchFamily="34" charset="-122"/>
-                <a:cs typeface="Georgia" pitchFamily="34" charset="-120"/>
-              </a:rPr>
-              <a:t>03</a:t>
-            </a:r>
-            <a:endParaRPr lang="en-US" sz="2600" dirty="0"/>
-          </a:p>
-        </p:txBody>
-      </p:sp>
-      <p:sp>
-        <p:nvSpPr>
-          <p:cNvPr id="10" name="Módulo 3"/>
+              <a:rPr lang="en-US" sz="2000" dirty="0">
+                <a:solidFill>
+                  <a:schemeClr val="bg1"/>
+                </a:solidFill>
+              </a:rPr>
+              <a:t>Lifting facial com preenchedores: raciocínio anatômico e estrutural</a:t>
+            </a:r>
+            <a:endParaRPr lang="en-US" sz="2000" dirty="0"/>
+          </a:p>
+        </p:txBody>
+      </p:sp>
+      <p:sp>
+        <p:nvSpPr>
+          <p:cNvPr id="11" name="Divisória 4"/>
+          <p:cNvSpPr/>
+          <p:nvPr/>
+        </p:nvSpPr>
+        <p:spPr>
+          <a:xfrm>
+            <a:off x="640080" y="5696712"/>
+            <a:ext cx="10881360" cy="0"/>
+          </a:xfrm>
+          <a:prstGeom prst="line">
+            <a:avLst/>
+          </a:prstGeom>
+          <a:noFill/>
+          <a:ln w="9525">
+            <a:solidFill>
+              <a:schemeClr val="accent5"/>
+            </a:solidFill>
+            <a:prstDash val="solid"/>
+          </a:ln>
+        </p:spPr>
+      </p:sp>
+      <p:sp>
+        <p:nvSpPr>
+          <p:cNvPr id="12" name="Módulo 5"/>
           <p:cNvSpPr txBox="1"/>
           <p:nvPr/>
         </p:nvSpPr>
         <p:spPr>
           <a:xfrm>
-            <a:off x="1463040" y="3538728"/>
-            <a:ext cx="5669280" cy="548640"/>
+            <a:off x="640080" y="5852160"/>
+            <a:ext cx="10881360" cy="548640"/>
           </a:xfrm>
           <a:prstGeom prst="rect">
             <a:avLst/>
@@ -2919,164 +2784,14 @@
               <a:buNone/>
             </a:pPr>
             <a:r>
-              <a:rPr lang="en-US" sz="1600" dirty="0">
+              <a:rPr lang="en-US" sz="2000" dirty="0">
                 <a:solidFill>
                   <a:schemeClr val="bg1"/>
                 </a:solidFill>
               </a:rPr>
-              <a:t>Bioestimuladores faciais e corporais: fundamentos, indicações e limites</a:t>
-            </a:r>
-            <a:endParaRPr lang="en-US" sz="1600" dirty="0"/>
-          </a:p>
-        </p:txBody>
-      </p:sp>
-      <p:sp>
-        <p:nvSpPr>
-          <p:cNvPr id="11" name="Módulo 4 número"/>
-          <p:cNvSpPr txBox="1"/>
-          <p:nvPr/>
-        </p:nvSpPr>
-        <p:spPr>
-          <a:xfrm>
-            <a:off x="640080" y="4325112"/>
-            <a:ext cx="731520" cy="548640"/>
-          </a:xfrm>
-          <a:prstGeom prst="rect">
-            <a:avLst/>
-          </a:prstGeom>
-          <a:noFill/>
-          <a:ln/>
-        </p:spPr>
-        <p:txBody>
-          <a:bodyPr wrap="square" lIns="0" tIns="0" rIns="0" bIns="0" rtlCol="0" anchor="ctr"/>
-          <a:lstStyle/>
-          <a:p>
-            <a:pPr indent="0" marL="0">
-              <a:buNone/>
-            </a:pPr>
-            <a:r>
-              <a:rPr lang="en-US" sz="2600" dirty="0">
-                <a:solidFill>
-                  <a:schemeClr val="accent1"/>
-                </a:solidFill>
-                <a:latin typeface="Georgia" pitchFamily="34" charset="0"/>
-                <a:ea typeface="Georgia" pitchFamily="34" charset="-122"/>
-                <a:cs typeface="Georgia" pitchFamily="34" charset="-120"/>
-              </a:rPr>
-              <a:t>04</a:t>
-            </a:r>
-            <a:endParaRPr lang="en-US" sz="2600" dirty="0"/>
-          </a:p>
-        </p:txBody>
-      </p:sp>
-      <p:sp>
-        <p:nvSpPr>
-          <p:cNvPr id="12" name="Módulo 4"/>
-          <p:cNvSpPr txBox="1"/>
-          <p:nvPr/>
-        </p:nvSpPr>
-        <p:spPr>
-          <a:xfrm>
-            <a:off x="1463040" y="4325112"/>
-            <a:ext cx="5669280" cy="548640"/>
-          </a:xfrm>
-          <a:prstGeom prst="rect">
-            <a:avLst/>
-          </a:prstGeom>
-          <a:noFill/>
-          <a:ln/>
-        </p:spPr>
-        <p:txBody>
-          <a:bodyPr wrap="square" lIns="0" tIns="0" rIns="0" bIns="0" rtlCol="0" anchor="ctr"/>
-          <a:lstStyle/>
-          <a:p>
-            <a:pPr indent="0" marL="0">
-              <a:buNone/>
-            </a:pPr>
-            <a:r>
-              <a:rPr lang="en-US" sz="1600" dirty="0">
-                <a:solidFill>
-                  <a:schemeClr val="bg1"/>
-                </a:solidFill>
-              </a:rPr>
-              <a:t>Lifting facial com preenchedores: raciocínio anatômico e estrutural</a:t>
-            </a:r>
-            <a:endParaRPr lang="en-US" sz="1600" dirty="0"/>
-          </a:p>
-        </p:txBody>
-      </p:sp>
-      <p:sp>
-        <p:nvSpPr>
-          <p:cNvPr id="13" name="Módulo 5 número"/>
-          <p:cNvSpPr txBox="1"/>
-          <p:nvPr/>
-        </p:nvSpPr>
-        <p:spPr>
-          <a:xfrm>
-            <a:off x="640080" y="5111496"/>
-            <a:ext cx="731520" cy="548640"/>
-          </a:xfrm>
-          <a:prstGeom prst="rect">
-            <a:avLst/>
-          </a:prstGeom>
-          <a:noFill/>
-          <a:ln/>
-        </p:spPr>
-        <p:txBody>
-          <a:bodyPr wrap="square" lIns="0" tIns="0" rIns="0" bIns="0" rtlCol="0" anchor="ctr"/>
-          <a:lstStyle/>
-          <a:p>
-            <a:pPr indent="0" marL="0">
-              <a:buNone/>
-            </a:pPr>
-            <a:r>
-              <a:rPr lang="en-US" sz="2600" dirty="0">
-                <a:solidFill>
-                  <a:schemeClr val="accent1"/>
-                </a:solidFill>
-                <a:latin typeface="Georgia" pitchFamily="34" charset="0"/>
-                <a:ea typeface="Georgia" pitchFamily="34" charset="-122"/>
-                <a:cs typeface="Georgia" pitchFamily="34" charset="-120"/>
-              </a:rPr>
-              <a:t>05</a:t>
-            </a:r>
-            <a:endParaRPr lang="en-US" sz="2600" dirty="0"/>
-          </a:p>
-        </p:txBody>
-      </p:sp>
-      <p:sp>
-        <p:nvSpPr>
-          <p:cNvPr id="14" name="Módulo 5"/>
-          <p:cNvSpPr txBox="1"/>
-          <p:nvPr/>
-        </p:nvSpPr>
-        <p:spPr>
-          <a:xfrm>
-            <a:off x="1463040" y="5111496"/>
-            <a:ext cx="5669280" cy="548640"/>
-          </a:xfrm>
-          <a:prstGeom prst="rect">
-            <a:avLst/>
-          </a:prstGeom>
-          <a:noFill/>
-          <a:ln/>
-        </p:spPr>
-        <p:txBody>
-          <a:bodyPr wrap="square" lIns="0" tIns="0" rIns="0" bIns="0" rtlCol="0" anchor="ctr"/>
-          <a:lstStyle/>
-          <a:p>
-            <a:pPr indent="0" marL="0">
-              <a:buNone/>
-            </a:pPr>
-            <a:r>
-              <a:rPr lang="en-US" sz="1600" dirty="0">
-                <a:solidFill>
-                  <a:schemeClr val="bg1"/>
-                </a:solidFill>
-              </a:rPr>
               <a:t>Full face: planejamento anatômico, segurança e naturalidade</a:t>
             </a:r>
-            <a:endParaRPr lang="en-US" sz="1600" dirty="0"/>
+            <a:endParaRPr lang="en-US" sz="2000" dirty="0"/>
           </a:p>
         </p:txBody>
       </p:sp>
@@ -3155,43 +2870,7 @@
       </p:grpSpPr>
       <p:sp>
         <p:nvSpPr>
-          <p:cNvPr id="2" name="Rótulo"/>
-          <p:cNvSpPr txBox="1"/>
-          <p:nvPr/>
-        </p:nvSpPr>
-        <p:spPr>
-          <a:xfrm>
-            <a:off x="640080" y="502920"/>
-            <a:ext cx="6035040" cy="274320"/>
-          </a:xfrm>
-          <a:prstGeom prst="rect">
-            <a:avLst/>
-          </a:prstGeom>
-          <a:noFill/>
-          <a:ln/>
-        </p:spPr>
-        <p:txBody>
-          <a:bodyPr wrap="square" lIns="0" tIns="0" rIns="0" bIns="0" rtlCol="0" anchor="ctr"/>
-          <a:lstStyle/>
-          <a:p>
-            <a:pPr indent="0" marL="0">
-              <a:buNone/>
-            </a:pPr>
-            <a:r>
-              <a:rPr lang="en-US" sz="1100" b="1" spc="600" kern="0" dirty="0">
-                <a:solidFill>
-                  <a:schemeClr val="accent1"/>
-                </a:solidFill>
-              </a:rPr>
-              <a:t>O PROGRAMA COMPLETO</a:t>
-            </a:r>
-            <a:endParaRPr lang="en-US" sz="1100" dirty="0"/>
-          </a:p>
-        </p:txBody>
-      </p:sp>
-      <p:sp>
-        <p:nvSpPr>
-          <p:cNvPr id="3" name="Text 0"/>
+          <p:cNvPr id="2" name="Text 0"/>
           <p:cNvSpPr/>
           <p:nvPr>
             <p:ph idx="100" type="title" hasCustomPrompt="1"/>
@@ -3232,7 +2911,7 @@
       </p:sp>
       <p:sp>
         <p:nvSpPr>
-          <p:cNvPr id="4" name="Cartão Etapa de Boston"/>
+          <p:cNvPr id="3" name="Cartão Boston"/>
           <p:cNvSpPr/>
           <p:nvPr/>
         </p:nvSpPr>
@@ -3257,14 +2936,14 @@
       </p:sp>
       <p:sp>
         <p:nvSpPr>
-          <p:cNvPr id="5" name="Etapa de Boston rótulo"/>
+          <p:cNvPr id="4" name="Boston título"/>
           <p:cNvSpPr txBox="1"/>
           <p:nvPr/>
         </p:nvSpPr>
         <p:spPr>
           <a:xfrm>
-            <a:off x="1051560" y="2514600"/>
-            <a:ext cx="4480560" cy="320040"/>
+            <a:off x="1051560" y="2468880"/>
+            <a:ext cx="4480560" cy="685800"/>
           </a:xfrm>
           <a:prstGeom prst="rect">
             <a:avLst/>
@@ -3280,43 +2959,7 @@
               <a:buNone/>
             </a:pPr>
             <a:r>
-              <a:rPr lang="en-US" sz="1200" b="1" spc="600" kern="0" dirty="0">
-                <a:solidFill>
-                  <a:schemeClr val="accent4"/>
-                </a:solidFill>
-              </a:rPr>
-              <a:t>ETAPA DE BOSTON</a:t>
-            </a:r>
-            <a:endParaRPr lang="en-US" sz="1200" dirty="0"/>
-          </a:p>
-        </p:txBody>
-      </p:sp>
-      <p:sp>
-        <p:nvSpPr>
-          <p:cNvPr id="6" name="Etapa de Boston título"/>
-          <p:cNvSpPr txBox="1"/>
-          <p:nvPr/>
-        </p:nvSpPr>
-        <p:spPr>
-          <a:xfrm>
-            <a:off x="1051560" y="2971800"/>
-            <a:ext cx="4480560" cy="1005840"/>
-          </a:xfrm>
-          <a:prstGeom prst="rect">
-            <a:avLst/>
-          </a:prstGeom>
-          <a:noFill/>
-          <a:ln/>
-        </p:spPr>
-        <p:txBody>
-          <a:bodyPr wrap="square" lIns="0" tIns="0" rIns="0" bIns="0" rtlCol="0" anchor="t"/>
-          <a:lstStyle/>
-          <a:p>
-            <a:pPr indent="0" marL="0">
-              <a:buNone/>
-            </a:pPr>
-            <a:r>
-              <a:rPr lang="en-US" sz="2800" dirty="0">
+              <a:rPr lang="en-US" sz="3800" dirty="0">
                 <a:solidFill>
                   <a:schemeClr val="bg1"/>
                 </a:solidFill>
@@ -3324,15 +2967,51 @@
                 <a:ea typeface="Georgia" pitchFamily="34" charset="-122"/>
                 <a:cs typeface="Georgia" pitchFamily="34" charset="-120"/>
               </a:rPr>
+              <a:t>Boston</a:t>
+            </a:r>
+            <a:endParaRPr lang="en-US" sz="3800" dirty="0"/>
+          </a:p>
+        </p:txBody>
+      </p:sp>
+      <p:sp>
+        <p:nvSpPr>
+          <p:cNvPr id="5" name="Boston subtítulo"/>
+          <p:cNvSpPr txBox="1"/>
+          <p:nvPr/>
+        </p:nvSpPr>
+        <p:spPr>
+          <a:xfrm>
+            <a:off x="1051560" y="3246120"/>
+            <a:ext cx="4480560" cy="457200"/>
+          </a:xfrm>
+          <a:prstGeom prst="rect">
+            <a:avLst/>
+          </a:prstGeom>
+          <a:noFill/>
+          <a:ln/>
+        </p:spPr>
+        <p:txBody>
+          <a:bodyPr wrap="square" lIns="0" tIns="0" rIns="0" bIns="0" rtlCol="0" anchor="t"/>
+          <a:lstStyle/>
+          <a:p>
+            <a:pPr indent="0" marL="0">
+              <a:buNone/>
+            </a:pPr>
+            <a:r>
+              <a:rPr lang="en-US" sz="1800" b="1" dirty="0">
+                <a:solidFill>
+                  <a:schemeClr val="bg1"/>
+                </a:solidFill>
+              </a:rPr>
               <a:t>Teoria e anatomia demonstrativa</a:t>
             </a:r>
-            <a:endParaRPr lang="en-US" sz="2800" dirty="0"/>
-          </a:p>
-        </p:txBody>
-      </p:sp>
-      <p:sp>
-        <p:nvSpPr>
-          <p:cNvPr id="7" name="Etapa de Boston texto"/>
+            <a:endParaRPr lang="en-US" sz="1800" dirty="0"/>
+          </a:p>
+        </p:txBody>
+      </p:sp>
+      <p:sp>
+        <p:nvSpPr>
+          <p:cNvPr id="6" name="Boston texto"/>
           <p:cNvSpPr txBox="1"/>
           <p:nvPr/>
         </p:nvSpPr>
@@ -3368,7 +3047,7 @@
       </p:sp>
       <p:sp>
         <p:nvSpPr>
-          <p:cNvPr id="8" name="Cartão Etapa de Miami"/>
+          <p:cNvPr id="7" name="Cartão Miami"/>
           <p:cNvSpPr/>
           <p:nvPr/>
         </p:nvSpPr>
@@ -3393,14 +3072,14 @@
       </p:sp>
       <p:sp>
         <p:nvSpPr>
-          <p:cNvPr id="9" name="Etapa de Miami rótulo"/>
+          <p:cNvPr id="8" name="Miami título"/>
           <p:cNvSpPr txBox="1"/>
           <p:nvPr/>
         </p:nvSpPr>
         <p:spPr>
           <a:xfrm>
-            <a:off x="6656832" y="2514600"/>
-            <a:ext cx="4480560" cy="320040"/>
+            <a:off x="6656832" y="2468880"/>
+            <a:ext cx="4480560" cy="685800"/>
           </a:xfrm>
           <a:prstGeom prst="rect">
             <a:avLst/>
@@ -3416,43 +3095,7 @@
               <a:buNone/>
             </a:pPr>
             <a:r>
-              <a:rPr lang="en-US" sz="1200" b="1" spc="600" kern="0" dirty="0">
-                <a:solidFill>
-                  <a:schemeClr val="bg1"/>
-                </a:solidFill>
-              </a:rPr>
-              <a:t>ETAPA DE MIAMI</a:t>
-            </a:r>
-            <a:endParaRPr lang="en-US" sz="1200" dirty="0"/>
-          </a:p>
-        </p:txBody>
-      </p:sp>
-      <p:sp>
-        <p:nvSpPr>
-          <p:cNvPr id="10" name="Etapa de Miami título"/>
-          <p:cNvSpPr txBox="1"/>
-          <p:nvPr/>
-        </p:nvSpPr>
-        <p:spPr>
-          <a:xfrm>
-            <a:off x="6656832" y="2971800"/>
-            <a:ext cx="4480560" cy="1005840"/>
-          </a:xfrm>
-          <a:prstGeom prst="rect">
-            <a:avLst/>
-          </a:prstGeom>
-          <a:noFill/>
-          <a:ln/>
-        </p:spPr>
-        <p:txBody>
-          <a:bodyPr wrap="square" lIns="0" tIns="0" rIns="0" bIns="0" rtlCol="0" anchor="t"/>
-          <a:lstStyle/>
-          <a:p>
-            <a:pPr indent="0" marL="0">
-              <a:buNone/>
-            </a:pPr>
-            <a:r>
-              <a:rPr lang="en-US" sz="2800" dirty="0">
+              <a:rPr lang="en-US" sz="3800" dirty="0">
                 <a:solidFill>
                   <a:schemeClr val="bg1"/>
                 </a:solidFill>
@@ -3460,15 +3103,51 @@
                 <a:ea typeface="Georgia" pitchFamily="34" charset="-122"/>
                 <a:cs typeface="Georgia" pitchFamily="34" charset="-120"/>
               </a:rPr>
+              <a:t>Miami</a:t>
+            </a:r>
+            <a:endParaRPr lang="en-US" sz="3800" dirty="0"/>
+          </a:p>
+        </p:txBody>
+      </p:sp>
+      <p:sp>
+        <p:nvSpPr>
+          <p:cNvPr id="9" name="Miami subtítulo"/>
+          <p:cNvSpPr txBox="1"/>
+          <p:nvPr/>
+        </p:nvSpPr>
+        <p:spPr>
+          <a:xfrm>
+            <a:off x="6656832" y="3246120"/>
+            <a:ext cx="4480560" cy="457200"/>
+          </a:xfrm>
+          <a:prstGeom prst="rect">
+            <a:avLst/>
+          </a:prstGeom>
+          <a:noFill/>
+          <a:ln/>
+        </p:spPr>
+        <p:txBody>
+          <a:bodyPr wrap="square" lIns="0" tIns="0" rIns="0" bIns="0" rtlCol="0" anchor="t"/>
+          <a:lstStyle/>
+          <a:p>
+            <a:pPr indent="0" marL="0">
+              <a:buNone/>
+            </a:pPr>
+            <a:r>
+              <a:rPr lang="en-US" sz="1800" b="1" dirty="0">
+                <a:solidFill>
+                  <a:schemeClr val="bg1"/>
+                </a:solidFill>
+              </a:rPr>
               <a:t>Prática real e hands-on</a:t>
             </a:r>
-            <a:endParaRPr lang="en-US" sz="2800" dirty="0"/>
-          </a:p>
-        </p:txBody>
-      </p:sp>
-      <p:sp>
-        <p:nvSpPr>
-          <p:cNvPr id="11" name="Etapa de Miami texto"/>
+            <a:endParaRPr lang="en-US" sz="1800" dirty="0"/>
+          </a:p>
+        </p:txBody>
+      </p:sp>
+      <p:sp>
+        <p:nvSpPr>
+          <p:cNvPr id="10" name="Miami texto"/>
           <p:cNvSpPr txBox="1"/>
           <p:nvPr/>
         </p:nvSpPr>
@@ -3496,7 +3175,7 @@
                   <a:schemeClr val="bg1"/>
                 </a:solidFill>
               </a:rPr>
-              <a:t>3 dias em laboratório de specimen: anatomia aplicada e prática supervisionada dos procedimentos.</a:t>
+              <a:t>19, 20 e 21 de maio de 2027, em laboratório de specimen: anatomia aplicada e prática supervisionada dos procedimentos.</a:t>
             </a:r>
             <a:endParaRPr lang="en-US" sz="1500" dirty="0"/>
           </a:p>
@@ -3577,7 +3256,7 @@
       </p:grpSpPr>
       <p:pic>
         <p:nvPicPr>
-          <p:cNvPr id="2" name="Foto prática" descr="Profissional de touca e avental realizando procedimento em laboratório">    </p:cNvPr>
+          <p:cNvPr id="2" name="Print Instagram" descr="Perfil @dra.rosanaa no Instagram, com 339 mil seguidores">    </p:cNvPr>
           <p:cNvPicPr>
             <a:picLocks noChangeAspect="1"/>
           </p:cNvPicPr>
@@ -3591,8 +3270,8 @@
         </p:blipFill>
         <p:spPr>
           <a:xfrm>
-            <a:off x="7498080" y="914400"/>
-            <a:ext cx="4251960" cy="5623560"/>
+            <a:off x="8412480" y="548640"/>
+            <a:ext cx="3182112" cy="5477256"/>
           </a:xfrm>
           <a:prstGeom prst="rect">
             <a:avLst/>
@@ -3601,14 +3280,14 @@
       </p:pic>
       <p:sp>
         <p:nvSpPr>
-          <p:cNvPr id="3" name="Rótulo"/>
+          <p:cNvPr id="3" name="Pré-título"/>
           <p:cNvSpPr txBox="1"/>
           <p:nvPr/>
         </p:nvSpPr>
         <p:spPr>
           <a:xfrm>
-            <a:off x="640080" y="502920"/>
-            <a:ext cx="6035040" cy="274320"/>
+            <a:off x="640080" y="411480"/>
+            <a:ext cx="6035040" cy="411480"/>
           </a:xfrm>
           <a:prstGeom prst="rect">
             <a:avLst/>
@@ -3624,14 +3303,17 @@
               <a:buNone/>
             </a:pPr>
             <a:r>
-              <a:rPr lang="en-US" sz="1100" b="1" spc="600" kern="0" dirty="0">
-                <a:solidFill>
-                  <a:schemeClr val="accent1"/>
-                </a:solidFill>
-              </a:rPr>
-              <a:t>QUEM ENSINA</a:t>
-            </a:r>
-            <a:endParaRPr lang="en-US" sz="1100" dirty="0"/>
+              <a:rPr lang="en-US" sz="2000" spc="300" kern="0" dirty="0">
+                <a:solidFill>
+                  <a:schemeClr val="accent4"/>
+                </a:solidFill>
+                <a:latin typeface="Georgia" pitchFamily="34" charset="0"/>
+                <a:ea typeface="Georgia" pitchFamily="34" charset="-122"/>
+                <a:cs typeface="Georgia" pitchFamily="34" charset="-120"/>
+              </a:rPr>
+              <a:t>O poder do</a:t>
+            </a:r>
+            <a:endParaRPr lang="en-US" sz="2000" dirty="0"/>
           </a:p>
         </p:txBody>
       </p:sp>
@@ -3670,7 +3352,7 @@
                 <a:ea typeface="Georgia" pitchFamily="34" charset="-122"/>
                 <a:cs typeface="Georgia" pitchFamily="34" charset="-120"/>
               </a:rPr>
-              <a:t>SPEAKERS</a:t>
+              <a:t>POSICIONAMENTO</a:t>
             </a:r>
             <a:endParaRPr lang="en-US" sz="3200" dirty="0"/>
           </a:p>
@@ -3678,14 +3360,14 @@
       </p:sp>
       <p:sp>
         <p:nvSpPr>
-          <p:cNvPr id="5" name="Introdução speakers"/>
+          <p:cNvPr id="5" name="Introdução posicionamento"/>
           <p:cNvSpPr txBox="1"/>
           <p:nvPr/>
         </p:nvSpPr>
         <p:spPr>
           <a:xfrm>
             <a:off x="640080" y="1920240"/>
-            <a:ext cx="6217920" cy="822960"/>
+            <a:ext cx="6949440" cy="548640"/>
           </a:xfrm>
           <a:prstGeom prst="rect">
             <a:avLst/>
@@ -3706,7 +3388,7 @@
                   <a:schemeClr val="accent4"/>
                 </a:solidFill>
               </a:rPr>
-              <a:t>O programa seleciona profissionais com técnicas consolidadas no mercado, para que você amplie seu conhecimento:</a:t>
+              <a:t>Um programa realizado em Boston e Miami reúne, além do conteúdo técnico:</a:t>
             </a:r>
             <a:endParaRPr lang="en-US" sz="1600" dirty="0"/>
           </a:p>
@@ -3714,14 +3396,14 @@
       </p:sp>
       <p:sp>
         <p:nvSpPr>
-          <p:cNvPr id="6" name="Lista speakers"/>
+          <p:cNvPr id="6" name="Item 1 título"/>
           <p:cNvSpPr txBox="1"/>
           <p:nvPr/>
         </p:nvSpPr>
         <p:spPr>
           <a:xfrm>
-            <a:off x="640080" y="2880360"/>
-            <a:ext cx="6217920" cy="1554480"/>
+            <a:off x="640080" y="2697480"/>
+            <a:ext cx="6949440" cy="365760"/>
           </a:xfrm>
           <a:prstGeom prst="rect">
             <a:avLst/>
@@ -3730,95 +3412,244 @@
           <a:ln/>
         </p:spPr>
         <p:txBody>
-          <a:bodyPr wrap="square" lIns="0" tIns="0" rIns="0" bIns="0" rtlCol="0" anchor="t"/>
-          <a:lstStyle/>
-          <a:p>
-            <a:pPr marL="342900" indent="-342900">
-              <a:spcAft>
-                <a:spcPts val="1000"/>
-              </a:spcAft>
-              <a:buSzPct val="100000"/>
-              <a:buChar char="•"/>
-            </a:pPr>
-            <a:r>
-              <a:rPr lang="en-US" sz="1600" dirty="0">
-                <a:solidFill>
-                  <a:schemeClr val="bg1"/>
-                </a:solidFill>
-              </a:rPr>
-              <a:t>Profissionais brasileiros reconhecidos na estética</a:t>
-            </a:r>
-            <a:endParaRPr lang="en-US" sz="1600" dirty="0"/>
-          </a:p>
-          <a:p>
-            <a:pPr marL="342900" indent="-342900">
-              <a:spcAft>
-                <a:spcPts val="1000"/>
-              </a:spcAft>
-              <a:buSzPct val="100000"/>
-              <a:buChar char="•"/>
-            </a:pPr>
-            <a:r>
-              <a:rPr lang="en-US" sz="1600" dirty="0">
-                <a:solidFill>
-                  <a:schemeClr val="bg1"/>
-                </a:solidFill>
-              </a:rPr>
-              <a:t>Convidados internacionais com atuação clínica e educacional</a:t>
-            </a:r>
-            <a:endParaRPr lang="en-US" sz="1600" dirty="0"/>
-          </a:p>
-          <a:p>
-            <a:pPr marL="342900" indent="-342900">
-              <a:spcAft>
-                <a:spcPts val="1000"/>
-              </a:spcAft>
-              <a:buSzPct val="100000"/>
-              <a:buChar char="•"/>
-            </a:pPr>
-            <a:r>
-              <a:rPr lang="en-US" sz="1600" dirty="0">
-                <a:solidFill>
-                  <a:schemeClr val="bg1"/>
-                </a:solidFill>
-              </a:rPr>
-              <a:t>Especialistas em anatomia, estética avançada e prática segura</a:t>
-            </a:r>
-            <a:endParaRPr lang="en-US" sz="1600" dirty="0"/>
-          </a:p>
-        </p:txBody>
-      </p:sp>
-      <p:sp>
-        <p:nvSpPr>
-          <p:cNvPr id="7" name="Nota speakers"/>
-          <p:cNvSpPr txBox="1"/>
-          <p:nvPr/>
-        </p:nvSpPr>
-        <p:spPr>
-          <a:xfrm>
-            <a:off x="640080" y="4800600"/>
-            <a:ext cx="6217920" cy="822960"/>
-          </a:xfrm>
-          <a:prstGeom prst="rect">
-            <a:avLst/>
-          </a:prstGeom>
-          <a:noFill/>
-          <a:ln/>
-        </p:spPr>
-        <p:txBody>
-          <a:bodyPr wrap="square" lIns="0" tIns="0" rIns="0" bIns="0" rtlCol="0" anchor="t"/>
+          <a:bodyPr wrap="square" lIns="0" tIns="0" rIns="0" bIns="0" rtlCol="0" anchor="ctr"/>
           <a:lstStyle/>
           <a:p>
             <a:pPr indent="0" marL="0">
               <a:buNone/>
             </a:pPr>
             <a:r>
+              <a:rPr lang="en-US" sz="2000" dirty="0">
+                <a:solidFill>
+                  <a:schemeClr val="bg1"/>
+                </a:solidFill>
+                <a:latin typeface="Georgia" pitchFamily="34" charset="0"/>
+                <a:ea typeface="Georgia" pitchFamily="34" charset="-122"/>
+                <a:cs typeface="Georgia" pitchFamily="34" charset="-120"/>
+              </a:rPr>
+              <a:t>Doutores da estética</a:t>
+            </a:r>
+            <a:endParaRPr lang="en-US" sz="2000" dirty="0"/>
+          </a:p>
+        </p:txBody>
+      </p:sp>
+      <p:sp>
+        <p:nvSpPr>
+          <p:cNvPr id="7" name="Item 1 texto"/>
+          <p:cNvSpPr txBox="1"/>
+          <p:nvPr/>
+        </p:nvSpPr>
+        <p:spPr>
+          <a:xfrm>
+            <a:off x="640080" y="3081528"/>
+            <a:ext cx="6949440" cy="411480"/>
+          </a:xfrm>
+          <a:prstGeom prst="rect">
+            <a:avLst/>
+          </a:prstGeom>
+          <a:noFill/>
+          <a:ln/>
+        </p:spPr>
+        <p:txBody>
+          <a:bodyPr wrap="square" lIns="0" tIns="0" rIns="0" bIns="0" rtlCol="0" anchor="ctr"/>
+          <a:lstStyle/>
+          <a:p>
+            <a:pPr indent="0" marL="0">
+              <a:buNone/>
+            </a:pPr>
+            <a:r>
+              <a:rPr lang="en-US" sz="1500" dirty="0">
+                <a:solidFill>
+                  <a:schemeClr val="accent4"/>
+                </a:solidFill>
+              </a:rPr>
+              <a:t>nacionais e internacionais</a:t>
+            </a:r>
+            <a:endParaRPr lang="en-US" sz="1500" dirty="0"/>
+          </a:p>
+        </p:txBody>
+      </p:sp>
+      <p:sp>
+        <p:nvSpPr>
+          <p:cNvPr id="8" name="Item 2 título"/>
+          <p:cNvSpPr txBox="1"/>
+          <p:nvPr/>
+        </p:nvSpPr>
+        <p:spPr>
+          <a:xfrm>
+            <a:off x="640080" y="3657600"/>
+            <a:ext cx="6949440" cy="365760"/>
+          </a:xfrm>
+          <a:prstGeom prst="rect">
+            <a:avLst/>
+          </a:prstGeom>
+          <a:noFill/>
+          <a:ln/>
+        </p:spPr>
+        <p:txBody>
+          <a:bodyPr wrap="square" lIns="0" tIns="0" rIns="0" bIns="0" rtlCol="0" anchor="ctr"/>
+          <a:lstStyle/>
+          <a:p>
+            <a:pPr indent="0" marL="0">
+              <a:buNone/>
+            </a:pPr>
+            <a:r>
+              <a:rPr lang="en-US" sz="2000" dirty="0">
+                <a:solidFill>
+                  <a:schemeClr val="bg1"/>
+                </a:solidFill>
+                <a:latin typeface="Georgia" pitchFamily="34" charset="0"/>
+                <a:ea typeface="Georgia" pitchFamily="34" charset="-122"/>
+                <a:cs typeface="Georgia" pitchFamily="34" charset="-120"/>
+              </a:rPr>
+              <a:t>Convidados</a:t>
+            </a:r>
+            <a:endParaRPr lang="en-US" sz="2000" dirty="0"/>
+          </a:p>
+        </p:txBody>
+      </p:sp>
+      <p:sp>
+        <p:nvSpPr>
+          <p:cNvPr id="9" name="Item 2 texto"/>
+          <p:cNvSpPr txBox="1"/>
+          <p:nvPr/>
+        </p:nvSpPr>
+        <p:spPr>
+          <a:xfrm>
+            <a:off x="640080" y="4041648"/>
+            <a:ext cx="6949440" cy="411480"/>
+          </a:xfrm>
+          <a:prstGeom prst="rect">
+            <a:avLst/>
+          </a:prstGeom>
+          <a:noFill/>
+          <a:ln/>
+        </p:spPr>
+        <p:txBody>
+          <a:bodyPr wrap="square" lIns="0" tIns="0" rIns="0" bIns="0" rtlCol="0" anchor="ctr"/>
+          <a:lstStyle/>
+          <a:p>
+            <a:pPr indent="0" marL="0">
+              <a:buNone/>
+            </a:pPr>
+            <a:r>
+              <a:rPr lang="en-US" sz="1500" dirty="0">
+                <a:solidFill>
+                  <a:schemeClr val="accent4"/>
+                </a:solidFill>
+              </a:rPr>
+              <a:t>com cases reais de sucesso na estética e no empreendedorismo</a:t>
+            </a:r>
+            <a:endParaRPr lang="en-US" sz="1500" dirty="0"/>
+          </a:p>
+        </p:txBody>
+      </p:sp>
+      <p:sp>
+        <p:nvSpPr>
+          <p:cNvPr id="10" name="Item 3 título"/>
+          <p:cNvSpPr txBox="1"/>
+          <p:nvPr/>
+        </p:nvSpPr>
+        <p:spPr>
+          <a:xfrm>
+            <a:off x="640080" y="4617720"/>
+            <a:ext cx="6949440" cy="365760"/>
+          </a:xfrm>
+          <a:prstGeom prst="rect">
+            <a:avLst/>
+          </a:prstGeom>
+          <a:noFill/>
+          <a:ln/>
+        </p:spPr>
+        <p:txBody>
+          <a:bodyPr wrap="square" lIns="0" tIns="0" rIns="0" bIns="0" rtlCol="0" anchor="ctr"/>
+          <a:lstStyle/>
+          <a:p>
+            <a:pPr indent="0" marL="0">
+              <a:buNone/>
+            </a:pPr>
+            <a:r>
+              <a:rPr lang="en-US" sz="2000" dirty="0">
+                <a:solidFill>
+                  <a:schemeClr val="bg1"/>
+                </a:solidFill>
+                <a:latin typeface="Georgia" pitchFamily="34" charset="0"/>
+                <a:ea typeface="Georgia" pitchFamily="34" charset="-122"/>
+                <a:cs typeface="Georgia" pitchFamily="34" charset="-120"/>
+              </a:rPr>
+              <a:t>Palestrantes</a:t>
+            </a:r>
+            <a:endParaRPr lang="en-US" sz="2000" dirty="0"/>
+          </a:p>
+        </p:txBody>
+      </p:sp>
+      <p:sp>
+        <p:nvSpPr>
+          <p:cNvPr id="11" name="Item 3 texto"/>
+          <p:cNvSpPr txBox="1"/>
+          <p:nvPr/>
+        </p:nvSpPr>
+        <p:spPr>
+          <a:xfrm>
+            <a:off x="640080" y="5001768"/>
+            <a:ext cx="6949440" cy="411480"/>
+          </a:xfrm>
+          <a:prstGeom prst="rect">
+            <a:avLst/>
+          </a:prstGeom>
+          <a:noFill/>
+          <a:ln/>
+        </p:spPr>
+        <p:txBody>
+          <a:bodyPr wrap="square" lIns="0" tIns="0" rIns="0" bIns="0" rtlCol="0" anchor="ctr"/>
+          <a:lstStyle/>
+          <a:p>
+            <a:pPr indent="0" marL="0">
+              <a:buNone/>
+            </a:pPr>
+            <a:r>
+              <a:rPr lang="en-US" sz="1500" dirty="0">
+                <a:solidFill>
+                  <a:schemeClr val="accent4"/>
+                </a:solidFill>
+              </a:rPr>
+              <a:t>que atuam com carreira, posicionamento e autoridade</a:t>
+            </a:r>
+            <a:endParaRPr lang="en-US" sz="1500" dirty="0"/>
+          </a:p>
+        </p:txBody>
+      </p:sp>
+      <p:sp>
+        <p:nvSpPr>
+          <p:cNvPr id="12" name="Nota posicionamento"/>
+          <p:cNvSpPr txBox="1"/>
+          <p:nvPr/>
+        </p:nvSpPr>
+        <p:spPr>
+          <a:xfrm>
+            <a:off x="640080" y="5623560"/>
+            <a:ext cx="7132320" cy="457200"/>
+          </a:xfrm>
+          <a:prstGeom prst="rect">
+            <a:avLst/>
+          </a:prstGeom>
+          <a:noFill/>
+          <a:ln/>
+        </p:spPr>
+        <p:txBody>
+          <a:bodyPr wrap="square" lIns="0" tIns="0" rIns="0" bIns="0" rtlCol="0" anchor="ctr"/>
+          <a:lstStyle/>
+          <a:p>
+            <a:pPr indent="0" marL="0">
+              <a:buNone/>
+            </a:pPr>
+            <a:r>
               <a:rPr lang="en-US" sz="1400" i="1" dirty="0">
                 <a:solidFill>
                   <a:schemeClr val="tx2"/>
                 </a:solidFill>
               </a:rPr>
-              <a:t>Os conteúdos são selecionados para manter coerência científica, profundidade técnica e aplicabilidade clínica.</a:t>
+              <a:t>Um momento desenhado para troca de experiências, visão de mercado e conexões profissionais relevantes.</a:t>
             </a:r>
             <a:endParaRPr lang="en-US" sz="1400" dirty="0"/>
           </a:p>
@@ -3897,9 +3728,50 @@
           <a:chExt cx="0" cy="0"/>
         </a:xfrm>
       </p:grpSpPr>
+      <p:sp>
+        <p:nvSpPr>
+          <p:cNvPr id="2" name="Text 0"/>
+          <p:cNvSpPr/>
+          <p:nvPr>
+            <p:ph idx="100" type="title" hasCustomPrompt="1"/>
+          </p:nvPr>
+        </p:nvSpPr>
+        <p:spPr>
+          <a:xfrm>
+            <a:off x="640080" y="868680"/>
+            <a:ext cx="10881360" cy="822960"/>
+          </a:xfrm>
+          <a:prstGeom prst="rect">
+            <a:avLst/>
+          </a:prstGeom>
+          <a:noFill/>
+          <a:ln/>
+        </p:spPr>
+        <p:txBody>
+          <a:bodyPr wrap="square" lIns="0" tIns="0" rIns="0" bIns="0" rtlCol="0" anchor="t"/>
+          <a:lstStyle/>
+          <a:p>
+            <a:pPr algn="l" indent="0" marL="0">
+              <a:buNone/>
+            </a:pPr>
+            <a:r>
+              <a:rPr lang="en-US" sz="3200" spc="200" kern="0" dirty="0">
+                <a:solidFill>
+                  <a:schemeClr val="bg1"/>
+                </a:solidFill>
+                <a:latin typeface="Georgia" pitchFamily="34" charset="0"/>
+                <a:ea typeface="Georgia" pitchFamily="34" charset="-122"/>
+                <a:cs typeface="Georgia" pitchFamily="34" charset="-120"/>
+              </a:rPr>
+              <a:t>O RESULTADO NA PRÁTICA</a:t>
+            </a:r>
+            <a:endParaRPr lang="en-US" sz="3200" dirty="0"/>
+          </a:p>
+        </p:txBody>
+      </p:sp>
       <p:pic>
         <p:nvPicPr>
-          <p:cNvPr id="2" name="Print Instagram" descr="Perfil @dra.rosanaa no Instagram, com 339 mil seguidores">    </p:cNvPr>
+          <p:cNvPr id="3" name="Depoimento" descr="Mensagem de aluna: depois da Formação Internacional, converteu o valor do curso em menos de 2 meses com 2 pacientes">    </p:cNvPr>
           <p:cNvPicPr>
             <a:picLocks noChangeAspect="1"/>
           </p:cNvPicPr>
@@ -3913,8 +3785,8 @@
         </p:blipFill>
         <p:spPr>
           <a:xfrm>
-            <a:off x="8412480" y="548640"/>
-            <a:ext cx="3182112" cy="5477256"/>
+            <a:off x="1984248" y="2194560"/>
+            <a:ext cx="8229600" cy="2468880"/>
           </a:xfrm>
           <a:prstGeom prst="rect">
             <a:avLst/>
@@ -3923,14 +3795,14 @@
       </p:pic>
       <p:sp>
         <p:nvSpPr>
-          <p:cNvPr id="3" name="Rótulo"/>
+          <p:cNvPr id="4" name="Legenda depoimento"/>
           <p:cNvSpPr txBox="1"/>
           <p:nvPr/>
         </p:nvSpPr>
         <p:spPr>
           <a:xfrm>
-            <a:off x="640080" y="502920"/>
-            <a:ext cx="6035040" cy="274320"/>
+            <a:off x="1984248" y="4892040"/>
+            <a:ext cx="8229600" cy="365760"/>
           </a:xfrm>
           <a:prstGeom prst="rect">
             <a:avLst/>
@@ -3946,352 +3818,14 @@
               <a:buNone/>
             </a:pPr>
             <a:r>
-              <a:rPr lang="en-US" sz="1100" b="1" spc="600" kern="0" dirty="0">
-                <a:solidFill>
-                  <a:schemeClr val="accent1"/>
-                </a:solidFill>
-              </a:rPr>
-              <a:t>O PODER DO</a:t>
-            </a:r>
-            <a:endParaRPr lang="en-US" sz="1100" dirty="0"/>
-          </a:p>
-        </p:txBody>
-      </p:sp>
-      <p:sp>
-        <p:nvSpPr>
-          <p:cNvPr id="4" name="Text 0"/>
-          <p:cNvSpPr/>
-          <p:nvPr>
-            <p:ph idx="100" type="title" hasCustomPrompt="1"/>
-          </p:nvPr>
-        </p:nvSpPr>
-        <p:spPr>
-          <a:xfrm>
-            <a:off x="640080" y="868680"/>
-            <a:ext cx="10881360" cy="822960"/>
-          </a:xfrm>
-          <a:prstGeom prst="rect">
-            <a:avLst/>
-          </a:prstGeom>
-          <a:noFill/>
-          <a:ln/>
-        </p:spPr>
-        <p:txBody>
-          <a:bodyPr wrap="square" lIns="0" tIns="0" rIns="0" bIns="0" rtlCol="0" anchor="t"/>
-          <a:lstStyle/>
-          <a:p>
-            <a:pPr algn="l" indent="0" marL="0">
-              <a:buNone/>
-            </a:pPr>
-            <a:r>
-              <a:rPr lang="en-US" sz="3200" spc="200" kern="0" dirty="0">
-                <a:solidFill>
-                  <a:schemeClr val="bg1"/>
-                </a:solidFill>
-                <a:latin typeface="Georgia" pitchFamily="34" charset="0"/>
-                <a:ea typeface="Georgia" pitchFamily="34" charset="-122"/>
-                <a:cs typeface="Georgia" pitchFamily="34" charset="-120"/>
-              </a:rPr>
-              <a:t>POSICIONAMENTO</a:t>
-            </a:r>
-            <a:endParaRPr lang="en-US" sz="3200" dirty="0"/>
-          </a:p>
-        </p:txBody>
-      </p:sp>
-      <p:sp>
-        <p:nvSpPr>
-          <p:cNvPr id="5" name="Introdução posicionamento"/>
-          <p:cNvSpPr txBox="1"/>
-          <p:nvPr/>
-        </p:nvSpPr>
-        <p:spPr>
-          <a:xfrm>
-            <a:off x="640080" y="1920240"/>
-            <a:ext cx="6949440" cy="548640"/>
-          </a:xfrm>
-          <a:prstGeom prst="rect">
-            <a:avLst/>
-          </a:prstGeom>
-          <a:noFill/>
-          <a:ln/>
-        </p:spPr>
-        <p:txBody>
-          <a:bodyPr wrap="square" lIns="0" tIns="0" rIns="0" bIns="0" rtlCol="0" anchor="t"/>
-          <a:lstStyle/>
-          <a:p>
-            <a:pPr indent="0" marL="0">
-              <a:buNone/>
-            </a:pPr>
-            <a:r>
-              <a:rPr lang="en-US" sz="1600" dirty="0">
-                <a:solidFill>
-                  <a:schemeClr val="accent4"/>
-                </a:solidFill>
-              </a:rPr>
-              <a:t>Um programa realizado em Boston e Miami reúne, além do conteúdo técnico:</a:t>
-            </a:r>
-            <a:endParaRPr lang="en-US" sz="1600" dirty="0"/>
-          </a:p>
-        </p:txBody>
-      </p:sp>
-      <p:sp>
-        <p:nvSpPr>
-          <p:cNvPr id="6" name="Item 1 título"/>
-          <p:cNvSpPr txBox="1"/>
-          <p:nvPr/>
-        </p:nvSpPr>
-        <p:spPr>
-          <a:xfrm>
-            <a:off x="640080" y="2697480"/>
-            <a:ext cx="6949440" cy="365760"/>
-          </a:xfrm>
-          <a:prstGeom prst="rect">
-            <a:avLst/>
-          </a:prstGeom>
-          <a:noFill/>
-          <a:ln/>
-        </p:spPr>
-        <p:txBody>
-          <a:bodyPr wrap="square" lIns="0" tIns="0" rIns="0" bIns="0" rtlCol="0" anchor="ctr"/>
-          <a:lstStyle/>
-          <a:p>
-            <a:pPr indent="0" marL="0">
-              <a:buNone/>
-            </a:pPr>
-            <a:r>
-              <a:rPr lang="en-US" sz="2000" dirty="0">
-                <a:solidFill>
-                  <a:schemeClr val="bg1"/>
-                </a:solidFill>
-                <a:latin typeface="Georgia" pitchFamily="34" charset="0"/>
-                <a:ea typeface="Georgia" pitchFamily="34" charset="-122"/>
-                <a:cs typeface="Georgia" pitchFamily="34" charset="-120"/>
-              </a:rPr>
-              <a:t>Doutores da estética</a:t>
-            </a:r>
-            <a:endParaRPr lang="en-US" sz="2000" dirty="0"/>
-          </a:p>
-        </p:txBody>
-      </p:sp>
-      <p:sp>
-        <p:nvSpPr>
-          <p:cNvPr id="7" name="Item 1 texto"/>
-          <p:cNvSpPr txBox="1"/>
-          <p:nvPr/>
-        </p:nvSpPr>
-        <p:spPr>
-          <a:xfrm>
-            <a:off x="640080" y="3081528"/>
-            <a:ext cx="6949440" cy="411480"/>
-          </a:xfrm>
-          <a:prstGeom prst="rect">
-            <a:avLst/>
-          </a:prstGeom>
-          <a:noFill/>
-          <a:ln/>
-        </p:spPr>
-        <p:txBody>
-          <a:bodyPr wrap="square" lIns="0" tIns="0" rIns="0" bIns="0" rtlCol="0" anchor="ctr"/>
-          <a:lstStyle/>
-          <a:p>
-            <a:pPr indent="0" marL="0">
-              <a:buNone/>
-            </a:pPr>
-            <a:r>
-              <a:rPr lang="en-US" sz="1500" dirty="0">
-                <a:solidFill>
-                  <a:schemeClr val="accent4"/>
-                </a:solidFill>
-              </a:rPr>
-              <a:t>nacionais e internacionais</a:t>
-            </a:r>
-            <a:endParaRPr lang="en-US" sz="1500" dirty="0"/>
-          </a:p>
-        </p:txBody>
-      </p:sp>
-      <p:sp>
-        <p:nvSpPr>
-          <p:cNvPr id="8" name="Item 2 título"/>
-          <p:cNvSpPr txBox="1"/>
-          <p:nvPr/>
-        </p:nvSpPr>
-        <p:spPr>
-          <a:xfrm>
-            <a:off x="640080" y="3657600"/>
-            <a:ext cx="6949440" cy="365760"/>
-          </a:xfrm>
-          <a:prstGeom prst="rect">
-            <a:avLst/>
-          </a:prstGeom>
-          <a:noFill/>
-          <a:ln/>
-        </p:spPr>
-        <p:txBody>
-          <a:bodyPr wrap="square" lIns="0" tIns="0" rIns="0" bIns="0" rtlCol="0" anchor="ctr"/>
-          <a:lstStyle/>
-          <a:p>
-            <a:pPr indent="0" marL="0">
-              <a:buNone/>
-            </a:pPr>
-            <a:r>
-              <a:rPr lang="en-US" sz="2000" dirty="0">
-                <a:solidFill>
-                  <a:schemeClr val="bg1"/>
-                </a:solidFill>
-                <a:latin typeface="Georgia" pitchFamily="34" charset="0"/>
-                <a:ea typeface="Georgia" pitchFamily="34" charset="-122"/>
-                <a:cs typeface="Georgia" pitchFamily="34" charset="-120"/>
-              </a:rPr>
-              <a:t>Convidados</a:t>
-            </a:r>
-            <a:endParaRPr lang="en-US" sz="2000" dirty="0"/>
-          </a:p>
-        </p:txBody>
-      </p:sp>
-      <p:sp>
-        <p:nvSpPr>
-          <p:cNvPr id="9" name="Item 2 texto"/>
-          <p:cNvSpPr txBox="1"/>
-          <p:nvPr/>
-        </p:nvSpPr>
-        <p:spPr>
-          <a:xfrm>
-            <a:off x="640080" y="4041648"/>
-            <a:ext cx="6949440" cy="411480"/>
-          </a:xfrm>
-          <a:prstGeom prst="rect">
-            <a:avLst/>
-          </a:prstGeom>
-          <a:noFill/>
-          <a:ln/>
-        </p:spPr>
-        <p:txBody>
-          <a:bodyPr wrap="square" lIns="0" tIns="0" rIns="0" bIns="0" rtlCol="0" anchor="ctr"/>
-          <a:lstStyle/>
-          <a:p>
-            <a:pPr indent="0" marL="0">
-              <a:buNone/>
-            </a:pPr>
-            <a:r>
-              <a:rPr lang="en-US" sz="1500" dirty="0">
-                <a:solidFill>
-                  <a:schemeClr val="accent4"/>
-                </a:solidFill>
-              </a:rPr>
-              <a:t>com cases reais de sucesso na estética e no empreendedorismo</a:t>
-            </a:r>
-            <a:endParaRPr lang="en-US" sz="1500" dirty="0"/>
-          </a:p>
-        </p:txBody>
-      </p:sp>
-      <p:sp>
-        <p:nvSpPr>
-          <p:cNvPr id="10" name="Item 3 título"/>
-          <p:cNvSpPr txBox="1"/>
-          <p:nvPr/>
-        </p:nvSpPr>
-        <p:spPr>
-          <a:xfrm>
-            <a:off x="640080" y="4617720"/>
-            <a:ext cx="6949440" cy="365760"/>
-          </a:xfrm>
-          <a:prstGeom prst="rect">
-            <a:avLst/>
-          </a:prstGeom>
-          <a:noFill/>
-          <a:ln/>
-        </p:spPr>
-        <p:txBody>
-          <a:bodyPr wrap="square" lIns="0" tIns="0" rIns="0" bIns="0" rtlCol="0" anchor="ctr"/>
-          <a:lstStyle/>
-          <a:p>
-            <a:pPr indent="0" marL="0">
-              <a:buNone/>
-            </a:pPr>
-            <a:r>
-              <a:rPr lang="en-US" sz="2000" dirty="0">
-                <a:solidFill>
-                  <a:schemeClr val="bg1"/>
-                </a:solidFill>
-                <a:latin typeface="Georgia" pitchFamily="34" charset="0"/>
-                <a:ea typeface="Georgia" pitchFamily="34" charset="-122"/>
-                <a:cs typeface="Georgia" pitchFamily="34" charset="-120"/>
-              </a:rPr>
-              <a:t>Palestrantes</a:t>
-            </a:r>
-            <a:endParaRPr lang="en-US" sz="2000" dirty="0"/>
-          </a:p>
-        </p:txBody>
-      </p:sp>
-      <p:sp>
-        <p:nvSpPr>
-          <p:cNvPr id="11" name="Item 3 texto"/>
-          <p:cNvSpPr txBox="1"/>
-          <p:nvPr/>
-        </p:nvSpPr>
-        <p:spPr>
-          <a:xfrm>
-            <a:off x="640080" y="5001768"/>
-            <a:ext cx="6949440" cy="411480"/>
-          </a:xfrm>
-          <a:prstGeom prst="rect">
-            <a:avLst/>
-          </a:prstGeom>
-          <a:noFill/>
-          <a:ln/>
-        </p:spPr>
-        <p:txBody>
-          <a:bodyPr wrap="square" lIns="0" tIns="0" rIns="0" bIns="0" rtlCol="0" anchor="ctr"/>
-          <a:lstStyle/>
-          <a:p>
-            <a:pPr indent="0" marL="0">
-              <a:buNone/>
-            </a:pPr>
-            <a:r>
-              <a:rPr lang="en-US" sz="1500" dirty="0">
-                <a:solidFill>
-                  <a:schemeClr val="accent4"/>
-                </a:solidFill>
-              </a:rPr>
-              <a:t>que atuam com carreira, posicionamento e autoridade</a:t>
-            </a:r>
-            <a:endParaRPr lang="en-US" sz="1500" dirty="0"/>
-          </a:p>
-        </p:txBody>
-      </p:sp>
-      <p:sp>
-        <p:nvSpPr>
-          <p:cNvPr id="12" name="Nota posicionamento"/>
-          <p:cNvSpPr txBox="1"/>
-          <p:nvPr/>
-        </p:nvSpPr>
-        <p:spPr>
-          <a:xfrm>
-            <a:off x="640080" y="5623560"/>
-            <a:ext cx="7132320" cy="457200"/>
-          </a:xfrm>
-          <a:prstGeom prst="rect">
-            <a:avLst/>
-          </a:prstGeom>
-          <a:noFill/>
-          <a:ln/>
-        </p:spPr>
-        <p:txBody>
-          <a:bodyPr wrap="square" lIns="0" tIns="0" rIns="0" bIns="0" rtlCol="0" anchor="ctr"/>
-          <a:lstStyle/>
-          <a:p>
-            <a:pPr indent="0" marL="0">
-              <a:buNone/>
-            </a:pPr>
-            <a:r>
-              <a:rPr lang="en-US" sz="1400" i="1" dirty="0">
+              <a:rPr lang="en-US" sz="1300" i="1" dirty="0">
                 <a:solidFill>
                   <a:schemeClr val="tx2"/>
                 </a:solidFill>
               </a:rPr>
-              <a:t>Um momento desenhado para troca de experiências, visão de mercado e conexões profissionais relevantes.</a:t>
-            </a:r>
-            <a:endParaRPr lang="en-US" sz="1400" dirty="0"/>
+              <a:t>Relato de aluna da Formação Internacional, enviado no grupo da turma.</a:t>
+            </a:r>
+            <a:endParaRPr lang="en-US" sz="1300" dirty="0"/>
           </a:p>
         </p:txBody>
       </p:sp>
@@ -4368,86 +3902,9 @@
           <a:chExt cx="0" cy="0"/>
         </a:xfrm>
       </p:grpSpPr>
-      <p:sp>
-        <p:nvSpPr>
-          <p:cNvPr id="2" name="Rótulo"/>
-          <p:cNvSpPr txBox="1"/>
-          <p:nvPr/>
-        </p:nvSpPr>
-        <p:spPr>
-          <a:xfrm>
-            <a:off x="640080" y="502920"/>
-            <a:ext cx="6035040" cy="274320"/>
-          </a:xfrm>
-          <a:prstGeom prst="rect">
-            <a:avLst/>
-          </a:prstGeom>
-          <a:noFill/>
-          <a:ln/>
-        </p:spPr>
-        <p:txBody>
-          <a:bodyPr wrap="square" lIns="0" tIns="0" rIns="0" bIns="0" rtlCol="0" anchor="ctr"/>
-          <a:lstStyle/>
-          <a:p>
-            <a:pPr indent="0" marL="0">
-              <a:buNone/>
-            </a:pPr>
-            <a:r>
-              <a:rPr lang="en-US" sz="1100" b="1" spc="600" kern="0" dirty="0">
-                <a:solidFill>
-                  <a:schemeClr val="accent1"/>
-                </a:solidFill>
-              </a:rPr>
-              <a:t>QUEM JÁ VIVEU</a:t>
-            </a:r>
-            <a:endParaRPr lang="en-US" sz="1100" dirty="0"/>
-          </a:p>
-        </p:txBody>
-      </p:sp>
-      <p:sp>
-        <p:nvSpPr>
-          <p:cNvPr id="3" name="Text 0"/>
-          <p:cNvSpPr/>
-          <p:nvPr>
-            <p:ph idx="100" type="title" hasCustomPrompt="1"/>
-          </p:nvPr>
-        </p:nvSpPr>
-        <p:spPr>
-          <a:xfrm>
-            <a:off x="640080" y="868680"/>
-            <a:ext cx="10881360" cy="822960"/>
-          </a:xfrm>
-          <a:prstGeom prst="rect">
-            <a:avLst/>
-          </a:prstGeom>
-          <a:noFill/>
-          <a:ln/>
-        </p:spPr>
-        <p:txBody>
-          <a:bodyPr wrap="square" lIns="0" tIns="0" rIns="0" bIns="0" rtlCol="0" anchor="t"/>
-          <a:lstStyle/>
-          <a:p>
-            <a:pPr algn="l" indent="0" marL="0">
-              <a:buNone/>
-            </a:pPr>
-            <a:r>
-              <a:rPr lang="en-US" sz="3200" spc="200" kern="0" dirty="0">
-                <a:solidFill>
-                  <a:schemeClr val="bg1"/>
-                </a:solidFill>
-                <a:latin typeface="Georgia" pitchFamily="34" charset="0"/>
-                <a:ea typeface="Georgia" pitchFamily="34" charset="-122"/>
-                <a:cs typeface="Georgia" pitchFamily="34" charset="-120"/>
-              </a:rPr>
-              <a:t>O RESULTADO NA PRÁTICA</a:t>
-            </a:r>
-            <a:endParaRPr lang="en-US" sz="3200" dirty="0"/>
-          </a:p>
-        </p:txBody>
-      </p:sp>
       <p:pic>
         <p:nvPicPr>
-          <p:cNvPr id="4" name="Depoimento" descr="Mensagem de aluna: depois da Formação Internacional, converteu o valor do curso em menos de 2 meses com 2 pacientes">    </p:cNvPr>
+          <p:cNvPr id="2" name="Bandeira" descr="Bandeira dos Estados Unidos tremulando">    </p:cNvPr>
           <p:cNvPicPr>
             <a:picLocks noChangeAspect="1"/>
           </p:cNvPicPr>
@@ -4461,8 +3918,8 @@
         </p:blipFill>
         <p:spPr>
           <a:xfrm>
-            <a:off x="1984248" y="2194560"/>
-            <a:ext cx="8229600" cy="2468880"/>
+            <a:off x="6400800" y="822960"/>
+            <a:ext cx="5760720" cy="3840480"/>
           </a:xfrm>
           <a:prstGeom prst="rect">
             <a:avLst/>
@@ -4471,14 +3928,14 @@
       </p:pic>
       <p:sp>
         <p:nvSpPr>
-          <p:cNvPr id="5" name="Legenda depoimento"/>
+          <p:cNvPr id="3" name="Rótulo final"/>
           <p:cNvSpPr txBox="1"/>
           <p:nvPr/>
         </p:nvSpPr>
         <p:spPr>
           <a:xfrm>
-            <a:off x="1984248" y="4892040"/>
-            <a:ext cx="8229600" cy="365760"/>
+            <a:off x="640080" y="1188720"/>
+            <a:ext cx="5943600" cy="411480"/>
           </a:xfrm>
           <a:prstGeom prst="rect">
             <a:avLst/>
@@ -4494,199 +3951,30 @@
               <a:buNone/>
             </a:pPr>
             <a:r>
-              <a:rPr lang="en-US" sz="1300" i="1" dirty="0">
-                <a:solidFill>
-                  <a:schemeClr val="tx2"/>
-                </a:solidFill>
-              </a:rPr>
-              <a:t>Relato de aluna da Formação Internacional, enviado no grupo da turma.</a:t>
-            </a:r>
-            <a:endParaRPr lang="en-US" sz="1300" dirty="0"/>
-          </a:p>
-        </p:txBody>
-      </p:sp>
-      <p:sp>
-        <p:nvSpPr>
-          <p:cNvPr id="25" name="Slide Number Placeholder 0"/>
-          <p:cNvSpPr>
-            <a:spLocks noGrp="1"/>
-          </p:cNvSpPr>
-          <p:nvPr>
-            <p:ph type="sldNum" sz="quarter" idx="4294967295"/>
-          </p:nvPr>
-        </p:nvSpPr>
-        <p:spPr>
-          <a:xfrm>
-            <a:off x="11155680" y="6355080"/>
-            <a:ext cx="411480" cy="274320"/>
-          </a:xfrm>
-          <a:prstGeom prst="rect">
-            <a:avLst/>
-          </a:prstGeom>
-          <a:extLst>
-            <a:ext uri="{C572A759-6A51-4108-AA02-DFA0A04FC94B}">
-              <ma14:wrappingTextBoxFlag xmlns:ma14="http://schemas.microsoft.com/office/mac/drawingml/2011/main" val="0"/>
-            </a:ext>
-          </a:extLst>
-        </p:spPr>
-        <p:txBody>
-          <a:bodyPr/>
-          <a:lstStyle>
-            <a:lvl1pPr>
-              <a:defRPr sz="900">
-                <a:solidFill>
-                  <a:schemeClr val="tx2"/>
-                </a:solidFill>
-              </a:defRPr>
-            </a:lvl1pPr>
-          </a:lstStyle>
-          <a:p>
-            <a:pPr algn="r"/>
-            <a:fld id="{F7021451-1387-4CA6-816F-3879F97B5CBC}" type="slidenum">
-              <a:rPr b="0" lang="en-US"/>
-              <a:t>8</a:t>
-            </a:fld>
-            <a:endParaRPr lang="en-US"/>
-          </a:p>
-        </p:txBody>
-      </p:sp>
-    </p:spTree>
-  </p:cSld>
-  <p:clrMapOvr>
-    <a:masterClrMapping/>
-  </p:clrMapOvr>
-  <p:transition spd="slow">
-    <p:fade/>
-  </p:transition>
-</p:sld>
-</file>
-
-<file path=ppt/slides/slide9.xml><?xml version="1.0" encoding="utf-8"?>
-<p:sld xmlns:a="http://schemas.openxmlformats.org/drawingml/2006/main" xmlns:r="http://schemas.openxmlformats.org/officeDocument/2006/relationships" xmlns:p="http://schemas.openxmlformats.org/presentationml/2006/main">
-  <p:cSld name="Slide 9">
-    <p:spTree>
-      <p:nvGrpSpPr>
-        <p:cNvPr id="1" name=""/>
-        <p:cNvGrpSpPr/>
-        <p:nvPr/>
-      </p:nvGrpSpPr>
-      <p:grpSpPr>
-        <a:xfrm>
-          <a:off x="0" y="0"/>
-          <a:ext cx="0" cy="0"/>
-          <a:chOff x="0" y="0"/>
-          <a:chExt cx="0" cy="0"/>
-        </a:xfrm>
-      </p:grpSpPr>
-      <p:pic>
-        <p:nvPicPr>
-          <p:cNvPr id="2" name="Bandeira" descr="Bandeira dos Estados Unidos tremulando">    </p:cNvPr>
-          <p:cNvPicPr>
-            <a:picLocks noChangeAspect="1"/>
-          </p:cNvPicPr>
-          <p:nvPr/>
-        </p:nvPicPr>
-        <p:blipFill>
-          <a:blip r:embed="rId1"/>
-          <a:stretch>
-            <a:fillRect/>
-          </a:stretch>
-        </p:blipFill>
-        <p:spPr>
-          <a:xfrm>
-            <a:off x="6400800" y="822960"/>
-            <a:ext cx="5760720" cy="3840480"/>
-          </a:xfrm>
-          <a:prstGeom prst="rect">
-            <a:avLst/>
-          </a:prstGeom>
-        </p:spPr>
-      </p:pic>
-      <p:sp>
-        <p:nvSpPr>
-          <p:cNvPr id="3" name="Rótulo final"/>
-          <p:cNvSpPr txBox="1"/>
-          <p:nvPr/>
-        </p:nvSpPr>
-        <p:spPr>
-          <a:xfrm>
-            <a:off x="640080" y="1280160"/>
-            <a:ext cx="5943600" cy="274320"/>
-          </a:xfrm>
-          <a:prstGeom prst="rect">
-            <a:avLst/>
-          </a:prstGeom>
-          <a:noFill/>
-          <a:ln/>
-        </p:spPr>
-        <p:txBody>
-          <a:bodyPr wrap="square" lIns="0" tIns="0" rIns="0" bIns="0" rtlCol="0" anchor="ctr"/>
-          <a:lstStyle/>
-          <a:p>
-            <a:pPr indent="0" marL="0">
-              <a:buNone/>
-            </a:pPr>
-            <a:r>
-              <a:rPr lang="en-US" sz="1200" b="1" spc="700" kern="0" dirty="0">
-                <a:solidFill>
-                  <a:schemeClr val="accent1"/>
-                </a:solidFill>
-              </a:rPr>
-              <a:t>ETAPA DE MIAMI</a:t>
-            </a:r>
-            <a:endParaRPr lang="en-US" sz="1200" dirty="0"/>
-          </a:p>
-        </p:txBody>
-      </p:sp>
-      <p:sp>
-        <p:nvSpPr>
-          <p:cNvPr id="4" name="Chamada"/>
-          <p:cNvSpPr txBox="1"/>
-          <p:nvPr/>
-        </p:nvSpPr>
-        <p:spPr>
-          <a:xfrm>
-            <a:off x="640080" y="1783080"/>
-            <a:ext cx="6400800" cy="1097280"/>
-          </a:xfrm>
-          <a:prstGeom prst="rect">
-            <a:avLst/>
-          </a:prstGeom>
-          <a:noFill/>
-          <a:ln/>
-        </p:spPr>
-        <p:txBody>
-          <a:bodyPr wrap="square" lIns="0" tIns="0" rIns="0" bIns="0" rtlCol="0" anchor="ctr"/>
-          <a:lstStyle/>
-          <a:p>
-            <a:pPr indent="0" marL="0">
-              <a:buNone/>
-            </a:pPr>
-            <a:r>
-              <a:rPr lang="en-US" sz="5400" dirty="0">
-                <a:solidFill>
-                  <a:schemeClr val="bg1"/>
+              <a:rPr lang="en-US" sz="2000" spc="300" kern="0" dirty="0">
+                <a:solidFill>
+                  <a:schemeClr val="accent4"/>
                 </a:solidFill>
                 <a:latin typeface="Georgia" pitchFamily="34" charset="0"/>
                 <a:ea typeface="Georgia" pitchFamily="34" charset="-122"/>
                 <a:cs typeface="Georgia" pitchFamily="34" charset="-120"/>
               </a:rPr>
-              <a:t>Garanta sua vaga</a:t>
-            </a:r>
-            <a:endParaRPr lang="en-US" sz="5400" dirty="0"/>
-          </a:p>
-        </p:txBody>
-      </p:sp>
-      <p:sp>
-        <p:nvSpPr>
-          <p:cNvPr id="5" name="Texto final"/>
+              <a:t>Etapa de Miami</a:t>
+            </a:r>
+            <a:endParaRPr lang="en-US" sz="2000" dirty="0"/>
+          </a:p>
+        </p:txBody>
+      </p:sp>
+      <p:sp>
+        <p:nvSpPr>
+          <p:cNvPr id="4" name="Chamada"/>
           <p:cNvSpPr txBox="1"/>
           <p:nvPr/>
         </p:nvSpPr>
         <p:spPr>
           <a:xfrm>
-            <a:off x="640080" y="3017520"/>
-            <a:ext cx="5943600" cy="457200"/>
+            <a:off x="640080" y="1783080"/>
+            <a:ext cx="6400800" cy="1097280"/>
           </a:xfrm>
           <a:prstGeom prst="rect">
             <a:avLst/>
@@ -4702,27 +3990,30 @@
               <a:buNone/>
             </a:pPr>
             <a:r>
-              <a:rPr lang="en-US" sz="1800" dirty="0">
-                <a:solidFill>
-                  <a:schemeClr val="accent4"/>
-                </a:solidFill>
-              </a:rPr>
-              <a:t>Datas, vagas e investimento com a nossa equipe.</a:t>
-            </a:r>
-            <a:endParaRPr lang="en-US" sz="1800" dirty="0"/>
-          </a:p>
-        </p:txBody>
-      </p:sp>
-      <p:sp>
-        <p:nvSpPr>
-          <p:cNvPr id="6" name="Instagram"/>
+              <a:rPr lang="en-US" sz="5400" dirty="0">
+                <a:solidFill>
+                  <a:schemeClr val="bg1"/>
+                </a:solidFill>
+                <a:latin typeface="Georgia" pitchFamily="34" charset="0"/>
+                <a:ea typeface="Georgia" pitchFamily="34" charset="-122"/>
+                <a:cs typeface="Georgia" pitchFamily="34" charset="-120"/>
+              </a:rPr>
+              <a:t>Garanta sua vaga</a:t>
+            </a:r>
+            <a:endParaRPr lang="en-US" sz="5400" dirty="0"/>
+          </a:p>
+        </p:txBody>
+      </p:sp>
+      <p:sp>
+        <p:nvSpPr>
+          <p:cNvPr id="5" name="Data final"/>
           <p:cNvSpPr txBox="1"/>
           <p:nvPr/>
         </p:nvSpPr>
         <p:spPr>
           <a:xfrm>
-            <a:off x="640080" y="4023360"/>
-            <a:ext cx="5486400" cy="457200"/>
+            <a:off x="640080" y="2971800"/>
+            <a:ext cx="5943600" cy="457200"/>
           </a:xfrm>
           <a:prstGeom prst="rect">
             <a:avLst/>
@@ -4738,37 +4029,65 @@
               <a:buNone/>
             </a:pPr>
             <a:r>
-              <a:rPr lang="en-US" sz="1100" spc="500" kern="0" dirty="0">
-                <a:solidFill>
-                  <a:schemeClr val="tx2"/>
-                </a:solidFill>
-              </a:rPr>
-              <a:t>INSTAGRAM  </a:t>
-            </a:r>
+              <a:rPr lang="en-US" sz="2400" dirty="0">
+                <a:solidFill>
+                  <a:schemeClr val="bg1"/>
+                </a:solidFill>
+                <a:latin typeface="Georgia" pitchFamily="34" charset="0"/>
+                <a:ea typeface="Georgia" pitchFamily="34" charset="-122"/>
+                <a:cs typeface="Georgia" pitchFamily="34" charset="-120"/>
+              </a:rPr>
+              <a:t>19, 20 e 21 de maio de 2027</a:t>
+            </a:r>
+            <a:endParaRPr lang="en-US" sz="2400" dirty="0"/>
+          </a:p>
+        </p:txBody>
+      </p:sp>
+      <p:sp>
+        <p:nvSpPr>
+          <p:cNvPr id="6" name="Texto final"/>
+          <p:cNvSpPr txBox="1"/>
+          <p:nvPr/>
+        </p:nvSpPr>
+        <p:spPr>
+          <a:xfrm>
+            <a:off x="640080" y="3520440"/>
+            <a:ext cx="5943600" cy="365760"/>
+          </a:xfrm>
+          <a:prstGeom prst="rect">
+            <a:avLst/>
+          </a:prstGeom>
+          <a:noFill/>
+          <a:ln/>
+        </p:spPr>
+        <p:txBody>
+          <a:bodyPr wrap="square" lIns="0" tIns="0" rIns="0" bIns="0" rtlCol="0" anchor="ctr"/>
+          <a:lstStyle/>
+          <a:p>
             <a:pPr indent="0" marL="0">
               <a:buNone/>
             </a:pPr>
             <a:r>
-              <a:rPr lang="en-US" sz="2000" dirty="0">
-                <a:solidFill>
-                  <a:schemeClr val="bg1"/>
-                </a:solidFill>
-              </a:rPr>
-              <a:t>@dra.rosanaa</a:t>
-            </a:r>
-            <a:endParaRPr lang="en-US" sz="1100" dirty="0"/>
-          </a:p>
-        </p:txBody>
-      </p:sp>
-      <p:sp>
-        <p:nvSpPr>
-          <p:cNvPr id="7" name="WhatsApp"/>
+              <a:rPr lang="en-US" sz="1600" dirty="0">
+                <a:solidFill>
+                  <a:schemeClr val="accent4"/>
+                </a:solidFill>
+              </a:rPr>
+              <a:t>Vagas e investimento com a nossa equipe.</a:t>
+            </a:r>
+            <a:endParaRPr lang="en-US" sz="1600" dirty="0"/>
+          </a:p>
+        </p:txBody>
+      </p:sp>
+      <p:sp>
+        <p:nvSpPr>
+          <p:cNvPr id="7" name="Instagram"/>
           <p:cNvSpPr txBox="1"/>
           <p:nvPr/>
         </p:nvSpPr>
         <p:spPr>
           <a:xfrm>
-            <a:off x="640080" y="4572000"/>
+            <a:off x="640080" y="4251960"/>
             <a:ext cx="5486400" cy="457200"/>
           </a:xfrm>
           <a:prstGeom prst="rect">
@@ -4785,12 +4104,12 @@
               <a:buNone/>
             </a:pPr>
             <a:r>
-              <a:rPr lang="en-US" sz="1100" spc="500" kern="0" dirty="0">
+              <a:rPr lang="en-US" sz="1600" dirty="0">
                 <a:solidFill>
                   <a:schemeClr val="tx2"/>
                 </a:solidFill>
               </a:rPr>
-              <a:t>WHATSAPP  </a:t>
+              <a:t>Instagram   </a:t>
             </a:r>
             <a:pPr indent="0" marL="0">
               <a:buNone/>
@@ -4801,15 +4120,62 @@
                   <a:schemeClr val="bg1"/>
                 </a:solidFill>
               </a:rPr>
+              <a:t>@dra.rosanaa</a:t>
+            </a:r>
+            <a:endParaRPr lang="en-US" sz="1600" dirty="0"/>
+          </a:p>
+        </p:txBody>
+      </p:sp>
+      <p:sp>
+        <p:nvSpPr>
+          <p:cNvPr id="8" name="WhatsApp"/>
+          <p:cNvSpPr txBox="1"/>
+          <p:nvPr/>
+        </p:nvSpPr>
+        <p:spPr>
+          <a:xfrm>
+            <a:off x="640080" y="4754880"/>
+            <a:ext cx="5486400" cy="457200"/>
+          </a:xfrm>
+          <a:prstGeom prst="rect">
+            <a:avLst/>
+          </a:prstGeom>
+          <a:noFill/>
+          <a:ln/>
+        </p:spPr>
+        <p:txBody>
+          <a:bodyPr wrap="square" lIns="0" tIns="0" rIns="0" bIns="0" rtlCol="0" anchor="ctr"/>
+          <a:lstStyle/>
+          <a:p>
+            <a:pPr indent="0" marL="0">
+              <a:buNone/>
+            </a:pPr>
+            <a:r>
+              <a:rPr lang="en-US" sz="1600" dirty="0">
+                <a:solidFill>
+                  <a:schemeClr val="tx2"/>
+                </a:solidFill>
+              </a:rPr>
+              <a:t>WhatsApp   </a:t>
+            </a:r>
+            <a:pPr indent="0" marL="0">
+              <a:buNone/>
+            </a:pPr>
+            <a:r>
+              <a:rPr lang="en-US" sz="2000" dirty="0">
+                <a:solidFill>
+                  <a:schemeClr val="bg1"/>
+                </a:solidFill>
+              </a:rPr>
               <a:t>(00) 00000-0000</a:t>
             </a:r>
-            <a:endParaRPr lang="en-US" sz="1100" dirty="0"/>
+            <a:endParaRPr lang="en-US" sz="1600" dirty="0"/>
           </a:p>
         </p:txBody>
       </p:sp>
       <p:pic>
         <p:nvPicPr>
-          <p:cNvPr id="8" name="Logo" descr="Logo Dra. Rosana Vecchi Caldas">    </p:cNvPr>
+          <p:cNvPr id="9" name="Logo" descr="Logo Dra. Rosana Vecchi Caldas">    </p:cNvPr>
           <p:cNvPicPr>
             <a:picLocks noChangeAspect="1"/>
           </p:cNvPicPr>

</xml_diff>

<commit_message>
Etapa Miami: adiciona WhatsApp e QR code com mensagem pronta
Co-Authored-By: Claude Opus 5.5 <noreply@anthropic.com>
Claude-Session: https://claude.ai/code/session_01ETjDEHo1Y5Ziwi4pumEH8K
</commit_message>
<xml_diff>
--- a/entregas/Formacao-Internacional-Etapa-Miami.pptx
+++ b/entregas/Formacao-Internacional-Etapa-Miami.pptx
@@ -114,26 +114,26 @@
   <p:extLst>
     <p:ext uri="{521415D9-36F7-43E2-AB2F-B90AF26B5E84}">
       <p14:sectionLst xmlns:p14="http://schemas.microsoft.com/office/powerpoint/2010/main">
-        <p14:section name="Abertura" id="{b160e7dc-cd48-cb2c-5a16-905423bd9aa7}">
+        <p14:section name="Abertura" id="{dce1f7f2-441a-7f1b-e3d4-b25c9b60c727}">
           <p14:sldIdLst>
             <p14:sldId id="256"/>
             <p14:sldId id="257"/>
           </p14:sldIdLst>
         </p14:section>
-        <p14:section name="A etapa" id="{76c40604-99ed-093e-03c5-4d20405c16f7}">
+        <p14:section name="A etapa" id="{869cfd57-cc3f-d517-0866-6f4944a5fc2b}">
           <p14:sldIdLst>
             <p14:sldId id="258"/>
             <p14:sldId id="259"/>
             <p14:sldId id="260"/>
           </p14:sldIdLst>
         </p14:section>
-        <p14:section name="Pessoas" id="{e6121930-c77f-6edc-8ca1-16f82258da45}">
+        <p14:section name="Pessoas" id="{e7f9c8c6-1c3f-8412-9752-2baebbf2519d}">
           <p14:sldIdLst>
             <p14:sldId id="261"/>
             <p14:sldId id="262"/>
           </p14:sldIdLst>
         </p14:section>
-        <p14:section name="Inscrição" id="{8261533c-e3db-f8a1-f887-647b99963fd5}">
+        <p14:section name="Inscrição" id="{bc3d8727-f71f-0c97-1897-b44f32604205}">
           <p14:sldIdLst>
             <p14:sldId id="263"/>
           </p14:sldIdLst>
@@ -1158,7 +1158,7 @@
           <a:p>
             <a:r>
               <a:rPr lang="en-US" dirty="0"/>
-              <a:t>Troque o número de WhatsApp pelo número real da equipe.</a:t>
+              <a:t>O QR code e o número abrem o WhatsApp (62) 98515-0061 com a mensagem pronta: Olá, quero saber mais do Programa de Formação Internacional.</a:t>
             </a:r>
             <a:endParaRPr lang="en-US" dirty="0"/>
           </a:p>
@@ -3918,17 +3918,79 @@
         </p:blipFill>
         <p:spPr>
           <a:xfrm>
-            <a:off x="6400800" y="822960"/>
-            <a:ext cx="5760720" cy="3840480"/>
+            <a:off x="9006840" y="228600"/>
+            <a:ext cx="2743200" cy="1828800"/>
           </a:xfrm>
           <a:prstGeom prst="rect">
             <a:avLst/>
           </a:prstGeom>
         </p:spPr>
       </p:pic>
-      <p:sp>
-        <p:nvSpPr>
-          <p:cNvPr id="3" name="Rótulo final"/>
+      <p:pic>
+        <p:nvPicPr>
+          <p:cNvPr id="3" name="QR code WhatsApp" descr="QR code que abre o WhatsApp (62) 98515-0061 com a mensagem: Olá, quero saber mais do Programa de Formação Internacional">
+            <a:hlinkClick r:id="rId3" tooltip="Falar no WhatsApp"/>
+          </p:cNvPr>
+          <p:cNvPicPr>
+            <a:picLocks noChangeAspect="1"/>
+          </p:cNvPicPr>
+          <p:nvPr/>
+        </p:nvPicPr>
+        <p:blipFill>
+          <a:blip r:embed="rId2"/>
+          <a:stretch>
+            <a:fillRect/>
+          </a:stretch>
+        </p:blipFill>
+        <p:spPr>
+          <a:xfrm>
+            <a:off x="8549640" y="2240280"/>
+            <a:ext cx="2743200" cy="2743200"/>
+          </a:xfrm>
+          <a:prstGeom prst="rect">
+            <a:avLst/>
+          </a:prstGeom>
+        </p:spPr>
+      </p:pic>
+      <p:sp>
+        <p:nvSpPr>
+          <p:cNvPr id="4" name="Legenda QR"/>
+          <p:cNvSpPr txBox="1"/>
+          <p:nvPr/>
+        </p:nvSpPr>
+        <p:spPr>
+          <a:xfrm>
+            <a:off x="8549640" y="5120640"/>
+            <a:ext cx="2743200" cy="548640"/>
+          </a:xfrm>
+          <a:prstGeom prst="rect">
+            <a:avLst/>
+          </a:prstGeom>
+          <a:noFill/>
+          <a:ln/>
+        </p:spPr>
+        <p:txBody>
+          <a:bodyPr wrap="square" lIns="0" tIns="0" rIns="0" bIns="0" rtlCol="0" anchor="t"/>
+          <a:lstStyle/>
+          <a:p>
+            <a:pPr algn="ctr" indent="0" marL="0">
+              <a:buNone/>
+            </a:pPr>
+            <a:r>
+              <a:rPr lang="en-US" sz="1200" dirty="0">
+                <a:solidFill>
+                  <a:schemeClr val="accent4"/>
+                </a:solidFill>
+              </a:rPr>
+              <a:t>Aponte a câmera do celular para falar com a equipe no WhatsApp</a:t>
+            </a:r>
+            <a:endParaRPr lang="en-US" sz="1200" dirty="0"/>
+          </a:p>
+        </p:txBody>
+      </p:sp>
+      <p:sp>
+        <p:nvSpPr>
+          <p:cNvPr id="5" name="Rótulo final"/>
           <p:cNvSpPr txBox="1"/>
           <p:nvPr/>
         </p:nvSpPr>
@@ -3967,7 +4029,7 @@
       </p:sp>
       <p:sp>
         <p:nvSpPr>
-          <p:cNvPr id="4" name="Chamada"/>
+          <p:cNvPr id="6" name="Chamada"/>
           <p:cNvSpPr txBox="1"/>
           <p:nvPr/>
         </p:nvSpPr>
@@ -4006,7 +4068,7 @@
       </p:sp>
       <p:sp>
         <p:nvSpPr>
-          <p:cNvPr id="5" name="Data final"/>
+          <p:cNvPr id="7" name="Data final"/>
           <p:cNvSpPr txBox="1"/>
           <p:nvPr/>
         </p:nvSpPr>
@@ -4045,7 +4107,7 @@
       </p:sp>
       <p:sp>
         <p:nvSpPr>
-          <p:cNvPr id="6" name="Texto final"/>
+          <p:cNvPr id="8" name="Texto final"/>
           <p:cNvSpPr txBox="1"/>
           <p:nvPr/>
         </p:nvSpPr>
@@ -4081,7 +4143,7 @@
       </p:sp>
       <p:sp>
         <p:nvSpPr>
-          <p:cNvPr id="7" name="Instagram"/>
+          <p:cNvPr id="9" name="Instagram"/>
           <p:cNvSpPr txBox="1"/>
           <p:nvPr/>
         </p:nvSpPr>
@@ -4128,7 +4190,7 @@
       </p:sp>
       <p:sp>
         <p:nvSpPr>
-          <p:cNvPr id="8" name="WhatsApp"/>
+          <p:cNvPr id="10" name="WhatsApp"/>
           <p:cNvSpPr txBox="1"/>
           <p:nvPr/>
         </p:nvSpPr>
@@ -4162,12 +4224,19 @@
               <a:buNone/>
             </a:pPr>
             <a:r>
-              <a:rPr lang="en-US" sz="2000" dirty="0">
+              <a:rPr lang="en-US" sz="2000" u="sng" dirty="0">
                 <a:solidFill>
                   <a:schemeClr val="bg1"/>
                 </a:solidFill>
-              </a:rPr>
-              <a:t>(00) 00000-0000</a:t>
+                <a:hlinkClick r:id="rId4" invalidUrl="" action="" tgtFrame="" tooltip="Falar no WhatsApp" history="1" highlightClick="0" endSnd="0">
+                  <a:extLst>
+                    <a:ext uri="{A12FA001-AC4F-418D-AE19-62706E023703}">
+                      <ahyp:hlinkClr xmlns:ahyp="http://schemas.microsoft.com/office/drawing/2018/hyperlinkcolor" val="tx"/>
+                    </a:ext>
+                  </a:extLst>
+                </a:hlinkClick>
+              </a:rPr>
+              <a:t>(62) 98515-0061</a:t>
             </a:r>
             <a:endParaRPr lang="en-US" sz="1600" dirty="0"/>
           </a:p>
@@ -4175,14 +4244,14 @@
       </p:sp>
       <p:pic>
         <p:nvPicPr>
-          <p:cNvPr id="9" name="Logo" descr="Logo Dra. Rosana Vecchi Caldas">    </p:cNvPr>
+          <p:cNvPr id="11" name="Logo" descr="Logo Dra. Rosana Vecchi Caldas">    </p:cNvPr>
           <p:cNvPicPr>
             <a:picLocks noChangeAspect="1"/>
           </p:cNvPicPr>
           <p:nvPr/>
         </p:nvPicPr>
         <p:blipFill>
-          <a:blip r:embed="rId2"/>
+          <a:blip r:embed="rId5"/>
           <a:stretch>
             <a:fillRect/>
           </a:stretch>

</xml_diff>

<commit_message>
Etapa Miami: capa igual à do material original
Co-Authored-By: Claude Opus 5.5 <noreply@anthropic.com>
Claude-Session: https://claude.ai/code/session_01ETjDEHo1Y5Ziwi4pumEH8K
</commit_message>
<xml_diff>
--- a/entregas/Formacao-Internacional-Etapa-Miami.pptx
+++ b/entregas/Formacao-Internacional-Etapa-Miami.pptx
@@ -13,9 +13,10 @@
     <p:sldId id="261" r:id="rId7"/>
     <p:sldId id="262" r:id="rId8"/>
     <p:sldId id="263" r:id="rId9"/>
+    <p:sldId id="264" r:id="rId10"/>
   </p:sldIdLst>
   <p:notesMasterIdLst>
-    <p:notesMasterId r:id="rId10"/>
+    <p:notesMasterId r:id="rId11"/>
   </p:notesMasterIdLst>
   <p:sldSz cx="12192000" cy="6858000"/>
   <p:notesSz cx="6858000" cy="12192000"/>
@@ -114,28 +115,29 @@
   <p:extLst>
     <p:ext uri="{521415D9-36F7-43E2-AB2F-B90AF26B5E84}">
       <p14:sectionLst xmlns:p14="http://schemas.microsoft.com/office/powerpoint/2010/main">
-        <p14:section name="Abertura" id="{dce1f7f2-441a-7f1b-e3d4-b25c9b60c727}">
+        <p14:section name="Abertura" id="{4b93c789-8ed5-0905-4585-63de3f987281}">
           <p14:sldIdLst>
             <p14:sldId id="256"/>
             <p14:sldId id="257"/>
+            <p14:sldId id="258"/>
           </p14:sldIdLst>
         </p14:section>
-        <p14:section name="A etapa" id="{869cfd57-cc3f-d517-0866-6f4944a5fc2b}">
+        <p14:section name="A etapa" id="{849ba996-f47f-d457-5e2b-f91978078b64}">
           <p14:sldIdLst>
-            <p14:sldId id="258"/>
             <p14:sldId id="259"/>
             <p14:sldId id="260"/>
+            <p14:sldId id="261"/>
           </p14:sldIdLst>
         </p14:section>
-        <p14:section name="Pessoas" id="{e7f9c8c6-1c3f-8412-9752-2baebbf2519d}">
+        <p14:section name="Pessoas" id="{adc3deab-adc3-d559-1723-f3b2dd93203f}">
           <p14:sldIdLst>
-            <p14:sldId id="261"/>
             <p14:sldId id="262"/>
+            <p14:sldId id="263"/>
           </p14:sldIdLst>
         </p14:section>
-        <p14:section name="Inscrição" id="{bc3d8727-f71f-0c97-1897-b44f32604205}">
+        <p14:section name="Inscrição" id="{6f716db8-faa2-e884-da9c-3f0db4394956}">
           <p14:sldIdLst>
-            <p14:sldId id="263"/>
+            <p14:sldId id="264"/>
           </p14:sldIdLst>
         </p14:section>
       </p14:sectionLst>
@@ -542,7 +544,7 @@
           <a:p>
             <a:r>
               <a:rPr lang="en-US" dirty="0"/>
-              <a:t>Capa. Para abrir com vídeo, insira o vídeo atrás do texto (Inserir &gt; Vídeo) e envie para trás (Organizar &gt; Enviar para trás).</a:t>
+              <a:t>Capa igual à do material original do Programa de Formação Internacional. É uma imagem única: para mudar o texto, edite no Canva e exporte de novo.</a:t>
             </a:r>
             <a:endParaRPr lang="en-US" dirty="0"/>
           </a:p>
@@ -630,7 +632,7 @@
           <a:p>
             <a:r>
               <a:rPr lang="en-US" dirty="0"/>
-              <a:t>Slide reservado para vídeo (laboratório, Miami ou o vídeo 3D das camadas da pele). Depois de inserir: aba Reprodução &gt; Iniciar: Automaticamente. Para vídeo de fundo sem som, marque também 'Repetir até parar' e deixe o volume mudo.</a:t>
+              <a:t>Capa. Para abrir com vídeo, insira o vídeo atrás do texto (Inserir &gt; Vídeo) e envie para trás (Organizar &gt; Enviar para trás).</a:t>
             </a:r>
             <a:endParaRPr lang="en-US" dirty="0"/>
           </a:p>
@@ -718,7 +720,7 @@
           <a:p>
             <a:r>
               <a:rPr lang="en-US" dirty="0"/>
-              <a:t/>
+              <a:t>Slide reservado para vídeo (laboratório, Miami ou o vídeo 3D das camadas da pele). Depois de inserir: aba Reprodução &gt; Iniciar: Automaticamente. Para vídeo de fundo sem som, marque também 'Repetir até parar' e deixe o volume mudo.</a:t>
             </a:r>
             <a:endParaRPr lang="en-US" dirty="0"/>
           </a:p>
@@ -1070,7 +1072,7 @@
           <a:p>
             <a:r>
               <a:rPr lang="en-US" dirty="0"/>
-              <a:t>Confirme que a aluna autorizou o uso do relato antes de divulgar este material fora da turma.</a:t>
+              <a:t/>
             </a:r>
             <a:endParaRPr lang="en-US" dirty="0"/>
           </a:p>
@@ -1158,7 +1160,7 @@
           <a:p>
             <a:r>
               <a:rPr lang="en-US" dirty="0"/>
-              <a:t>O QR code e o número abrem o WhatsApp (62) 98515-0061 com a mensagem pronta: Olá, quero saber mais do Programa de Formação Internacional.</a:t>
+              <a:t>Confirme que a aluna autorizou o uso do relato antes de divulgar este material fora da turma.</a:t>
             </a:r>
             <a:endParaRPr lang="en-US" dirty="0"/>
           </a:p>
@@ -1182,6 +1184,94 @@
             <a:fld id="{F7021451-1387-4CA6-816F-3879F97B5CBC}" type="slidenum">
               <a:rPr lang="en-US"/>
               <a:t>8</a:t>
+            </a:fld>
+            <a:endParaRPr lang="en-US"/>
+          </a:p>
+        </p:txBody>
+      </p:sp>
+    </p:spTree>
+    <p:extLst>
+      <p:ext uri="{BB962C8B-B14F-4D97-AF65-F5344CB8AC3E}">
+        <p14:creationId xmlns:p14="http://schemas.microsoft.com/office/powerpoint/2010/main" val="1024086991"/>
+      </p:ext>
+    </p:extLst>
+  </p:cSld>
+  <p:clrMapOvr>
+    <a:masterClrMapping/>
+  </p:clrMapOvr>
+</p:notes>
+</file>
+
+<file path=ppt/notesSlides/notesSlide9.xml><?xml version="1.0" encoding="utf-8"?>
+<p:notes xmlns:a="http://schemas.openxmlformats.org/drawingml/2006/main" xmlns:r="http://schemas.openxmlformats.org/officeDocument/2006/relationships" xmlns:p="http://schemas.openxmlformats.org/presentationml/2006/main">
+  <p:cSld>
+    <p:spTree>
+      <p:nvGrpSpPr>
+        <p:cNvPr id="1" name=""/>
+        <p:cNvGrpSpPr/>
+        <p:nvPr/>
+      </p:nvGrpSpPr>
+      <p:grpSpPr>
+        <a:xfrm>
+          <a:off x="0" y="0"/>
+          <a:ext cx="0" cy="0"/>
+          <a:chOff x="0" y="0"/>
+          <a:chExt cx="0" cy="0"/>
+        </a:xfrm>
+      </p:grpSpPr>
+      <p:sp>
+        <p:nvSpPr>
+          <p:cNvPr id="2" name="Slide Image Placeholder 1"/>
+          <p:cNvSpPr>
+            <a:spLocks noGrp="1" noRot="1" noChangeAspect="1"/>
+          </p:cNvSpPr>
+          <p:nvPr>
+            <p:ph type="sldImg"/>
+          </p:nvPr>
+        </p:nvSpPr>
+        <p:spPr/>
+      </p:sp>
+      <p:sp>
+        <p:nvSpPr>
+          <p:cNvPr id="3" name="Notes Placeholder 2"/>
+          <p:cNvSpPr>
+            <a:spLocks noGrp="1"/>
+          </p:cNvSpPr>
+          <p:nvPr>
+            <p:ph type="body" idx="1"/>
+          </p:nvPr>
+        </p:nvSpPr>
+        <p:spPr/>
+        <p:txBody>
+          <a:bodyPr/>
+          <a:lstStyle/>
+          <a:p>
+            <a:r>
+              <a:rPr lang="en-US" dirty="0"/>
+              <a:t>O QR code e o número abrem o WhatsApp (62) 98515-0061 com a mensagem pronta: Olá, quero saber mais do Programa de Formação Internacional.</a:t>
+            </a:r>
+            <a:endParaRPr lang="en-US" dirty="0"/>
+          </a:p>
+        </p:txBody>
+      </p:sp>
+      <p:sp>
+        <p:nvSpPr>
+          <p:cNvPr id="4" name="Slide Number Placeholder 3"/>
+          <p:cNvSpPr>
+            <a:spLocks noGrp="1"/>
+          </p:cNvSpPr>
+          <p:nvPr>
+            <p:ph type="sldNum" sz="quarter" idx="10"/>
+          </p:nvPr>
+        </p:nvSpPr>
+        <p:spPr/>
+        <p:txBody>
+          <a:bodyPr/>
+          <a:lstStyle/>
+          <a:p>
+            <a:fld id="{F7021451-1387-4CA6-816F-3879F97B5CBC}" type="slidenum">
+              <a:rPr lang="en-US"/>
+              <a:t>9</a:t>
             </a:fld>
             <a:endParaRPr lang="en-US"/>
           </a:p>
@@ -1735,7 +1825,7 @@
       </p:grpSpPr>
       <p:pic>
         <p:nvPicPr>
-          <p:cNvPr id="2" name="Foto laboratório" descr="Dra. Rosana em laboratório de anatomia, ao lado de uma mesa de specimen">    </p:cNvPr>
+          <p:cNvPr id="2" name="Capa Programa de Formação Internacional" descr="Capa: bandeira dos Estados Unidos à noite diante de um prédio com colunas e o título Programa de Formação Internacional">    </p:cNvPr>
           <p:cNvPicPr>
             <a:picLocks noChangeAspect="1"/>
           </p:cNvPicPr>
@@ -1749,274 +1839,8 @@
         </p:blipFill>
         <p:spPr>
           <a:xfrm>
-            <a:off x="7050024" y="0"/>
-            <a:ext cx="5143500" cy="6858000"/>
-          </a:xfrm>
-          <a:prstGeom prst="rect">
-            <a:avLst/>
-          </a:prstGeom>
-        </p:spPr>
-      </p:pic>
-      <p:sp>
-        <p:nvSpPr>
-          <p:cNvPr id="3" name="Escurecer foto"/>
-          <p:cNvSpPr/>
-          <p:nvPr/>
-        </p:nvSpPr>
-        <p:spPr>
-          <a:xfrm>
-            <a:off x="7050024" y="0"/>
-            <a:ext cx="5143500" cy="6858000"/>
-          </a:xfrm>
-          <a:prstGeom prst="rect">
-            <a:avLst/>
-          </a:prstGeom>
-          <a:solidFill>
-            <a:schemeClr val="tx1">
-              <a:alpha val="20000"/>
-            </a:schemeClr>
-          </a:solidFill>
-          <a:ln w="12700">
-            <a:solidFill>
-              <a:schemeClr val="tx1">
-                <a:alpha val="0"/>
-              </a:schemeClr>
-            </a:solidFill>
-            <a:prstDash val="solid"/>
-          </a:ln>
-        </p:spPr>
-      </p:sp>
-      <p:pic>
-        <p:nvPicPr>
-          <p:cNvPr id="4" name="Bandeira" descr="Bandeira dos Estados Unidos tremulando">    </p:cNvPr>
-          <p:cNvPicPr>
-            <a:picLocks noChangeAspect="1"/>
-          </p:cNvPicPr>
-          <p:nvPr/>
-        </p:nvPicPr>
-        <p:blipFill>
-          <a:blip r:embed="rId2"/>
-          <a:stretch>
-            <a:fillRect/>
-          </a:stretch>
-        </p:blipFill>
-        <p:spPr>
-          <a:xfrm>
-            <a:off x="5852160" y="91440"/>
-            <a:ext cx="3108960" cy="2075688"/>
-          </a:xfrm>
-          <a:prstGeom prst="rect">
-            <a:avLst/>
-          </a:prstGeom>
-        </p:spPr>
-      </p:pic>
-      <p:sp>
-        <p:nvSpPr>
-          <p:cNvPr id="5" name="Programa"/>
-          <p:cNvSpPr txBox="1"/>
-          <p:nvPr/>
-        </p:nvSpPr>
-        <p:spPr>
-          <a:xfrm>
-            <a:off x="640080" y="1417320"/>
-            <a:ext cx="5120640" cy="274320"/>
-          </a:xfrm>
-          <a:prstGeom prst="rect">
-            <a:avLst/>
-          </a:prstGeom>
-          <a:noFill/>
-          <a:ln/>
-        </p:spPr>
-        <p:txBody>
-          <a:bodyPr wrap="square" lIns="0" tIns="0" rIns="0" bIns="0" rtlCol="0" anchor="ctr"/>
-          <a:lstStyle/>
-          <a:p>
-            <a:pPr indent="0" marL="0">
-              <a:buNone/>
-            </a:pPr>
-            <a:r>
-              <a:rPr lang="en-US" sz="1200" spc="300" kern="0" dirty="0">
-                <a:solidFill>
-                  <a:schemeClr val="accent4"/>
-                </a:solidFill>
-              </a:rPr>
-              <a:t>PROGRAMA DE FORMAÇÃO INTERNACIONAL</a:t>
-            </a:r>
-            <a:endParaRPr lang="en-US" sz="1200" dirty="0"/>
-          </a:p>
-        </p:txBody>
-      </p:sp>
-      <p:sp>
-        <p:nvSpPr>
-          <p:cNvPr id="6" name="Etapa de"/>
-          <p:cNvSpPr txBox="1"/>
-          <p:nvPr/>
-        </p:nvSpPr>
-        <p:spPr>
-          <a:xfrm>
-            <a:off x="640080" y="2148840"/>
-            <a:ext cx="4572000" cy="548640"/>
-          </a:xfrm>
-          <a:prstGeom prst="rect">
-            <a:avLst/>
-          </a:prstGeom>
-          <a:noFill/>
-          <a:ln/>
-        </p:spPr>
-        <p:txBody>
-          <a:bodyPr wrap="square" lIns="0" tIns="0" rIns="0" bIns="0" rtlCol="0" anchor="ctr"/>
-          <a:lstStyle/>
-          <a:p>
-            <a:pPr indent="0" marL="0">
-              <a:buNone/>
-            </a:pPr>
-            <a:r>
-              <a:rPr lang="en-US" sz="2800" spc="600" kern="0" dirty="0">
-                <a:solidFill>
-                  <a:schemeClr val="accent6"/>
-                </a:solidFill>
-                <a:latin typeface="Georgia" pitchFamily="34" charset="0"/>
-                <a:ea typeface="Georgia" pitchFamily="34" charset="-122"/>
-                <a:cs typeface="Georgia" pitchFamily="34" charset="-120"/>
-              </a:rPr>
-              <a:t>Etapa de</a:t>
-            </a:r>
-            <a:endParaRPr lang="en-US" sz="2800" dirty="0"/>
-          </a:p>
-        </p:txBody>
-      </p:sp>
-      <p:sp>
-        <p:nvSpPr>
-          <p:cNvPr id="7" name="Título da capa"/>
-          <p:cNvSpPr txBox="1"/>
-          <p:nvPr/>
-        </p:nvSpPr>
-        <p:spPr>
-          <a:xfrm>
-            <a:off x="548640" y="2651760"/>
-            <a:ext cx="6583680" cy="1463040"/>
-          </a:xfrm>
-          <a:prstGeom prst="rect">
-            <a:avLst/>
-          </a:prstGeom>
-          <a:noFill/>
-          <a:ln/>
-        </p:spPr>
-        <p:txBody>
-          <a:bodyPr wrap="square" lIns="0" tIns="0" rIns="0" bIns="0" rtlCol="0" anchor="ctr"/>
-          <a:lstStyle/>
-          <a:p>
-            <a:pPr indent="0" marL="0">
-              <a:buNone/>
-            </a:pPr>
-            <a:r>
-              <a:rPr lang="en-US" sz="11000" spc="600" kern="0" dirty="0">
-                <a:solidFill>
-                  <a:schemeClr val="bg1"/>
-                </a:solidFill>
-                <a:latin typeface="Georgia" pitchFamily="34" charset="0"/>
-                <a:ea typeface="Georgia" pitchFamily="34" charset="-122"/>
-                <a:cs typeface="Georgia" pitchFamily="34" charset="-120"/>
-              </a:rPr>
-              <a:t>MIAMI</a:t>
-            </a:r>
-            <a:endParaRPr lang="en-US" sz="11000" dirty="0"/>
-          </a:p>
-        </p:txBody>
-      </p:sp>
-      <p:sp>
-        <p:nvSpPr>
-          <p:cNvPr id="8" name="Subtítulo"/>
-          <p:cNvSpPr txBox="1"/>
-          <p:nvPr/>
-        </p:nvSpPr>
-        <p:spPr>
-          <a:xfrm>
-            <a:off x="640080" y="4160520"/>
-            <a:ext cx="5120640" cy="822960"/>
-          </a:xfrm>
-          <a:prstGeom prst="rect">
-            <a:avLst/>
-          </a:prstGeom>
-          <a:noFill/>
-          <a:ln/>
-        </p:spPr>
-        <p:txBody>
-          <a:bodyPr wrap="square" lIns="0" tIns="0" rIns="0" bIns="0" rtlCol="0" anchor="t"/>
-          <a:lstStyle/>
-          <a:p>
-            <a:pPr indent="0" marL="0">
-              <a:buNone/>
-            </a:pPr>
-            <a:r>
-              <a:rPr lang="en-US" sz="1800" dirty="0">
-                <a:solidFill>
-                  <a:schemeClr val="accent4"/>
-                </a:solidFill>
-              </a:rPr>
-              <a:t>Imersão de 3 dias com prática real em laboratório de specimen</a:t>
-            </a:r>
-            <a:endParaRPr lang="en-US" sz="1800" dirty="0"/>
-          </a:p>
-        </p:txBody>
-      </p:sp>
-      <p:sp>
-        <p:nvSpPr>
-          <p:cNvPr id="9" name="Data"/>
-          <p:cNvSpPr txBox="1"/>
-          <p:nvPr/>
-        </p:nvSpPr>
-        <p:spPr>
-          <a:xfrm>
-            <a:off x="640080" y="4937760"/>
-            <a:ext cx="5943600" cy="411480"/>
-          </a:xfrm>
-          <a:prstGeom prst="rect">
-            <a:avLst/>
-          </a:prstGeom>
-          <a:noFill/>
-          <a:ln/>
-        </p:spPr>
-        <p:txBody>
-          <a:bodyPr wrap="square" lIns="0" tIns="0" rIns="0" bIns="0" rtlCol="0" anchor="ctr"/>
-          <a:lstStyle/>
-          <a:p>
-            <a:pPr indent="0" marL="0">
-              <a:buNone/>
-            </a:pPr>
-            <a:r>
-              <a:rPr lang="en-US" sz="2000" dirty="0">
-                <a:solidFill>
-                  <a:schemeClr val="bg1"/>
-                </a:solidFill>
-                <a:latin typeface="Georgia" pitchFamily="34" charset="0"/>
-                <a:ea typeface="Georgia" pitchFamily="34" charset="-122"/>
-                <a:cs typeface="Georgia" pitchFamily="34" charset="-120"/>
-              </a:rPr>
-              <a:t>19, 20 e 21 de maio de 2027</a:t>
-            </a:r>
-            <a:endParaRPr lang="en-US" sz="2000" dirty="0"/>
-          </a:p>
-        </p:txBody>
-      </p:sp>
-      <p:pic>
-        <p:nvPicPr>
-          <p:cNvPr id="10" name="Logo" descr="Logo Dra. Rosana Vecchi Caldas">    </p:cNvPr>
-          <p:cNvPicPr>
-            <a:picLocks noChangeAspect="1"/>
-          </p:cNvPicPr>
-          <p:nvPr/>
-        </p:nvPicPr>
-        <p:blipFill>
-          <a:blip r:embed="rId3"/>
-          <a:stretch>
-            <a:fillRect/>
-          </a:stretch>
-        </p:blipFill>
-        <p:spPr>
-          <a:xfrm>
-            <a:off x="548640" y="5486400"/>
-            <a:ext cx="1051560" cy="1051560"/>
+            <a:off x="0" y="0"/>
+            <a:ext cx="12191695" cy="6858000"/>
           </a:xfrm>
           <a:prstGeom prst="rect">
             <a:avLst/>
@@ -2051,41 +1875,93 @@
           <a:chExt cx="0" cy="0"/>
         </a:xfrm>
       </p:grpSpPr>
-      <p:sp>
-        <p:nvSpPr>
-          <p:cNvPr id="2" name="Área do vídeo"/>
+      <p:pic>
+        <p:nvPicPr>
+          <p:cNvPr id="2" name="Foto laboratório" descr="Dra. Rosana em laboratório de anatomia, ao lado de uma mesa de specimen">    </p:cNvPr>
+          <p:cNvPicPr>
+            <a:picLocks noChangeAspect="1"/>
+          </p:cNvPicPr>
+          <p:nvPr/>
+        </p:nvPicPr>
+        <p:blipFill>
+          <a:blip r:embed="rId1"/>
+          <a:stretch>
+            <a:fillRect/>
+          </a:stretch>
+        </p:blipFill>
+        <p:spPr>
+          <a:xfrm>
+            <a:off x="7050024" y="0"/>
+            <a:ext cx="5143500" cy="6858000"/>
+          </a:xfrm>
+          <a:prstGeom prst="rect">
+            <a:avLst/>
+          </a:prstGeom>
+        </p:spPr>
+      </p:pic>
+      <p:sp>
+        <p:nvSpPr>
+          <p:cNvPr id="3" name="Escurecer foto"/>
           <p:cNvSpPr/>
           <p:nvPr/>
         </p:nvSpPr>
         <p:spPr>
           <a:xfrm>
-            <a:off x="640080" y="548640"/>
-            <a:ext cx="10908792" cy="5760720"/>
+            <a:off x="7050024" y="0"/>
+            <a:ext cx="5143500" cy="6858000"/>
           </a:xfrm>
           <a:prstGeom prst="rect">
             <a:avLst/>
           </a:prstGeom>
           <a:solidFill>
-            <a:schemeClr val="accent3"/>
+            <a:schemeClr val="tx1">
+              <a:alpha val="20000"/>
+            </a:schemeClr>
           </a:solidFill>
           <a:ln w="12700">
             <a:solidFill>
-              <a:schemeClr val="accent1"/>
+              <a:schemeClr val="tx1">
+                <a:alpha val="0"/>
+              </a:schemeClr>
             </a:solidFill>
-            <a:prstDash val="dash"/>
+            <a:prstDash val="solid"/>
           </a:ln>
         </p:spPr>
       </p:sp>
-      <p:sp>
-        <p:nvSpPr>
-          <p:cNvPr id="3" name="Instrução do vídeo"/>
+      <p:pic>
+        <p:nvPicPr>
+          <p:cNvPr id="4" name="Bandeira" descr="Bandeira dos Estados Unidos tremulando">    </p:cNvPr>
+          <p:cNvPicPr>
+            <a:picLocks noChangeAspect="1"/>
+          </p:cNvPicPr>
+          <p:nvPr/>
+        </p:nvPicPr>
+        <p:blipFill>
+          <a:blip r:embed="rId2"/>
+          <a:stretch>
+            <a:fillRect/>
+          </a:stretch>
+        </p:blipFill>
+        <p:spPr>
+          <a:xfrm>
+            <a:off x="5852160" y="91440"/>
+            <a:ext cx="3108960" cy="2075688"/>
+          </a:xfrm>
+          <a:prstGeom prst="rect">
+            <a:avLst/>
+          </a:prstGeom>
+        </p:spPr>
+      </p:pic>
+      <p:sp>
+        <p:nvSpPr>
+          <p:cNvPr id="5" name="Programa"/>
           <p:cNvSpPr txBox="1"/>
           <p:nvPr/>
         </p:nvSpPr>
         <p:spPr>
           <a:xfrm>
-            <a:off x="640080" y="548640"/>
-            <a:ext cx="10908792" cy="5760720"/>
+            <a:off x="640080" y="1417320"/>
+            <a:ext cx="5120640" cy="274320"/>
           </a:xfrm>
           <a:prstGeom prst="rect">
             <a:avLst/>
@@ -2097,38 +1973,198 @@
           <a:bodyPr wrap="square" lIns="0" tIns="0" rIns="0" bIns="0" rtlCol="0" anchor="ctr"/>
           <a:lstStyle/>
           <a:p>
-            <a:pPr algn="ctr" indent="0" marL="0">
+            <a:pPr indent="0" marL="0">
               <a:buNone/>
             </a:pPr>
             <a:r>
-              <a:rPr lang="en-US" sz="3000" dirty="0">
-                <a:solidFill>
-                  <a:schemeClr val="bg1"/>
+              <a:rPr lang="en-US" sz="1200" spc="300" kern="0" dirty="0">
+                <a:solidFill>
+                  <a:schemeClr val="accent4"/>
+                </a:solidFill>
+              </a:rPr>
+              <a:t>PROGRAMA DE FORMAÇÃO INTERNACIONAL</a:t>
+            </a:r>
+            <a:endParaRPr lang="en-US" sz="1200" dirty="0"/>
+          </a:p>
+        </p:txBody>
+      </p:sp>
+      <p:sp>
+        <p:nvSpPr>
+          <p:cNvPr id="6" name="Etapa de"/>
+          <p:cNvSpPr txBox="1"/>
+          <p:nvPr/>
+        </p:nvSpPr>
+        <p:spPr>
+          <a:xfrm>
+            <a:off x="640080" y="2148840"/>
+            <a:ext cx="4572000" cy="548640"/>
+          </a:xfrm>
+          <a:prstGeom prst="rect">
+            <a:avLst/>
+          </a:prstGeom>
+          <a:noFill/>
+          <a:ln/>
+        </p:spPr>
+        <p:txBody>
+          <a:bodyPr wrap="square" lIns="0" tIns="0" rIns="0" bIns="0" rtlCol="0" anchor="ctr"/>
+          <a:lstStyle/>
+          <a:p>
+            <a:pPr indent="0" marL="0">
+              <a:buNone/>
+            </a:pPr>
+            <a:r>
+              <a:rPr lang="en-US" sz="2800" spc="600" kern="0" dirty="0">
+                <a:solidFill>
+                  <a:schemeClr val="accent6"/>
                 </a:solidFill>
                 <a:latin typeface="Georgia" pitchFamily="34" charset="0"/>
                 <a:ea typeface="Georgia" pitchFamily="34" charset="-122"/>
                 <a:cs typeface="Georgia" pitchFamily="34" charset="-120"/>
               </a:rPr>
-              <a:t>Insira aqui o vídeo</a:t>
-            </a:r>
-            <a:endParaRPr lang="en-US" sz="3000" dirty="0"/>
-          </a:p>
-          <a:p>
-            <a:pPr algn="ctr" indent="0" marL="0">
+              <a:t>Etapa de</a:t>
+            </a:r>
+            <a:endParaRPr lang="en-US" sz="2800" dirty="0"/>
+          </a:p>
+        </p:txBody>
+      </p:sp>
+      <p:sp>
+        <p:nvSpPr>
+          <p:cNvPr id="7" name="Título da capa"/>
+          <p:cNvSpPr txBox="1"/>
+          <p:nvPr/>
+        </p:nvSpPr>
+        <p:spPr>
+          <a:xfrm>
+            <a:off x="548640" y="2651760"/>
+            <a:ext cx="6583680" cy="1463040"/>
+          </a:xfrm>
+          <a:prstGeom prst="rect">
+            <a:avLst/>
+          </a:prstGeom>
+          <a:noFill/>
+          <a:ln/>
+        </p:spPr>
+        <p:txBody>
+          <a:bodyPr wrap="square" lIns="0" tIns="0" rIns="0" bIns="0" rtlCol="0" anchor="ctr"/>
+          <a:lstStyle/>
+          <a:p>
+            <a:pPr indent="0" marL="0">
               <a:buNone/>
             </a:pPr>
             <a:r>
-              <a:rPr lang="en-US" sz="1500" dirty="0">
+              <a:rPr lang="en-US" sz="11000" spc="600" kern="0" dirty="0">
+                <a:solidFill>
+                  <a:schemeClr val="bg1"/>
+                </a:solidFill>
+                <a:latin typeface="Georgia" pitchFamily="34" charset="0"/>
+                <a:ea typeface="Georgia" pitchFamily="34" charset="-122"/>
+                <a:cs typeface="Georgia" pitchFamily="34" charset="-120"/>
+              </a:rPr>
+              <a:t>MIAMI</a:t>
+            </a:r>
+            <a:endParaRPr lang="en-US" sz="11000" dirty="0"/>
+          </a:p>
+        </p:txBody>
+      </p:sp>
+      <p:sp>
+        <p:nvSpPr>
+          <p:cNvPr id="8" name="Subtítulo"/>
+          <p:cNvSpPr txBox="1"/>
+          <p:nvPr/>
+        </p:nvSpPr>
+        <p:spPr>
+          <a:xfrm>
+            <a:off x="640080" y="4160520"/>
+            <a:ext cx="5120640" cy="822960"/>
+          </a:xfrm>
+          <a:prstGeom prst="rect">
+            <a:avLst/>
+          </a:prstGeom>
+          <a:noFill/>
+          <a:ln/>
+        </p:spPr>
+        <p:txBody>
+          <a:bodyPr wrap="square" lIns="0" tIns="0" rIns="0" bIns="0" rtlCol="0" anchor="t"/>
+          <a:lstStyle/>
+          <a:p>
+            <a:pPr indent="0" marL="0">
+              <a:buNone/>
+            </a:pPr>
+            <a:r>
+              <a:rPr lang="en-US" sz="1800" dirty="0">
                 <a:solidFill>
                   <a:schemeClr val="accent4"/>
                 </a:solidFill>
               </a:rPr>
-              <a:t>Inserir  ›  Vídeo  ›  Este dispositivo. Depois apague esta caixa e o retângulo.</a:t>
-            </a:r>
-            <a:endParaRPr lang="en-US" sz="3000" dirty="0"/>
-          </a:p>
-        </p:txBody>
-      </p:sp>
+              <a:t>Imersão de 3 dias com prática real em laboratório de specimen</a:t>
+            </a:r>
+            <a:endParaRPr lang="en-US" sz="1800" dirty="0"/>
+          </a:p>
+        </p:txBody>
+      </p:sp>
+      <p:sp>
+        <p:nvSpPr>
+          <p:cNvPr id="9" name="Data"/>
+          <p:cNvSpPr txBox="1"/>
+          <p:nvPr/>
+        </p:nvSpPr>
+        <p:spPr>
+          <a:xfrm>
+            <a:off x="640080" y="4937760"/>
+            <a:ext cx="5943600" cy="411480"/>
+          </a:xfrm>
+          <a:prstGeom prst="rect">
+            <a:avLst/>
+          </a:prstGeom>
+          <a:noFill/>
+          <a:ln/>
+        </p:spPr>
+        <p:txBody>
+          <a:bodyPr wrap="square" lIns="0" tIns="0" rIns="0" bIns="0" rtlCol="0" anchor="ctr"/>
+          <a:lstStyle/>
+          <a:p>
+            <a:pPr indent="0" marL="0">
+              <a:buNone/>
+            </a:pPr>
+            <a:r>
+              <a:rPr lang="en-US" sz="2000" dirty="0">
+                <a:solidFill>
+                  <a:schemeClr val="bg1"/>
+                </a:solidFill>
+                <a:latin typeface="Georgia" pitchFamily="34" charset="0"/>
+                <a:ea typeface="Georgia" pitchFamily="34" charset="-122"/>
+                <a:cs typeface="Georgia" pitchFamily="34" charset="-120"/>
+              </a:rPr>
+              <a:t>19, 20 e 21 de maio de 2027</a:t>
+            </a:r>
+            <a:endParaRPr lang="en-US" sz="2000" dirty="0"/>
+          </a:p>
+        </p:txBody>
+      </p:sp>
+      <p:pic>
+        <p:nvPicPr>
+          <p:cNvPr id="10" name="Logo" descr="Logo Dra. Rosana Vecchi Caldas">    </p:cNvPr>
+          <p:cNvPicPr>
+            <a:picLocks noChangeAspect="1"/>
+          </p:cNvPicPr>
+          <p:nvPr/>
+        </p:nvPicPr>
+        <p:blipFill>
+          <a:blip r:embed="rId3"/>
+          <a:stretch>
+            <a:fillRect/>
+          </a:stretch>
+        </p:blipFill>
+        <p:spPr>
+          <a:xfrm>
+            <a:off x="548640" y="5486400"/>
+            <a:ext cx="1051560" cy="1051560"/>
+          </a:xfrm>
+          <a:prstGeom prst="rect">
+            <a:avLst/>
+          </a:prstGeom>
+        </p:spPr>
+      </p:pic>
     </p:spTree>
   </p:cSld>
   <p:clrMapOvr>
@@ -2157,42 +2193,41 @@
           <a:chExt cx="0" cy="0"/>
         </a:xfrm>
       </p:grpSpPr>
-      <p:pic>
-        <p:nvPicPr>
-          <p:cNvPr id="2" name="Foto Miami" descr="Prédios de Miami vistos da rua">    </p:cNvPr>
-          <p:cNvPicPr>
-            <a:picLocks noChangeAspect="1"/>
-          </p:cNvPicPr>
-          <p:nvPr/>
-        </p:nvPicPr>
-        <p:blipFill>
-          <a:blip r:embed="rId1"/>
-          <a:stretch>
-            <a:fillRect/>
-          </a:stretch>
-        </p:blipFill>
-        <p:spPr>
-          <a:xfrm>
-            <a:off x="7050024" y="0"/>
-            <a:ext cx="5143500" cy="6858000"/>
-          </a:xfrm>
-          <a:prstGeom prst="rect">
-            <a:avLst/>
-          </a:prstGeom>
-        </p:spPr>
-      </p:pic>
-      <p:sp>
-        <p:nvSpPr>
-          <p:cNvPr id="3" name="Text 0"/>
+      <p:sp>
+        <p:nvSpPr>
+          <p:cNvPr id="2" name="Área do vídeo"/>
           <p:cNvSpPr/>
-          <p:nvPr>
-            <p:ph idx="100" type="title" hasCustomPrompt="1"/>
-          </p:nvPr>
-        </p:nvSpPr>
-        <p:spPr>
-          <a:xfrm>
-            <a:off x="640080" y="868680"/>
-            <a:ext cx="10881360" cy="822960"/>
+          <p:nvPr/>
+        </p:nvSpPr>
+        <p:spPr>
+          <a:xfrm>
+            <a:off x="640080" y="548640"/>
+            <a:ext cx="10908792" cy="5760720"/>
+          </a:xfrm>
+          <a:prstGeom prst="rect">
+            <a:avLst/>
+          </a:prstGeom>
+          <a:solidFill>
+            <a:schemeClr val="accent3"/>
+          </a:solidFill>
+          <a:ln w="12700">
+            <a:solidFill>
+              <a:schemeClr val="accent1"/>
+            </a:solidFill>
+            <a:prstDash val="dash"/>
+          </a:ln>
+        </p:spPr>
+      </p:sp>
+      <p:sp>
+        <p:nvSpPr>
+          <p:cNvPr id="3" name="Instrução do vídeo"/>
+          <p:cNvSpPr txBox="1"/>
+          <p:nvPr/>
+        </p:nvSpPr>
+        <p:spPr>
+          <a:xfrm>
+            <a:off x="640080" y="548640"/>
+            <a:ext cx="10908792" cy="5760720"/>
           </a:xfrm>
           <a:prstGeom prst="rect">
             <a:avLst/>
@@ -2201,14 +2236,14 @@
           <a:ln/>
         </p:spPr>
         <p:txBody>
-          <a:bodyPr wrap="square" lIns="0" tIns="0" rIns="0" bIns="0" rtlCol="0" anchor="t"/>
-          <a:lstStyle/>
-          <a:p>
-            <a:pPr algn="l" indent="0" marL="0">
+          <a:bodyPr wrap="square" lIns="0" tIns="0" rIns="0" bIns="0" rtlCol="0" anchor="ctr"/>
+          <a:lstStyle/>
+          <a:p>
+            <a:pPr algn="ctr" indent="0" marL="0">
               <a:buNone/>
             </a:pPr>
             <a:r>
-              <a:rPr lang="en-US" sz="3200" spc="200" kern="0" dirty="0">
+              <a:rPr lang="en-US" sz="3000" dirty="0">
                 <a:solidFill>
                   <a:schemeClr val="bg1"/>
                 </a:solidFill>
@@ -2216,205 +2251,23 @@
                 <a:ea typeface="Georgia" pitchFamily="34" charset="-122"/>
                 <a:cs typeface="Georgia" pitchFamily="34" charset="-120"/>
               </a:rPr>
-              <a:t>POR QUE MIAMI?</a:t>
-            </a:r>
-            <a:endParaRPr lang="en-US" sz="3200" dirty="0"/>
-          </a:p>
-        </p:txBody>
-      </p:sp>
-      <p:sp>
-        <p:nvSpPr>
-          <p:cNvPr id="4" name="Texto Miami"/>
-          <p:cNvSpPr txBox="1"/>
-          <p:nvPr/>
-        </p:nvSpPr>
-        <p:spPr>
-          <a:xfrm>
-            <a:off x="640080" y="1920240"/>
-            <a:ext cx="5760720" cy="1371600"/>
-          </a:xfrm>
-          <a:prstGeom prst="rect">
-            <a:avLst/>
-          </a:prstGeom>
-          <a:noFill/>
-          <a:ln/>
-        </p:spPr>
-        <p:txBody>
-          <a:bodyPr wrap="square" lIns="0" tIns="0" rIns="0" bIns="0" rtlCol="0" anchor="t"/>
-          <a:lstStyle/>
-          <a:p>
-            <a:pPr indent="0" marL="0">
+              <a:t>Insira aqui o vídeo</a:t>
+            </a:r>
+            <a:endParaRPr lang="en-US" sz="3000" dirty="0"/>
+          </a:p>
+          <a:p>
+            <a:pPr algn="ctr" indent="0" marL="0">
               <a:buNone/>
             </a:pPr>
             <a:r>
-              <a:rPr lang="en-US" sz="1700" dirty="0">
+              <a:rPr lang="en-US" sz="1500" dirty="0">
                 <a:solidFill>
                   <a:schemeClr val="accent4"/>
                 </a:solidFill>
               </a:rPr>
-              <a:t>Nos Estados Unidos, laboratórios privados de anatomia oferecem estrutura para treinamento hands-on em specimen, a peça anatômica real. Em Miami, o conteúdo científico vira prática.</a:t>
-            </a:r>
-            <a:endParaRPr lang="en-US" sz="1700" dirty="0"/>
-          </a:p>
-        </p:txBody>
-      </p:sp>
-      <p:sp>
-        <p:nvSpPr>
-          <p:cNvPr id="5" name="Lista Miami"/>
-          <p:cNvSpPr txBox="1"/>
-          <p:nvPr/>
-        </p:nvSpPr>
-        <p:spPr>
-          <a:xfrm>
-            <a:off x="640080" y="3520440"/>
-            <a:ext cx="5760720" cy="1463040"/>
-          </a:xfrm>
-          <a:prstGeom prst="rect">
-            <a:avLst/>
-          </a:prstGeom>
-          <a:noFill/>
-          <a:ln/>
-        </p:spPr>
-        <p:txBody>
-          <a:bodyPr wrap="square" lIns="0" tIns="0" rIns="0" bIns="0" rtlCol="0" anchor="t"/>
-          <a:lstStyle/>
-          <a:p>
-            <a:pPr marL="342900" indent="-342900">
-              <a:spcAft>
-                <a:spcPts val="1000"/>
-              </a:spcAft>
-              <a:buSzPct val="100000"/>
-              <a:buChar char="•"/>
-            </a:pPr>
-            <a:r>
-              <a:rPr lang="en-US" sz="1700" dirty="0">
-                <a:solidFill>
-                  <a:schemeClr val="bg1"/>
-                </a:solidFill>
-              </a:rPr>
-              <a:t>Imersão de 3 dias com prática real</a:t>
-            </a:r>
-            <a:endParaRPr lang="en-US" sz="1700" dirty="0"/>
-          </a:p>
-          <a:p>
-            <a:pPr marL="342900" indent="-342900">
-              <a:spcAft>
-                <a:spcPts val="1000"/>
-              </a:spcAft>
-              <a:buSzPct val="100000"/>
-              <a:buChar char="•"/>
-            </a:pPr>
-            <a:r>
-              <a:rPr lang="en-US" sz="1700" dirty="0">
-                <a:solidFill>
-                  <a:schemeClr val="bg1"/>
-                </a:solidFill>
-              </a:rPr>
-              <a:t>Laboratórios privados preparados para hands-on avançado</a:t>
-            </a:r>
-            <a:endParaRPr lang="en-US" sz="1700" dirty="0"/>
-          </a:p>
-          <a:p>
-            <a:pPr marL="342900" indent="-342900">
-              <a:spcAft>
-                <a:spcPts val="1000"/>
-              </a:spcAft>
-              <a:buSzPct val="100000"/>
-              <a:buChar char="•"/>
-            </a:pPr>
-            <a:r>
-              <a:rPr lang="en-US" sz="1700" dirty="0">
-                <a:solidFill>
-                  <a:schemeClr val="bg1"/>
-                </a:solidFill>
-              </a:rPr>
-              <a:t>Anatomia aplicada direto na peça anatômica</a:t>
-            </a:r>
-            <a:endParaRPr lang="en-US" sz="1700" dirty="0"/>
-          </a:p>
-        </p:txBody>
-      </p:sp>
-      <p:sp>
-        <p:nvSpPr>
-          <p:cNvPr id="6" name="Data"/>
-          <p:cNvSpPr txBox="1"/>
-          <p:nvPr/>
-        </p:nvSpPr>
-        <p:spPr>
-          <a:xfrm>
-            <a:off x="640080" y="5349240"/>
-            <a:ext cx="5760720" cy="411480"/>
-          </a:xfrm>
-          <a:prstGeom prst="rect">
-            <a:avLst/>
-          </a:prstGeom>
-          <a:noFill/>
-          <a:ln/>
-        </p:spPr>
-        <p:txBody>
-          <a:bodyPr wrap="square" lIns="0" tIns="0" rIns="0" bIns="0" rtlCol="0" anchor="ctr"/>
-          <a:lstStyle/>
-          <a:p>
-            <a:pPr indent="0" marL="0">
-              <a:buNone/>
-            </a:pPr>
-            <a:r>
-              <a:rPr lang="en-US" sz="2000" dirty="0">
-                <a:solidFill>
-                  <a:schemeClr val="bg1"/>
-                </a:solidFill>
-                <a:latin typeface="Georgia" pitchFamily="34" charset="0"/>
-                <a:ea typeface="Georgia" pitchFamily="34" charset="-122"/>
-                <a:cs typeface="Georgia" pitchFamily="34" charset="-120"/>
-              </a:rPr>
-              <a:t>19, 20 e 21 de maio de 2027</a:t>
-            </a:r>
-            <a:endParaRPr lang="en-US" sz="2000" dirty="0"/>
-          </a:p>
-        </p:txBody>
-      </p:sp>
-      <p:sp>
-        <p:nvSpPr>
-          <p:cNvPr id="25" name="Slide Number Placeholder 0"/>
-          <p:cNvSpPr>
-            <a:spLocks noGrp="1"/>
-          </p:cNvSpPr>
-          <p:nvPr>
-            <p:ph type="sldNum" sz="quarter" idx="4294967295"/>
-          </p:nvPr>
-        </p:nvSpPr>
-        <p:spPr>
-          <a:xfrm>
-            <a:off x="11155680" y="6355080"/>
-            <a:ext cx="411480" cy="274320"/>
-          </a:xfrm>
-          <a:prstGeom prst="rect">
-            <a:avLst/>
-          </a:prstGeom>
-          <a:extLst>
-            <a:ext uri="{C572A759-6A51-4108-AA02-DFA0A04FC94B}">
-              <ma14:wrappingTextBoxFlag xmlns:ma14="http://schemas.microsoft.com/office/mac/drawingml/2011/main" val="0"/>
-            </a:ext>
-          </a:extLst>
-        </p:spPr>
-        <p:txBody>
-          <a:bodyPr/>
-          <a:lstStyle>
-            <a:lvl1pPr>
-              <a:defRPr sz="900">
-                <a:solidFill>
-                  <a:schemeClr val="tx2"/>
-                </a:solidFill>
-              </a:defRPr>
-            </a:lvl1pPr>
-          </a:lstStyle>
-          <a:p>
-            <a:pPr algn="r"/>
-            <a:fld id="{F7021451-1387-4CA6-816F-3879F97B5CBC}" type="slidenum">
-              <a:rPr b="0" lang="en-US"/>
-              <a:t>3</a:t>
-            </a:fld>
-            <a:endParaRPr lang="en-US"/>
+              <a:t>Inserir  ›  Vídeo  ›  Este dispositivo. Depois apague esta caixa e o retângulo.</a:t>
+            </a:r>
+            <a:endParaRPr lang="en-US" sz="3000" dirty="0"/>
           </a:p>
         </p:txBody>
       </p:sp>
@@ -2446,9 +2299,33 @@
           <a:chExt cx="0" cy="0"/>
         </a:xfrm>
       </p:grpSpPr>
-      <p:sp>
-        <p:nvSpPr>
-          <p:cNvPr id="2" name="Text 0"/>
+      <p:pic>
+        <p:nvPicPr>
+          <p:cNvPr id="2" name="Foto Miami" descr="Prédios de Miami vistos da rua">    </p:cNvPr>
+          <p:cNvPicPr>
+            <a:picLocks noChangeAspect="1"/>
+          </p:cNvPicPr>
+          <p:nvPr/>
+        </p:nvPicPr>
+        <p:blipFill>
+          <a:blip r:embed="rId1"/>
+          <a:stretch>
+            <a:fillRect/>
+          </a:stretch>
+        </p:blipFill>
+        <p:spPr>
+          <a:xfrm>
+            <a:off x="7050024" y="0"/>
+            <a:ext cx="5143500" cy="6858000"/>
+          </a:xfrm>
+          <a:prstGeom prst="rect">
+            <a:avLst/>
+          </a:prstGeom>
+        </p:spPr>
+      </p:pic>
+      <p:sp>
+        <p:nvSpPr>
+          <p:cNvPr id="3" name="Text 0"/>
           <p:cNvSpPr/>
           <p:nvPr>
             <p:ph idx="100" type="title" hasCustomPrompt="1"/>
@@ -2481,7 +2358,7 @@
                 <a:ea typeface="Georgia" pitchFamily="34" charset="-122"/>
                 <a:cs typeface="Georgia" pitchFamily="34" charset="-120"/>
               </a:rPr>
-              <a:t>PROGRAMAÇÃO PRÁTICA</a:t>
+              <a:t>POR QUE MIAMI?</a:t>
             </a:r>
             <a:endParaRPr lang="en-US" sz="3200" dirty="0"/>
           </a:p>
@@ -2489,14 +2366,14 @@
       </p:sp>
       <p:sp>
         <p:nvSpPr>
-          <p:cNvPr id="3" name="Subtítulo"/>
+          <p:cNvPr id="4" name="Texto Miami"/>
           <p:cNvSpPr txBox="1"/>
           <p:nvPr/>
         </p:nvSpPr>
         <p:spPr>
           <a:xfrm>
-            <a:off x="640080" y="1463040"/>
-            <a:ext cx="6400800" cy="365760"/>
+            <a:off x="640080" y="1920240"/>
+            <a:ext cx="5760720" cy="1371600"/>
           </a:xfrm>
           <a:prstGeom prst="rect">
             <a:avLst/>
@@ -2505,7 +2382,7 @@
           <a:ln/>
         </p:spPr>
         <p:txBody>
-          <a:bodyPr wrap="square" lIns="0" tIns="0" rIns="0" bIns="0" rtlCol="0" anchor="ctr"/>
+          <a:bodyPr wrap="square" lIns="0" tIns="0" rIns="0" bIns="0" rtlCol="0" anchor="t"/>
           <a:lstStyle/>
           <a:p>
             <a:pPr indent="0" marL="0">
@@ -2517,7 +2394,7 @@
                   <a:schemeClr val="accent4"/>
                 </a:solidFill>
               </a:rPr>
-              <a:t>Anatomia aplicada e hands-on</a:t>
+              <a:t>Nos Estados Unidos, laboratórios privados de anatomia oferecem estrutura para treinamento hands-on em specimen, a peça anatômica real. Em Miami, o conteúdo científico vira prática.</a:t>
             </a:r>
             <a:endParaRPr lang="en-US" sz="1700" dirty="0"/>
           </a:p>
@@ -2525,14 +2402,90 @@
       </p:sp>
       <p:sp>
         <p:nvSpPr>
-          <p:cNvPr id="4" name="Módulo 1"/>
+          <p:cNvPr id="5" name="Lista Miami"/>
           <p:cNvSpPr txBox="1"/>
           <p:nvPr/>
         </p:nvSpPr>
         <p:spPr>
           <a:xfrm>
-            <a:off x="640080" y="2377440"/>
-            <a:ext cx="10881360" cy="548640"/>
+            <a:off x="640080" y="3520440"/>
+            <a:ext cx="5760720" cy="1463040"/>
+          </a:xfrm>
+          <a:prstGeom prst="rect">
+            <a:avLst/>
+          </a:prstGeom>
+          <a:noFill/>
+          <a:ln/>
+        </p:spPr>
+        <p:txBody>
+          <a:bodyPr wrap="square" lIns="0" tIns="0" rIns="0" bIns="0" rtlCol="0" anchor="t"/>
+          <a:lstStyle/>
+          <a:p>
+            <a:pPr marL="342900" indent="-342900">
+              <a:spcAft>
+                <a:spcPts val="1000"/>
+              </a:spcAft>
+              <a:buSzPct val="100000"/>
+              <a:buChar char="•"/>
+            </a:pPr>
+            <a:r>
+              <a:rPr lang="en-US" sz="1700" dirty="0">
+                <a:solidFill>
+                  <a:schemeClr val="bg1"/>
+                </a:solidFill>
+              </a:rPr>
+              <a:t>Imersão de 3 dias com prática real</a:t>
+            </a:r>
+            <a:endParaRPr lang="en-US" sz="1700" dirty="0"/>
+          </a:p>
+          <a:p>
+            <a:pPr marL="342900" indent="-342900">
+              <a:spcAft>
+                <a:spcPts val="1000"/>
+              </a:spcAft>
+              <a:buSzPct val="100000"/>
+              <a:buChar char="•"/>
+            </a:pPr>
+            <a:r>
+              <a:rPr lang="en-US" sz="1700" dirty="0">
+                <a:solidFill>
+                  <a:schemeClr val="bg1"/>
+                </a:solidFill>
+              </a:rPr>
+              <a:t>Laboratórios privados preparados para hands-on avançado</a:t>
+            </a:r>
+            <a:endParaRPr lang="en-US" sz="1700" dirty="0"/>
+          </a:p>
+          <a:p>
+            <a:pPr marL="342900" indent="-342900">
+              <a:spcAft>
+                <a:spcPts val="1000"/>
+              </a:spcAft>
+              <a:buSzPct val="100000"/>
+              <a:buChar char="•"/>
+            </a:pPr>
+            <a:r>
+              <a:rPr lang="en-US" sz="1700" dirty="0">
+                <a:solidFill>
+                  <a:schemeClr val="bg1"/>
+                </a:solidFill>
+              </a:rPr>
+              <a:t>Anatomia aplicada direto na peça anatômica</a:t>
+            </a:r>
+            <a:endParaRPr lang="en-US" sz="1700" dirty="0"/>
+          </a:p>
+        </p:txBody>
+      </p:sp>
+      <p:sp>
+        <p:nvSpPr>
+          <p:cNvPr id="6" name="Data"/>
+          <p:cNvSpPr txBox="1"/>
+          <p:nvPr/>
+        </p:nvSpPr>
+        <p:spPr>
+          <a:xfrm>
+            <a:off x="640080" y="5349240"/>
+            <a:ext cx="5760720" cy="411480"/>
           </a:xfrm>
           <a:prstGeom prst="rect">
             <a:avLst/>
@@ -2552,244 +2505,11 @@
                 <a:solidFill>
                   <a:schemeClr val="bg1"/>
                 </a:solidFill>
-              </a:rPr>
-              <a:t>Anatomia avançada de cabeça e pescoço aplicada a injetáveis</a:t>
-            </a:r>
-            <a:endParaRPr lang="en-US" sz="2000" dirty="0"/>
-          </a:p>
-        </p:txBody>
-      </p:sp>
-      <p:sp>
-        <p:nvSpPr>
-          <p:cNvPr id="5" name="Divisória 1"/>
-          <p:cNvSpPr/>
-          <p:nvPr/>
-        </p:nvSpPr>
-        <p:spPr>
-          <a:xfrm>
-            <a:off x="640080" y="3090672"/>
-            <a:ext cx="10881360" cy="0"/>
-          </a:xfrm>
-          <a:prstGeom prst="line">
-            <a:avLst/>
-          </a:prstGeom>
-          <a:noFill/>
-          <a:ln w="9525">
-            <a:solidFill>
-              <a:schemeClr val="accent5"/>
-            </a:solidFill>
-            <a:prstDash val="solid"/>
-          </a:ln>
-        </p:spPr>
-      </p:sp>
-      <p:sp>
-        <p:nvSpPr>
-          <p:cNvPr id="6" name="Módulo 2"/>
-          <p:cNvSpPr txBox="1"/>
-          <p:nvPr/>
-        </p:nvSpPr>
-        <p:spPr>
-          <a:xfrm>
-            <a:off x="640080" y="3246120"/>
-            <a:ext cx="10881360" cy="548640"/>
-          </a:xfrm>
-          <a:prstGeom prst="rect">
-            <a:avLst/>
-          </a:prstGeom>
-          <a:noFill/>
-          <a:ln/>
-        </p:spPr>
-        <p:txBody>
-          <a:bodyPr wrap="square" lIns="0" tIns="0" rIns="0" bIns="0" rtlCol="0" anchor="ctr"/>
-          <a:lstStyle/>
-          <a:p>
-            <a:pPr indent="0" marL="0">
-              <a:buNone/>
-            </a:pPr>
-            <a:r>
-              <a:rPr lang="en-US" sz="2000" dirty="0">
-                <a:solidFill>
-                  <a:schemeClr val="bg1"/>
-                </a:solidFill>
-              </a:rPr>
-              <a:t>Anatomia avançada de cabeça e pescoço aplicada a fios faciais</a:t>
-            </a:r>
-            <a:endParaRPr lang="en-US" sz="2000" dirty="0"/>
-          </a:p>
-        </p:txBody>
-      </p:sp>
-      <p:sp>
-        <p:nvSpPr>
-          <p:cNvPr id="7" name="Divisória 2"/>
-          <p:cNvSpPr/>
-          <p:nvPr/>
-        </p:nvSpPr>
-        <p:spPr>
-          <a:xfrm>
-            <a:off x="640080" y="3959352"/>
-            <a:ext cx="10881360" cy="0"/>
-          </a:xfrm>
-          <a:prstGeom prst="line">
-            <a:avLst/>
-          </a:prstGeom>
-          <a:noFill/>
-          <a:ln w="9525">
-            <a:solidFill>
-              <a:schemeClr val="accent5"/>
-            </a:solidFill>
-            <a:prstDash val="solid"/>
-          </a:ln>
-        </p:spPr>
-      </p:sp>
-      <p:sp>
-        <p:nvSpPr>
-          <p:cNvPr id="8" name="Módulo 3"/>
-          <p:cNvSpPr txBox="1"/>
-          <p:nvPr/>
-        </p:nvSpPr>
-        <p:spPr>
-          <a:xfrm>
-            <a:off x="640080" y="4114800"/>
-            <a:ext cx="10881360" cy="548640"/>
-          </a:xfrm>
-          <a:prstGeom prst="rect">
-            <a:avLst/>
-          </a:prstGeom>
-          <a:noFill/>
-          <a:ln/>
-        </p:spPr>
-        <p:txBody>
-          <a:bodyPr wrap="square" lIns="0" tIns="0" rIns="0" bIns="0" rtlCol="0" anchor="ctr"/>
-          <a:lstStyle/>
-          <a:p>
-            <a:pPr indent="0" marL="0">
-              <a:buNone/>
-            </a:pPr>
-            <a:r>
-              <a:rPr lang="en-US" sz="2000" dirty="0">
-                <a:solidFill>
-                  <a:schemeClr val="bg1"/>
-                </a:solidFill>
-              </a:rPr>
-              <a:t>Bioestimuladores faciais e corporais: fundamentos, indicações e limites</a:t>
-            </a:r>
-            <a:endParaRPr lang="en-US" sz="2000" dirty="0"/>
-          </a:p>
-        </p:txBody>
-      </p:sp>
-      <p:sp>
-        <p:nvSpPr>
-          <p:cNvPr id="9" name="Divisória 3"/>
-          <p:cNvSpPr/>
-          <p:nvPr/>
-        </p:nvSpPr>
-        <p:spPr>
-          <a:xfrm>
-            <a:off x="640080" y="4828032"/>
-            <a:ext cx="10881360" cy="0"/>
-          </a:xfrm>
-          <a:prstGeom prst="line">
-            <a:avLst/>
-          </a:prstGeom>
-          <a:noFill/>
-          <a:ln w="9525">
-            <a:solidFill>
-              <a:schemeClr val="accent5"/>
-            </a:solidFill>
-            <a:prstDash val="solid"/>
-          </a:ln>
-        </p:spPr>
-      </p:sp>
-      <p:sp>
-        <p:nvSpPr>
-          <p:cNvPr id="10" name="Módulo 4"/>
-          <p:cNvSpPr txBox="1"/>
-          <p:nvPr/>
-        </p:nvSpPr>
-        <p:spPr>
-          <a:xfrm>
-            <a:off x="640080" y="4983480"/>
-            <a:ext cx="10881360" cy="548640"/>
-          </a:xfrm>
-          <a:prstGeom prst="rect">
-            <a:avLst/>
-          </a:prstGeom>
-          <a:noFill/>
-          <a:ln/>
-        </p:spPr>
-        <p:txBody>
-          <a:bodyPr wrap="square" lIns="0" tIns="0" rIns="0" bIns="0" rtlCol="0" anchor="ctr"/>
-          <a:lstStyle/>
-          <a:p>
-            <a:pPr indent="0" marL="0">
-              <a:buNone/>
-            </a:pPr>
-            <a:r>
-              <a:rPr lang="en-US" sz="2000" dirty="0">
-                <a:solidFill>
-                  <a:schemeClr val="bg1"/>
-                </a:solidFill>
-              </a:rPr>
-              <a:t>Lifting facial com preenchedores: raciocínio anatômico e estrutural</a:t>
-            </a:r>
-            <a:endParaRPr lang="en-US" sz="2000" dirty="0"/>
-          </a:p>
-        </p:txBody>
-      </p:sp>
-      <p:sp>
-        <p:nvSpPr>
-          <p:cNvPr id="11" name="Divisória 4"/>
-          <p:cNvSpPr/>
-          <p:nvPr/>
-        </p:nvSpPr>
-        <p:spPr>
-          <a:xfrm>
-            <a:off x="640080" y="5696712"/>
-            <a:ext cx="10881360" cy="0"/>
-          </a:xfrm>
-          <a:prstGeom prst="line">
-            <a:avLst/>
-          </a:prstGeom>
-          <a:noFill/>
-          <a:ln w="9525">
-            <a:solidFill>
-              <a:schemeClr val="accent5"/>
-            </a:solidFill>
-            <a:prstDash val="solid"/>
-          </a:ln>
-        </p:spPr>
-      </p:sp>
-      <p:sp>
-        <p:nvSpPr>
-          <p:cNvPr id="12" name="Módulo 5"/>
-          <p:cNvSpPr txBox="1"/>
-          <p:nvPr/>
-        </p:nvSpPr>
-        <p:spPr>
-          <a:xfrm>
-            <a:off x="640080" y="5852160"/>
-            <a:ext cx="10881360" cy="548640"/>
-          </a:xfrm>
-          <a:prstGeom prst="rect">
-            <a:avLst/>
-          </a:prstGeom>
-          <a:noFill/>
-          <a:ln/>
-        </p:spPr>
-        <p:txBody>
-          <a:bodyPr wrap="square" lIns="0" tIns="0" rIns="0" bIns="0" rtlCol="0" anchor="ctr"/>
-          <a:lstStyle/>
-          <a:p>
-            <a:pPr indent="0" marL="0">
-              <a:buNone/>
-            </a:pPr>
-            <a:r>
-              <a:rPr lang="en-US" sz="2000" dirty="0">
-                <a:solidFill>
-                  <a:schemeClr val="bg1"/>
-                </a:solidFill>
-              </a:rPr>
-              <a:t>Full face: planejamento anatômico, segurança e naturalidade</a:t>
+                <a:latin typeface="Georgia" pitchFamily="34" charset="0"/>
+                <a:ea typeface="Georgia" pitchFamily="34" charset="-122"/>
+                <a:cs typeface="Georgia" pitchFamily="34" charset="-120"/>
+              </a:rPr>
+              <a:t>19, 20 e 21 de maio de 2027</a:t>
             </a:r>
             <a:endParaRPr lang="en-US" sz="2000" dirty="0"/>
           </a:p>
@@ -2903,7 +2623,7 @@
                 <a:ea typeface="Georgia" pitchFamily="34" charset="-122"/>
                 <a:cs typeface="Georgia" pitchFamily="34" charset="-120"/>
               </a:rPr>
-              <a:t>DA TEORIA À PRÁTICA</a:t>
+              <a:t>PROGRAMAÇÃO PRÁTICA</a:t>
             </a:r>
             <a:endParaRPr lang="en-US" sz="3200" dirty="0"/>
           </a:p>
@@ -2911,22 +2631,92 @@
       </p:sp>
       <p:sp>
         <p:nvSpPr>
-          <p:cNvPr id="3" name="Cartão Boston"/>
+          <p:cNvPr id="3" name="Subtítulo"/>
+          <p:cNvSpPr txBox="1"/>
+          <p:nvPr/>
+        </p:nvSpPr>
+        <p:spPr>
+          <a:xfrm>
+            <a:off x="640080" y="1463040"/>
+            <a:ext cx="6400800" cy="365760"/>
+          </a:xfrm>
+          <a:prstGeom prst="rect">
+            <a:avLst/>
+          </a:prstGeom>
+          <a:noFill/>
+          <a:ln/>
+        </p:spPr>
+        <p:txBody>
+          <a:bodyPr wrap="square" lIns="0" tIns="0" rIns="0" bIns="0" rtlCol="0" anchor="ctr"/>
+          <a:lstStyle/>
+          <a:p>
+            <a:pPr indent="0" marL="0">
+              <a:buNone/>
+            </a:pPr>
+            <a:r>
+              <a:rPr lang="en-US" sz="1700" dirty="0">
+                <a:solidFill>
+                  <a:schemeClr val="accent4"/>
+                </a:solidFill>
+              </a:rPr>
+              <a:t>Anatomia aplicada e hands-on</a:t>
+            </a:r>
+            <a:endParaRPr lang="en-US" sz="1700" dirty="0"/>
+          </a:p>
+        </p:txBody>
+      </p:sp>
+      <p:sp>
+        <p:nvSpPr>
+          <p:cNvPr id="4" name="Módulo 1"/>
+          <p:cNvSpPr txBox="1"/>
+          <p:nvPr/>
+        </p:nvSpPr>
+        <p:spPr>
+          <a:xfrm>
+            <a:off x="640080" y="2377440"/>
+            <a:ext cx="10881360" cy="548640"/>
+          </a:xfrm>
+          <a:prstGeom prst="rect">
+            <a:avLst/>
+          </a:prstGeom>
+          <a:noFill/>
+          <a:ln/>
+        </p:spPr>
+        <p:txBody>
+          <a:bodyPr wrap="square" lIns="0" tIns="0" rIns="0" bIns="0" rtlCol="0" anchor="ctr"/>
+          <a:lstStyle/>
+          <a:p>
+            <a:pPr indent="0" marL="0">
+              <a:buNone/>
+            </a:pPr>
+            <a:r>
+              <a:rPr lang="en-US" sz="2000" dirty="0">
+                <a:solidFill>
+                  <a:schemeClr val="bg1"/>
+                </a:solidFill>
+              </a:rPr>
+              <a:t>Anatomia avançada de cabeça e pescoço aplicada a injetáveis</a:t>
+            </a:r>
+            <a:endParaRPr lang="en-US" sz="2000" dirty="0"/>
+          </a:p>
+        </p:txBody>
+      </p:sp>
+      <p:sp>
+        <p:nvSpPr>
+          <p:cNvPr id="5" name="Divisória 1"/>
           <p:cNvSpPr/>
           <p:nvPr/>
         </p:nvSpPr>
         <p:spPr>
           <a:xfrm>
-            <a:off x="640080" y="2103120"/>
-            <a:ext cx="5303520" cy="3566160"/>
-          </a:xfrm>
-          <a:prstGeom prst="rect">
-            <a:avLst/>
-          </a:prstGeom>
-          <a:solidFill>
-            <a:schemeClr val="accent5"/>
-          </a:solidFill>
-          <a:ln w="12700">
+            <a:off x="640080" y="3090672"/>
+            <a:ext cx="10881360" cy="0"/>
+          </a:xfrm>
+          <a:prstGeom prst="line">
+            <a:avLst/>
+          </a:prstGeom>
+          <a:noFill/>
+          <a:ln w="9525">
             <a:solidFill>
               <a:schemeClr val="accent5"/>
             </a:solidFill>
@@ -2936,14 +2726,14 @@
       </p:sp>
       <p:sp>
         <p:nvSpPr>
-          <p:cNvPr id="4" name="Boston título"/>
+          <p:cNvPr id="6" name="Módulo 2"/>
           <p:cNvSpPr txBox="1"/>
           <p:nvPr/>
         </p:nvSpPr>
         <p:spPr>
           <a:xfrm>
-            <a:off x="1051560" y="2468880"/>
-            <a:ext cx="4480560" cy="685800"/>
+            <a:off x="640080" y="3246120"/>
+            <a:ext cx="10881360" cy="548640"/>
           </a:xfrm>
           <a:prstGeom prst="rect">
             <a:avLst/>
@@ -2959,112 +2749,35 @@
               <a:buNone/>
             </a:pPr>
             <a:r>
-              <a:rPr lang="en-US" sz="3800" dirty="0">
+              <a:rPr lang="en-US" sz="2000" dirty="0">
                 <a:solidFill>
                   <a:schemeClr val="bg1"/>
                 </a:solidFill>
-                <a:latin typeface="Georgia" pitchFamily="34" charset="0"/>
-                <a:ea typeface="Georgia" pitchFamily="34" charset="-122"/>
-                <a:cs typeface="Georgia" pitchFamily="34" charset="-120"/>
-              </a:rPr>
-              <a:t>Boston</a:t>
-            </a:r>
-            <a:endParaRPr lang="en-US" sz="3800" dirty="0"/>
-          </a:p>
-        </p:txBody>
-      </p:sp>
-      <p:sp>
-        <p:nvSpPr>
-          <p:cNvPr id="5" name="Boston subtítulo"/>
-          <p:cNvSpPr txBox="1"/>
-          <p:nvPr/>
-        </p:nvSpPr>
-        <p:spPr>
-          <a:xfrm>
-            <a:off x="1051560" y="3246120"/>
-            <a:ext cx="4480560" cy="457200"/>
-          </a:xfrm>
-          <a:prstGeom prst="rect">
-            <a:avLst/>
-          </a:prstGeom>
-          <a:noFill/>
-          <a:ln/>
-        </p:spPr>
-        <p:txBody>
-          <a:bodyPr wrap="square" lIns="0" tIns="0" rIns="0" bIns="0" rtlCol="0" anchor="t"/>
-          <a:lstStyle/>
-          <a:p>
-            <a:pPr indent="0" marL="0">
-              <a:buNone/>
-            </a:pPr>
-            <a:r>
-              <a:rPr lang="en-US" sz="1800" b="1" dirty="0">
-                <a:solidFill>
-                  <a:schemeClr val="bg1"/>
-                </a:solidFill>
-              </a:rPr>
-              <a:t>Teoria e anatomia demonstrativa</a:t>
-            </a:r>
-            <a:endParaRPr lang="en-US" sz="1800" dirty="0"/>
-          </a:p>
-        </p:txBody>
-      </p:sp>
-      <p:sp>
-        <p:nvSpPr>
-          <p:cNvPr id="6" name="Boston texto"/>
-          <p:cNvSpPr txBox="1"/>
-          <p:nvPr/>
-        </p:nvSpPr>
-        <p:spPr>
-          <a:xfrm>
-            <a:off x="1051560" y="4160520"/>
-            <a:ext cx="4480560" cy="1188720"/>
-          </a:xfrm>
-          <a:prstGeom prst="rect">
-            <a:avLst/>
-          </a:prstGeom>
-          <a:noFill/>
-          <a:ln/>
-        </p:spPr>
-        <p:txBody>
-          <a:bodyPr wrap="square" lIns="0" tIns="0" rIns="0" bIns="0" rtlCol="0" anchor="t"/>
-          <a:lstStyle/>
-          <a:p>
-            <a:pPr indent="0" marL="0">
-              <a:buNone/>
-            </a:pPr>
-            <a:r>
-              <a:rPr lang="en-US" sz="1500" dirty="0">
-                <a:solidFill>
-                  <a:schemeClr val="accent4"/>
-                </a:solidFill>
-              </a:rPr>
-              <a:t>3 dias em ambiente acadêmico: aulas científicas, anatomy review com anatomista e demonstração de dissecação.</a:t>
-            </a:r>
-            <a:endParaRPr lang="en-US" sz="1500" dirty="0"/>
-          </a:p>
-        </p:txBody>
-      </p:sp>
-      <p:sp>
-        <p:nvSpPr>
-          <p:cNvPr id="7" name="Cartão Miami"/>
+              </a:rPr>
+              <a:t>Anatomia avançada de cabeça e pescoço aplicada a fios faciais</a:t>
+            </a:r>
+            <a:endParaRPr lang="en-US" sz="2000" dirty="0"/>
+          </a:p>
+        </p:txBody>
+      </p:sp>
+      <p:sp>
+        <p:nvSpPr>
+          <p:cNvPr id="7" name="Divisória 2"/>
           <p:cNvSpPr/>
           <p:nvPr/>
         </p:nvSpPr>
         <p:spPr>
           <a:xfrm>
-            <a:off x="6245352" y="2103120"/>
-            <a:ext cx="5303520" cy="3566160"/>
-          </a:xfrm>
-          <a:prstGeom prst="rect">
-            <a:avLst/>
-          </a:prstGeom>
-          <a:solidFill>
-            <a:schemeClr val="accent1"/>
-          </a:solidFill>
-          <a:ln w="12700">
+            <a:off x="640080" y="3959352"/>
+            <a:ext cx="10881360" cy="0"/>
+          </a:xfrm>
+          <a:prstGeom prst="line">
+            <a:avLst/>
+          </a:prstGeom>
+          <a:noFill/>
+          <a:ln w="9525">
             <a:solidFill>
-              <a:schemeClr val="accent1"/>
+              <a:schemeClr val="accent5"/>
             </a:solidFill>
             <a:prstDash val="solid"/>
           </a:ln>
@@ -3072,14 +2785,14 @@
       </p:sp>
       <p:sp>
         <p:nvSpPr>
-          <p:cNvPr id="8" name="Miami título"/>
+          <p:cNvPr id="8" name="Módulo 3"/>
           <p:cNvSpPr txBox="1"/>
           <p:nvPr/>
         </p:nvSpPr>
         <p:spPr>
           <a:xfrm>
-            <a:off x="6656832" y="2468880"/>
-            <a:ext cx="4480560" cy="685800"/>
+            <a:off x="640080" y="4114800"/>
+            <a:ext cx="10881360" cy="548640"/>
           </a:xfrm>
           <a:prstGeom prst="rect">
             <a:avLst/>
@@ -3095,30 +2808,50 @@
               <a:buNone/>
             </a:pPr>
             <a:r>
-              <a:rPr lang="en-US" sz="3800" dirty="0">
+              <a:rPr lang="en-US" sz="2000" dirty="0">
                 <a:solidFill>
                   <a:schemeClr val="bg1"/>
                 </a:solidFill>
-                <a:latin typeface="Georgia" pitchFamily="34" charset="0"/>
-                <a:ea typeface="Georgia" pitchFamily="34" charset="-122"/>
-                <a:cs typeface="Georgia" pitchFamily="34" charset="-120"/>
-              </a:rPr>
-              <a:t>Miami</a:t>
-            </a:r>
-            <a:endParaRPr lang="en-US" sz="3800" dirty="0"/>
-          </a:p>
-        </p:txBody>
-      </p:sp>
-      <p:sp>
-        <p:nvSpPr>
-          <p:cNvPr id="9" name="Miami subtítulo"/>
+              </a:rPr>
+              <a:t>Bioestimuladores faciais e corporais: fundamentos, indicações e limites</a:t>
+            </a:r>
+            <a:endParaRPr lang="en-US" sz="2000" dirty="0"/>
+          </a:p>
+        </p:txBody>
+      </p:sp>
+      <p:sp>
+        <p:nvSpPr>
+          <p:cNvPr id="9" name="Divisória 3"/>
+          <p:cNvSpPr/>
+          <p:nvPr/>
+        </p:nvSpPr>
+        <p:spPr>
+          <a:xfrm>
+            <a:off x="640080" y="4828032"/>
+            <a:ext cx="10881360" cy="0"/>
+          </a:xfrm>
+          <a:prstGeom prst="line">
+            <a:avLst/>
+          </a:prstGeom>
+          <a:noFill/>
+          <a:ln w="9525">
+            <a:solidFill>
+              <a:schemeClr val="accent5"/>
+            </a:solidFill>
+            <a:prstDash val="solid"/>
+          </a:ln>
+        </p:spPr>
+      </p:sp>
+      <p:sp>
+        <p:nvSpPr>
+          <p:cNvPr id="10" name="Módulo 4"/>
           <p:cNvSpPr txBox="1"/>
           <p:nvPr/>
         </p:nvSpPr>
         <p:spPr>
           <a:xfrm>
-            <a:off x="6656832" y="3246120"/>
-            <a:ext cx="4480560" cy="457200"/>
+            <a:off x="640080" y="4983480"/>
+            <a:ext cx="10881360" cy="548640"/>
           </a:xfrm>
           <a:prstGeom prst="rect">
             <a:avLst/>
@@ -3127,34 +2860,57 @@
           <a:ln/>
         </p:spPr>
         <p:txBody>
-          <a:bodyPr wrap="square" lIns="0" tIns="0" rIns="0" bIns="0" rtlCol="0" anchor="t"/>
+          <a:bodyPr wrap="square" lIns="0" tIns="0" rIns="0" bIns="0" rtlCol="0" anchor="ctr"/>
           <a:lstStyle/>
           <a:p>
             <a:pPr indent="0" marL="0">
               <a:buNone/>
             </a:pPr>
             <a:r>
-              <a:rPr lang="en-US" sz="1800" b="1" dirty="0">
+              <a:rPr lang="en-US" sz="2000" dirty="0">
                 <a:solidFill>
                   <a:schemeClr val="bg1"/>
                 </a:solidFill>
               </a:rPr>
-              <a:t>Prática real e hands-on</a:t>
-            </a:r>
-            <a:endParaRPr lang="en-US" sz="1800" dirty="0"/>
-          </a:p>
-        </p:txBody>
-      </p:sp>
-      <p:sp>
-        <p:nvSpPr>
-          <p:cNvPr id="10" name="Miami texto"/>
+              <a:t>Lifting facial com preenchedores: raciocínio anatômico e estrutural</a:t>
+            </a:r>
+            <a:endParaRPr lang="en-US" sz="2000" dirty="0"/>
+          </a:p>
+        </p:txBody>
+      </p:sp>
+      <p:sp>
+        <p:nvSpPr>
+          <p:cNvPr id="11" name="Divisória 4"/>
+          <p:cNvSpPr/>
+          <p:nvPr/>
+        </p:nvSpPr>
+        <p:spPr>
+          <a:xfrm>
+            <a:off x="640080" y="5696712"/>
+            <a:ext cx="10881360" cy="0"/>
+          </a:xfrm>
+          <a:prstGeom prst="line">
+            <a:avLst/>
+          </a:prstGeom>
+          <a:noFill/>
+          <a:ln w="9525">
+            <a:solidFill>
+              <a:schemeClr val="accent5"/>
+            </a:solidFill>
+            <a:prstDash val="solid"/>
+          </a:ln>
+        </p:spPr>
+      </p:sp>
+      <p:sp>
+        <p:nvSpPr>
+          <p:cNvPr id="12" name="Módulo 5"/>
           <p:cNvSpPr txBox="1"/>
           <p:nvPr/>
         </p:nvSpPr>
         <p:spPr>
           <a:xfrm>
-            <a:off x="6656832" y="4160520"/>
-            <a:ext cx="4480560" cy="1188720"/>
+            <a:off x="640080" y="5852160"/>
+            <a:ext cx="10881360" cy="548640"/>
           </a:xfrm>
           <a:prstGeom prst="rect">
             <a:avLst/>
@@ -3163,21 +2919,21 @@
           <a:ln/>
         </p:spPr>
         <p:txBody>
-          <a:bodyPr wrap="square" lIns="0" tIns="0" rIns="0" bIns="0" rtlCol="0" anchor="t"/>
+          <a:bodyPr wrap="square" lIns="0" tIns="0" rIns="0" bIns="0" rtlCol="0" anchor="ctr"/>
           <a:lstStyle/>
           <a:p>
             <a:pPr indent="0" marL="0">
               <a:buNone/>
             </a:pPr>
             <a:r>
-              <a:rPr lang="en-US" sz="1500" dirty="0">
+              <a:rPr lang="en-US" sz="2000" dirty="0">
                 <a:solidFill>
                   <a:schemeClr val="bg1"/>
                 </a:solidFill>
               </a:rPr>
-              <a:t>19, 20 e 21 de maio de 2027, em laboratório de specimen: anatomia aplicada e prática supervisionada dos procedimentos.</a:t>
-            </a:r>
-            <a:endParaRPr lang="en-US" sz="1500" dirty="0"/>
+              <a:t>Full face: planejamento anatômico, segurança e naturalidade</a:t>
+            </a:r>
+            <a:endParaRPr lang="en-US" sz="2000" dirty="0"/>
           </a:p>
         </p:txBody>
       </p:sp>
@@ -3254,72 +3010,9 @@
           <a:chExt cx="0" cy="0"/>
         </a:xfrm>
       </p:grpSpPr>
-      <p:pic>
-        <p:nvPicPr>
-          <p:cNvPr id="2" name="Print Instagram" descr="Perfil @dra.rosanaa no Instagram, com 339 mil seguidores">    </p:cNvPr>
-          <p:cNvPicPr>
-            <a:picLocks noChangeAspect="1"/>
-          </p:cNvPicPr>
-          <p:nvPr/>
-        </p:nvPicPr>
-        <p:blipFill>
-          <a:blip r:embed="rId1"/>
-          <a:stretch>
-            <a:fillRect/>
-          </a:stretch>
-        </p:blipFill>
-        <p:spPr>
-          <a:xfrm>
-            <a:off x="8412480" y="548640"/>
-            <a:ext cx="3182112" cy="5477256"/>
-          </a:xfrm>
-          <a:prstGeom prst="rect">
-            <a:avLst/>
-          </a:prstGeom>
-        </p:spPr>
-      </p:pic>
-      <p:sp>
-        <p:nvSpPr>
-          <p:cNvPr id="3" name="Pré-título"/>
-          <p:cNvSpPr txBox="1"/>
-          <p:nvPr/>
-        </p:nvSpPr>
-        <p:spPr>
-          <a:xfrm>
-            <a:off x="640080" y="411480"/>
-            <a:ext cx="6035040" cy="411480"/>
-          </a:xfrm>
-          <a:prstGeom prst="rect">
-            <a:avLst/>
-          </a:prstGeom>
-          <a:noFill/>
-          <a:ln/>
-        </p:spPr>
-        <p:txBody>
-          <a:bodyPr wrap="square" lIns="0" tIns="0" rIns="0" bIns="0" rtlCol="0" anchor="ctr"/>
-          <a:lstStyle/>
-          <a:p>
-            <a:pPr indent="0" marL="0">
-              <a:buNone/>
-            </a:pPr>
-            <a:r>
-              <a:rPr lang="en-US" sz="2000" spc="300" kern="0" dirty="0">
-                <a:solidFill>
-                  <a:schemeClr val="accent4"/>
-                </a:solidFill>
-                <a:latin typeface="Georgia" pitchFamily="34" charset="0"/>
-                <a:ea typeface="Georgia" pitchFamily="34" charset="-122"/>
-                <a:cs typeface="Georgia" pitchFamily="34" charset="-120"/>
-              </a:rPr>
-              <a:t>O poder do</a:t>
-            </a:r>
-            <a:endParaRPr lang="en-US" sz="2000" dirty="0"/>
-          </a:p>
-        </p:txBody>
-      </p:sp>
-      <p:sp>
-        <p:nvSpPr>
-          <p:cNvPr id="4" name="Text 0"/>
+      <p:sp>
+        <p:nvSpPr>
+          <p:cNvPr id="2" name="Text 0"/>
           <p:cNvSpPr/>
           <p:nvPr>
             <p:ph idx="100" type="title" hasCustomPrompt="1"/>
@@ -3352,7 +3045,7 @@
                 <a:ea typeface="Georgia" pitchFamily="34" charset="-122"/>
                 <a:cs typeface="Georgia" pitchFamily="34" charset="-120"/>
               </a:rPr>
-              <a:t>POSICIONAMENTO</a:t>
+              <a:t>DA TEORIA À PRÁTICA</a:t>
             </a:r>
             <a:endParaRPr lang="en-US" sz="3200" dirty="0"/>
           </a:p>
@@ -3360,14 +3053,39 @@
       </p:sp>
       <p:sp>
         <p:nvSpPr>
-          <p:cNvPr id="5" name="Introdução posicionamento"/>
+          <p:cNvPr id="3" name="Cartão Boston"/>
+          <p:cNvSpPr/>
+          <p:nvPr/>
+        </p:nvSpPr>
+        <p:spPr>
+          <a:xfrm>
+            <a:off x="640080" y="2103120"/>
+            <a:ext cx="5303520" cy="3566160"/>
+          </a:xfrm>
+          <a:prstGeom prst="rect">
+            <a:avLst/>
+          </a:prstGeom>
+          <a:solidFill>
+            <a:schemeClr val="accent5"/>
+          </a:solidFill>
+          <a:ln w="12700">
+            <a:solidFill>
+              <a:schemeClr val="accent5"/>
+            </a:solidFill>
+            <a:prstDash val="solid"/>
+          </a:ln>
+        </p:spPr>
+      </p:sp>
+      <p:sp>
+        <p:nvSpPr>
+          <p:cNvPr id="4" name="Boston título"/>
           <p:cNvSpPr txBox="1"/>
           <p:nvPr/>
         </p:nvSpPr>
         <p:spPr>
           <a:xfrm>
-            <a:off x="640080" y="1920240"/>
-            <a:ext cx="6949440" cy="548640"/>
+            <a:off x="1051560" y="2468880"/>
+            <a:ext cx="4480560" cy="685800"/>
           </a:xfrm>
           <a:prstGeom prst="rect">
             <a:avLst/>
@@ -3376,50 +3094,14 @@
           <a:ln/>
         </p:spPr>
         <p:txBody>
-          <a:bodyPr wrap="square" lIns="0" tIns="0" rIns="0" bIns="0" rtlCol="0" anchor="t"/>
+          <a:bodyPr wrap="square" lIns="0" tIns="0" rIns="0" bIns="0" rtlCol="0" anchor="ctr"/>
           <a:lstStyle/>
           <a:p>
             <a:pPr indent="0" marL="0">
               <a:buNone/>
             </a:pPr>
             <a:r>
-              <a:rPr lang="en-US" sz="1600" dirty="0">
-                <a:solidFill>
-                  <a:schemeClr val="accent4"/>
-                </a:solidFill>
-              </a:rPr>
-              <a:t>Um programa realizado em Boston e Miami reúne, além do conteúdo técnico:</a:t>
-            </a:r>
-            <a:endParaRPr lang="en-US" sz="1600" dirty="0"/>
-          </a:p>
-        </p:txBody>
-      </p:sp>
-      <p:sp>
-        <p:nvSpPr>
-          <p:cNvPr id="6" name="Item 1 título"/>
-          <p:cNvSpPr txBox="1"/>
-          <p:nvPr/>
-        </p:nvSpPr>
-        <p:spPr>
-          <a:xfrm>
-            <a:off x="640080" y="2697480"/>
-            <a:ext cx="6949440" cy="365760"/>
-          </a:xfrm>
-          <a:prstGeom prst="rect">
-            <a:avLst/>
-          </a:prstGeom>
-          <a:noFill/>
-          <a:ln/>
-        </p:spPr>
-        <p:txBody>
-          <a:bodyPr wrap="square" lIns="0" tIns="0" rIns="0" bIns="0" rtlCol="0" anchor="ctr"/>
-          <a:lstStyle/>
-          <a:p>
-            <a:pPr indent="0" marL="0">
-              <a:buNone/>
-            </a:pPr>
-            <a:r>
-              <a:rPr lang="en-US" sz="2000" dirty="0">
+              <a:rPr lang="en-US" sz="3800" dirty="0">
                 <a:solidFill>
                   <a:schemeClr val="bg1"/>
                 </a:solidFill>
@@ -3427,22 +3109,22 @@
                 <a:ea typeface="Georgia" pitchFamily="34" charset="-122"/>
                 <a:cs typeface="Georgia" pitchFamily="34" charset="-120"/>
               </a:rPr>
-              <a:t>Doutores da estética</a:t>
-            </a:r>
-            <a:endParaRPr lang="en-US" sz="2000" dirty="0"/>
-          </a:p>
-        </p:txBody>
-      </p:sp>
-      <p:sp>
-        <p:nvSpPr>
-          <p:cNvPr id="7" name="Item 1 texto"/>
+              <a:t>Boston</a:t>
+            </a:r>
+            <a:endParaRPr lang="en-US" sz="3800" dirty="0"/>
+          </a:p>
+        </p:txBody>
+      </p:sp>
+      <p:sp>
+        <p:nvSpPr>
+          <p:cNvPr id="5" name="Boston subtítulo"/>
           <p:cNvSpPr txBox="1"/>
           <p:nvPr/>
         </p:nvSpPr>
         <p:spPr>
           <a:xfrm>
-            <a:off x="640080" y="3081528"/>
-            <a:ext cx="6949440" cy="411480"/>
+            <a:off x="1051560" y="3246120"/>
+            <a:ext cx="4480560" cy="457200"/>
           </a:xfrm>
           <a:prstGeom prst="rect">
             <a:avLst/>
@@ -3451,34 +3133,34 @@
           <a:ln/>
         </p:spPr>
         <p:txBody>
-          <a:bodyPr wrap="square" lIns="0" tIns="0" rIns="0" bIns="0" rtlCol="0" anchor="ctr"/>
+          <a:bodyPr wrap="square" lIns="0" tIns="0" rIns="0" bIns="0" rtlCol="0" anchor="t"/>
           <a:lstStyle/>
           <a:p>
             <a:pPr indent="0" marL="0">
               <a:buNone/>
             </a:pPr>
             <a:r>
-              <a:rPr lang="en-US" sz="1500" dirty="0">
-                <a:solidFill>
-                  <a:schemeClr val="accent4"/>
-                </a:solidFill>
-              </a:rPr>
-              <a:t>nacionais e internacionais</a:t>
-            </a:r>
-            <a:endParaRPr lang="en-US" sz="1500" dirty="0"/>
-          </a:p>
-        </p:txBody>
-      </p:sp>
-      <p:sp>
-        <p:nvSpPr>
-          <p:cNvPr id="8" name="Item 2 título"/>
+              <a:rPr lang="en-US" sz="1800" b="1" dirty="0">
+                <a:solidFill>
+                  <a:schemeClr val="bg1"/>
+                </a:solidFill>
+              </a:rPr>
+              <a:t>Teoria e anatomia demonstrativa</a:t>
+            </a:r>
+            <a:endParaRPr lang="en-US" sz="1800" dirty="0"/>
+          </a:p>
+        </p:txBody>
+      </p:sp>
+      <p:sp>
+        <p:nvSpPr>
+          <p:cNvPr id="6" name="Boston texto"/>
           <p:cNvSpPr txBox="1"/>
           <p:nvPr/>
         </p:nvSpPr>
         <p:spPr>
           <a:xfrm>
-            <a:off x="640080" y="3657600"/>
-            <a:ext cx="6949440" cy="365760"/>
+            <a:off x="1051560" y="4160520"/>
+            <a:ext cx="4480560" cy="1188720"/>
           </a:xfrm>
           <a:prstGeom prst="rect">
             <a:avLst/>
@@ -3487,14 +3169,75 @@
           <a:ln/>
         </p:spPr>
         <p:txBody>
-          <a:bodyPr wrap="square" lIns="0" tIns="0" rIns="0" bIns="0" rtlCol="0" anchor="ctr"/>
+          <a:bodyPr wrap="square" lIns="0" tIns="0" rIns="0" bIns="0" rtlCol="0" anchor="t"/>
           <a:lstStyle/>
           <a:p>
             <a:pPr indent="0" marL="0">
               <a:buNone/>
             </a:pPr>
             <a:r>
-              <a:rPr lang="en-US" sz="2000" dirty="0">
+              <a:rPr lang="en-US" sz="1500" dirty="0">
+                <a:solidFill>
+                  <a:schemeClr val="accent4"/>
+                </a:solidFill>
+              </a:rPr>
+              <a:t>3 dias em ambiente acadêmico: aulas científicas, anatomy review com anatomista e demonstração de dissecação.</a:t>
+            </a:r>
+            <a:endParaRPr lang="en-US" sz="1500" dirty="0"/>
+          </a:p>
+        </p:txBody>
+      </p:sp>
+      <p:sp>
+        <p:nvSpPr>
+          <p:cNvPr id="7" name="Cartão Miami"/>
+          <p:cNvSpPr/>
+          <p:nvPr/>
+        </p:nvSpPr>
+        <p:spPr>
+          <a:xfrm>
+            <a:off x="6245352" y="2103120"/>
+            <a:ext cx="5303520" cy="3566160"/>
+          </a:xfrm>
+          <a:prstGeom prst="rect">
+            <a:avLst/>
+          </a:prstGeom>
+          <a:solidFill>
+            <a:schemeClr val="accent1"/>
+          </a:solidFill>
+          <a:ln w="12700">
+            <a:solidFill>
+              <a:schemeClr val="accent1"/>
+            </a:solidFill>
+            <a:prstDash val="solid"/>
+          </a:ln>
+        </p:spPr>
+      </p:sp>
+      <p:sp>
+        <p:nvSpPr>
+          <p:cNvPr id="8" name="Miami título"/>
+          <p:cNvSpPr txBox="1"/>
+          <p:nvPr/>
+        </p:nvSpPr>
+        <p:spPr>
+          <a:xfrm>
+            <a:off x="6656832" y="2468880"/>
+            <a:ext cx="4480560" cy="685800"/>
+          </a:xfrm>
+          <a:prstGeom prst="rect">
+            <a:avLst/>
+          </a:prstGeom>
+          <a:noFill/>
+          <a:ln/>
+        </p:spPr>
+        <p:txBody>
+          <a:bodyPr wrap="square" lIns="0" tIns="0" rIns="0" bIns="0" rtlCol="0" anchor="ctr"/>
+          <a:lstStyle/>
+          <a:p>
+            <a:pPr indent="0" marL="0">
+              <a:buNone/>
+            </a:pPr>
+            <a:r>
+              <a:rPr lang="en-US" sz="3800" dirty="0">
                 <a:solidFill>
                   <a:schemeClr val="bg1"/>
                 </a:solidFill>
@@ -3502,22 +3245,22 @@
                 <a:ea typeface="Georgia" pitchFamily="34" charset="-122"/>
                 <a:cs typeface="Georgia" pitchFamily="34" charset="-120"/>
               </a:rPr>
-              <a:t>Convidados</a:t>
-            </a:r>
-            <a:endParaRPr lang="en-US" sz="2000" dirty="0"/>
-          </a:p>
-        </p:txBody>
-      </p:sp>
-      <p:sp>
-        <p:nvSpPr>
-          <p:cNvPr id="9" name="Item 2 texto"/>
+              <a:t>Miami</a:t>
+            </a:r>
+            <a:endParaRPr lang="en-US" sz="3800" dirty="0"/>
+          </a:p>
+        </p:txBody>
+      </p:sp>
+      <p:sp>
+        <p:nvSpPr>
+          <p:cNvPr id="9" name="Miami subtítulo"/>
           <p:cNvSpPr txBox="1"/>
           <p:nvPr/>
         </p:nvSpPr>
         <p:spPr>
           <a:xfrm>
-            <a:off x="640080" y="4041648"/>
-            <a:ext cx="6949440" cy="411480"/>
+            <a:off x="6656832" y="3246120"/>
+            <a:ext cx="4480560" cy="457200"/>
           </a:xfrm>
           <a:prstGeom prst="rect">
             <a:avLst/>
@@ -3526,34 +3269,34 @@
           <a:ln/>
         </p:spPr>
         <p:txBody>
-          <a:bodyPr wrap="square" lIns="0" tIns="0" rIns="0" bIns="0" rtlCol="0" anchor="ctr"/>
+          <a:bodyPr wrap="square" lIns="0" tIns="0" rIns="0" bIns="0" rtlCol="0" anchor="t"/>
           <a:lstStyle/>
           <a:p>
             <a:pPr indent="0" marL="0">
               <a:buNone/>
             </a:pPr>
             <a:r>
-              <a:rPr lang="en-US" sz="1500" dirty="0">
-                <a:solidFill>
-                  <a:schemeClr val="accent4"/>
-                </a:solidFill>
-              </a:rPr>
-              <a:t>com cases reais de sucesso na estética e no empreendedorismo</a:t>
-            </a:r>
-            <a:endParaRPr lang="en-US" sz="1500" dirty="0"/>
-          </a:p>
-        </p:txBody>
-      </p:sp>
-      <p:sp>
-        <p:nvSpPr>
-          <p:cNvPr id="10" name="Item 3 título"/>
+              <a:rPr lang="en-US" sz="1800" b="1" dirty="0">
+                <a:solidFill>
+                  <a:schemeClr val="bg1"/>
+                </a:solidFill>
+              </a:rPr>
+              <a:t>Prática real e hands-on</a:t>
+            </a:r>
+            <a:endParaRPr lang="en-US" sz="1800" dirty="0"/>
+          </a:p>
+        </p:txBody>
+      </p:sp>
+      <p:sp>
+        <p:nvSpPr>
+          <p:cNvPr id="10" name="Miami texto"/>
           <p:cNvSpPr txBox="1"/>
           <p:nvPr/>
         </p:nvSpPr>
         <p:spPr>
           <a:xfrm>
-            <a:off x="640080" y="4617720"/>
-            <a:ext cx="6949440" cy="365760"/>
+            <a:off x="6656832" y="4160520"/>
+            <a:ext cx="4480560" cy="1188720"/>
           </a:xfrm>
           <a:prstGeom prst="rect">
             <a:avLst/>
@@ -3562,96 +3305,21 @@
           <a:ln/>
         </p:spPr>
         <p:txBody>
-          <a:bodyPr wrap="square" lIns="0" tIns="0" rIns="0" bIns="0" rtlCol="0" anchor="ctr"/>
+          <a:bodyPr wrap="square" lIns="0" tIns="0" rIns="0" bIns="0" rtlCol="0" anchor="t"/>
           <a:lstStyle/>
           <a:p>
             <a:pPr indent="0" marL="0">
               <a:buNone/>
             </a:pPr>
             <a:r>
-              <a:rPr lang="en-US" sz="2000" dirty="0">
+              <a:rPr lang="en-US" sz="1500" dirty="0">
                 <a:solidFill>
                   <a:schemeClr val="bg1"/>
                 </a:solidFill>
-                <a:latin typeface="Georgia" pitchFamily="34" charset="0"/>
-                <a:ea typeface="Georgia" pitchFamily="34" charset="-122"/>
-                <a:cs typeface="Georgia" pitchFamily="34" charset="-120"/>
-              </a:rPr>
-              <a:t>Palestrantes</a:t>
-            </a:r>
-            <a:endParaRPr lang="en-US" sz="2000" dirty="0"/>
-          </a:p>
-        </p:txBody>
-      </p:sp>
-      <p:sp>
-        <p:nvSpPr>
-          <p:cNvPr id="11" name="Item 3 texto"/>
-          <p:cNvSpPr txBox="1"/>
-          <p:nvPr/>
-        </p:nvSpPr>
-        <p:spPr>
-          <a:xfrm>
-            <a:off x="640080" y="5001768"/>
-            <a:ext cx="6949440" cy="411480"/>
-          </a:xfrm>
-          <a:prstGeom prst="rect">
-            <a:avLst/>
-          </a:prstGeom>
-          <a:noFill/>
-          <a:ln/>
-        </p:spPr>
-        <p:txBody>
-          <a:bodyPr wrap="square" lIns="0" tIns="0" rIns="0" bIns="0" rtlCol="0" anchor="ctr"/>
-          <a:lstStyle/>
-          <a:p>
-            <a:pPr indent="0" marL="0">
-              <a:buNone/>
-            </a:pPr>
-            <a:r>
-              <a:rPr lang="en-US" sz="1500" dirty="0">
-                <a:solidFill>
-                  <a:schemeClr val="accent4"/>
-                </a:solidFill>
-              </a:rPr>
-              <a:t>que atuam com carreira, posicionamento e autoridade</a:t>
+              </a:rPr>
+              <a:t>19, 20 e 21 de maio de 2027, em laboratório de specimen: anatomia aplicada e prática supervisionada dos procedimentos.</a:t>
             </a:r>
             <a:endParaRPr lang="en-US" sz="1500" dirty="0"/>
-          </a:p>
-        </p:txBody>
-      </p:sp>
-      <p:sp>
-        <p:nvSpPr>
-          <p:cNvPr id="12" name="Nota posicionamento"/>
-          <p:cNvSpPr txBox="1"/>
-          <p:nvPr/>
-        </p:nvSpPr>
-        <p:spPr>
-          <a:xfrm>
-            <a:off x="640080" y="5623560"/>
-            <a:ext cx="7132320" cy="457200"/>
-          </a:xfrm>
-          <a:prstGeom prst="rect">
-            <a:avLst/>
-          </a:prstGeom>
-          <a:noFill/>
-          <a:ln/>
-        </p:spPr>
-        <p:txBody>
-          <a:bodyPr wrap="square" lIns="0" tIns="0" rIns="0" bIns="0" rtlCol="0" anchor="ctr"/>
-          <a:lstStyle/>
-          <a:p>
-            <a:pPr indent="0" marL="0">
-              <a:buNone/>
-            </a:pPr>
-            <a:r>
-              <a:rPr lang="en-US" sz="1400" i="1" dirty="0">
-                <a:solidFill>
-                  <a:schemeClr val="tx2"/>
-                </a:solidFill>
-              </a:rPr>
-              <a:t>Um momento desenhado para troca de experiências, visão de mercado e conexões profissionais relevantes.</a:t>
-            </a:r>
-            <a:endParaRPr lang="en-US" sz="1400" dirty="0"/>
           </a:p>
         </p:txBody>
       </p:sp>
@@ -3728,50 +3396,9 @@
           <a:chExt cx="0" cy="0"/>
         </a:xfrm>
       </p:grpSpPr>
-      <p:sp>
-        <p:nvSpPr>
-          <p:cNvPr id="2" name="Text 0"/>
-          <p:cNvSpPr/>
-          <p:nvPr>
-            <p:ph idx="100" type="title" hasCustomPrompt="1"/>
-          </p:nvPr>
-        </p:nvSpPr>
-        <p:spPr>
-          <a:xfrm>
-            <a:off x="640080" y="868680"/>
-            <a:ext cx="10881360" cy="822960"/>
-          </a:xfrm>
-          <a:prstGeom prst="rect">
-            <a:avLst/>
-          </a:prstGeom>
-          <a:noFill/>
-          <a:ln/>
-        </p:spPr>
-        <p:txBody>
-          <a:bodyPr wrap="square" lIns="0" tIns="0" rIns="0" bIns="0" rtlCol="0" anchor="t"/>
-          <a:lstStyle/>
-          <a:p>
-            <a:pPr algn="l" indent="0" marL="0">
-              <a:buNone/>
-            </a:pPr>
-            <a:r>
-              <a:rPr lang="en-US" sz="3200" spc="200" kern="0" dirty="0">
-                <a:solidFill>
-                  <a:schemeClr val="bg1"/>
-                </a:solidFill>
-                <a:latin typeface="Georgia" pitchFamily="34" charset="0"/>
-                <a:ea typeface="Georgia" pitchFamily="34" charset="-122"/>
-                <a:cs typeface="Georgia" pitchFamily="34" charset="-120"/>
-              </a:rPr>
-              <a:t>O RESULTADO NA PRÁTICA</a:t>
-            </a:r>
-            <a:endParaRPr lang="en-US" sz="3200" dirty="0"/>
-          </a:p>
-        </p:txBody>
-      </p:sp>
       <p:pic>
         <p:nvPicPr>
-          <p:cNvPr id="3" name="Depoimento" descr="Mensagem de aluna: depois da Formação Internacional, converteu o valor do curso em menos de 2 meses com 2 pacientes">    </p:cNvPr>
+          <p:cNvPr id="2" name="Print Instagram" descr="Perfil @dra.rosanaa no Instagram, com 339 mil seguidores">    </p:cNvPr>
           <p:cNvPicPr>
             <a:picLocks noChangeAspect="1"/>
           </p:cNvPicPr>
@@ -3785,8 +3412,8 @@
         </p:blipFill>
         <p:spPr>
           <a:xfrm>
-            <a:off x="1984248" y="2194560"/>
-            <a:ext cx="8229600" cy="2468880"/>
+            <a:off x="8412480" y="548640"/>
+            <a:ext cx="3182112" cy="5477256"/>
           </a:xfrm>
           <a:prstGeom prst="rect">
             <a:avLst/>
@@ -3795,14 +3422,14 @@
       </p:pic>
       <p:sp>
         <p:nvSpPr>
-          <p:cNvPr id="4" name="Legenda depoimento"/>
+          <p:cNvPr id="3" name="Pré-título"/>
           <p:cNvSpPr txBox="1"/>
           <p:nvPr/>
         </p:nvSpPr>
         <p:spPr>
           <a:xfrm>
-            <a:off x="1984248" y="4892040"/>
-            <a:ext cx="8229600" cy="365760"/>
+            <a:off x="640080" y="411480"/>
+            <a:ext cx="6035040" cy="411480"/>
           </a:xfrm>
           <a:prstGeom prst="rect">
             <a:avLst/>
@@ -3818,14 +3445,355 @@
               <a:buNone/>
             </a:pPr>
             <a:r>
-              <a:rPr lang="en-US" sz="1300" i="1" dirty="0">
+              <a:rPr lang="en-US" sz="2000" spc="300" kern="0" dirty="0">
+                <a:solidFill>
+                  <a:schemeClr val="accent4"/>
+                </a:solidFill>
+                <a:latin typeface="Georgia" pitchFamily="34" charset="0"/>
+                <a:ea typeface="Georgia" pitchFamily="34" charset="-122"/>
+                <a:cs typeface="Georgia" pitchFamily="34" charset="-120"/>
+              </a:rPr>
+              <a:t>O poder do</a:t>
+            </a:r>
+            <a:endParaRPr lang="en-US" sz="2000" dirty="0"/>
+          </a:p>
+        </p:txBody>
+      </p:sp>
+      <p:sp>
+        <p:nvSpPr>
+          <p:cNvPr id="4" name="Text 0"/>
+          <p:cNvSpPr/>
+          <p:nvPr>
+            <p:ph idx="100" type="title" hasCustomPrompt="1"/>
+          </p:nvPr>
+        </p:nvSpPr>
+        <p:spPr>
+          <a:xfrm>
+            <a:off x="640080" y="868680"/>
+            <a:ext cx="10881360" cy="822960"/>
+          </a:xfrm>
+          <a:prstGeom prst="rect">
+            <a:avLst/>
+          </a:prstGeom>
+          <a:noFill/>
+          <a:ln/>
+        </p:spPr>
+        <p:txBody>
+          <a:bodyPr wrap="square" lIns="0" tIns="0" rIns="0" bIns="0" rtlCol="0" anchor="t"/>
+          <a:lstStyle/>
+          <a:p>
+            <a:pPr algn="l" indent="0" marL="0">
+              <a:buNone/>
+            </a:pPr>
+            <a:r>
+              <a:rPr lang="en-US" sz="3200" spc="200" kern="0" dirty="0">
+                <a:solidFill>
+                  <a:schemeClr val="bg1"/>
+                </a:solidFill>
+                <a:latin typeface="Georgia" pitchFamily="34" charset="0"/>
+                <a:ea typeface="Georgia" pitchFamily="34" charset="-122"/>
+                <a:cs typeface="Georgia" pitchFamily="34" charset="-120"/>
+              </a:rPr>
+              <a:t>POSICIONAMENTO</a:t>
+            </a:r>
+            <a:endParaRPr lang="en-US" sz="3200" dirty="0"/>
+          </a:p>
+        </p:txBody>
+      </p:sp>
+      <p:sp>
+        <p:nvSpPr>
+          <p:cNvPr id="5" name="Introdução posicionamento"/>
+          <p:cNvSpPr txBox="1"/>
+          <p:nvPr/>
+        </p:nvSpPr>
+        <p:spPr>
+          <a:xfrm>
+            <a:off x="640080" y="1920240"/>
+            <a:ext cx="6949440" cy="548640"/>
+          </a:xfrm>
+          <a:prstGeom prst="rect">
+            <a:avLst/>
+          </a:prstGeom>
+          <a:noFill/>
+          <a:ln/>
+        </p:spPr>
+        <p:txBody>
+          <a:bodyPr wrap="square" lIns="0" tIns="0" rIns="0" bIns="0" rtlCol="0" anchor="t"/>
+          <a:lstStyle/>
+          <a:p>
+            <a:pPr indent="0" marL="0">
+              <a:buNone/>
+            </a:pPr>
+            <a:r>
+              <a:rPr lang="en-US" sz="1600" dirty="0">
+                <a:solidFill>
+                  <a:schemeClr val="accent4"/>
+                </a:solidFill>
+              </a:rPr>
+              <a:t>Um programa realizado em Boston e Miami reúne, além do conteúdo técnico:</a:t>
+            </a:r>
+            <a:endParaRPr lang="en-US" sz="1600" dirty="0"/>
+          </a:p>
+        </p:txBody>
+      </p:sp>
+      <p:sp>
+        <p:nvSpPr>
+          <p:cNvPr id="6" name="Item 1 título"/>
+          <p:cNvSpPr txBox="1"/>
+          <p:nvPr/>
+        </p:nvSpPr>
+        <p:spPr>
+          <a:xfrm>
+            <a:off x="640080" y="2697480"/>
+            <a:ext cx="6949440" cy="365760"/>
+          </a:xfrm>
+          <a:prstGeom prst="rect">
+            <a:avLst/>
+          </a:prstGeom>
+          <a:noFill/>
+          <a:ln/>
+        </p:spPr>
+        <p:txBody>
+          <a:bodyPr wrap="square" lIns="0" tIns="0" rIns="0" bIns="0" rtlCol="0" anchor="ctr"/>
+          <a:lstStyle/>
+          <a:p>
+            <a:pPr indent="0" marL="0">
+              <a:buNone/>
+            </a:pPr>
+            <a:r>
+              <a:rPr lang="en-US" sz="2000" dirty="0">
+                <a:solidFill>
+                  <a:schemeClr val="bg1"/>
+                </a:solidFill>
+                <a:latin typeface="Georgia" pitchFamily="34" charset="0"/>
+                <a:ea typeface="Georgia" pitchFamily="34" charset="-122"/>
+                <a:cs typeface="Georgia" pitchFamily="34" charset="-120"/>
+              </a:rPr>
+              <a:t>Doutores da estética</a:t>
+            </a:r>
+            <a:endParaRPr lang="en-US" sz="2000" dirty="0"/>
+          </a:p>
+        </p:txBody>
+      </p:sp>
+      <p:sp>
+        <p:nvSpPr>
+          <p:cNvPr id="7" name="Item 1 texto"/>
+          <p:cNvSpPr txBox="1"/>
+          <p:nvPr/>
+        </p:nvSpPr>
+        <p:spPr>
+          <a:xfrm>
+            <a:off x="640080" y="3081528"/>
+            <a:ext cx="6949440" cy="411480"/>
+          </a:xfrm>
+          <a:prstGeom prst="rect">
+            <a:avLst/>
+          </a:prstGeom>
+          <a:noFill/>
+          <a:ln/>
+        </p:spPr>
+        <p:txBody>
+          <a:bodyPr wrap="square" lIns="0" tIns="0" rIns="0" bIns="0" rtlCol="0" anchor="ctr"/>
+          <a:lstStyle/>
+          <a:p>
+            <a:pPr indent="0" marL="0">
+              <a:buNone/>
+            </a:pPr>
+            <a:r>
+              <a:rPr lang="en-US" sz="1500" dirty="0">
+                <a:solidFill>
+                  <a:schemeClr val="accent4"/>
+                </a:solidFill>
+              </a:rPr>
+              <a:t>nacionais e internacionais</a:t>
+            </a:r>
+            <a:endParaRPr lang="en-US" sz="1500" dirty="0"/>
+          </a:p>
+        </p:txBody>
+      </p:sp>
+      <p:sp>
+        <p:nvSpPr>
+          <p:cNvPr id="8" name="Item 2 título"/>
+          <p:cNvSpPr txBox="1"/>
+          <p:nvPr/>
+        </p:nvSpPr>
+        <p:spPr>
+          <a:xfrm>
+            <a:off x="640080" y="3657600"/>
+            <a:ext cx="6949440" cy="365760"/>
+          </a:xfrm>
+          <a:prstGeom prst="rect">
+            <a:avLst/>
+          </a:prstGeom>
+          <a:noFill/>
+          <a:ln/>
+        </p:spPr>
+        <p:txBody>
+          <a:bodyPr wrap="square" lIns="0" tIns="0" rIns="0" bIns="0" rtlCol="0" anchor="ctr"/>
+          <a:lstStyle/>
+          <a:p>
+            <a:pPr indent="0" marL="0">
+              <a:buNone/>
+            </a:pPr>
+            <a:r>
+              <a:rPr lang="en-US" sz="2000" dirty="0">
+                <a:solidFill>
+                  <a:schemeClr val="bg1"/>
+                </a:solidFill>
+                <a:latin typeface="Georgia" pitchFamily="34" charset="0"/>
+                <a:ea typeface="Georgia" pitchFamily="34" charset="-122"/>
+                <a:cs typeface="Georgia" pitchFamily="34" charset="-120"/>
+              </a:rPr>
+              <a:t>Convidados</a:t>
+            </a:r>
+            <a:endParaRPr lang="en-US" sz="2000" dirty="0"/>
+          </a:p>
+        </p:txBody>
+      </p:sp>
+      <p:sp>
+        <p:nvSpPr>
+          <p:cNvPr id="9" name="Item 2 texto"/>
+          <p:cNvSpPr txBox="1"/>
+          <p:nvPr/>
+        </p:nvSpPr>
+        <p:spPr>
+          <a:xfrm>
+            <a:off x="640080" y="4041648"/>
+            <a:ext cx="6949440" cy="411480"/>
+          </a:xfrm>
+          <a:prstGeom prst="rect">
+            <a:avLst/>
+          </a:prstGeom>
+          <a:noFill/>
+          <a:ln/>
+        </p:spPr>
+        <p:txBody>
+          <a:bodyPr wrap="square" lIns="0" tIns="0" rIns="0" bIns="0" rtlCol="0" anchor="ctr"/>
+          <a:lstStyle/>
+          <a:p>
+            <a:pPr indent="0" marL="0">
+              <a:buNone/>
+            </a:pPr>
+            <a:r>
+              <a:rPr lang="en-US" sz="1500" dirty="0">
+                <a:solidFill>
+                  <a:schemeClr val="accent4"/>
+                </a:solidFill>
+              </a:rPr>
+              <a:t>com cases reais de sucesso na estética e no empreendedorismo</a:t>
+            </a:r>
+            <a:endParaRPr lang="en-US" sz="1500" dirty="0"/>
+          </a:p>
+        </p:txBody>
+      </p:sp>
+      <p:sp>
+        <p:nvSpPr>
+          <p:cNvPr id="10" name="Item 3 título"/>
+          <p:cNvSpPr txBox="1"/>
+          <p:nvPr/>
+        </p:nvSpPr>
+        <p:spPr>
+          <a:xfrm>
+            <a:off x="640080" y="4617720"/>
+            <a:ext cx="6949440" cy="365760"/>
+          </a:xfrm>
+          <a:prstGeom prst="rect">
+            <a:avLst/>
+          </a:prstGeom>
+          <a:noFill/>
+          <a:ln/>
+        </p:spPr>
+        <p:txBody>
+          <a:bodyPr wrap="square" lIns="0" tIns="0" rIns="0" bIns="0" rtlCol="0" anchor="ctr"/>
+          <a:lstStyle/>
+          <a:p>
+            <a:pPr indent="0" marL="0">
+              <a:buNone/>
+            </a:pPr>
+            <a:r>
+              <a:rPr lang="en-US" sz="2000" dirty="0">
+                <a:solidFill>
+                  <a:schemeClr val="bg1"/>
+                </a:solidFill>
+                <a:latin typeface="Georgia" pitchFamily="34" charset="0"/>
+                <a:ea typeface="Georgia" pitchFamily="34" charset="-122"/>
+                <a:cs typeface="Georgia" pitchFamily="34" charset="-120"/>
+              </a:rPr>
+              <a:t>Palestrantes</a:t>
+            </a:r>
+            <a:endParaRPr lang="en-US" sz="2000" dirty="0"/>
+          </a:p>
+        </p:txBody>
+      </p:sp>
+      <p:sp>
+        <p:nvSpPr>
+          <p:cNvPr id="11" name="Item 3 texto"/>
+          <p:cNvSpPr txBox="1"/>
+          <p:nvPr/>
+        </p:nvSpPr>
+        <p:spPr>
+          <a:xfrm>
+            <a:off x="640080" y="5001768"/>
+            <a:ext cx="6949440" cy="411480"/>
+          </a:xfrm>
+          <a:prstGeom prst="rect">
+            <a:avLst/>
+          </a:prstGeom>
+          <a:noFill/>
+          <a:ln/>
+        </p:spPr>
+        <p:txBody>
+          <a:bodyPr wrap="square" lIns="0" tIns="0" rIns="0" bIns="0" rtlCol="0" anchor="ctr"/>
+          <a:lstStyle/>
+          <a:p>
+            <a:pPr indent="0" marL="0">
+              <a:buNone/>
+            </a:pPr>
+            <a:r>
+              <a:rPr lang="en-US" sz="1500" dirty="0">
+                <a:solidFill>
+                  <a:schemeClr val="accent4"/>
+                </a:solidFill>
+              </a:rPr>
+              <a:t>que atuam com carreira, posicionamento e autoridade</a:t>
+            </a:r>
+            <a:endParaRPr lang="en-US" sz="1500" dirty="0"/>
+          </a:p>
+        </p:txBody>
+      </p:sp>
+      <p:sp>
+        <p:nvSpPr>
+          <p:cNvPr id="12" name="Nota posicionamento"/>
+          <p:cNvSpPr txBox="1"/>
+          <p:nvPr/>
+        </p:nvSpPr>
+        <p:spPr>
+          <a:xfrm>
+            <a:off x="640080" y="5623560"/>
+            <a:ext cx="7132320" cy="457200"/>
+          </a:xfrm>
+          <a:prstGeom prst="rect">
+            <a:avLst/>
+          </a:prstGeom>
+          <a:noFill/>
+          <a:ln/>
+        </p:spPr>
+        <p:txBody>
+          <a:bodyPr wrap="square" lIns="0" tIns="0" rIns="0" bIns="0" rtlCol="0" anchor="ctr"/>
+          <a:lstStyle/>
+          <a:p>
+            <a:pPr indent="0" marL="0">
+              <a:buNone/>
+            </a:pPr>
+            <a:r>
+              <a:rPr lang="en-US" sz="1400" i="1" dirty="0">
                 <a:solidFill>
                   <a:schemeClr val="tx2"/>
                 </a:solidFill>
               </a:rPr>
-              <a:t>Relato de aluna da Formação Internacional, enviado no grupo da turma.</a:t>
-            </a:r>
-            <a:endParaRPr lang="en-US" sz="1300" dirty="0"/>
+              <a:t>Um momento desenhado para troca de experiências, visão de mercado e conexões profissionais relevantes.</a:t>
+            </a:r>
+            <a:endParaRPr lang="en-US" sz="1400" dirty="0"/>
           </a:p>
         </p:txBody>
       </p:sp>
@@ -3888,6 +3856,180 @@
 <file path=ppt/slides/slide8.xml><?xml version="1.0" encoding="utf-8"?>
 <p:sld xmlns:a="http://schemas.openxmlformats.org/drawingml/2006/main" xmlns:r="http://schemas.openxmlformats.org/officeDocument/2006/relationships" xmlns:p="http://schemas.openxmlformats.org/presentationml/2006/main">
   <p:cSld name="Slide 8">
+    <p:spTree>
+      <p:nvGrpSpPr>
+        <p:cNvPr id="1" name=""/>
+        <p:cNvGrpSpPr/>
+        <p:nvPr/>
+      </p:nvGrpSpPr>
+      <p:grpSpPr>
+        <a:xfrm>
+          <a:off x="0" y="0"/>
+          <a:ext cx="0" cy="0"/>
+          <a:chOff x="0" y="0"/>
+          <a:chExt cx="0" cy="0"/>
+        </a:xfrm>
+      </p:grpSpPr>
+      <p:sp>
+        <p:nvSpPr>
+          <p:cNvPr id="2" name="Text 0"/>
+          <p:cNvSpPr/>
+          <p:nvPr>
+            <p:ph idx="100" type="title" hasCustomPrompt="1"/>
+          </p:nvPr>
+        </p:nvSpPr>
+        <p:spPr>
+          <a:xfrm>
+            <a:off x="640080" y="868680"/>
+            <a:ext cx="10881360" cy="822960"/>
+          </a:xfrm>
+          <a:prstGeom prst="rect">
+            <a:avLst/>
+          </a:prstGeom>
+          <a:noFill/>
+          <a:ln/>
+        </p:spPr>
+        <p:txBody>
+          <a:bodyPr wrap="square" lIns="0" tIns="0" rIns="0" bIns="0" rtlCol="0" anchor="t"/>
+          <a:lstStyle/>
+          <a:p>
+            <a:pPr algn="l" indent="0" marL="0">
+              <a:buNone/>
+            </a:pPr>
+            <a:r>
+              <a:rPr lang="en-US" sz="3200" spc="200" kern="0" dirty="0">
+                <a:solidFill>
+                  <a:schemeClr val="bg1"/>
+                </a:solidFill>
+                <a:latin typeface="Georgia" pitchFamily="34" charset="0"/>
+                <a:ea typeface="Georgia" pitchFamily="34" charset="-122"/>
+                <a:cs typeface="Georgia" pitchFamily="34" charset="-120"/>
+              </a:rPr>
+              <a:t>O RESULTADO NA PRÁTICA</a:t>
+            </a:r>
+            <a:endParaRPr lang="en-US" sz="3200" dirty="0"/>
+          </a:p>
+        </p:txBody>
+      </p:sp>
+      <p:pic>
+        <p:nvPicPr>
+          <p:cNvPr id="3" name="Depoimento" descr="Mensagem de aluna: depois da Formação Internacional, converteu o valor do curso em menos de 2 meses com 2 pacientes">    </p:cNvPr>
+          <p:cNvPicPr>
+            <a:picLocks noChangeAspect="1"/>
+          </p:cNvPicPr>
+          <p:nvPr/>
+        </p:nvPicPr>
+        <p:blipFill>
+          <a:blip r:embed="rId1"/>
+          <a:stretch>
+            <a:fillRect/>
+          </a:stretch>
+        </p:blipFill>
+        <p:spPr>
+          <a:xfrm>
+            <a:off x="1984248" y="2194560"/>
+            <a:ext cx="8229600" cy="2468880"/>
+          </a:xfrm>
+          <a:prstGeom prst="rect">
+            <a:avLst/>
+          </a:prstGeom>
+        </p:spPr>
+      </p:pic>
+      <p:sp>
+        <p:nvSpPr>
+          <p:cNvPr id="4" name="Legenda depoimento"/>
+          <p:cNvSpPr txBox="1"/>
+          <p:nvPr/>
+        </p:nvSpPr>
+        <p:spPr>
+          <a:xfrm>
+            <a:off x="1984248" y="4892040"/>
+            <a:ext cx="8229600" cy="365760"/>
+          </a:xfrm>
+          <a:prstGeom prst="rect">
+            <a:avLst/>
+          </a:prstGeom>
+          <a:noFill/>
+          <a:ln/>
+        </p:spPr>
+        <p:txBody>
+          <a:bodyPr wrap="square" lIns="0" tIns="0" rIns="0" bIns="0" rtlCol="0" anchor="ctr"/>
+          <a:lstStyle/>
+          <a:p>
+            <a:pPr indent="0" marL="0">
+              <a:buNone/>
+            </a:pPr>
+            <a:r>
+              <a:rPr lang="en-US" sz="1300" i="1" dirty="0">
+                <a:solidFill>
+                  <a:schemeClr val="tx2"/>
+                </a:solidFill>
+              </a:rPr>
+              <a:t>Relato de aluna da Formação Internacional, enviado no grupo da turma.</a:t>
+            </a:r>
+            <a:endParaRPr lang="en-US" sz="1300" dirty="0"/>
+          </a:p>
+        </p:txBody>
+      </p:sp>
+      <p:sp>
+        <p:nvSpPr>
+          <p:cNvPr id="25" name="Slide Number Placeholder 0"/>
+          <p:cNvSpPr>
+            <a:spLocks noGrp="1"/>
+          </p:cNvSpPr>
+          <p:nvPr>
+            <p:ph type="sldNum" sz="quarter" idx="4294967295"/>
+          </p:nvPr>
+        </p:nvSpPr>
+        <p:spPr>
+          <a:xfrm>
+            <a:off x="11155680" y="6355080"/>
+            <a:ext cx="411480" cy="274320"/>
+          </a:xfrm>
+          <a:prstGeom prst="rect">
+            <a:avLst/>
+          </a:prstGeom>
+          <a:extLst>
+            <a:ext uri="{C572A759-6A51-4108-AA02-DFA0A04FC94B}">
+              <ma14:wrappingTextBoxFlag xmlns:ma14="http://schemas.microsoft.com/office/mac/drawingml/2011/main" val="0"/>
+            </a:ext>
+          </a:extLst>
+        </p:spPr>
+        <p:txBody>
+          <a:bodyPr/>
+          <a:lstStyle>
+            <a:lvl1pPr>
+              <a:defRPr sz="900">
+                <a:solidFill>
+                  <a:schemeClr val="tx2"/>
+                </a:solidFill>
+              </a:defRPr>
+            </a:lvl1pPr>
+          </a:lstStyle>
+          <a:p>
+            <a:pPr algn="r"/>
+            <a:fld id="{F7021451-1387-4CA6-816F-3879F97B5CBC}" type="slidenum">
+              <a:rPr b="0" lang="en-US"/>
+              <a:t>8</a:t>
+            </a:fld>
+            <a:endParaRPr lang="en-US"/>
+          </a:p>
+        </p:txBody>
+      </p:sp>
+    </p:spTree>
+  </p:cSld>
+  <p:clrMapOvr>
+    <a:masterClrMapping/>
+  </p:clrMapOvr>
+  <p:transition spd="slow">
+    <p:fade/>
+  </p:transition>
+</p:sld>
+</file>
+
+<file path=ppt/slides/slide9.xml><?xml version="1.0" encoding="utf-8"?>
+<p:sld xmlns:a="http://schemas.openxmlformats.org/drawingml/2006/main" xmlns:r="http://schemas.openxmlformats.org/officeDocument/2006/relationships" xmlns:p="http://schemas.openxmlformats.org/presentationml/2006/main">
+  <p:cSld name="Slide 9">
     <p:spTree>
       <p:nvGrpSpPr>
         <p:cNvPr id="1" name=""/>

</xml_diff>

<commit_message>
Etapa Miami: adiciona slide com a foto da turma
Co-Authored-By: Claude Opus 5.5 <noreply@anthropic.com>
Claude-Session: https://claude.ai/code/session_01ETjDEHo1Y5Ziwi4pumEH8K
</commit_message>
<xml_diff>
--- a/entregas/Formacao-Internacional-Etapa-Miami.pptx
+++ b/entregas/Formacao-Internacional-Etapa-Miami.pptx
@@ -14,9 +14,10 @@
     <p:sldId id="262" r:id="rId8"/>
     <p:sldId id="263" r:id="rId9"/>
     <p:sldId id="264" r:id="rId10"/>
+    <p:sldId id="265" r:id="rId11"/>
   </p:sldIdLst>
   <p:notesMasterIdLst>
-    <p:notesMasterId r:id="rId11"/>
+    <p:notesMasterId r:id="rId12"/>
   </p:notesMasterIdLst>
   <p:sldSz cx="12192000" cy="6858000"/>
   <p:notesSz cx="6858000" cy="12192000"/>
@@ -115,29 +116,30 @@
   <p:extLst>
     <p:ext uri="{521415D9-36F7-43E2-AB2F-B90AF26B5E84}">
       <p14:sectionLst xmlns:p14="http://schemas.microsoft.com/office/powerpoint/2010/main">
-        <p14:section name="Abertura" id="{4b93c789-8ed5-0905-4585-63de3f987281}">
+        <p14:section name="Abertura" id="{0263382f-3e44-32ef-df8c-44d5ba2547cc}">
           <p14:sldIdLst>
             <p14:sldId id="256"/>
             <p14:sldId id="257"/>
             <p14:sldId id="258"/>
           </p14:sldIdLst>
         </p14:section>
-        <p14:section name="A etapa" id="{849ba996-f47f-d457-5e2b-f91978078b64}">
+        <p14:section name="A etapa" id="{cdec921f-a21a-86f1-21f6-9e8ceff42764}">
           <p14:sldIdLst>
             <p14:sldId id="259"/>
             <p14:sldId id="260"/>
             <p14:sldId id="261"/>
           </p14:sldIdLst>
         </p14:section>
-        <p14:section name="Pessoas" id="{adc3deab-adc3-d559-1723-f3b2dd93203f}">
+        <p14:section name="Pessoas" id="{7ba98e77-765d-1a48-8ce3-7898d80fa773}">
           <p14:sldIdLst>
             <p14:sldId id="262"/>
             <p14:sldId id="263"/>
+            <p14:sldId id="264"/>
           </p14:sldIdLst>
         </p14:section>
-        <p14:section name="Inscrição" id="{6f716db8-faa2-e884-da9c-3f0db4394956}">
+        <p14:section name="Inscrição" id="{d0544a75-e3e1-f894-360a-37270c204646}">
           <p14:sldIdLst>
-            <p14:sldId id="264"/>
+            <p14:sldId id="265"/>
           </p14:sldIdLst>
         </p14:section>
       </p14:sectionLst>
@@ -586,6 +588,94 @@
 </p:notes>
 </file>
 
+<file path=ppt/notesSlides/notesSlide10.xml><?xml version="1.0" encoding="utf-8"?>
+<p:notes xmlns:a="http://schemas.openxmlformats.org/drawingml/2006/main" xmlns:r="http://schemas.openxmlformats.org/officeDocument/2006/relationships" xmlns:p="http://schemas.openxmlformats.org/presentationml/2006/main">
+  <p:cSld>
+    <p:spTree>
+      <p:nvGrpSpPr>
+        <p:cNvPr id="1" name=""/>
+        <p:cNvGrpSpPr/>
+        <p:nvPr/>
+      </p:nvGrpSpPr>
+      <p:grpSpPr>
+        <a:xfrm>
+          <a:off x="0" y="0"/>
+          <a:ext cx="0" cy="0"/>
+          <a:chOff x="0" y="0"/>
+          <a:chExt cx="0" cy="0"/>
+        </a:xfrm>
+      </p:grpSpPr>
+      <p:sp>
+        <p:nvSpPr>
+          <p:cNvPr id="2" name="Slide Image Placeholder 1"/>
+          <p:cNvSpPr>
+            <a:spLocks noGrp="1" noRot="1" noChangeAspect="1"/>
+          </p:cNvSpPr>
+          <p:nvPr>
+            <p:ph type="sldImg"/>
+          </p:nvPr>
+        </p:nvSpPr>
+        <p:spPr/>
+      </p:sp>
+      <p:sp>
+        <p:nvSpPr>
+          <p:cNvPr id="3" name="Notes Placeholder 2"/>
+          <p:cNvSpPr>
+            <a:spLocks noGrp="1"/>
+          </p:cNvSpPr>
+          <p:nvPr>
+            <p:ph type="body" idx="1"/>
+          </p:nvPr>
+        </p:nvSpPr>
+        <p:spPr/>
+        <p:txBody>
+          <a:bodyPr/>
+          <a:lstStyle/>
+          <a:p>
+            <a:r>
+              <a:rPr lang="en-US" dirty="0"/>
+              <a:t>O QR code e o número abrem o WhatsApp (62) 98515-0061 com a mensagem pronta: Olá, quero saber mais do Programa de Formação Internacional.</a:t>
+            </a:r>
+            <a:endParaRPr lang="en-US" dirty="0"/>
+          </a:p>
+        </p:txBody>
+      </p:sp>
+      <p:sp>
+        <p:nvSpPr>
+          <p:cNvPr id="4" name="Slide Number Placeholder 3"/>
+          <p:cNvSpPr>
+            <a:spLocks noGrp="1"/>
+          </p:cNvSpPr>
+          <p:nvPr>
+            <p:ph type="sldNum" sz="quarter" idx="10"/>
+          </p:nvPr>
+        </p:nvSpPr>
+        <p:spPr/>
+        <p:txBody>
+          <a:bodyPr/>
+          <a:lstStyle/>
+          <a:p>
+            <a:fld id="{F7021451-1387-4CA6-816F-3879F97B5CBC}" type="slidenum">
+              <a:rPr lang="en-US"/>
+              <a:t>10</a:t>
+            </a:fld>
+            <a:endParaRPr lang="en-US"/>
+          </a:p>
+        </p:txBody>
+      </p:sp>
+    </p:spTree>
+    <p:extLst>
+      <p:ext uri="{BB962C8B-B14F-4D97-AF65-F5344CB8AC3E}">
+        <p14:creationId xmlns:p14="http://schemas.microsoft.com/office/powerpoint/2010/main" val="1024086991"/>
+      </p:ext>
+    </p:extLst>
+  </p:cSld>
+  <p:clrMapOvr>
+    <a:masterClrMapping/>
+  </p:clrMapOvr>
+</p:notes>
+</file>
+
 <file path=ppt/notesSlides/notesSlide2.xml><?xml version="1.0" encoding="utf-8"?>
 <p:notes xmlns:a="http://schemas.openxmlformats.org/drawingml/2006/main" xmlns:r="http://schemas.openxmlformats.org/officeDocument/2006/relationships" xmlns:p="http://schemas.openxmlformats.org/presentationml/2006/main">
   <p:cSld>
@@ -1160,7 +1250,7 @@
           <a:p>
             <a:r>
               <a:rPr lang="en-US" dirty="0"/>
-              <a:t>Confirme que a aluna autorizou o uso do relato antes de divulgar este material fora da turma.</a:t>
+              <a:t>Confirme a turma e o evento da foto. Antes de divulgar fora da turma, garanta a autorização de uso de imagem das pessoas que aparecem.</a:t>
             </a:r>
             <a:endParaRPr lang="en-US" dirty="0"/>
           </a:p>
@@ -1248,7 +1338,7 @@
           <a:p>
             <a:r>
               <a:rPr lang="en-US" dirty="0"/>
-              <a:t>O QR code e o número abrem o WhatsApp (62) 98515-0061 com a mensagem pronta: Olá, quero saber mais do Programa de Formação Internacional.</a:t>
+              <a:t>Confirme que a aluna autorizou o uso do relato antes de divulgar este material fora da turma.</a:t>
             </a:r>
             <a:endParaRPr lang="en-US" dirty="0"/>
           </a:p>
@@ -1858,6 +1948,398 @@
 </p:sld>
 </file>
 
+<file path=ppt/slides/slide10.xml><?xml version="1.0" encoding="utf-8"?>
+<p:sld xmlns:a="http://schemas.openxmlformats.org/drawingml/2006/main" xmlns:r="http://schemas.openxmlformats.org/officeDocument/2006/relationships" xmlns:p="http://schemas.openxmlformats.org/presentationml/2006/main">
+  <p:cSld name="Slide 10">
+    <p:spTree>
+      <p:nvGrpSpPr>
+        <p:cNvPr id="1" name=""/>
+        <p:cNvGrpSpPr/>
+        <p:nvPr/>
+      </p:nvGrpSpPr>
+      <p:grpSpPr>
+        <a:xfrm>
+          <a:off x="0" y="0"/>
+          <a:ext cx="0" cy="0"/>
+          <a:chOff x="0" y="0"/>
+          <a:chExt cx="0" cy="0"/>
+        </a:xfrm>
+      </p:grpSpPr>
+      <p:pic>
+        <p:nvPicPr>
+          <p:cNvPr id="2" name="Bandeira" descr="Bandeira dos Estados Unidos tremulando">    </p:cNvPr>
+          <p:cNvPicPr>
+            <a:picLocks noChangeAspect="1"/>
+          </p:cNvPicPr>
+          <p:nvPr/>
+        </p:nvPicPr>
+        <p:blipFill>
+          <a:blip r:embed="rId1"/>
+          <a:stretch>
+            <a:fillRect/>
+          </a:stretch>
+        </p:blipFill>
+        <p:spPr>
+          <a:xfrm>
+            <a:off x="9006840" y="228600"/>
+            <a:ext cx="2743200" cy="1828800"/>
+          </a:xfrm>
+          <a:prstGeom prst="rect">
+            <a:avLst/>
+          </a:prstGeom>
+        </p:spPr>
+      </p:pic>
+      <p:pic>
+        <p:nvPicPr>
+          <p:cNvPr id="3" name="QR code WhatsApp" descr="QR code que abre o WhatsApp (62) 98515-0061 com a mensagem: Olá, quero saber mais do Programa de Formação Internacional">
+            <a:hlinkClick r:id="rId3" tooltip="Falar no WhatsApp"/>
+          </p:cNvPr>
+          <p:cNvPicPr>
+            <a:picLocks noChangeAspect="1"/>
+          </p:cNvPicPr>
+          <p:nvPr/>
+        </p:nvPicPr>
+        <p:blipFill>
+          <a:blip r:embed="rId2"/>
+          <a:stretch>
+            <a:fillRect/>
+          </a:stretch>
+        </p:blipFill>
+        <p:spPr>
+          <a:xfrm>
+            <a:off x="8549640" y="2240280"/>
+            <a:ext cx="2743200" cy="2743200"/>
+          </a:xfrm>
+          <a:prstGeom prst="rect">
+            <a:avLst/>
+          </a:prstGeom>
+        </p:spPr>
+      </p:pic>
+      <p:sp>
+        <p:nvSpPr>
+          <p:cNvPr id="4" name="Legenda QR"/>
+          <p:cNvSpPr txBox="1"/>
+          <p:nvPr/>
+        </p:nvSpPr>
+        <p:spPr>
+          <a:xfrm>
+            <a:off x="8549640" y="5120640"/>
+            <a:ext cx="2743200" cy="548640"/>
+          </a:xfrm>
+          <a:prstGeom prst="rect">
+            <a:avLst/>
+          </a:prstGeom>
+          <a:noFill/>
+          <a:ln/>
+        </p:spPr>
+        <p:txBody>
+          <a:bodyPr wrap="square" lIns="0" tIns="0" rIns="0" bIns="0" rtlCol="0" anchor="t"/>
+          <a:lstStyle/>
+          <a:p>
+            <a:pPr algn="ctr" indent="0" marL="0">
+              <a:buNone/>
+            </a:pPr>
+            <a:r>
+              <a:rPr lang="en-US" sz="1200" dirty="0">
+                <a:solidFill>
+                  <a:schemeClr val="accent4"/>
+                </a:solidFill>
+              </a:rPr>
+              <a:t>Aponte a câmera do celular para falar com a equipe no WhatsApp</a:t>
+            </a:r>
+            <a:endParaRPr lang="en-US" sz="1200" dirty="0"/>
+          </a:p>
+        </p:txBody>
+      </p:sp>
+      <p:sp>
+        <p:nvSpPr>
+          <p:cNvPr id="5" name="Rótulo final"/>
+          <p:cNvSpPr txBox="1"/>
+          <p:nvPr/>
+        </p:nvSpPr>
+        <p:spPr>
+          <a:xfrm>
+            <a:off x="640080" y="1188720"/>
+            <a:ext cx="5943600" cy="411480"/>
+          </a:xfrm>
+          <a:prstGeom prst="rect">
+            <a:avLst/>
+          </a:prstGeom>
+          <a:noFill/>
+          <a:ln/>
+        </p:spPr>
+        <p:txBody>
+          <a:bodyPr wrap="square" lIns="0" tIns="0" rIns="0" bIns="0" rtlCol="0" anchor="ctr"/>
+          <a:lstStyle/>
+          <a:p>
+            <a:pPr indent="0" marL="0">
+              <a:buNone/>
+            </a:pPr>
+            <a:r>
+              <a:rPr lang="en-US" sz="2000" spc="300" kern="0" dirty="0">
+                <a:solidFill>
+                  <a:schemeClr val="accent4"/>
+                </a:solidFill>
+                <a:latin typeface="Georgia" pitchFamily="34" charset="0"/>
+                <a:ea typeface="Georgia" pitchFamily="34" charset="-122"/>
+                <a:cs typeface="Georgia" pitchFamily="34" charset="-120"/>
+              </a:rPr>
+              <a:t>Etapa de Miami</a:t>
+            </a:r>
+            <a:endParaRPr lang="en-US" sz="2000" dirty="0"/>
+          </a:p>
+        </p:txBody>
+      </p:sp>
+      <p:sp>
+        <p:nvSpPr>
+          <p:cNvPr id="6" name="Chamada"/>
+          <p:cNvSpPr txBox="1"/>
+          <p:nvPr/>
+        </p:nvSpPr>
+        <p:spPr>
+          <a:xfrm>
+            <a:off x="640080" y="1783080"/>
+            <a:ext cx="6400800" cy="1097280"/>
+          </a:xfrm>
+          <a:prstGeom prst="rect">
+            <a:avLst/>
+          </a:prstGeom>
+          <a:noFill/>
+          <a:ln/>
+        </p:spPr>
+        <p:txBody>
+          <a:bodyPr wrap="square" lIns="0" tIns="0" rIns="0" bIns="0" rtlCol="0" anchor="ctr"/>
+          <a:lstStyle/>
+          <a:p>
+            <a:pPr indent="0" marL="0">
+              <a:buNone/>
+            </a:pPr>
+            <a:r>
+              <a:rPr lang="en-US" sz="5400" dirty="0">
+                <a:solidFill>
+                  <a:schemeClr val="bg1"/>
+                </a:solidFill>
+                <a:latin typeface="Georgia" pitchFamily="34" charset="0"/>
+                <a:ea typeface="Georgia" pitchFamily="34" charset="-122"/>
+                <a:cs typeface="Georgia" pitchFamily="34" charset="-120"/>
+              </a:rPr>
+              <a:t>Garanta sua vaga</a:t>
+            </a:r>
+            <a:endParaRPr lang="en-US" sz="5400" dirty="0"/>
+          </a:p>
+        </p:txBody>
+      </p:sp>
+      <p:sp>
+        <p:nvSpPr>
+          <p:cNvPr id="7" name="Data final"/>
+          <p:cNvSpPr txBox="1"/>
+          <p:nvPr/>
+        </p:nvSpPr>
+        <p:spPr>
+          <a:xfrm>
+            <a:off x="640080" y="2971800"/>
+            <a:ext cx="5943600" cy="457200"/>
+          </a:xfrm>
+          <a:prstGeom prst="rect">
+            <a:avLst/>
+          </a:prstGeom>
+          <a:noFill/>
+          <a:ln/>
+        </p:spPr>
+        <p:txBody>
+          <a:bodyPr wrap="square" lIns="0" tIns="0" rIns="0" bIns="0" rtlCol="0" anchor="ctr"/>
+          <a:lstStyle/>
+          <a:p>
+            <a:pPr indent="0" marL="0">
+              <a:buNone/>
+            </a:pPr>
+            <a:r>
+              <a:rPr lang="en-US" sz="2400" dirty="0">
+                <a:solidFill>
+                  <a:schemeClr val="bg1"/>
+                </a:solidFill>
+                <a:latin typeface="Georgia" pitchFamily="34" charset="0"/>
+                <a:ea typeface="Georgia" pitchFamily="34" charset="-122"/>
+                <a:cs typeface="Georgia" pitchFamily="34" charset="-120"/>
+              </a:rPr>
+              <a:t>19, 20 e 21 de maio de 2027</a:t>
+            </a:r>
+            <a:endParaRPr lang="en-US" sz="2400" dirty="0"/>
+          </a:p>
+        </p:txBody>
+      </p:sp>
+      <p:sp>
+        <p:nvSpPr>
+          <p:cNvPr id="8" name="Texto final"/>
+          <p:cNvSpPr txBox="1"/>
+          <p:nvPr/>
+        </p:nvSpPr>
+        <p:spPr>
+          <a:xfrm>
+            <a:off x="640080" y="3520440"/>
+            <a:ext cx="5943600" cy="365760"/>
+          </a:xfrm>
+          <a:prstGeom prst="rect">
+            <a:avLst/>
+          </a:prstGeom>
+          <a:noFill/>
+          <a:ln/>
+        </p:spPr>
+        <p:txBody>
+          <a:bodyPr wrap="square" lIns="0" tIns="0" rIns="0" bIns="0" rtlCol="0" anchor="ctr"/>
+          <a:lstStyle/>
+          <a:p>
+            <a:pPr indent="0" marL="0">
+              <a:buNone/>
+            </a:pPr>
+            <a:r>
+              <a:rPr lang="en-US" sz="1600" dirty="0">
+                <a:solidFill>
+                  <a:schemeClr val="accent4"/>
+                </a:solidFill>
+              </a:rPr>
+              <a:t>Vagas e investimento com a nossa equipe.</a:t>
+            </a:r>
+            <a:endParaRPr lang="en-US" sz="1600" dirty="0"/>
+          </a:p>
+        </p:txBody>
+      </p:sp>
+      <p:sp>
+        <p:nvSpPr>
+          <p:cNvPr id="9" name="Instagram"/>
+          <p:cNvSpPr txBox="1"/>
+          <p:nvPr/>
+        </p:nvSpPr>
+        <p:spPr>
+          <a:xfrm>
+            <a:off x="640080" y="4251960"/>
+            <a:ext cx="5486400" cy="457200"/>
+          </a:xfrm>
+          <a:prstGeom prst="rect">
+            <a:avLst/>
+          </a:prstGeom>
+          <a:noFill/>
+          <a:ln/>
+        </p:spPr>
+        <p:txBody>
+          <a:bodyPr wrap="square" lIns="0" tIns="0" rIns="0" bIns="0" rtlCol="0" anchor="ctr"/>
+          <a:lstStyle/>
+          <a:p>
+            <a:pPr indent="0" marL="0">
+              <a:buNone/>
+            </a:pPr>
+            <a:r>
+              <a:rPr lang="en-US" sz="1600" dirty="0">
+                <a:solidFill>
+                  <a:schemeClr val="tx2"/>
+                </a:solidFill>
+              </a:rPr>
+              <a:t>Instagram   </a:t>
+            </a:r>
+            <a:pPr indent="0" marL="0">
+              <a:buNone/>
+            </a:pPr>
+            <a:r>
+              <a:rPr lang="en-US" sz="2000" dirty="0">
+                <a:solidFill>
+                  <a:schemeClr val="bg1"/>
+                </a:solidFill>
+              </a:rPr>
+              <a:t>@dra.rosanaa</a:t>
+            </a:r>
+            <a:endParaRPr lang="en-US" sz="1600" dirty="0"/>
+          </a:p>
+        </p:txBody>
+      </p:sp>
+      <p:sp>
+        <p:nvSpPr>
+          <p:cNvPr id="10" name="WhatsApp"/>
+          <p:cNvSpPr txBox="1"/>
+          <p:nvPr/>
+        </p:nvSpPr>
+        <p:spPr>
+          <a:xfrm>
+            <a:off x="640080" y="4754880"/>
+            <a:ext cx="5486400" cy="457200"/>
+          </a:xfrm>
+          <a:prstGeom prst="rect">
+            <a:avLst/>
+          </a:prstGeom>
+          <a:noFill/>
+          <a:ln/>
+        </p:spPr>
+        <p:txBody>
+          <a:bodyPr wrap="square" lIns="0" tIns="0" rIns="0" bIns="0" rtlCol="0" anchor="ctr"/>
+          <a:lstStyle/>
+          <a:p>
+            <a:pPr indent="0" marL="0">
+              <a:buNone/>
+            </a:pPr>
+            <a:r>
+              <a:rPr lang="en-US" sz="1600" dirty="0">
+                <a:solidFill>
+                  <a:schemeClr val="tx2"/>
+                </a:solidFill>
+              </a:rPr>
+              <a:t>WhatsApp   </a:t>
+            </a:r>
+            <a:pPr indent="0" marL="0">
+              <a:buNone/>
+            </a:pPr>
+            <a:r>
+              <a:rPr lang="en-US" sz="2000" u="sng" dirty="0">
+                <a:solidFill>
+                  <a:schemeClr val="bg1"/>
+                </a:solidFill>
+                <a:hlinkClick r:id="rId4" invalidUrl="" action="" tgtFrame="" tooltip="Falar no WhatsApp" history="1" highlightClick="0" endSnd="0">
+                  <a:extLst>
+                    <a:ext uri="{A12FA001-AC4F-418D-AE19-62706E023703}">
+                      <ahyp:hlinkClr xmlns:ahyp="http://schemas.microsoft.com/office/drawing/2018/hyperlinkcolor" val="tx"/>
+                    </a:ext>
+                  </a:extLst>
+                </a:hlinkClick>
+              </a:rPr>
+              <a:t>(62) 98515-0061</a:t>
+            </a:r>
+            <a:endParaRPr lang="en-US" sz="1600" dirty="0"/>
+          </a:p>
+        </p:txBody>
+      </p:sp>
+      <p:pic>
+        <p:nvPicPr>
+          <p:cNvPr id="11" name="Logo" descr="Logo Dra. Rosana Vecchi Caldas">    </p:cNvPr>
+          <p:cNvPicPr>
+            <a:picLocks noChangeAspect="1"/>
+          </p:cNvPicPr>
+          <p:nvPr/>
+        </p:nvPicPr>
+        <p:blipFill>
+          <a:blip r:embed="rId5"/>
+          <a:stretch>
+            <a:fillRect/>
+          </a:stretch>
+        </p:blipFill>
+        <p:spPr>
+          <a:xfrm>
+            <a:off x="548640" y="5486400"/>
+            <a:ext cx="1051560" cy="1051560"/>
+          </a:xfrm>
+          <a:prstGeom prst="rect">
+            <a:avLst/>
+          </a:prstGeom>
+        </p:spPr>
+      </p:pic>
+    </p:spTree>
+  </p:cSld>
+  <p:clrMapOvr>
+    <a:masterClrMapping/>
+  </p:clrMapOvr>
+  <p:transition spd="slow">
+    <p:fade/>
+  </p:transition>
+</p:sld>
+</file>
+
 <file path=ppt/slides/slide2.xml><?xml version="1.0" encoding="utf-8"?>
 <p:sld xmlns:a="http://schemas.openxmlformats.org/drawingml/2006/main" xmlns:r="http://schemas.openxmlformats.org/officeDocument/2006/relationships" xmlns:p="http://schemas.openxmlformats.org/presentationml/2006/main">
   <p:cSld name="Slide 2">
@@ -3870,50 +4352,9 @@
           <a:chExt cx="0" cy="0"/>
         </a:xfrm>
       </p:grpSpPr>
-      <p:sp>
-        <p:nvSpPr>
-          <p:cNvPr id="2" name="Text 0"/>
-          <p:cNvSpPr/>
-          <p:nvPr>
-            <p:ph idx="100" type="title" hasCustomPrompt="1"/>
-          </p:nvPr>
-        </p:nvSpPr>
-        <p:spPr>
-          <a:xfrm>
-            <a:off x="640080" y="868680"/>
-            <a:ext cx="10881360" cy="822960"/>
-          </a:xfrm>
-          <a:prstGeom prst="rect">
-            <a:avLst/>
-          </a:prstGeom>
-          <a:noFill/>
-          <a:ln/>
-        </p:spPr>
-        <p:txBody>
-          <a:bodyPr wrap="square" lIns="0" tIns="0" rIns="0" bIns="0" rtlCol="0" anchor="t"/>
-          <a:lstStyle/>
-          <a:p>
-            <a:pPr algn="l" indent="0" marL="0">
-              <a:buNone/>
-            </a:pPr>
-            <a:r>
-              <a:rPr lang="en-US" sz="3200" spc="200" kern="0" dirty="0">
-                <a:solidFill>
-                  <a:schemeClr val="bg1"/>
-                </a:solidFill>
-                <a:latin typeface="Georgia" pitchFamily="34" charset="0"/>
-                <a:ea typeface="Georgia" pitchFamily="34" charset="-122"/>
-                <a:cs typeface="Georgia" pitchFamily="34" charset="-120"/>
-              </a:rPr>
-              <a:t>O RESULTADO NA PRÁTICA</a:t>
-            </a:r>
-            <a:endParaRPr lang="en-US" sz="3200" dirty="0"/>
-          </a:p>
-        </p:txBody>
-      </p:sp>
       <p:pic>
         <p:nvPicPr>
-          <p:cNvPr id="3" name="Depoimento" descr="Mensagem de aluna: depois da Formação Internacional, converteu o valor do curso em menos de 2 meses com 2 pacientes">    </p:cNvPr>
+          <p:cNvPr id="2" name="Foto da turma" descr="Turma da Formação Internacional reunida em uma escadaria, de uniforme vinho, segurando certificados e uma bandeira de Harvard">    </p:cNvPr>
           <p:cNvPicPr>
             <a:picLocks noChangeAspect="1"/>
           </p:cNvPicPr>
@@ -3927,8 +4368,8 @@
         </p:blipFill>
         <p:spPr>
           <a:xfrm>
-            <a:off x="1984248" y="2194560"/>
-            <a:ext cx="8229600" cy="2468880"/>
+            <a:off x="5486400" y="0"/>
+            <a:ext cx="6705295" cy="6858000"/>
           </a:xfrm>
           <a:prstGeom prst="rect">
             <a:avLst/>
@@ -3937,14 +4378,55 @@
       </p:pic>
       <p:sp>
         <p:nvSpPr>
-          <p:cNvPr id="4" name="Legenda depoimento"/>
+          <p:cNvPr id="3" name="Text 0"/>
+          <p:cNvSpPr/>
+          <p:nvPr>
+            <p:ph idx="100" type="title" hasCustomPrompt="1"/>
+          </p:nvPr>
+        </p:nvSpPr>
+        <p:spPr>
+          <a:xfrm>
+            <a:off x="640080" y="868680"/>
+            <a:ext cx="10881360" cy="822960"/>
+          </a:xfrm>
+          <a:prstGeom prst="rect">
+            <a:avLst/>
+          </a:prstGeom>
+          <a:noFill/>
+          <a:ln/>
+        </p:spPr>
+        <p:txBody>
+          <a:bodyPr wrap="square" lIns="0" tIns="0" rIns="0" bIns="0" rtlCol="0" anchor="t"/>
+          <a:lstStyle/>
+          <a:p>
+            <a:pPr algn="l" indent="0" marL="0">
+              <a:buNone/>
+            </a:pPr>
+            <a:r>
+              <a:rPr lang="en-US" sz="3200" spc="200" kern="0" dirty="0">
+                <a:solidFill>
+                  <a:schemeClr val="bg1"/>
+                </a:solidFill>
+                <a:latin typeface="Georgia" pitchFamily="34" charset="0"/>
+                <a:ea typeface="Georgia" pitchFamily="34" charset="-122"/>
+                <a:cs typeface="Georgia" pitchFamily="34" charset="-120"/>
+              </a:rPr>
+              <a:t>QUEM JÁ VIVEU</a:t>
+            </a:r>
+            <a:endParaRPr lang="en-US" sz="3200" dirty="0"/>
+          </a:p>
+        </p:txBody>
+      </p:sp>
+      <p:sp>
+        <p:nvSpPr>
+          <p:cNvPr id="4" name="Texto turma"/>
           <p:cNvSpPr txBox="1"/>
           <p:nvPr/>
         </p:nvSpPr>
         <p:spPr>
           <a:xfrm>
-            <a:off x="1984248" y="4892040"/>
-            <a:ext cx="8229600" cy="365760"/>
+            <a:off x="640080" y="1920240"/>
+            <a:ext cx="4480560" cy="1280160"/>
           </a:xfrm>
           <a:prstGeom prst="rect">
             <a:avLst/>
@@ -3953,21 +4435,99 @@
           <a:ln/>
         </p:spPr>
         <p:txBody>
-          <a:bodyPr wrap="square" lIns="0" tIns="0" rIns="0" bIns="0" rtlCol="0" anchor="ctr"/>
+          <a:bodyPr wrap="square" lIns="0" tIns="0" rIns="0" bIns="0" rtlCol="0" anchor="t"/>
           <a:lstStyle/>
           <a:p>
             <a:pPr indent="0" marL="0">
               <a:buNone/>
             </a:pPr>
             <a:r>
-              <a:rPr lang="en-US" sz="1300" i="1" dirty="0">
-                <a:solidFill>
-                  <a:schemeClr val="tx2"/>
-                </a:solidFill>
-              </a:rPr>
-              <a:t>Relato de aluna da Formação Internacional, enviado no grupo da turma.</a:t>
-            </a:r>
-            <a:endParaRPr lang="en-US" sz="1300" dirty="0"/>
+              <a:rPr lang="en-US" sz="2000" dirty="0">
+                <a:solidFill>
+                  <a:schemeClr val="accent4"/>
+                </a:solidFill>
+              </a:rPr>
+              <a:t>Turma da Formação Internacional na etapa de Boston, com os certificados em mãos.</a:t>
+            </a:r>
+            <a:endParaRPr lang="en-US" sz="2000" dirty="0"/>
+          </a:p>
+        </p:txBody>
+      </p:sp>
+      <p:sp>
+        <p:nvSpPr>
+          <p:cNvPr id="5" name="Chamada turma"/>
+          <p:cNvSpPr txBox="1"/>
+          <p:nvPr/>
+        </p:nvSpPr>
+        <p:spPr>
+          <a:xfrm>
+            <a:off x="640080" y="4206240"/>
+            <a:ext cx="4572000" cy="548640"/>
+          </a:xfrm>
+          <a:prstGeom prst="rect">
+            <a:avLst/>
+          </a:prstGeom>
+          <a:noFill/>
+          <a:ln/>
+        </p:spPr>
+        <p:txBody>
+          <a:bodyPr wrap="square" lIns="0" tIns="0" rIns="0" bIns="0" rtlCol="0" anchor="ctr"/>
+          <a:lstStyle/>
+          <a:p>
+            <a:pPr indent="0" marL="0">
+              <a:buNone/>
+            </a:pPr>
+            <a:r>
+              <a:rPr lang="en-US" sz="2600" dirty="0">
+                <a:solidFill>
+                  <a:schemeClr val="bg1"/>
+                </a:solidFill>
+                <a:latin typeface="Georgia" pitchFamily="34" charset="0"/>
+                <a:ea typeface="Georgia" pitchFamily="34" charset="-122"/>
+                <a:cs typeface="Georgia" pitchFamily="34" charset="-120"/>
+              </a:rPr>
+              <a:t>A próxima etapa é em Miami.</a:t>
+            </a:r>
+            <a:endParaRPr lang="en-US" sz="2600" dirty="0"/>
+          </a:p>
+        </p:txBody>
+      </p:sp>
+      <p:sp>
+        <p:nvSpPr>
+          <p:cNvPr id="6" name="Data turma"/>
+          <p:cNvSpPr txBox="1"/>
+          <p:nvPr/>
+        </p:nvSpPr>
+        <p:spPr>
+          <a:xfrm>
+            <a:off x="640080" y="4800600"/>
+            <a:ext cx="5760720" cy="411480"/>
+          </a:xfrm>
+          <a:prstGeom prst="rect">
+            <a:avLst/>
+          </a:prstGeom>
+          <a:noFill/>
+          <a:ln/>
+        </p:spPr>
+        <p:txBody>
+          <a:bodyPr wrap="square" lIns="0" tIns="0" rIns="0" bIns="0" rtlCol="0" anchor="ctr"/>
+          <a:lstStyle/>
+          <a:p>
+            <a:pPr indent="0" marL="0">
+              <a:buNone/>
+            </a:pPr>
+            <a:r>
+              <a:rPr lang="en-US" sz="2000" dirty="0">
+                <a:solidFill>
+                  <a:schemeClr val="accent4"/>
+                </a:solidFill>
+                <a:latin typeface="Georgia" pitchFamily="34" charset="0"/>
+                <a:ea typeface="Georgia" pitchFamily="34" charset="-122"/>
+                <a:cs typeface="Georgia" pitchFamily="34" charset="-120"/>
+              </a:rPr>
+              <a:t>19, 20 e 21 de maio de 2027</a:t>
+            </a:r>
+            <a:endParaRPr lang="en-US" sz="2000" dirty="0"/>
           </a:p>
         </p:txBody>
       </p:sp>
@@ -4044,9 +4604,50 @@
           <a:chExt cx="0" cy="0"/>
         </a:xfrm>
       </p:grpSpPr>
+      <p:sp>
+        <p:nvSpPr>
+          <p:cNvPr id="2" name="Text 0"/>
+          <p:cNvSpPr/>
+          <p:nvPr>
+            <p:ph idx="100" type="title" hasCustomPrompt="1"/>
+          </p:nvPr>
+        </p:nvSpPr>
+        <p:spPr>
+          <a:xfrm>
+            <a:off x="640080" y="868680"/>
+            <a:ext cx="10881360" cy="822960"/>
+          </a:xfrm>
+          <a:prstGeom prst="rect">
+            <a:avLst/>
+          </a:prstGeom>
+          <a:noFill/>
+          <a:ln/>
+        </p:spPr>
+        <p:txBody>
+          <a:bodyPr wrap="square" lIns="0" tIns="0" rIns="0" bIns="0" rtlCol="0" anchor="t"/>
+          <a:lstStyle/>
+          <a:p>
+            <a:pPr algn="l" indent="0" marL="0">
+              <a:buNone/>
+            </a:pPr>
+            <a:r>
+              <a:rPr lang="en-US" sz="3200" spc="200" kern="0" dirty="0">
+                <a:solidFill>
+                  <a:schemeClr val="bg1"/>
+                </a:solidFill>
+                <a:latin typeface="Georgia" pitchFamily="34" charset="0"/>
+                <a:ea typeface="Georgia" pitchFamily="34" charset="-122"/>
+                <a:cs typeface="Georgia" pitchFamily="34" charset="-120"/>
+              </a:rPr>
+              <a:t>O RESULTADO NA PRÁTICA</a:t>
+            </a:r>
+            <a:endParaRPr lang="en-US" sz="3200" dirty="0"/>
+          </a:p>
+        </p:txBody>
+      </p:sp>
       <p:pic>
         <p:nvPicPr>
-          <p:cNvPr id="2" name="Bandeira" descr="Bandeira dos Estados Unidos tremulando">    </p:cNvPr>
+          <p:cNvPr id="3" name="Depoimento" descr="Mensagem de aluna: depois da Formação Internacional, converteu o valor do curso em menos de 2 meses com 2 pacientes">    </p:cNvPr>
           <p:cNvPicPr>
             <a:picLocks noChangeAspect="1"/>
           </p:cNvPicPr>
@@ -4060,86 +4661,24 @@
         </p:blipFill>
         <p:spPr>
           <a:xfrm>
-            <a:off x="9006840" y="228600"/>
-            <a:ext cx="2743200" cy="1828800"/>
+            <a:off x="1984248" y="2194560"/>
+            <a:ext cx="8229600" cy="2468880"/>
           </a:xfrm>
           <a:prstGeom prst="rect">
             <a:avLst/>
           </a:prstGeom>
         </p:spPr>
       </p:pic>
-      <p:pic>
-        <p:nvPicPr>
-          <p:cNvPr id="3" name="QR code WhatsApp" descr="QR code que abre o WhatsApp (62) 98515-0061 com a mensagem: Olá, quero saber mais do Programa de Formação Internacional">
-            <a:hlinkClick r:id="rId3" tooltip="Falar no WhatsApp"/>
-          </p:cNvPr>
-          <p:cNvPicPr>
-            <a:picLocks noChangeAspect="1"/>
-          </p:cNvPicPr>
-          <p:nvPr/>
-        </p:nvPicPr>
-        <p:blipFill>
-          <a:blip r:embed="rId2"/>
-          <a:stretch>
-            <a:fillRect/>
-          </a:stretch>
-        </p:blipFill>
-        <p:spPr>
-          <a:xfrm>
-            <a:off x="8549640" y="2240280"/>
-            <a:ext cx="2743200" cy="2743200"/>
-          </a:xfrm>
-          <a:prstGeom prst="rect">
-            <a:avLst/>
-          </a:prstGeom>
-        </p:spPr>
-      </p:pic>
-      <p:sp>
-        <p:nvSpPr>
-          <p:cNvPr id="4" name="Legenda QR"/>
+      <p:sp>
+        <p:nvSpPr>
+          <p:cNvPr id="4" name="Legenda depoimento"/>
           <p:cNvSpPr txBox="1"/>
           <p:nvPr/>
         </p:nvSpPr>
         <p:spPr>
           <a:xfrm>
-            <a:off x="8549640" y="5120640"/>
-            <a:ext cx="2743200" cy="548640"/>
-          </a:xfrm>
-          <a:prstGeom prst="rect">
-            <a:avLst/>
-          </a:prstGeom>
-          <a:noFill/>
-          <a:ln/>
-        </p:spPr>
-        <p:txBody>
-          <a:bodyPr wrap="square" lIns="0" tIns="0" rIns="0" bIns="0" rtlCol="0" anchor="t"/>
-          <a:lstStyle/>
-          <a:p>
-            <a:pPr algn="ctr" indent="0" marL="0">
-              <a:buNone/>
-            </a:pPr>
-            <a:r>
-              <a:rPr lang="en-US" sz="1200" dirty="0">
-                <a:solidFill>
-                  <a:schemeClr val="accent4"/>
-                </a:solidFill>
-              </a:rPr>
-              <a:t>Aponte a câmera do celular para falar com a equipe no WhatsApp</a:t>
-            </a:r>
-            <a:endParaRPr lang="en-US" sz="1200" dirty="0"/>
-          </a:p>
-        </p:txBody>
-      </p:sp>
-      <p:sp>
-        <p:nvSpPr>
-          <p:cNvPr id="5" name="Rótulo final"/>
-          <p:cNvSpPr txBox="1"/>
-          <p:nvPr/>
-        </p:nvSpPr>
-        <p:spPr>
-          <a:xfrm>
-            <a:off x="640080" y="1188720"/>
-            <a:ext cx="5943600" cy="411480"/>
+            <a:off x="1984248" y="4892040"/>
+            <a:ext cx="8229600" cy="365760"/>
           </a:xfrm>
           <a:prstGeom prst="rect">
             <a:avLst/>
@@ -4155,259 +4694,62 @@
               <a:buNone/>
             </a:pPr>
             <a:r>
-              <a:rPr lang="en-US" sz="2000" spc="300" kern="0" dirty="0">
-                <a:solidFill>
-                  <a:schemeClr val="accent4"/>
-                </a:solidFill>
-                <a:latin typeface="Georgia" pitchFamily="34" charset="0"/>
-                <a:ea typeface="Georgia" pitchFamily="34" charset="-122"/>
-                <a:cs typeface="Georgia" pitchFamily="34" charset="-120"/>
-              </a:rPr>
-              <a:t>Etapa de Miami</a:t>
-            </a:r>
-            <a:endParaRPr lang="en-US" sz="2000" dirty="0"/>
-          </a:p>
-        </p:txBody>
-      </p:sp>
-      <p:sp>
-        <p:nvSpPr>
-          <p:cNvPr id="6" name="Chamada"/>
-          <p:cNvSpPr txBox="1"/>
-          <p:nvPr/>
-        </p:nvSpPr>
-        <p:spPr>
-          <a:xfrm>
-            <a:off x="640080" y="1783080"/>
-            <a:ext cx="6400800" cy="1097280"/>
-          </a:xfrm>
-          <a:prstGeom prst="rect">
-            <a:avLst/>
-          </a:prstGeom>
-          <a:noFill/>
-          <a:ln/>
-        </p:spPr>
-        <p:txBody>
-          <a:bodyPr wrap="square" lIns="0" tIns="0" rIns="0" bIns="0" rtlCol="0" anchor="ctr"/>
-          <a:lstStyle/>
-          <a:p>
-            <a:pPr indent="0" marL="0">
-              <a:buNone/>
-            </a:pPr>
-            <a:r>
-              <a:rPr lang="en-US" sz="5400" dirty="0">
-                <a:solidFill>
-                  <a:schemeClr val="bg1"/>
-                </a:solidFill>
-                <a:latin typeface="Georgia" pitchFamily="34" charset="0"/>
-                <a:ea typeface="Georgia" pitchFamily="34" charset="-122"/>
-                <a:cs typeface="Georgia" pitchFamily="34" charset="-120"/>
-              </a:rPr>
-              <a:t>Garanta sua vaga</a:t>
-            </a:r>
-            <a:endParaRPr lang="en-US" sz="5400" dirty="0"/>
-          </a:p>
-        </p:txBody>
-      </p:sp>
-      <p:sp>
-        <p:nvSpPr>
-          <p:cNvPr id="7" name="Data final"/>
-          <p:cNvSpPr txBox="1"/>
-          <p:nvPr/>
-        </p:nvSpPr>
-        <p:spPr>
-          <a:xfrm>
-            <a:off x="640080" y="2971800"/>
-            <a:ext cx="5943600" cy="457200"/>
-          </a:xfrm>
-          <a:prstGeom prst="rect">
-            <a:avLst/>
-          </a:prstGeom>
-          <a:noFill/>
-          <a:ln/>
-        </p:spPr>
-        <p:txBody>
-          <a:bodyPr wrap="square" lIns="0" tIns="0" rIns="0" bIns="0" rtlCol="0" anchor="ctr"/>
-          <a:lstStyle/>
-          <a:p>
-            <a:pPr indent="0" marL="0">
-              <a:buNone/>
-            </a:pPr>
-            <a:r>
-              <a:rPr lang="en-US" sz="2400" dirty="0">
-                <a:solidFill>
-                  <a:schemeClr val="bg1"/>
-                </a:solidFill>
-                <a:latin typeface="Georgia" pitchFamily="34" charset="0"/>
-                <a:ea typeface="Georgia" pitchFamily="34" charset="-122"/>
-                <a:cs typeface="Georgia" pitchFamily="34" charset="-120"/>
-              </a:rPr>
-              <a:t>19, 20 e 21 de maio de 2027</a:t>
-            </a:r>
-            <a:endParaRPr lang="en-US" sz="2400" dirty="0"/>
-          </a:p>
-        </p:txBody>
-      </p:sp>
-      <p:sp>
-        <p:nvSpPr>
-          <p:cNvPr id="8" name="Texto final"/>
-          <p:cNvSpPr txBox="1"/>
-          <p:nvPr/>
-        </p:nvSpPr>
-        <p:spPr>
-          <a:xfrm>
-            <a:off x="640080" y="3520440"/>
-            <a:ext cx="5943600" cy="365760"/>
-          </a:xfrm>
-          <a:prstGeom prst="rect">
-            <a:avLst/>
-          </a:prstGeom>
-          <a:noFill/>
-          <a:ln/>
-        </p:spPr>
-        <p:txBody>
-          <a:bodyPr wrap="square" lIns="0" tIns="0" rIns="0" bIns="0" rtlCol="0" anchor="ctr"/>
-          <a:lstStyle/>
-          <a:p>
-            <a:pPr indent="0" marL="0">
-              <a:buNone/>
-            </a:pPr>
-            <a:r>
-              <a:rPr lang="en-US" sz="1600" dirty="0">
-                <a:solidFill>
-                  <a:schemeClr val="accent4"/>
-                </a:solidFill>
-              </a:rPr>
-              <a:t>Vagas e investimento com a nossa equipe.</a:t>
-            </a:r>
-            <a:endParaRPr lang="en-US" sz="1600" dirty="0"/>
-          </a:p>
-        </p:txBody>
-      </p:sp>
-      <p:sp>
-        <p:nvSpPr>
-          <p:cNvPr id="9" name="Instagram"/>
-          <p:cNvSpPr txBox="1"/>
-          <p:nvPr/>
-        </p:nvSpPr>
-        <p:spPr>
-          <a:xfrm>
-            <a:off x="640080" y="4251960"/>
-            <a:ext cx="5486400" cy="457200"/>
-          </a:xfrm>
-          <a:prstGeom prst="rect">
-            <a:avLst/>
-          </a:prstGeom>
-          <a:noFill/>
-          <a:ln/>
-        </p:spPr>
-        <p:txBody>
-          <a:bodyPr wrap="square" lIns="0" tIns="0" rIns="0" bIns="0" rtlCol="0" anchor="ctr"/>
-          <a:lstStyle/>
-          <a:p>
-            <a:pPr indent="0" marL="0">
-              <a:buNone/>
-            </a:pPr>
-            <a:r>
-              <a:rPr lang="en-US" sz="1600" dirty="0">
+              <a:rPr lang="en-US" sz="1300" i="1" dirty="0">
                 <a:solidFill>
                   <a:schemeClr val="tx2"/>
                 </a:solidFill>
               </a:rPr>
-              <a:t>Instagram   </a:t>
-            </a:r>
-            <a:pPr indent="0" marL="0">
-              <a:buNone/>
-            </a:pPr>
-            <a:r>
-              <a:rPr lang="en-US" sz="2000" dirty="0">
-                <a:solidFill>
-                  <a:schemeClr val="bg1"/>
-                </a:solidFill>
-              </a:rPr>
-              <a:t>@dra.rosanaa</a:t>
-            </a:r>
-            <a:endParaRPr lang="en-US" sz="1600" dirty="0"/>
-          </a:p>
-        </p:txBody>
-      </p:sp>
-      <p:sp>
-        <p:nvSpPr>
-          <p:cNvPr id="10" name="WhatsApp"/>
-          <p:cNvSpPr txBox="1"/>
-          <p:nvPr/>
-        </p:nvSpPr>
-        <p:spPr>
-          <a:xfrm>
-            <a:off x="640080" y="4754880"/>
-            <a:ext cx="5486400" cy="457200"/>
-          </a:xfrm>
-          <a:prstGeom prst="rect">
-            <a:avLst/>
-          </a:prstGeom>
-          <a:noFill/>
-          <a:ln/>
-        </p:spPr>
-        <p:txBody>
-          <a:bodyPr wrap="square" lIns="0" tIns="0" rIns="0" bIns="0" rtlCol="0" anchor="ctr"/>
-          <a:lstStyle/>
-          <a:p>
-            <a:pPr indent="0" marL="0">
-              <a:buNone/>
-            </a:pPr>
-            <a:r>
-              <a:rPr lang="en-US" sz="1600" dirty="0">
+              <a:t>Relato de aluna da Formação Internacional, enviado no grupo da turma.</a:t>
+            </a:r>
+            <a:endParaRPr lang="en-US" sz="1300" dirty="0"/>
+          </a:p>
+        </p:txBody>
+      </p:sp>
+      <p:sp>
+        <p:nvSpPr>
+          <p:cNvPr id="25" name="Slide Number Placeholder 0"/>
+          <p:cNvSpPr>
+            <a:spLocks noGrp="1"/>
+          </p:cNvSpPr>
+          <p:nvPr>
+            <p:ph type="sldNum" sz="quarter" idx="4294967295"/>
+          </p:nvPr>
+        </p:nvSpPr>
+        <p:spPr>
+          <a:xfrm>
+            <a:off x="11155680" y="6355080"/>
+            <a:ext cx="411480" cy="274320"/>
+          </a:xfrm>
+          <a:prstGeom prst="rect">
+            <a:avLst/>
+          </a:prstGeom>
+          <a:extLst>
+            <a:ext uri="{C572A759-6A51-4108-AA02-DFA0A04FC94B}">
+              <ma14:wrappingTextBoxFlag xmlns:ma14="http://schemas.microsoft.com/office/mac/drawingml/2011/main" val="0"/>
+            </a:ext>
+          </a:extLst>
+        </p:spPr>
+        <p:txBody>
+          <a:bodyPr/>
+          <a:lstStyle>
+            <a:lvl1pPr>
+              <a:defRPr sz="900">
                 <a:solidFill>
                   <a:schemeClr val="tx2"/>
                 </a:solidFill>
-              </a:rPr>
-              <a:t>WhatsApp   </a:t>
-            </a:r>
-            <a:pPr indent="0" marL="0">
-              <a:buNone/>
-            </a:pPr>
-            <a:r>
-              <a:rPr lang="en-US" sz="2000" u="sng" dirty="0">
-                <a:solidFill>
-                  <a:schemeClr val="bg1"/>
-                </a:solidFill>
-                <a:hlinkClick r:id="rId4" invalidUrl="" action="" tgtFrame="" tooltip="Falar no WhatsApp" history="1" highlightClick="0" endSnd="0">
-                  <a:extLst>
-                    <a:ext uri="{A12FA001-AC4F-418D-AE19-62706E023703}">
-                      <ahyp:hlinkClr xmlns:ahyp="http://schemas.microsoft.com/office/drawing/2018/hyperlinkcolor" val="tx"/>
-                    </a:ext>
-                  </a:extLst>
-                </a:hlinkClick>
-              </a:rPr>
-              <a:t>(62) 98515-0061</a:t>
-            </a:r>
-            <a:endParaRPr lang="en-US" sz="1600" dirty="0"/>
-          </a:p>
-        </p:txBody>
-      </p:sp>
-      <p:pic>
-        <p:nvPicPr>
-          <p:cNvPr id="11" name="Logo" descr="Logo Dra. Rosana Vecchi Caldas">    </p:cNvPr>
-          <p:cNvPicPr>
-            <a:picLocks noChangeAspect="1"/>
-          </p:cNvPicPr>
-          <p:nvPr/>
-        </p:nvPicPr>
-        <p:blipFill>
-          <a:blip r:embed="rId5"/>
-          <a:stretch>
-            <a:fillRect/>
-          </a:stretch>
-        </p:blipFill>
-        <p:spPr>
-          <a:xfrm>
-            <a:off x="548640" y="5486400"/>
-            <a:ext cx="1051560" cy="1051560"/>
-          </a:xfrm>
-          <a:prstGeom prst="rect">
-            <a:avLst/>
-          </a:prstGeom>
-        </p:spPr>
-      </p:pic>
+              </a:defRPr>
+            </a:lvl1pPr>
+          </a:lstStyle>
+          <a:p>
+            <a:pPr algn="r"/>
+            <a:fld id="{F7021451-1387-4CA6-816F-3879F97B5CBC}" type="slidenum">
+              <a:rPr b="0" lang="en-US"/>
+              <a:t>9</a:t>
+            </a:fld>
+            <a:endParaRPr lang="en-US"/>
+          </a:p>
+        </p:txBody>
+      </p:sp>
     </p:spTree>
   </p:cSld>
   <p:clrMapOvr>

</xml_diff>

<commit_message>
Etapa Miami: remove lembretes das anotações (uso interno)
Co-Authored-By: Claude Opus 5.5 <noreply@anthropic.com>
Claude-Session: https://claude.ai/code/session_01ETjDEHo1Y5Ziwi4pumEH8K
</commit_message>
<xml_diff>
--- a/entregas/Formacao-Internacional-Etapa-Miami.pptx
+++ b/entregas/Formacao-Internacional-Etapa-Miami.pptx
@@ -116,28 +116,28 @@
   <p:extLst>
     <p:ext uri="{521415D9-36F7-43E2-AB2F-B90AF26B5E84}">
       <p14:sectionLst xmlns:p14="http://schemas.microsoft.com/office/powerpoint/2010/main">
-        <p14:section name="Abertura" id="{0263382f-3e44-32ef-df8c-44d5ba2547cc}">
+        <p14:section name="Abertura" id="{cbf528a6-e69b-1ad9-17a5-ea32583af8e2}">
           <p14:sldIdLst>
             <p14:sldId id="256"/>
             <p14:sldId id="257"/>
             <p14:sldId id="258"/>
           </p14:sldIdLst>
         </p14:section>
-        <p14:section name="A etapa" id="{cdec921f-a21a-86f1-21f6-9e8ceff42764}">
+        <p14:section name="A etapa" id="{a6581c06-9c20-272c-17fa-84bfaa46c658}">
           <p14:sldIdLst>
             <p14:sldId id="259"/>
             <p14:sldId id="260"/>
             <p14:sldId id="261"/>
           </p14:sldIdLst>
         </p14:section>
-        <p14:section name="Pessoas" id="{7ba98e77-765d-1a48-8ce3-7898d80fa773}">
+        <p14:section name="Pessoas" id="{106039f7-9203-21a0-c2cf-99c42ea1077a}">
           <p14:sldIdLst>
             <p14:sldId id="262"/>
             <p14:sldId id="263"/>
             <p14:sldId id="264"/>
           </p14:sldIdLst>
         </p14:section>
-        <p14:section name="Inscrição" id="{d0544a75-e3e1-f894-360a-37270c204646}">
+        <p14:section name="Inscrição" id="{567869bc-ac47-cbc8-631c-20c3f6f445b7}">
           <p14:sldIdLst>
             <p14:sldId id="265"/>
           </p14:sldIdLst>
@@ -1250,7 +1250,7 @@
           <a:p>
             <a:r>
               <a:rPr lang="en-US" dirty="0"/>
-              <a:t>Confirme a turma e o evento da foto. Antes de divulgar fora da turma, garanta a autorização de uso de imagem das pessoas que aparecem.</a:t>
+              <a:t/>
             </a:r>
             <a:endParaRPr lang="en-US" dirty="0"/>
           </a:p>
@@ -1338,7 +1338,7 @@
           <a:p>
             <a:r>
               <a:rPr lang="en-US" dirty="0"/>
-              <a:t>Confirme que a aluna autorizou o uso do relato antes de divulgar este material fora da turma.</a:t>
+              <a:t/>
             </a:r>
             <a:endParaRPr lang="en-US" dirty="0"/>
           </a:p>

</xml_diff>

<commit_message>
Etapa Miami: novo visual com vinho, marfim, Garamond e Century Gothic
Co-Authored-By: Claude Opus 5.5 <noreply@anthropic.com>
Claude-Session: https://claude.ai/code/session_01ETjDEHo1Y5Ziwi4pumEH8K
</commit_message>
<xml_diff>
--- a/entregas/Formacao-Internacional-Etapa-Miami.pptx
+++ b/entregas/Formacao-Internacional-Etapa-Miami.pptx
@@ -116,28 +116,28 @@
   <p:extLst>
     <p:ext uri="{521415D9-36F7-43E2-AB2F-B90AF26B5E84}">
       <p14:sectionLst xmlns:p14="http://schemas.microsoft.com/office/powerpoint/2010/main">
-        <p14:section name="Abertura" id="{cbf528a6-e69b-1ad9-17a5-ea32583af8e2}">
+        <p14:section name="Abertura" id="{0d560b6e-caf9-2d30-07b5-912f2486563e}">
           <p14:sldIdLst>
             <p14:sldId id="256"/>
             <p14:sldId id="257"/>
             <p14:sldId id="258"/>
           </p14:sldIdLst>
         </p14:section>
-        <p14:section name="A etapa" id="{a6581c06-9c20-272c-17fa-84bfaa46c658}">
+        <p14:section name="A etapa" id="{5d01691f-ad47-f40b-ba83-8382f22766b9}">
           <p14:sldIdLst>
             <p14:sldId id="259"/>
             <p14:sldId id="260"/>
             <p14:sldId id="261"/>
           </p14:sldIdLst>
         </p14:section>
-        <p14:section name="Pessoas" id="{106039f7-9203-21a0-c2cf-99c42ea1077a}">
+        <p14:section name="Pessoas" id="{4dfaa058-7255-37e9-77eb-bf32afe1b12e}">
           <p14:sldIdLst>
             <p14:sldId id="262"/>
             <p14:sldId id="263"/>
             <p14:sldId id="264"/>
           </p14:sldIdLst>
         </p14:section>
-        <p14:section name="Inscrição" id="{567869bc-ac47-cbc8-631c-20c3f6f445b7}">
+        <p14:section name="Inscrição" id="{c35dbee8-1251-ea30-f51e-e104f0d56a1b}">
           <p14:sldIdLst>
             <p14:sldId id="265"/>
           </p14:sldIdLst>
@@ -722,7 +722,7 @@
           <a:p>
             <a:r>
               <a:rPr lang="en-US" dirty="0"/>
-              <a:t>Capa. Para abrir com vídeo, insira o vídeo atrás do texto (Inserir &gt; Vídeo) e envie para trás (Organizar &gt; Enviar para trás).</a:t>
+              <a:t/>
             </a:r>
             <a:endParaRPr lang="en-US" dirty="0"/>
           </a:p>
@@ -810,7 +810,7 @@
           <a:p>
             <a:r>
               <a:rPr lang="en-US" dirty="0"/>
-              <a:t>Slide reservado para vídeo (laboratório, Miami ou o vídeo 3D das camadas da pele). Depois de inserir: aba Reprodução &gt; Iniciar: Automaticamente. Para vídeo de fundo sem som, marque também 'Repetir até parar' e deixe o volume mudo.</a:t>
+              <a:t>Slide reservado para vídeo. Depois de inserir: aba Reprodução &gt; Iniciar: Automaticamente. Para vídeo de fundo sem som, marque 'Repetir até parar' e deixe o volume mudo.</a:t>
             </a:r>
             <a:endParaRPr lang="en-US" dirty="0"/>
           </a:p>
@@ -1412,11 +1412,11 @@
 
 <file path=ppt/slideLayouts/slideLayout2.xml><?xml version="1.0" encoding="utf-8"?>
 <p:sldLayout xmlns:a="http://schemas.openxmlformats.org/drawingml/2006/main" xmlns:r="http://schemas.openxmlformats.org/officeDocument/2006/relationships" xmlns:p="http://schemas.openxmlformats.org/presentationml/2006/main" preserve="1">
-  <p:cSld name="CAPA">
+  <p:cSld name="LIVRE">
     <p:bg>
       <p:bgPr>
         <a:solidFill>
-          <a:schemeClr val="tx1"/>
+          <a:schemeClr val="bg2"/>
         </a:solidFill>
       </p:bgPr>
     </p:bg>
@@ -1444,11 +1444,11 @@
 
 <file path=ppt/slideLayouts/slideLayout3.xml><?xml version="1.0" encoding="utf-8"?>
 <p:sldLayout xmlns:a="http://schemas.openxmlformats.org/drawingml/2006/main" xmlns:r="http://schemas.openxmlformats.org/officeDocument/2006/relationships" xmlns:p="http://schemas.openxmlformats.org/presentationml/2006/main" preserve="1">
-  <p:cSld name="CONTEUDO">
+  <p:cSld name="CLARO">
     <p:bg>
       <p:bgPr>
         <a:solidFill>
-          <a:schemeClr val="tx1"/>
+          <a:schemeClr val="bg2"/>
         </a:solidFill>
       </p:bgPr>
     </p:bg>
@@ -1476,8 +1476,8 @@
         </p:nvSpPr>
         <p:spPr>
           <a:xfrm>
-            <a:off x="640080" y="868680"/>
-            <a:ext cx="10881360" cy="822960"/>
+            <a:off x="731520" y="777240"/>
+            <a:ext cx="10698480" cy="914400"/>
           </a:xfrm>
           <a:prstGeom prst="rect">
             <a:avLst/>
@@ -1490,13 +1490,13 @@
           <a:lstStyle>
             <a:lvl1pPr algn="l" indent="0" marL="0">
               <a:buNone/>
-              <a:defRPr lang="en-US" sz="3200" spc="200" kern="0" dirty="0">
-                <a:solidFill>
-                  <a:schemeClr val="bg1"/>
-                </a:solidFill>
-                <a:latin typeface="Georgia" pitchFamily="34" charset="0"/>
-                <a:ea typeface="Georgia" pitchFamily="34" charset="-122"/>
-                <a:cs typeface="Georgia" pitchFamily="34" charset="-120"/>
+              <a:defRPr lang="en-US" sz="4400" dirty="0">
+                <a:solidFill>
+                  <a:schemeClr val="accent1"/>
+                </a:solidFill>
+                <a:latin typeface="Garamond" pitchFamily="34" charset="0"/>
+                <a:ea typeface="Garamond" pitchFamily="34" charset="-122"/>
+                <a:cs typeface="Garamond" pitchFamily="34" charset="-120"/>
               </a:defRPr>
             </a:lvl1pPr>
           </a:lstStyle>
@@ -1505,17 +1505,17 @@
               <a:buNone/>
             </a:pPr>
             <a:r>
-              <a:rPr lang="en-US" sz="3200" spc="200" kern="0" dirty="0">
-                <a:solidFill>
-                  <a:schemeClr val="bg1"/>
-                </a:solidFill>
-                <a:latin typeface="Georgia" pitchFamily="34" charset="0"/>
-                <a:ea typeface="Georgia" pitchFamily="34" charset="-122"/>
-                <a:cs typeface="Georgia" pitchFamily="34" charset="-120"/>
+              <a:rPr lang="en-US" sz="4400" dirty="0">
+                <a:solidFill>
+                  <a:schemeClr val="accent1"/>
+                </a:solidFill>
+                <a:latin typeface="Garamond" pitchFamily="34" charset="0"/>
+                <a:ea typeface="Garamond" pitchFamily="34" charset="-122"/>
+                <a:cs typeface="Garamond" pitchFamily="34" charset="-120"/>
               </a:rPr>
-              <a:t>TÍTULO</a:t>
-            </a:r>
-            <a:endParaRPr lang="en-US" sz="3200" dirty="0"/>
+              <a:t>Título</a:t>
+            </a:r>
+            <a:endParaRPr lang="en-US" sz="4400" dirty="0"/>
           </a:p>
         </p:txBody>
       </p:sp>
@@ -1561,6 +1561,91 @@
               <a:t>1003</a:t>
             </a:fld>
             <a:endParaRPr lang="en-US"/>
+          </a:p>
+        </p:txBody>
+      </p:sp>
+    </p:spTree>
+  </p:cSld>
+  <p:clrMapOvr>
+    <a:masterClrMapping/>
+  </p:clrMapOvr>
+</p:sldLayout>
+</file>
+
+<file path=ppt/slideLayouts/slideLayout4.xml><?xml version="1.0" encoding="utf-8"?>
+<p:sldLayout xmlns:a="http://schemas.openxmlformats.org/drawingml/2006/main" xmlns:r="http://schemas.openxmlformats.org/officeDocument/2006/relationships" xmlns:p="http://schemas.openxmlformats.org/presentationml/2006/main" preserve="1">
+  <p:cSld name="VINHO">
+    <p:bg>
+      <p:bgPr>
+        <a:solidFill>
+          <a:schemeClr val="accent1"/>
+        </a:solidFill>
+      </p:bgPr>
+    </p:bg>
+    <p:spTree>
+      <p:nvGrpSpPr>
+        <p:cNvPr id="1" name=""/>
+        <p:cNvGrpSpPr/>
+        <p:nvPr/>
+      </p:nvGrpSpPr>
+      <p:grpSpPr>
+        <a:xfrm>
+          <a:off x="0" y="0"/>
+          <a:ext cx="0" cy="0"/>
+          <a:chOff x="0" y="0"/>
+          <a:chExt cx="0" cy="0"/>
+        </a:xfrm>
+      </p:grpSpPr>
+      <p:sp>
+        <p:nvSpPr>
+          <p:cNvPr id="2" name="Text 0"/>
+          <p:cNvSpPr/>
+          <p:nvPr>
+            <p:ph idx="100" type="title" hasCustomPrompt="1"/>
+          </p:nvPr>
+        </p:nvSpPr>
+        <p:spPr>
+          <a:xfrm>
+            <a:off x="731520" y="777240"/>
+            <a:ext cx="10698480" cy="914400"/>
+          </a:xfrm>
+          <a:prstGeom prst="rect">
+            <a:avLst/>
+          </a:prstGeom>
+          <a:noFill/>
+          <a:ln/>
+        </p:spPr>
+        <p:txBody>
+          <a:bodyPr wrap="square" rtlCol="0"/>
+          <a:lstStyle>
+            <a:lvl1pPr algn="l" indent="0" marL="0">
+              <a:buNone/>
+              <a:defRPr lang="en-US" sz="4400" dirty="0">
+                <a:solidFill>
+                  <a:schemeClr val="bg1"/>
+                </a:solidFill>
+                <a:latin typeface="Garamond" pitchFamily="34" charset="0"/>
+                <a:ea typeface="Garamond" pitchFamily="34" charset="-122"/>
+                <a:cs typeface="Garamond" pitchFamily="34" charset="-120"/>
+              </a:defRPr>
+            </a:lvl1pPr>
+          </a:lstStyle>
+          <a:p>
+            <a:pPr algn="l" indent="0" marL="0">
+              <a:buNone/>
+            </a:pPr>
+            <a:r>
+              <a:rPr lang="en-US" sz="4400" dirty="0">
+                <a:solidFill>
+                  <a:schemeClr val="bg1"/>
+                </a:solidFill>
+                <a:latin typeface="Garamond" pitchFamily="34" charset="0"/>
+                <a:ea typeface="Garamond" pitchFamily="34" charset="-122"/>
+                <a:cs typeface="Garamond" pitchFamily="34" charset="-120"/>
+              </a:rPr>
+              <a:t>Título</a:t>
+            </a:r>
+            <a:endParaRPr lang="en-US" sz="4400" dirty="0"/>
           </a:p>
         </p:txBody>
       </p:sp>
@@ -1641,6 +1726,7 @@
     <p:sldLayoutId id="2147483649" r:id="rId1"/>
     <p:sldLayoutId id="2147483650" r:id="rId2"/>
     <p:sldLayoutId id="2147483651" r:id="rId3"/>
+    <p:sldLayoutId id="2147483652" r:id="rId4"/>
   </p:sldLayoutIdLst>
   <p:hf sldNum="0" hdr="0" ftr="0" dt="0"/>
   <p:txStyles>
@@ -1965,66 +2051,16 @@
           <a:chExt cx="0" cy="0"/>
         </a:xfrm>
       </p:grpSpPr>
-      <p:pic>
-        <p:nvPicPr>
-          <p:cNvPr id="2" name="Bandeira" descr="Bandeira dos Estados Unidos tremulando">    </p:cNvPr>
-          <p:cNvPicPr>
-            <a:picLocks noChangeAspect="1"/>
-          </p:cNvPicPr>
-          <p:nvPr/>
-        </p:nvPicPr>
-        <p:blipFill>
-          <a:blip r:embed="rId1"/>
-          <a:stretch>
-            <a:fillRect/>
-          </a:stretch>
-        </p:blipFill>
-        <p:spPr>
-          <a:xfrm>
-            <a:off x="9006840" y="228600"/>
-            <a:ext cx="2743200" cy="1828800"/>
-          </a:xfrm>
-          <a:prstGeom prst="rect">
-            <a:avLst/>
-          </a:prstGeom>
-        </p:spPr>
-      </p:pic>
-      <p:pic>
-        <p:nvPicPr>
-          <p:cNvPr id="3" name="QR code WhatsApp" descr="QR code que abre o WhatsApp (62) 98515-0061 com a mensagem: Olá, quero saber mais do Programa de Formação Internacional">
-            <a:hlinkClick r:id="rId3" tooltip="Falar no WhatsApp"/>
-          </p:cNvPr>
-          <p:cNvPicPr>
-            <a:picLocks noChangeAspect="1"/>
-          </p:cNvPicPr>
-          <p:nvPr/>
-        </p:nvPicPr>
-        <p:blipFill>
-          <a:blip r:embed="rId2"/>
-          <a:stretch>
-            <a:fillRect/>
-          </a:stretch>
-        </p:blipFill>
-        <p:spPr>
-          <a:xfrm>
-            <a:off x="8549640" y="2240280"/>
-            <a:ext cx="2743200" cy="2743200"/>
-          </a:xfrm>
-          <a:prstGeom prst="rect">
-            <a:avLst/>
-          </a:prstGeom>
-        </p:spPr>
-      </p:pic>
-      <p:sp>
-        <p:nvSpPr>
-          <p:cNvPr id="4" name="Legenda QR"/>
+      <p:sp>
+        <p:nvSpPr>
+          <p:cNvPr id="2" name="Text 0"/>
           <p:cNvSpPr txBox="1"/>
           <p:nvPr/>
         </p:nvSpPr>
         <p:spPr>
           <a:xfrm>
-            <a:off x="8549640" y="5120640"/>
-            <a:ext cx="2743200" cy="548640"/>
+            <a:off x="731520" y="1097280"/>
+            <a:ext cx="5943600" cy="457200"/>
           </a:xfrm>
           <a:prstGeom prst="rect">
             <a:avLst/>
@@ -2036,70 +2072,34 @@
           <a:bodyPr wrap="square" lIns="0" tIns="0" rIns="0" bIns="0" rtlCol="0" anchor="t"/>
           <a:lstStyle/>
           <a:p>
-            <a:pPr algn="ctr" indent="0" marL="0">
-              <a:buNone/>
-            </a:pPr>
-            <a:r>
-              <a:rPr lang="en-US" sz="1200" dirty="0">
-                <a:solidFill>
-                  <a:schemeClr val="accent4"/>
-                </a:solidFill>
-              </a:rPr>
-              <a:t>Aponte a câmera do celular para falar com a equipe no WhatsApp</a:t>
-            </a:r>
-            <a:endParaRPr lang="en-US" sz="1200" dirty="0"/>
-          </a:p>
-        </p:txBody>
-      </p:sp>
-      <p:sp>
-        <p:nvSpPr>
-          <p:cNvPr id="5" name="Rótulo final"/>
-          <p:cNvSpPr txBox="1"/>
-          <p:nvPr/>
-        </p:nvSpPr>
-        <p:spPr>
-          <a:xfrm>
-            <a:off x="640080" y="1188720"/>
-            <a:ext cx="5943600" cy="411480"/>
-          </a:xfrm>
-          <a:prstGeom prst="rect">
-            <a:avLst/>
-          </a:prstGeom>
-          <a:noFill/>
-          <a:ln/>
-        </p:spPr>
-        <p:txBody>
-          <a:bodyPr wrap="square" lIns="0" tIns="0" rIns="0" bIns="0" rtlCol="0" anchor="ctr"/>
-          <a:lstStyle/>
-          <a:p>
             <a:pPr indent="0" marL="0">
               <a:buNone/>
             </a:pPr>
             <a:r>
-              <a:rPr lang="en-US" sz="2000" spc="300" kern="0" dirty="0">
-                <a:solidFill>
-                  <a:schemeClr val="accent4"/>
-                </a:solidFill>
-                <a:latin typeface="Georgia" pitchFamily="34" charset="0"/>
-                <a:ea typeface="Georgia" pitchFamily="34" charset="-122"/>
-                <a:cs typeface="Georgia" pitchFamily="34" charset="-120"/>
+              <a:rPr lang="en-US" sz="2400" i="1" dirty="0">
+                <a:solidFill>
+                  <a:schemeClr val="tx2"/>
+                </a:solidFill>
+                <a:latin typeface="Garamond" pitchFamily="34" charset="0"/>
+                <a:ea typeface="Garamond" pitchFamily="34" charset="-122"/>
+                <a:cs typeface="Garamond" pitchFamily="34" charset="-120"/>
               </a:rPr>
               <a:t>Etapa de Miami</a:t>
             </a:r>
-            <a:endParaRPr lang="en-US" sz="2000" dirty="0"/>
-          </a:p>
-        </p:txBody>
-      </p:sp>
-      <p:sp>
-        <p:nvSpPr>
-          <p:cNvPr id="6" name="Chamada"/>
+            <a:endParaRPr lang="en-US" sz="2400" dirty="0"/>
+          </a:p>
+        </p:txBody>
+      </p:sp>
+      <p:sp>
+        <p:nvSpPr>
+          <p:cNvPr id="3" name="Chamada"/>
           <p:cNvSpPr txBox="1"/>
           <p:nvPr/>
         </p:nvSpPr>
         <p:spPr>
           <a:xfrm>
-            <a:off x="640080" y="1783080"/>
-            <a:ext cx="6400800" cy="1097280"/>
+            <a:off x="731520" y="1600200"/>
+            <a:ext cx="6858000" cy="1097280"/>
           </a:xfrm>
           <a:prstGeom prst="rect">
             <a:avLst/>
@@ -2108,36 +2108,36 @@
           <a:ln/>
         </p:spPr>
         <p:txBody>
-          <a:bodyPr wrap="square" lIns="0" tIns="0" rIns="0" bIns="0" rtlCol="0" anchor="ctr"/>
+          <a:bodyPr wrap="square" lIns="0" tIns="0" rIns="0" bIns="0" rtlCol="0" anchor="t"/>
           <a:lstStyle/>
           <a:p>
             <a:pPr indent="0" marL="0">
               <a:buNone/>
             </a:pPr>
             <a:r>
-              <a:rPr lang="en-US" sz="5400" dirty="0">
-                <a:solidFill>
-                  <a:schemeClr val="bg1"/>
-                </a:solidFill>
-                <a:latin typeface="Georgia" pitchFamily="34" charset="0"/>
-                <a:ea typeface="Georgia" pitchFamily="34" charset="-122"/>
-                <a:cs typeface="Georgia" pitchFamily="34" charset="-120"/>
+              <a:rPr lang="en-US" sz="6400" dirty="0">
+                <a:solidFill>
+                  <a:schemeClr val="accent1"/>
+                </a:solidFill>
+                <a:latin typeface="Garamond" pitchFamily="34" charset="0"/>
+                <a:ea typeface="Garamond" pitchFamily="34" charset="-122"/>
+                <a:cs typeface="Garamond" pitchFamily="34" charset="-120"/>
               </a:rPr>
               <a:t>Garanta sua vaga</a:t>
             </a:r>
-            <a:endParaRPr lang="en-US" sz="5400" dirty="0"/>
-          </a:p>
-        </p:txBody>
-      </p:sp>
-      <p:sp>
-        <p:nvSpPr>
-          <p:cNvPr id="7" name="Data final"/>
+            <a:endParaRPr lang="en-US" sz="6400" dirty="0"/>
+          </a:p>
+        </p:txBody>
+      </p:sp>
+      <p:sp>
+        <p:nvSpPr>
+          <p:cNvPr id="4" name="Data final"/>
           <p:cNvSpPr txBox="1"/>
           <p:nvPr/>
         </p:nvSpPr>
         <p:spPr>
           <a:xfrm>
-            <a:off x="640080" y="2971800"/>
+            <a:off x="731520" y="2880360"/>
             <a:ext cx="5943600" cy="457200"/>
           </a:xfrm>
           <a:prstGeom prst="rect">
@@ -2147,36 +2147,36 @@
           <a:ln/>
         </p:spPr>
         <p:txBody>
-          <a:bodyPr wrap="square" lIns="0" tIns="0" rIns="0" bIns="0" rtlCol="0" anchor="ctr"/>
+          <a:bodyPr wrap="square" lIns="0" tIns="0" rIns="0" bIns="0" rtlCol="0" anchor="t"/>
           <a:lstStyle/>
           <a:p>
             <a:pPr indent="0" marL="0">
               <a:buNone/>
             </a:pPr>
             <a:r>
-              <a:rPr lang="en-US" sz="2400" dirty="0">
-                <a:solidFill>
-                  <a:schemeClr val="bg1"/>
-                </a:solidFill>
-                <a:latin typeface="Georgia" pitchFamily="34" charset="0"/>
-                <a:ea typeface="Georgia" pitchFamily="34" charset="-122"/>
-                <a:cs typeface="Georgia" pitchFamily="34" charset="-120"/>
+              <a:rPr lang="en-US" sz="2600" dirty="0">
+                <a:solidFill>
+                  <a:schemeClr val="tx1"/>
+                </a:solidFill>
+                <a:latin typeface="Garamond" pitchFamily="34" charset="0"/>
+                <a:ea typeface="Garamond" pitchFamily="34" charset="-122"/>
+                <a:cs typeface="Garamond" pitchFamily="34" charset="-120"/>
               </a:rPr>
               <a:t>19, 20 e 21 de maio de 2027</a:t>
             </a:r>
-            <a:endParaRPr lang="en-US" sz="2400" dirty="0"/>
-          </a:p>
-        </p:txBody>
-      </p:sp>
-      <p:sp>
-        <p:nvSpPr>
-          <p:cNvPr id="8" name="Texto final"/>
+            <a:endParaRPr lang="en-US" sz="2600" dirty="0"/>
+          </a:p>
+        </p:txBody>
+      </p:sp>
+      <p:sp>
+        <p:nvSpPr>
+          <p:cNvPr id="5" name="Text 3"/>
           <p:cNvSpPr txBox="1"/>
           <p:nvPr/>
         </p:nvSpPr>
         <p:spPr>
           <a:xfrm>
-            <a:off x="640080" y="3520440"/>
+            <a:off x="731520" y="3429000"/>
             <a:ext cx="5943600" cy="365760"/>
           </a:xfrm>
           <a:prstGeom prst="rect">
@@ -2186,34 +2186,57 @@
           <a:ln/>
         </p:spPr>
         <p:txBody>
-          <a:bodyPr wrap="square" lIns="0" tIns="0" rIns="0" bIns="0" rtlCol="0" anchor="ctr"/>
+          <a:bodyPr wrap="square" lIns="0" tIns="0" rIns="0" bIns="0" rtlCol="0" anchor="t"/>
           <a:lstStyle/>
           <a:p>
             <a:pPr indent="0" marL="0">
               <a:buNone/>
             </a:pPr>
             <a:r>
-              <a:rPr lang="en-US" sz="1600" dirty="0">
-                <a:solidFill>
-                  <a:schemeClr val="accent4"/>
+              <a:rPr lang="en-US" sz="1500" dirty="0">
+                <a:solidFill>
+                  <a:schemeClr val="tx2"/>
                 </a:solidFill>
               </a:rPr>
               <a:t>Vagas e investimento com a nossa equipe.</a:t>
             </a:r>
-            <a:endParaRPr lang="en-US" sz="1600" dirty="0"/>
-          </a:p>
-        </p:txBody>
-      </p:sp>
-      <p:sp>
-        <p:nvSpPr>
-          <p:cNvPr id="9" name="Instagram"/>
+            <a:endParaRPr lang="en-US" sz="1500" dirty="0"/>
+          </a:p>
+        </p:txBody>
+      </p:sp>
+      <p:sp>
+        <p:nvSpPr>
+          <p:cNvPr id="6" name="Fio 1"/>
+          <p:cNvSpPr/>
+          <p:nvPr/>
+        </p:nvSpPr>
+        <p:spPr>
+          <a:xfrm>
+            <a:off x="731520" y="4206240"/>
+            <a:ext cx="5852160" cy="0"/>
+          </a:xfrm>
+          <a:prstGeom prst="line">
+            <a:avLst/>
+          </a:prstGeom>
+          <a:noFill/>
+          <a:ln w="12700">
+            <a:solidFill>
+              <a:schemeClr val="accent3"/>
+            </a:solidFill>
+            <a:prstDash val="solid"/>
+          </a:ln>
+        </p:spPr>
+      </p:sp>
+      <p:sp>
+        <p:nvSpPr>
+          <p:cNvPr id="7" name="Instagram"/>
           <p:cNvSpPr txBox="1"/>
           <p:nvPr/>
         </p:nvSpPr>
         <p:spPr>
           <a:xfrm>
-            <a:off x="640080" y="4251960"/>
-            <a:ext cx="5486400" cy="457200"/>
+            <a:off x="731520" y="4343400"/>
+            <a:ext cx="5852160" cy="457200"/>
           </a:xfrm>
           <a:prstGeom prst="rect">
             <a:avLst/>
@@ -2229,7 +2252,7 @@
               <a:buNone/>
             </a:pPr>
             <a:r>
-              <a:rPr lang="en-US" sz="1600" dirty="0">
+              <a:rPr lang="en-US" sz="1300" dirty="0">
                 <a:solidFill>
                   <a:schemeClr val="tx2"/>
                 </a:solidFill>
@@ -2240,27 +2263,50 @@
               <a:buNone/>
             </a:pPr>
             <a:r>
-              <a:rPr lang="en-US" sz="2000" dirty="0">
-                <a:solidFill>
-                  <a:schemeClr val="bg1"/>
+              <a:rPr lang="en-US" sz="1800" dirty="0">
+                <a:solidFill>
+                  <a:schemeClr val="tx1"/>
                 </a:solidFill>
               </a:rPr>
               <a:t>@dra.rosanaa</a:t>
             </a:r>
-            <a:endParaRPr lang="en-US" sz="1600" dirty="0"/>
-          </a:p>
-        </p:txBody>
-      </p:sp>
-      <p:sp>
-        <p:nvSpPr>
-          <p:cNvPr id="10" name="WhatsApp"/>
+            <a:endParaRPr lang="en-US" sz="1300" dirty="0"/>
+          </a:p>
+        </p:txBody>
+      </p:sp>
+      <p:sp>
+        <p:nvSpPr>
+          <p:cNvPr id="8" name="Fio 2"/>
+          <p:cNvSpPr/>
+          <p:nvPr/>
+        </p:nvSpPr>
+        <p:spPr>
+          <a:xfrm>
+            <a:off x="731520" y="4937760"/>
+            <a:ext cx="5852160" cy="0"/>
+          </a:xfrm>
+          <a:prstGeom prst="line">
+            <a:avLst/>
+          </a:prstGeom>
+          <a:noFill/>
+          <a:ln w="12700">
+            <a:solidFill>
+              <a:schemeClr val="accent3"/>
+            </a:solidFill>
+            <a:prstDash val="solid"/>
+          </a:ln>
+        </p:spPr>
+      </p:sp>
+      <p:sp>
+        <p:nvSpPr>
+          <p:cNvPr id="9" name="WhatsApp"/>
           <p:cNvSpPr txBox="1"/>
           <p:nvPr/>
         </p:nvSpPr>
         <p:spPr>
           <a:xfrm>
-            <a:off x="640080" y="4754880"/>
-            <a:ext cx="5486400" cy="457200"/>
+            <a:off x="731520" y="5074920"/>
+            <a:ext cx="5852160" cy="457200"/>
           </a:xfrm>
           <a:prstGeom prst="rect">
             <a:avLst/>
@@ -2276,7 +2322,7 @@
               <a:buNone/>
             </a:pPr>
             <a:r>
-              <a:rPr lang="en-US" sz="1600" dirty="0">
+              <a:rPr lang="en-US" sz="1300" dirty="0">
                 <a:solidFill>
                   <a:schemeClr val="tx2"/>
                 </a:solidFill>
@@ -2287,11 +2333,11 @@
               <a:buNone/>
             </a:pPr>
             <a:r>
-              <a:rPr lang="en-US" sz="2000" u="sng" dirty="0">
-                <a:solidFill>
-                  <a:schemeClr val="bg1"/>
-                </a:solidFill>
-                <a:hlinkClick r:id="rId4" invalidUrl="" action="" tgtFrame="" tooltip="Falar no WhatsApp" history="1" highlightClick="0" endSnd="0">
+              <a:rPr lang="en-US" sz="1800" u="sng" dirty="0">
+                <a:solidFill>
+                  <a:schemeClr val="tx1"/>
+                </a:solidFill>
+                <a:hlinkClick r:id="rId1" invalidUrl="" action="" tgtFrame="" tooltip="Falar no WhatsApp" history="1" highlightClick="0" endSnd="0">
                   <a:extLst>
                     <a:ext uri="{A12FA001-AC4F-418D-AE19-62706E023703}">
                       <ahyp:hlinkClr xmlns:ahyp="http://schemas.microsoft.com/office/drawing/2018/hyperlinkcolor" val="tx"/>
@@ -2301,28 +2347,163 @@
               </a:rPr>
               <a:t>(62) 98515-0061</a:t>
             </a:r>
-            <a:endParaRPr lang="en-US" sz="1600" dirty="0"/>
-          </a:p>
-        </p:txBody>
+            <a:endParaRPr lang="en-US" sz="1300" dirty="0"/>
+          </a:p>
+        </p:txBody>
+      </p:sp>
+      <p:sp>
+        <p:nvSpPr>
+          <p:cNvPr id="10" name="Fio 3"/>
+          <p:cNvSpPr/>
+          <p:nvPr/>
+        </p:nvSpPr>
+        <p:spPr>
+          <a:xfrm>
+            <a:off x="731520" y="5669280"/>
+            <a:ext cx="5852160" cy="0"/>
+          </a:xfrm>
+          <a:prstGeom prst="line">
+            <a:avLst/>
+          </a:prstGeom>
+          <a:noFill/>
+          <a:ln w="12700">
+            <a:solidFill>
+              <a:schemeClr val="accent3"/>
+            </a:solidFill>
+            <a:prstDash val="solid"/>
+          </a:ln>
+        </p:spPr>
+      </p:sp>
+      <p:sp>
+        <p:nvSpPr>
+          <p:cNvPr id="11" name="Painel vinho"/>
+          <p:cNvSpPr/>
+          <p:nvPr/>
+        </p:nvSpPr>
+        <p:spPr>
+          <a:xfrm>
+            <a:off x="8001000" y="0"/>
+            <a:ext cx="4190695" cy="6858000"/>
+          </a:xfrm>
+          <a:prstGeom prst="rect">
+            <a:avLst/>
+          </a:prstGeom>
+          <a:solidFill>
+            <a:schemeClr val="accent1"/>
+          </a:solidFill>
+          <a:ln w="12700">
+            <a:solidFill>
+              <a:schemeClr val="accent1"/>
+            </a:solidFill>
+            <a:prstDash val="solid"/>
+          </a:ln>
+        </p:spPr>
+      </p:sp>
+      <p:sp>
+        <p:nvSpPr>
+          <p:cNvPr id="12" name="Fundo QR"/>
+          <p:cNvSpPr/>
+          <p:nvPr/>
+        </p:nvSpPr>
+        <p:spPr>
+          <a:xfrm>
+            <a:off x="8595360" y="1417320"/>
+            <a:ext cx="3017520" cy="3017520"/>
+          </a:xfrm>
+          <a:prstGeom prst="rect">
+            <a:avLst/>
+          </a:prstGeom>
+          <a:solidFill>
+            <a:schemeClr val="bg1"/>
+          </a:solidFill>
+          <a:ln w="12700">
+            <a:solidFill>
+              <a:schemeClr val="bg1"/>
+            </a:solidFill>
+            <a:prstDash val="solid"/>
+          </a:ln>
+        </p:spPr>
       </p:sp>
       <p:pic>
         <p:nvPicPr>
-          <p:cNvPr id="11" name="Logo" descr="Logo Dra. Rosana Vecchi Caldas">    </p:cNvPr>
+          <p:cNvPr id="13" name="QR code WhatsApp" descr="QR code que abre o WhatsApp (62) 98515-0061 com a mensagem: Olá, quero saber mais do Programa de Formação Internacional">
+            <a:hlinkClick r:id="rId3" tooltip="Falar no WhatsApp"/>
+          </p:cNvPr>
           <p:cNvPicPr>
             <a:picLocks noChangeAspect="1"/>
           </p:cNvPicPr>
           <p:nvPr/>
         </p:nvPicPr>
         <p:blipFill>
-          <a:blip r:embed="rId5"/>
+          <a:blip r:embed="rId2"/>
           <a:stretch>
             <a:fillRect/>
           </a:stretch>
         </p:blipFill>
         <p:spPr>
           <a:xfrm>
-            <a:off x="548640" y="5486400"/>
-            <a:ext cx="1051560" cy="1051560"/>
+            <a:off x="8732520" y="1554480"/>
+            <a:ext cx="2743200" cy="2743200"/>
+          </a:xfrm>
+          <a:prstGeom prst="rect">
+            <a:avLst/>
+          </a:prstGeom>
+        </p:spPr>
+      </p:pic>
+      <p:sp>
+        <p:nvSpPr>
+          <p:cNvPr id="14" name="Text 11"/>
+          <p:cNvSpPr txBox="1"/>
+          <p:nvPr/>
+        </p:nvSpPr>
+        <p:spPr>
+          <a:xfrm>
+            <a:off x="8595360" y="4663440"/>
+            <a:ext cx="3017520" cy="731520"/>
+          </a:xfrm>
+          <a:prstGeom prst="rect">
+            <a:avLst/>
+          </a:prstGeom>
+          <a:noFill/>
+          <a:ln/>
+        </p:spPr>
+        <p:txBody>
+          <a:bodyPr wrap="square" lIns="0" tIns="0" rIns="0" bIns="0" rtlCol="0" anchor="t"/>
+          <a:lstStyle/>
+          <a:p>
+            <a:pPr algn="ctr" indent="0" marL="0">
+              <a:buNone/>
+            </a:pPr>
+            <a:r>
+              <a:rPr lang="en-US" sz="1300" dirty="0">
+                <a:solidFill>
+                  <a:schemeClr val="accent4"/>
+                </a:solidFill>
+              </a:rPr>
+              <a:t>Aponte a câmera do celular para falar com a equipe no WhatsApp</a:t>
+            </a:r>
+            <a:endParaRPr lang="en-US" sz="1300" dirty="0"/>
+          </a:p>
+        </p:txBody>
+      </p:sp>
+      <p:pic>
+        <p:nvPicPr>
+          <p:cNvPr id="15" name="Logo" descr="Logo Dra. Rosana Vecchi Caldas">    </p:cNvPr>
+          <p:cNvPicPr>
+            <a:picLocks noChangeAspect="1"/>
+          </p:cNvPicPr>
+          <p:nvPr/>
+        </p:nvPicPr>
+        <p:blipFill>
+          <a:blip r:embed="rId4"/>
+          <a:stretch>
+            <a:fillRect/>
+          </a:stretch>
+        </p:blipFill>
+        <p:spPr>
+          <a:xfrm>
+            <a:off x="9601200" y="5532120"/>
+            <a:ext cx="1005840" cy="1005840"/>
           </a:xfrm>
           <a:prstGeom prst="rect">
             <a:avLst/>
@@ -2383,67 +2564,187 @@
       </p:pic>
       <p:sp>
         <p:nvSpPr>
-          <p:cNvPr id="3" name="Escurecer foto"/>
+          <p:cNvPr id="3" name="Text 0"/>
+          <p:cNvSpPr txBox="1"/>
+          <p:nvPr/>
+        </p:nvSpPr>
+        <p:spPr>
+          <a:xfrm>
+            <a:off x="731520" y="1188720"/>
+            <a:ext cx="5852160" cy="365760"/>
+          </a:xfrm>
+          <a:prstGeom prst="rect">
+            <a:avLst/>
+          </a:prstGeom>
+          <a:noFill/>
+          <a:ln/>
+        </p:spPr>
+        <p:txBody>
+          <a:bodyPr wrap="square" lIns="0" tIns="0" rIns="0" bIns="0" rtlCol="0" anchor="t"/>
+          <a:lstStyle/>
+          <a:p>
+            <a:pPr indent="0" marL="0">
+              <a:buNone/>
+            </a:pPr>
+            <a:r>
+              <a:rPr lang="en-US" sz="1400" dirty="0">
+                <a:solidFill>
+                  <a:schemeClr val="accent4"/>
+                </a:solidFill>
+              </a:rPr>
+              <a:t>Programa de Formação Internacional</a:t>
+            </a:r>
+            <a:endParaRPr lang="en-US" sz="1400" dirty="0"/>
+          </a:p>
+        </p:txBody>
+      </p:sp>
+      <p:sp>
+        <p:nvSpPr>
+          <p:cNvPr id="4" name="Text 1"/>
+          <p:cNvSpPr txBox="1"/>
+          <p:nvPr/>
+        </p:nvSpPr>
+        <p:spPr>
+          <a:xfrm>
+            <a:off x="731520" y="1874520"/>
+            <a:ext cx="5852160" cy="640080"/>
+          </a:xfrm>
+          <a:prstGeom prst="rect">
+            <a:avLst/>
+          </a:prstGeom>
+          <a:noFill/>
+          <a:ln/>
+        </p:spPr>
+        <p:txBody>
+          <a:bodyPr wrap="square" lIns="0" tIns="0" rIns="0" bIns="0" rtlCol="0" anchor="t"/>
+          <a:lstStyle/>
+          <a:p>
+            <a:pPr indent="0" marL="0">
+              <a:buNone/>
+            </a:pPr>
+            <a:r>
+              <a:rPr lang="en-US" sz="3400" i="1" dirty="0">
+                <a:solidFill>
+                  <a:schemeClr val="accent4"/>
+                </a:solidFill>
+                <a:latin typeface="Garamond" pitchFamily="34" charset="0"/>
+                <a:ea typeface="Garamond" pitchFamily="34" charset="-122"/>
+                <a:cs typeface="Garamond" pitchFamily="34" charset="-120"/>
+              </a:rPr>
+              <a:t>Etapa de</a:t>
+            </a:r>
+            <a:endParaRPr lang="en-US" sz="3400" dirty="0"/>
+          </a:p>
+        </p:txBody>
+      </p:sp>
+      <p:sp>
+        <p:nvSpPr>
+          <p:cNvPr id="5" name="Título"/>
+          <p:cNvSpPr txBox="1"/>
+          <p:nvPr/>
+        </p:nvSpPr>
+        <p:spPr>
+          <a:xfrm>
+            <a:off x="685800" y="2377440"/>
+            <a:ext cx="6035040" cy="1463040"/>
+          </a:xfrm>
+          <a:prstGeom prst="rect">
+            <a:avLst/>
+          </a:prstGeom>
+          <a:noFill/>
+          <a:ln/>
+        </p:spPr>
+        <p:txBody>
+          <a:bodyPr wrap="square" lIns="0" tIns="0" rIns="0" bIns="0" rtlCol="0" anchor="t"/>
+          <a:lstStyle/>
+          <a:p>
+            <a:pPr indent="0" marL="0">
+              <a:buNone/>
+            </a:pPr>
+            <a:r>
+              <a:rPr lang="en-US" sz="10800" dirty="0">
+                <a:solidFill>
+                  <a:schemeClr val="bg1"/>
+                </a:solidFill>
+                <a:latin typeface="Garamond" pitchFamily="34" charset="0"/>
+                <a:ea typeface="Garamond" pitchFamily="34" charset="-122"/>
+                <a:cs typeface="Garamond" pitchFamily="34" charset="-120"/>
+              </a:rPr>
+              <a:t>Miami</a:t>
+            </a:r>
+            <a:endParaRPr lang="en-US" sz="10800" dirty="0"/>
+          </a:p>
+        </p:txBody>
+      </p:sp>
+      <p:sp>
+        <p:nvSpPr>
+          <p:cNvPr id="6" name="Text 3"/>
+          <p:cNvSpPr txBox="1"/>
+          <p:nvPr/>
+        </p:nvSpPr>
+        <p:spPr>
+          <a:xfrm>
+            <a:off x="731520" y="4069080"/>
+            <a:ext cx="5394960" cy="822960"/>
+          </a:xfrm>
+          <a:prstGeom prst="rect">
+            <a:avLst/>
+          </a:prstGeom>
+          <a:noFill/>
+          <a:ln/>
+        </p:spPr>
+        <p:txBody>
+          <a:bodyPr wrap="square" lIns="0" tIns="0" rIns="0" bIns="0" rtlCol="0" anchor="t"/>
+          <a:lstStyle/>
+          <a:p>
+            <a:pPr indent="0" marL="0">
+              <a:buNone/>
+            </a:pPr>
+            <a:r>
+              <a:rPr lang="en-US" sz="1700" dirty="0">
+                <a:solidFill>
+                  <a:schemeClr val="accent4"/>
+                </a:solidFill>
+              </a:rPr>
+              <a:t>Imersão de 3 dias com prática real em laboratório de specimen</a:t>
+            </a:r>
+            <a:endParaRPr lang="en-US" sz="1700" dirty="0"/>
+          </a:p>
+        </p:txBody>
+      </p:sp>
+      <p:sp>
+        <p:nvSpPr>
+          <p:cNvPr id="7" name="Fio"/>
           <p:cNvSpPr/>
           <p:nvPr/>
         </p:nvSpPr>
         <p:spPr>
           <a:xfrm>
-            <a:off x="7050024" y="0"/>
-            <a:ext cx="5143500" cy="6858000"/>
-          </a:xfrm>
-          <a:prstGeom prst="rect">
-            <a:avLst/>
-          </a:prstGeom>
-          <a:solidFill>
-            <a:schemeClr val="tx1">
-              <a:alpha val="20000"/>
-            </a:schemeClr>
-          </a:solidFill>
-          <a:ln w="12700">
+            <a:off x="731520" y="5074920"/>
+            <a:ext cx="822960" cy="0"/>
+          </a:xfrm>
+          <a:prstGeom prst="line">
+            <a:avLst/>
+          </a:prstGeom>
+          <a:noFill/>
+          <a:ln w="15875">
             <a:solidFill>
-              <a:schemeClr val="tx1">
-                <a:alpha val="0"/>
-              </a:schemeClr>
+              <a:schemeClr val="accent2"/>
             </a:solidFill>
             <a:prstDash val="solid"/>
           </a:ln>
         </p:spPr>
       </p:sp>
-      <p:pic>
-        <p:nvPicPr>
-          <p:cNvPr id="4" name="Bandeira" descr="Bandeira dos Estados Unidos tremulando">    </p:cNvPr>
-          <p:cNvPicPr>
-            <a:picLocks noChangeAspect="1"/>
-          </p:cNvPicPr>
-          <p:nvPr/>
-        </p:nvPicPr>
-        <p:blipFill>
-          <a:blip r:embed="rId2"/>
-          <a:stretch>
-            <a:fillRect/>
-          </a:stretch>
-        </p:blipFill>
-        <p:spPr>
-          <a:xfrm>
-            <a:off x="5852160" y="91440"/>
-            <a:ext cx="3108960" cy="2075688"/>
-          </a:xfrm>
-          <a:prstGeom prst="rect">
-            <a:avLst/>
-          </a:prstGeom>
-        </p:spPr>
-      </p:pic>
-      <p:sp>
-        <p:nvSpPr>
-          <p:cNvPr id="5" name="Programa"/>
+      <p:sp>
+        <p:nvSpPr>
+          <p:cNvPr id="8" name="Data"/>
           <p:cNvSpPr txBox="1"/>
           <p:nvPr/>
         </p:nvSpPr>
         <p:spPr>
           <a:xfrm>
-            <a:off x="640080" y="1417320"/>
-            <a:ext cx="5120640" cy="274320"/>
+            <a:off x="731520" y="5257800"/>
+            <a:ext cx="5852160" cy="457200"/>
           </a:xfrm>
           <a:prstGeom prst="rect">
             <a:avLst/>
@@ -2452,201 +2753,57 @@
           <a:ln/>
         </p:spPr>
         <p:txBody>
-          <a:bodyPr wrap="square" lIns="0" tIns="0" rIns="0" bIns="0" rtlCol="0" anchor="ctr"/>
+          <a:bodyPr wrap="square" lIns="0" tIns="0" rIns="0" bIns="0" rtlCol="0" anchor="t"/>
           <a:lstStyle/>
           <a:p>
             <a:pPr indent="0" marL="0">
               <a:buNone/>
             </a:pPr>
             <a:r>
-              <a:rPr lang="en-US" sz="1200" spc="300" kern="0" dirty="0">
-                <a:solidFill>
-                  <a:schemeClr val="accent4"/>
-                </a:solidFill>
-              </a:rPr>
-              <a:t>PROGRAMA DE FORMAÇÃO INTERNACIONAL</a:t>
-            </a:r>
-            <a:endParaRPr lang="en-US" sz="1200" dirty="0"/>
-          </a:p>
-        </p:txBody>
-      </p:sp>
-      <p:sp>
-        <p:nvSpPr>
-          <p:cNvPr id="6" name="Etapa de"/>
-          <p:cNvSpPr txBox="1"/>
-          <p:nvPr/>
-        </p:nvSpPr>
-        <p:spPr>
-          <a:xfrm>
-            <a:off x="640080" y="2148840"/>
-            <a:ext cx="4572000" cy="548640"/>
-          </a:xfrm>
-          <a:prstGeom prst="rect">
-            <a:avLst/>
-          </a:prstGeom>
-          <a:noFill/>
-          <a:ln/>
-        </p:spPr>
-        <p:txBody>
-          <a:bodyPr wrap="square" lIns="0" tIns="0" rIns="0" bIns="0" rtlCol="0" anchor="ctr"/>
-          <a:lstStyle/>
-          <a:p>
-            <a:pPr indent="0" marL="0">
-              <a:buNone/>
-            </a:pPr>
-            <a:r>
-              <a:rPr lang="en-US" sz="2800" spc="600" kern="0" dirty="0">
-                <a:solidFill>
-                  <a:schemeClr val="accent6"/>
-                </a:solidFill>
-                <a:latin typeface="Georgia" pitchFamily="34" charset="0"/>
-                <a:ea typeface="Georgia" pitchFamily="34" charset="-122"/>
-                <a:cs typeface="Georgia" pitchFamily="34" charset="-120"/>
-              </a:rPr>
-              <a:t>Etapa de</a:t>
-            </a:r>
-            <a:endParaRPr lang="en-US" sz="2800" dirty="0"/>
-          </a:p>
-        </p:txBody>
-      </p:sp>
-      <p:sp>
-        <p:nvSpPr>
-          <p:cNvPr id="7" name="Título da capa"/>
-          <p:cNvSpPr txBox="1"/>
-          <p:nvPr/>
-        </p:nvSpPr>
-        <p:spPr>
-          <a:xfrm>
-            <a:off x="548640" y="2651760"/>
-            <a:ext cx="6583680" cy="1463040"/>
-          </a:xfrm>
-          <a:prstGeom prst="rect">
-            <a:avLst/>
-          </a:prstGeom>
-          <a:noFill/>
-          <a:ln/>
-        </p:spPr>
-        <p:txBody>
-          <a:bodyPr wrap="square" lIns="0" tIns="0" rIns="0" bIns="0" rtlCol="0" anchor="ctr"/>
-          <a:lstStyle/>
-          <a:p>
-            <a:pPr indent="0" marL="0">
-              <a:buNone/>
-            </a:pPr>
-            <a:r>
-              <a:rPr lang="en-US" sz="11000" spc="600" kern="0" dirty="0">
+              <a:rPr lang="en-US" sz="2400" dirty="0">
                 <a:solidFill>
                   <a:schemeClr val="bg1"/>
                 </a:solidFill>
-                <a:latin typeface="Georgia" pitchFamily="34" charset="0"/>
-                <a:ea typeface="Georgia" pitchFamily="34" charset="-122"/>
-                <a:cs typeface="Georgia" pitchFamily="34" charset="-120"/>
-              </a:rPr>
-              <a:t>MIAMI</a:t>
-            </a:r>
-            <a:endParaRPr lang="en-US" sz="11000" dirty="0"/>
-          </a:p>
-        </p:txBody>
-      </p:sp>
-      <p:sp>
-        <p:nvSpPr>
-          <p:cNvPr id="8" name="Subtítulo"/>
-          <p:cNvSpPr txBox="1"/>
-          <p:nvPr/>
-        </p:nvSpPr>
-        <p:spPr>
-          <a:xfrm>
-            <a:off x="640080" y="4160520"/>
-            <a:ext cx="5120640" cy="822960"/>
-          </a:xfrm>
-          <a:prstGeom prst="rect">
-            <a:avLst/>
-          </a:prstGeom>
-          <a:noFill/>
-          <a:ln/>
-        </p:spPr>
-        <p:txBody>
-          <a:bodyPr wrap="square" lIns="0" tIns="0" rIns="0" bIns="0" rtlCol="0" anchor="t"/>
-          <a:lstStyle/>
-          <a:p>
-            <a:pPr indent="0" marL="0">
-              <a:buNone/>
-            </a:pPr>
-            <a:r>
-              <a:rPr lang="en-US" sz="1800" dirty="0">
-                <a:solidFill>
-                  <a:schemeClr val="accent4"/>
-                </a:solidFill>
-              </a:rPr>
-              <a:t>Imersão de 3 dias com prática real em laboratório de specimen</a:t>
-            </a:r>
-            <a:endParaRPr lang="en-US" sz="1800" dirty="0"/>
-          </a:p>
-        </p:txBody>
-      </p:sp>
-      <p:sp>
-        <p:nvSpPr>
-          <p:cNvPr id="9" name="Data"/>
-          <p:cNvSpPr txBox="1"/>
-          <p:nvPr/>
-        </p:nvSpPr>
-        <p:spPr>
-          <a:xfrm>
-            <a:off x="640080" y="4937760"/>
-            <a:ext cx="5943600" cy="411480"/>
-          </a:xfrm>
-          <a:prstGeom prst="rect">
-            <a:avLst/>
-          </a:prstGeom>
-          <a:noFill/>
-          <a:ln/>
-        </p:spPr>
-        <p:txBody>
-          <a:bodyPr wrap="square" lIns="0" tIns="0" rIns="0" bIns="0" rtlCol="0" anchor="ctr"/>
-          <a:lstStyle/>
-          <a:p>
-            <a:pPr indent="0" marL="0">
-              <a:buNone/>
-            </a:pPr>
-            <a:r>
-              <a:rPr lang="en-US" sz="2000" dirty="0">
-                <a:solidFill>
-                  <a:schemeClr val="bg1"/>
-                </a:solidFill>
-                <a:latin typeface="Georgia" pitchFamily="34" charset="0"/>
-                <a:ea typeface="Georgia" pitchFamily="34" charset="-122"/>
-                <a:cs typeface="Georgia" pitchFamily="34" charset="-120"/>
+                <a:latin typeface="Garamond" pitchFamily="34" charset="0"/>
+                <a:ea typeface="Garamond" pitchFamily="34" charset="-122"/>
+                <a:cs typeface="Garamond" pitchFamily="34" charset="-120"/>
               </a:rPr>
               <a:t>19, 20 e 21 de maio de 2027</a:t>
             </a:r>
-            <a:endParaRPr lang="en-US" sz="2000" dirty="0"/>
-          </a:p>
-        </p:txBody>
-      </p:sp>
-      <p:pic>
-        <p:nvPicPr>
-          <p:cNvPr id="10" name="Logo" descr="Logo Dra. Rosana Vecchi Caldas">    </p:cNvPr>
-          <p:cNvPicPr>
-            <a:picLocks noChangeAspect="1"/>
-          </p:cNvPicPr>
-          <p:nvPr/>
-        </p:nvPicPr>
-        <p:blipFill>
-          <a:blip r:embed="rId3"/>
-          <a:stretch>
-            <a:fillRect/>
-          </a:stretch>
-        </p:blipFill>
-        <p:spPr>
-          <a:xfrm>
-            <a:off x="548640" y="5486400"/>
-            <a:ext cx="1051560" cy="1051560"/>
-          </a:xfrm>
-          <a:prstGeom prst="rect">
-            <a:avLst/>
-          </a:prstGeom>
-        </p:spPr>
-      </p:pic>
+            <a:endParaRPr lang="en-US" sz="2400" dirty="0"/>
+          </a:p>
+        </p:txBody>
+      </p:sp>
+      <p:sp>
+        <p:nvSpPr>
+          <p:cNvPr id="9" name="Text 0"/>
+          <p:cNvSpPr/>
+          <p:nvPr>
+            <p:ph idx="100" type="title" hasCustomPrompt="1"/>
+          </p:nvPr>
+        </p:nvSpPr>
+        <p:spPr>
+          <a:xfrm>
+            <a:off x="731520" y="777240"/>
+            <a:ext cx="10698480" cy="914400"/>
+          </a:xfrm>
+          <a:prstGeom prst="rect">
+            <a:avLst/>
+          </a:prstGeom>
+          <a:noFill/>
+          <a:ln/>
+        </p:spPr>
+        <p:txBody>
+          <a:bodyPr wrap="square" lIns="0" tIns="0" rIns="0" bIns="0" rtlCol="0" anchor="t"/>
+          <a:lstStyle/>
+          <a:p>
+            <a:pPr algn="l" indent="0" marL="0">
+              <a:buNone/>
+            </a:pPr>
+            <a:endParaRPr lang="en-US" sz="4400" dirty="0"/>
+          </a:p>
+        </p:txBody>
+      </p:sp>
     </p:spTree>
   </p:cSld>
   <p:clrMapOvr>
@@ -2677,24 +2834,49 @@
       </p:grpSpPr>
       <p:sp>
         <p:nvSpPr>
-          <p:cNvPr id="2" name="Área do vídeo"/>
+          <p:cNvPr id="2" name="Fundo"/>
           <p:cNvSpPr/>
           <p:nvPr/>
         </p:nvSpPr>
         <p:spPr>
           <a:xfrm>
-            <a:off x="640080" y="548640"/>
-            <a:ext cx="10908792" cy="5760720"/>
+            <a:off x="0" y="0"/>
+            <a:ext cx="12191695" cy="6858000"/>
           </a:xfrm>
           <a:prstGeom prst="rect">
             <a:avLst/>
           </a:prstGeom>
           <a:solidFill>
-            <a:schemeClr val="accent3"/>
+            <a:schemeClr val="accent5"/>
           </a:solidFill>
           <a:ln w="12700">
             <a:solidFill>
-              <a:schemeClr val="accent1"/>
+              <a:schemeClr val="accent5"/>
+            </a:solidFill>
+            <a:prstDash val="solid"/>
+          </a:ln>
+        </p:spPr>
+      </p:sp>
+      <p:sp>
+        <p:nvSpPr>
+          <p:cNvPr id="3" name="Área do vídeo"/>
+          <p:cNvSpPr/>
+          <p:nvPr/>
+        </p:nvSpPr>
+        <p:spPr>
+          <a:xfrm>
+            <a:off x="731520" y="640080"/>
+            <a:ext cx="10725912" cy="5577840"/>
+          </a:xfrm>
+          <a:prstGeom prst="rect">
+            <a:avLst/>
+          </a:prstGeom>
+          <a:solidFill>
+            <a:schemeClr val="accent1"/>
+          </a:solidFill>
+          <a:ln w="12700">
+            <a:solidFill>
+              <a:schemeClr val="accent2"/>
             </a:solidFill>
             <a:prstDash val="dash"/>
           </a:ln>
@@ -2702,14 +2884,14 @@
       </p:sp>
       <p:sp>
         <p:nvSpPr>
-          <p:cNvPr id="3" name="Instrução do vídeo"/>
+          <p:cNvPr id="4" name="Instrução do vídeo"/>
           <p:cNvSpPr txBox="1"/>
           <p:nvPr/>
         </p:nvSpPr>
         <p:spPr>
           <a:xfrm>
-            <a:off x="640080" y="548640"/>
-            <a:ext cx="10908792" cy="5760720"/>
+            <a:off x="731520" y="640080"/>
+            <a:ext cx="10725912" cy="5577840"/>
           </a:xfrm>
           <a:prstGeom prst="rect">
             <a:avLst/>
@@ -2725,31 +2907,31 @@
               <a:buNone/>
             </a:pPr>
             <a:r>
-              <a:rPr lang="en-US" sz="3000" dirty="0">
+              <a:rPr lang="en-US" sz="3400" dirty="0">
                 <a:solidFill>
                   <a:schemeClr val="bg1"/>
                 </a:solidFill>
-                <a:latin typeface="Georgia" pitchFamily="34" charset="0"/>
-                <a:ea typeface="Georgia" pitchFamily="34" charset="-122"/>
-                <a:cs typeface="Georgia" pitchFamily="34" charset="-120"/>
+                <a:latin typeface="Garamond" pitchFamily="34" charset="0"/>
+                <a:ea typeface="Garamond" pitchFamily="34" charset="-122"/>
+                <a:cs typeface="Garamond" pitchFamily="34" charset="-120"/>
               </a:rPr>
               <a:t>Insira aqui o vídeo</a:t>
             </a:r>
-            <a:endParaRPr lang="en-US" sz="3000" dirty="0"/>
+            <a:endParaRPr lang="en-US" sz="3400" dirty="0"/>
           </a:p>
           <a:p>
             <a:pPr algn="ctr" indent="0" marL="0">
               <a:buNone/>
             </a:pPr>
             <a:r>
-              <a:rPr lang="en-US" sz="1500" dirty="0">
+              <a:rPr lang="en-US" sz="1400" dirty="0">
                 <a:solidFill>
                   <a:schemeClr val="accent4"/>
                 </a:solidFill>
               </a:rPr>
               <a:t>Inserir  ›  Vídeo  ›  Este dispositivo. Depois apague esta caixa e o retângulo.</a:t>
             </a:r>
-            <a:endParaRPr lang="en-US" sz="3000" dirty="0"/>
+            <a:endParaRPr lang="en-US" sz="3400" dirty="0"/>
           </a:p>
         </p:txBody>
       </p:sp>
@@ -2815,8 +2997,8 @@
         </p:nvSpPr>
         <p:spPr>
           <a:xfrm>
-            <a:off x="640080" y="868680"/>
-            <a:ext cx="10881360" cy="822960"/>
+            <a:off x="731520" y="777240"/>
+            <a:ext cx="10698480" cy="914400"/>
           </a:xfrm>
           <a:prstGeom prst="rect">
             <a:avLst/>
@@ -2832,30 +3014,30 @@
               <a:buNone/>
             </a:pPr>
             <a:r>
-              <a:rPr lang="en-US" sz="3200" spc="200" kern="0" dirty="0">
-                <a:solidFill>
-                  <a:schemeClr val="bg1"/>
-                </a:solidFill>
-                <a:latin typeface="Georgia" pitchFamily="34" charset="0"/>
-                <a:ea typeface="Georgia" pitchFamily="34" charset="-122"/>
-                <a:cs typeface="Georgia" pitchFamily="34" charset="-120"/>
+              <a:rPr lang="en-US" sz="4400" dirty="0">
+                <a:solidFill>
+                  <a:schemeClr val="accent1"/>
+                </a:solidFill>
+                <a:latin typeface="Garamond" pitchFamily="34" charset="0"/>
+                <a:ea typeface="Garamond" pitchFamily="34" charset="-122"/>
+                <a:cs typeface="Garamond" pitchFamily="34" charset="-120"/>
               </a:rPr>
-              <a:t>POR QUE MIAMI?</a:t>
-            </a:r>
-            <a:endParaRPr lang="en-US" sz="3200" dirty="0"/>
-          </a:p>
-        </p:txBody>
-      </p:sp>
-      <p:sp>
-        <p:nvSpPr>
-          <p:cNvPr id="4" name="Texto Miami"/>
+              <a:t>Por que Miami?</a:t>
+            </a:r>
+            <a:endParaRPr lang="en-US" sz="4400" dirty="0"/>
+          </a:p>
+        </p:txBody>
+      </p:sp>
+      <p:sp>
+        <p:nvSpPr>
+          <p:cNvPr id="4" name="Text 1"/>
           <p:cNvSpPr txBox="1"/>
           <p:nvPr/>
         </p:nvSpPr>
         <p:spPr>
           <a:xfrm>
-            <a:off x="640080" y="1920240"/>
-            <a:ext cx="5760720" cy="1371600"/>
+            <a:off x="731520" y="1920240"/>
+            <a:ext cx="5669280" cy="1554480"/>
           </a:xfrm>
           <a:prstGeom prst="rect">
             <a:avLst/>
@@ -2868,30 +3050,56 @@
           <a:lstStyle/>
           <a:p>
             <a:pPr indent="0" marL="0">
-              <a:buNone/>
-            </a:pPr>
-            <a:r>
-              <a:rPr lang="en-US" sz="1700" dirty="0">
-                <a:solidFill>
-                  <a:schemeClr val="accent4"/>
+              <a:lnSpc>
+                <a:spcPct val="115000"/>
+              </a:lnSpc>
+              <a:buNone/>
+            </a:pPr>
+            <a:r>
+              <a:rPr lang="en-US" sz="1600" dirty="0">
+                <a:solidFill>
+                  <a:schemeClr val="tx1"/>
                 </a:solidFill>
               </a:rPr>
               <a:t>Nos Estados Unidos, laboratórios privados de anatomia oferecem estrutura para treinamento hands-on em specimen, a peça anatômica real. Em Miami, o conteúdo científico vira prática.</a:t>
             </a:r>
-            <a:endParaRPr lang="en-US" sz="1700" dirty="0"/>
-          </a:p>
-        </p:txBody>
-      </p:sp>
-      <p:sp>
-        <p:nvSpPr>
-          <p:cNvPr id="5" name="Lista Miami"/>
+            <a:endParaRPr lang="en-US" sz="1600" dirty="0"/>
+          </a:p>
+        </p:txBody>
+      </p:sp>
+      <p:sp>
+        <p:nvSpPr>
+          <p:cNvPr id="5" name="Fio 1"/>
+          <p:cNvSpPr/>
+          <p:nvPr/>
+        </p:nvSpPr>
+        <p:spPr>
+          <a:xfrm>
+            <a:off x="731520" y="3611880"/>
+            <a:ext cx="5669280" cy="0"/>
+          </a:xfrm>
+          <a:prstGeom prst="line">
+            <a:avLst/>
+          </a:prstGeom>
+          <a:noFill/>
+          <a:ln w="12700">
+            <a:solidFill>
+              <a:schemeClr val="accent3"/>
+            </a:solidFill>
+            <a:prstDash val="solid"/>
+          </a:ln>
+        </p:spPr>
+      </p:sp>
+      <p:sp>
+        <p:nvSpPr>
+          <p:cNvPr id="6" name="Item 1 título"/>
           <p:cNvSpPr txBox="1"/>
           <p:nvPr/>
         </p:nvSpPr>
         <p:spPr>
           <a:xfrm>
-            <a:off x="640080" y="3520440"/>
-            <a:ext cx="5760720" cy="1463040"/>
+            <a:off x="731520" y="3721608"/>
+            <a:ext cx="5669280" cy="384048"/>
           </a:xfrm>
           <a:prstGeom prst="rect">
             <a:avLst/>
@@ -2903,71 +3111,132 @@
           <a:bodyPr wrap="square" lIns="0" tIns="0" rIns="0" bIns="0" rtlCol="0" anchor="t"/>
           <a:lstStyle/>
           <a:p>
-            <a:pPr marL="342900" indent="-342900">
-              <a:spcAft>
-                <a:spcPts val="1000"/>
-              </a:spcAft>
-              <a:buSzPct val="100000"/>
-              <a:buChar char="•"/>
-            </a:pPr>
-            <a:r>
-              <a:rPr lang="en-US" sz="1700" dirty="0">
-                <a:solidFill>
-                  <a:schemeClr val="bg1"/>
-                </a:solidFill>
+            <a:pPr indent="0" marL="0">
+              <a:buNone/>
+            </a:pPr>
+            <a:r>
+              <a:rPr lang="en-US" sz="2200" dirty="0">
+                <a:solidFill>
+                  <a:schemeClr val="accent1"/>
+                </a:solidFill>
+                <a:latin typeface="Garamond" pitchFamily="34" charset="0"/>
+                <a:ea typeface="Garamond" pitchFamily="34" charset="-122"/>
+                <a:cs typeface="Garamond" pitchFamily="34" charset="-120"/>
               </a:rPr>
-              <a:t>Imersão de 3 dias com prática real</a:t>
-            </a:r>
-            <a:endParaRPr lang="en-US" sz="1700" dirty="0"/>
-          </a:p>
-          <a:p>
-            <a:pPr marL="342900" indent="-342900">
-              <a:spcAft>
-                <a:spcPts val="1000"/>
-              </a:spcAft>
-              <a:buSzPct val="100000"/>
-              <a:buChar char="•"/>
-            </a:pPr>
-            <a:r>
-              <a:rPr lang="en-US" sz="1700" dirty="0">
-                <a:solidFill>
-                  <a:schemeClr val="bg1"/>
+              <a:t>Imersão de 3 dias</a:t>
+            </a:r>
+            <a:endParaRPr lang="en-US" sz="2200" dirty="0"/>
+          </a:p>
+        </p:txBody>
+      </p:sp>
+      <p:sp>
+        <p:nvSpPr>
+          <p:cNvPr id="7" name="Item 1 texto"/>
+          <p:cNvSpPr txBox="1"/>
+          <p:nvPr/>
+        </p:nvSpPr>
+        <p:spPr>
+          <a:xfrm>
+            <a:off x="731520" y="4096512"/>
+            <a:ext cx="5669280" cy="292608"/>
+          </a:xfrm>
+          <a:prstGeom prst="rect">
+            <a:avLst/>
+          </a:prstGeom>
+          <a:noFill/>
+          <a:ln/>
+        </p:spPr>
+        <p:txBody>
+          <a:bodyPr wrap="square" lIns="0" tIns="0" rIns="0" bIns="0" rtlCol="0" anchor="t"/>
+          <a:lstStyle/>
+          <a:p>
+            <a:pPr indent="0" marL="0">
+              <a:buNone/>
+            </a:pPr>
+            <a:r>
+              <a:rPr lang="en-US" sz="1400" dirty="0">
+                <a:solidFill>
+                  <a:schemeClr val="tx2"/>
                 </a:solidFill>
               </a:rPr>
-              <a:t>Laboratórios privados preparados para hands-on avançado</a:t>
-            </a:r>
-            <a:endParaRPr lang="en-US" sz="1700" dirty="0"/>
-          </a:p>
-          <a:p>
-            <a:pPr marL="342900" indent="-342900">
-              <a:spcAft>
-                <a:spcPts val="1000"/>
-              </a:spcAft>
-              <a:buSzPct val="100000"/>
-              <a:buChar char="•"/>
-            </a:pPr>
-            <a:r>
-              <a:rPr lang="en-US" sz="1700" dirty="0">
-                <a:solidFill>
-                  <a:schemeClr val="bg1"/>
-                </a:solidFill>
+              <a:t>com prática real</a:t>
+            </a:r>
+            <a:endParaRPr lang="en-US" sz="1400" dirty="0"/>
+          </a:p>
+        </p:txBody>
+      </p:sp>
+      <p:sp>
+        <p:nvSpPr>
+          <p:cNvPr id="8" name="Fio 2"/>
+          <p:cNvSpPr/>
+          <p:nvPr/>
+        </p:nvSpPr>
+        <p:spPr>
+          <a:xfrm>
+            <a:off x="731520" y="4480560"/>
+            <a:ext cx="5669280" cy="0"/>
+          </a:xfrm>
+          <a:prstGeom prst="line">
+            <a:avLst/>
+          </a:prstGeom>
+          <a:noFill/>
+          <a:ln w="12700">
+            <a:solidFill>
+              <a:schemeClr val="accent3"/>
+            </a:solidFill>
+            <a:prstDash val="solid"/>
+          </a:ln>
+        </p:spPr>
+      </p:sp>
+      <p:sp>
+        <p:nvSpPr>
+          <p:cNvPr id="9" name="Item 2 título"/>
+          <p:cNvSpPr txBox="1"/>
+          <p:nvPr/>
+        </p:nvSpPr>
+        <p:spPr>
+          <a:xfrm>
+            <a:off x="731520" y="4590288"/>
+            <a:ext cx="5669280" cy="384048"/>
+          </a:xfrm>
+          <a:prstGeom prst="rect">
+            <a:avLst/>
+          </a:prstGeom>
+          <a:noFill/>
+          <a:ln/>
+        </p:spPr>
+        <p:txBody>
+          <a:bodyPr wrap="square" lIns="0" tIns="0" rIns="0" bIns="0" rtlCol="0" anchor="t"/>
+          <a:lstStyle/>
+          <a:p>
+            <a:pPr indent="0" marL="0">
+              <a:buNone/>
+            </a:pPr>
+            <a:r>
+              <a:rPr lang="en-US" sz="2200" dirty="0">
+                <a:solidFill>
+                  <a:schemeClr val="accent1"/>
+                </a:solidFill>
+                <a:latin typeface="Garamond" pitchFamily="34" charset="0"/>
+                <a:ea typeface="Garamond" pitchFamily="34" charset="-122"/>
+                <a:cs typeface="Garamond" pitchFamily="34" charset="-120"/>
               </a:rPr>
-              <a:t>Anatomia aplicada direto na peça anatômica</a:t>
-            </a:r>
-            <a:endParaRPr lang="en-US" sz="1700" dirty="0"/>
-          </a:p>
-        </p:txBody>
-      </p:sp>
-      <p:sp>
-        <p:nvSpPr>
-          <p:cNvPr id="6" name="Data"/>
+              <a:t>Laboratórios privados</a:t>
+            </a:r>
+            <a:endParaRPr lang="en-US" sz="2200" dirty="0"/>
+          </a:p>
+        </p:txBody>
+      </p:sp>
+      <p:sp>
+        <p:nvSpPr>
+          <p:cNvPr id="10" name="Item 2 texto"/>
           <p:cNvSpPr txBox="1"/>
           <p:nvPr/>
         </p:nvSpPr>
         <p:spPr>
           <a:xfrm>
-            <a:off x="640080" y="5349240"/>
-            <a:ext cx="5760720" cy="411480"/>
+            <a:off x="731520" y="4965192"/>
+            <a:ext cx="5669280" cy="292608"/>
           </a:xfrm>
           <a:prstGeom prst="rect">
             <a:avLst/>
@@ -2976,24 +3245,119 @@
           <a:ln/>
         </p:spPr>
         <p:txBody>
-          <a:bodyPr wrap="square" lIns="0" tIns="0" rIns="0" bIns="0" rtlCol="0" anchor="ctr"/>
+          <a:bodyPr wrap="square" lIns="0" tIns="0" rIns="0" bIns="0" rtlCol="0" anchor="t"/>
           <a:lstStyle/>
           <a:p>
             <a:pPr indent="0" marL="0">
               <a:buNone/>
             </a:pPr>
             <a:r>
-              <a:rPr lang="en-US" sz="2000" dirty="0">
-                <a:solidFill>
-                  <a:schemeClr val="bg1"/>
-                </a:solidFill>
-                <a:latin typeface="Georgia" pitchFamily="34" charset="0"/>
-                <a:ea typeface="Georgia" pitchFamily="34" charset="-122"/>
-                <a:cs typeface="Georgia" pitchFamily="34" charset="-120"/>
+              <a:rPr lang="en-US" sz="1400" dirty="0">
+                <a:solidFill>
+                  <a:schemeClr val="tx2"/>
+                </a:solidFill>
               </a:rPr>
-              <a:t>19, 20 e 21 de maio de 2027</a:t>
-            </a:r>
-            <a:endParaRPr lang="en-US" sz="2000" dirty="0"/>
+              <a:t>preparados para hands-on avançado</a:t>
+            </a:r>
+            <a:endParaRPr lang="en-US" sz="1400" dirty="0"/>
+          </a:p>
+        </p:txBody>
+      </p:sp>
+      <p:sp>
+        <p:nvSpPr>
+          <p:cNvPr id="11" name="Fio 3"/>
+          <p:cNvSpPr/>
+          <p:nvPr/>
+        </p:nvSpPr>
+        <p:spPr>
+          <a:xfrm>
+            <a:off x="731520" y="5349240"/>
+            <a:ext cx="5669280" cy="0"/>
+          </a:xfrm>
+          <a:prstGeom prst="line">
+            <a:avLst/>
+          </a:prstGeom>
+          <a:noFill/>
+          <a:ln w="12700">
+            <a:solidFill>
+              <a:schemeClr val="accent3"/>
+            </a:solidFill>
+            <a:prstDash val="solid"/>
+          </a:ln>
+        </p:spPr>
+      </p:sp>
+      <p:sp>
+        <p:nvSpPr>
+          <p:cNvPr id="12" name="Item 3 título"/>
+          <p:cNvSpPr txBox="1"/>
+          <p:nvPr/>
+        </p:nvSpPr>
+        <p:spPr>
+          <a:xfrm>
+            <a:off x="731520" y="5458968"/>
+            <a:ext cx="5669280" cy="384048"/>
+          </a:xfrm>
+          <a:prstGeom prst="rect">
+            <a:avLst/>
+          </a:prstGeom>
+          <a:noFill/>
+          <a:ln/>
+        </p:spPr>
+        <p:txBody>
+          <a:bodyPr wrap="square" lIns="0" tIns="0" rIns="0" bIns="0" rtlCol="0" anchor="t"/>
+          <a:lstStyle/>
+          <a:p>
+            <a:pPr indent="0" marL="0">
+              <a:buNone/>
+            </a:pPr>
+            <a:r>
+              <a:rPr lang="en-US" sz="2200" dirty="0">
+                <a:solidFill>
+                  <a:schemeClr val="accent1"/>
+                </a:solidFill>
+                <a:latin typeface="Garamond" pitchFamily="34" charset="0"/>
+                <a:ea typeface="Garamond" pitchFamily="34" charset="-122"/>
+                <a:cs typeface="Garamond" pitchFamily="34" charset="-120"/>
+              </a:rPr>
+              <a:t>Anatomia aplicada</a:t>
+            </a:r>
+            <a:endParaRPr lang="en-US" sz="2200" dirty="0"/>
+          </a:p>
+        </p:txBody>
+      </p:sp>
+      <p:sp>
+        <p:nvSpPr>
+          <p:cNvPr id="13" name="Item 3 texto"/>
+          <p:cNvSpPr txBox="1"/>
+          <p:nvPr/>
+        </p:nvSpPr>
+        <p:spPr>
+          <a:xfrm>
+            <a:off x="731520" y="5833872"/>
+            <a:ext cx="5669280" cy="292608"/>
+          </a:xfrm>
+          <a:prstGeom prst="rect">
+            <a:avLst/>
+          </a:prstGeom>
+          <a:noFill/>
+          <a:ln/>
+        </p:spPr>
+        <p:txBody>
+          <a:bodyPr wrap="square" lIns="0" tIns="0" rIns="0" bIns="0" rtlCol="0" anchor="t"/>
+          <a:lstStyle/>
+          <a:p>
+            <a:pPr indent="0" marL="0">
+              <a:buNone/>
+            </a:pPr>
+            <a:r>
+              <a:rPr lang="en-US" sz="1400" dirty="0">
+                <a:solidFill>
+                  <a:schemeClr val="tx2"/>
+                </a:solidFill>
+              </a:rPr>
+              <a:t>direto na peça anatômica</a:t>
+            </a:r>
+            <a:endParaRPr lang="en-US" sz="1400" dirty="0"/>
           </a:p>
         </p:txBody>
       </p:sp>
@@ -3080,8 +3444,8 @@
         </p:nvSpPr>
         <p:spPr>
           <a:xfrm>
-            <a:off x="640080" y="868680"/>
-            <a:ext cx="10881360" cy="822960"/>
+            <a:off x="731520" y="777240"/>
+            <a:ext cx="10698480" cy="914400"/>
           </a:xfrm>
           <a:prstGeom prst="rect">
             <a:avLst/>
@@ -3097,30 +3461,30 @@
               <a:buNone/>
             </a:pPr>
             <a:r>
-              <a:rPr lang="en-US" sz="3200" spc="200" kern="0" dirty="0">
-                <a:solidFill>
-                  <a:schemeClr val="bg1"/>
-                </a:solidFill>
-                <a:latin typeface="Georgia" pitchFamily="34" charset="0"/>
-                <a:ea typeface="Georgia" pitchFamily="34" charset="-122"/>
-                <a:cs typeface="Georgia" pitchFamily="34" charset="-120"/>
+              <a:rPr lang="en-US" sz="4400" dirty="0">
+                <a:solidFill>
+                  <a:schemeClr val="accent1"/>
+                </a:solidFill>
+                <a:latin typeface="Garamond" pitchFamily="34" charset="0"/>
+                <a:ea typeface="Garamond" pitchFamily="34" charset="-122"/>
+                <a:cs typeface="Garamond" pitchFamily="34" charset="-120"/>
               </a:rPr>
-              <a:t>PROGRAMAÇÃO PRÁTICA</a:t>
-            </a:r>
-            <a:endParaRPr lang="en-US" sz="3200" dirty="0"/>
-          </a:p>
-        </p:txBody>
-      </p:sp>
-      <p:sp>
-        <p:nvSpPr>
-          <p:cNvPr id="3" name="Subtítulo"/>
+              <a:t>Programação prática</a:t>
+            </a:r>
+            <a:endParaRPr lang="en-US" sz="4400" dirty="0"/>
+          </a:p>
+        </p:txBody>
+      </p:sp>
+      <p:sp>
+        <p:nvSpPr>
+          <p:cNvPr id="3" name="Text 1"/>
           <p:cNvSpPr txBox="1"/>
           <p:nvPr/>
         </p:nvSpPr>
         <p:spPr>
           <a:xfrm>
-            <a:off x="640080" y="1463040"/>
-            <a:ext cx="6400800" cy="365760"/>
+            <a:off x="731520" y="1600200"/>
+            <a:ext cx="7315200" cy="365760"/>
           </a:xfrm>
           <a:prstGeom prst="rect">
             <a:avLst/>
@@ -3129,78 +3493,42 @@
           <a:ln/>
         </p:spPr>
         <p:txBody>
-          <a:bodyPr wrap="square" lIns="0" tIns="0" rIns="0" bIns="0" rtlCol="0" anchor="ctr"/>
+          <a:bodyPr wrap="square" lIns="0" tIns="0" rIns="0" bIns="0" rtlCol="0" anchor="t"/>
           <a:lstStyle/>
           <a:p>
             <a:pPr indent="0" marL="0">
               <a:buNone/>
             </a:pPr>
             <a:r>
-              <a:rPr lang="en-US" sz="1700" dirty="0">
-                <a:solidFill>
-                  <a:schemeClr val="accent4"/>
+              <a:rPr lang="en-US" sz="1600" dirty="0">
+                <a:solidFill>
+                  <a:schemeClr val="tx2"/>
                 </a:solidFill>
               </a:rPr>
               <a:t>Anatomia aplicada e hands-on</a:t>
             </a:r>
-            <a:endParaRPr lang="en-US" sz="1700" dirty="0"/>
-          </a:p>
-        </p:txBody>
-      </p:sp>
-      <p:sp>
-        <p:nvSpPr>
-          <p:cNvPr id="4" name="Módulo 1"/>
-          <p:cNvSpPr txBox="1"/>
-          <p:nvPr/>
-        </p:nvSpPr>
-        <p:spPr>
-          <a:xfrm>
-            <a:off x="640080" y="2377440"/>
-            <a:ext cx="10881360" cy="548640"/>
-          </a:xfrm>
-          <a:prstGeom prst="rect">
-            <a:avLst/>
-          </a:prstGeom>
-          <a:noFill/>
-          <a:ln/>
-        </p:spPr>
-        <p:txBody>
-          <a:bodyPr wrap="square" lIns="0" tIns="0" rIns="0" bIns="0" rtlCol="0" anchor="ctr"/>
-          <a:lstStyle/>
-          <a:p>
-            <a:pPr indent="0" marL="0">
-              <a:buNone/>
-            </a:pPr>
-            <a:r>
-              <a:rPr lang="en-US" sz="2000" dirty="0">
-                <a:solidFill>
-                  <a:schemeClr val="bg1"/>
-                </a:solidFill>
-              </a:rPr>
-              <a:t>Anatomia avançada de cabeça e pescoço aplicada a injetáveis</a:t>
-            </a:r>
-            <a:endParaRPr lang="en-US" sz="2000" dirty="0"/>
-          </a:p>
-        </p:txBody>
-      </p:sp>
-      <p:sp>
-        <p:nvSpPr>
-          <p:cNvPr id="5" name="Divisória 1"/>
+            <a:endParaRPr lang="en-US" sz="1600" dirty="0"/>
+          </a:p>
+        </p:txBody>
+      </p:sp>
+      <p:sp>
+        <p:nvSpPr>
+          <p:cNvPr id="4" name="Fio 1"/>
           <p:cNvSpPr/>
           <p:nvPr/>
         </p:nvSpPr>
         <p:spPr>
           <a:xfrm>
-            <a:off x="640080" y="3090672"/>
-            <a:ext cx="10881360" cy="0"/>
+            <a:off x="731520" y="2331720"/>
+            <a:ext cx="10725912" cy="0"/>
           </a:xfrm>
           <a:prstGeom prst="line">
             <a:avLst/>
           </a:prstGeom>
           <a:noFill/>
-          <a:ln w="9525">
+          <a:ln w="12700">
             <a:solidFill>
-              <a:schemeClr val="accent5"/>
+              <a:schemeClr val="accent3"/>
             </a:solidFill>
             <a:prstDash val="solid"/>
           </a:ln>
@@ -3208,14 +3536,14 @@
       </p:sp>
       <p:sp>
         <p:nvSpPr>
-          <p:cNvPr id="6" name="Módulo 2"/>
+          <p:cNvPr id="5" name="Módulo 1"/>
           <p:cNvSpPr txBox="1"/>
           <p:nvPr/>
         </p:nvSpPr>
         <p:spPr>
           <a:xfrm>
-            <a:off x="640080" y="3246120"/>
-            <a:ext cx="10881360" cy="548640"/>
+            <a:off x="731520" y="2459736"/>
+            <a:ext cx="10698480" cy="548640"/>
           </a:xfrm>
           <a:prstGeom prst="rect">
             <a:avLst/>
@@ -3231,35 +3559,38 @@
               <a:buNone/>
             </a:pPr>
             <a:r>
-              <a:rPr lang="en-US" sz="2000" dirty="0">
-                <a:solidFill>
-                  <a:schemeClr val="bg1"/>
-                </a:solidFill>
+              <a:rPr lang="en-US" sz="2400" dirty="0">
+                <a:solidFill>
+                  <a:schemeClr val="tx1"/>
+                </a:solidFill>
+                <a:latin typeface="Garamond" pitchFamily="34" charset="0"/>
+                <a:ea typeface="Garamond" pitchFamily="34" charset="-122"/>
+                <a:cs typeface="Garamond" pitchFamily="34" charset="-120"/>
               </a:rPr>
-              <a:t>Anatomia avançada de cabeça e pescoço aplicada a fios faciais</a:t>
-            </a:r>
-            <a:endParaRPr lang="en-US" sz="2000" dirty="0"/>
-          </a:p>
-        </p:txBody>
-      </p:sp>
-      <p:sp>
-        <p:nvSpPr>
-          <p:cNvPr id="7" name="Divisória 2"/>
+              <a:t>Anatomia avançada de cabeça e pescoço aplicada a injetáveis</a:t>
+            </a:r>
+            <a:endParaRPr lang="en-US" sz="2400" dirty="0"/>
+          </a:p>
+        </p:txBody>
+      </p:sp>
+      <p:sp>
+        <p:nvSpPr>
+          <p:cNvPr id="6" name="Fio 2"/>
           <p:cNvSpPr/>
           <p:nvPr/>
         </p:nvSpPr>
         <p:spPr>
           <a:xfrm>
-            <a:off x="640080" y="3959352"/>
-            <a:ext cx="10881360" cy="0"/>
+            <a:off x="731520" y="3118104"/>
+            <a:ext cx="10725912" cy="0"/>
           </a:xfrm>
           <a:prstGeom prst="line">
             <a:avLst/>
           </a:prstGeom>
           <a:noFill/>
-          <a:ln w="9525">
+          <a:ln w="12700">
             <a:solidFill>
-              <a:schemeClr val="accent5"/>
+              <a:schemeClr val="accent3"/>
             </a:solidFill>
             <a:prstDash val="solid"/>
           </a:ln>
@@ -3267,14 +3598,14 @@
       </p:sp>
       <p:sp>
         <p:nvSpPr>
-          <p:cNvPr id="8" name="Módulo 3"/>
+          <p:cNvPr id="7" name="Módulo 2"/>
           <p:cNvSpPr txBox="1"/>
           <p:nvPr/>
         </p:nvSpPr>
         <p:spPr>
           <a:xfrm>
-            <a:off x="640080" y="4114800"/>
-            <a:ext cx="10881360" cy="548640"/>
+            <a:off x="731520" y="3246120"/>
+            <a:ext cx="10698480" cy="548640"/>
           </a:xfrm>
           <a:prstGeom prst="rect">
             <a:avLst/>
@@ -3290,35 +3621,38 @@
               <a:buNone/>
             </a:pPr>
             <a:r>
-              <a:rPr lang="en-US" sz="2000" dirty="0">
-                <a:solidFill>
-                  <a:schemeClr val="bg1"/>
-                </a:solidFill>
+              <a:rPr lang="en-US" sz="2400" dirty="0">
+                <a:solidFill>
+                  <a:schemeClr val="tx1"/>
+                </a:solidFill>
+                <a:latin typeface="Garamond" pitchFamily="34" charset="0"/>
+                <a:ea typeface="Garamond" pitchFamily="34" charset="-122"/>
+                <a:cs typeface="Garamond" pitchFamily="34" charset="-120"/>
               </a:rPr>
-              <a:t>Bioestimuladores faciais e corporais: fundamentos, indicações e limites</a:t>
-            </a:r>
-            <a:endParaRPr lang="en-US" sz="2000" dirty="0"/>
-          </a:p>
-        </p:txBody>
-      </p:sp>
-      <p:sp>
-        <p:nvSpPr>
-          <p:cNvPr id="9" name="Divisória 3"/>
+              <a:t>Anatomia avançada de cabeça e pescoço aplicada a fios faciais</a:t>
+            </a:r>
+            <a:endParaRPr lang="en-US" sz="2400" dirty="0"/>
+          </a:p>
+        </p:txBody>
+      </p:sp>
+      <p:sp>
+        <p:nvSpPr>
+          <p:cNvPr id="8" name="Fio 3"/>
           <p:cNvSpPr/>
           <p:nvPr/>
         </p:nvSpPr>
         <p:spPr>
           <a:xfrm>
-            <a:off x="640080" y="4828032"/>
-            <a:ext cx="10881360" cy="0"/>
+            <a:off x="731520" y="3904488"/>
+            <a:ext cx="10725912" cy="0"/>
           </a:xfrm>
           <a:prstGeom prst="line">
             <a:avLst/>
           </a:prstGeom>
           <a:noFill/>
-          <a:ln w="9525">
+          <a:ln w="12700">
             <a:solidFill>
-              <a:schemeClr val="accent5"/>
+              <a:schemeClr val="accent3"/>
             </a:solidFill>
             <a:prstDash val="solid"/>
           </a:ln>
@@ -3326,14 +3660,14 @@
       </p:sp>
       <p:sp>
         <p:nvSpPr>
-          <p:cNvPr id="10" name="Módulo 4"/>
+          <p:cNvPr id="9" name="Módulo 3"/>
           <p:cNvSpPr txBox="1"/>
           <p:nvPr/>
         </p:nvSpPr>
         <p:spPr>
           <a:xfrm>
-            <a:off x="640080" y="4983480"/>
-            <a:ext cx="10881360" cy="548640"/>
+            <a:off x="731520" y="4032504"/>
+            <a:ext cx="10698480" cy="548640"/>
           </a:xfrm>
           <a:prstGeom prst="rect">
             <a:avLst/>
@@ -3349,35 +3683,38 @@
               <a:buNone/>
             </a:pPr>
             <a:r>
-              <a:rPr lang="en-US" sz="2000" dirty="0">
-                <a:solidFill>
-                  <a:schemeClr val="bg1"/>
-                </a:solidFill>
+              <a:rPr lang="en-US" sz="2400" dirty="0">
+                <a:solidFill>
+                  <a:schemeClr val="tx1"/>
+                </a:solidFill>
+                <a:latin typeface="Garamond" pitchFamily="34" charset="0"/>
+                <a:ea typeface="Garamond" pitchFamily="34" charset="-122"/>
+                <a:cs typeface="Garamond" pitchFamily="34" charset="-120"/>
               </a:rPr>
-              <a:t>Lifting facial com preenchedores: raciocínio anatômico e estrutural</a:t>
-            </a:r>
-            <a:endParaRPr lang="en-US" sz="2000" dirty="0"/>
-          </a:p>
-        </p:txBody>
-      </p:sp>
-      <p:sp>
-        <p:nvSpPr>
-          <p:cNvPr id="11" name="Divisória 4"/>
+              <a:t>Bioestimuladores faciais e corporais: fundamentos, indicações e limites</a:t>
+            </a:r>
+            <a:endParaRPr lang="en-US" sz="2400" dirty="0"/>
+          </a:p>
+        </p:txBody>
+      </p:sp>
+      <p:sp>
+        <p:nvSpPr>
+          <p:cNvPr id="10" name="Fio 4"/>
           <p:cNvSpPr/>
           <p:nvPr/>
         </p:nvSpPr>
         <p:spPr>
           <a:xfrm>
-            <a:off x="640080" y="5696712"/>
-            <a:ext cx="10881360" cy="0"/>
+            <a:off x="731520" y="4690872"/>
+            <a:ext cx="10725912" cy="0"/>
           </a:xfrm>
           <a:prstGeom prst="line">
             <a:avLst/>
           </a:prstGeom>
           <a:noFill/>
-          <a:ln w="9525">
+          <a:ln w="12700">
             <a:solidFill>
-              <a:schemeClr val="accent5"/>
+              <a:schemeClr val="accent3"/>
             </a:solidFill>
             <a:prstDash val="solid"/>
           </a:ln>
@@ -3385,14 +3722,14 @@
       </p:sp>
       <p:sp>
         <p:nvSpPr>
-          <p:cNvPr id="12" name="Módulo 5"/>
+          <p:cNvPr id="11" name="Módulo 4"/>
           <p:cNvSpPr txBox="1"/>
           <p:nvPr/>
         </p:nvSpPr>
         <p:spPr>
           <a:xfrm>
-            <a:off x="640080" y="5852160"/>
-            <a:ext cx="10881360" cy="548640"/>
+            <a:off x="731520" y="4818888"/>
+            <a:ext cx="10698480" cy="548640"/>
           </a:xfrm>
           <a:prstGeom prst="rect">
             <a:avLst/>
@@ -3408,16 +3745,104 @@
               <a:buNone/>
             </a:pPr>
             <a:r>
-              <a:rPr lang="en-US" sz="2000" dirty="0">
-                <a:solidFill>
-                  <a:schemeClr val="bg1"/>
-                </a:solidFill>
+              <a:rPr lang="en-US" sz="2400" dirty="0">
+                <a:solidFill>
+                  <a:schemeClr val="tx1"/>
+                </a:solidFill>
+                <a:latin typeface="Garamond" pitchFamily="34" charset="0"/>
+                <a:ea typeface="Garamond" pitchFamily="34" charset="-122"/>
+                <a:cs typeface="Garamond" pitchFamily="34" charset="-120"/>
+              </a:rPr>
+              <a:t>Lifting facial com preenchedores: raciocínio anatômico e estrutural</a:t>
+            </a:r>
+            <a:endParaRPr lang="en-US" sz="2400" dirty="0"/>
+          </a:p>
+        </p:txBody>
+      </p:sp>
+      <p:sp>
+        <p:nvSpPr>
+          <p:cNvPr id="12" name="Fio 5"/>
+          <p:cNvSpPr/>
+          <p:nvPr/>
+        </p:nvSpPr>
+        <p:spPr>
+          <a:xfrm>
+            <a:off x="731520" y="5477256"/>
+            <a:ext cx="10725912" cy="0"/>
+          </a:xfrm>
+          <a:prstGeom prst="line">
+            <a:avLst/>
+          </a:prstGeom>
+          <a:noFill/>
+          <a:ln w="12700">
+            <a:solidFill>
+              <a:schemeClr val="accent3"/>
+            </a:solidFill>
+            <a:prstDash val="solid"/>
+          </a:ln>
+        </p:spPr>
+      </p:sp>
+      <p:sp>
+        <p:nvSpPr>
+          <p:cNvPr id="13" name="Módulo 5"/>
+          <p:cNvSpPr txBox="1"/>
+          <p:nvPr/>
+        </p:nvSpPr>
+        <p:spPr>
+          <a:xfrm>
+            <a:off x="731520" y="5605272"/>
+            <a:ext cx="10698480" cy="548640"/>
+          </a:xfrm>
+          <a:prstGeom prst="rect">
+            <a:avLst/>
+          </a:prstGeom>
+          <a:noFill/>
+          <a:ln/>
+        </p:spPr>
+        <p:txBody>
+          <a:bodyPr wrap="square" lIns="0" tIns="0" rIns="0" bIns="0" rtlCol="0" anchor="ctr"/>
+          <a:lstStyle/>
+          <a:p>
+            <a:pPr indent="0" marL="0">
+              <a:buNone/>
+            </a:pPr>
+            <a:r>
+              <a:rPr lang="en-US" sz="2400" dirty="0">
+                <a:solidFill>
+                  <a:schemeClr val="tx1"/>
+                </a:solidFill>
+                <a:latin typeface="Garamond" pitchFamily="34" charset="0"/>
+                <a:ea typeface="Garamond" pitchFamily="34" charset="-122"/>
+                <a:cs typeface="Garamond" pitchFamily="34" charset="-120"/>
               </a:rPr>
               <a:t>Full face: planejamento anatômico, segurança e naturalidade</a:t>
             </a:r>
-            <a:endParaRPr lang="en-US" sz="2000" dirty="0"/>
-          </a:p>
-        </p:txBody>
+            <a:endParaRPr lang="en-US" sz="2400" dirty="0"/>
+          </a:p>
+        </p:txBody>
+      </p:sp>
+      <p:sp>
+        <p:nvSpPr>
+          <p:cNvPr id="14" name="Fio final"/>
+          <p:cNvSpPr/>
+          <p:nvPr/>
+        </p:nvSpPr>
+        <p:spPr>
+          <a:xfrm>
+            <a:off x="731520" y="6263640"/>
+            <a:ext cx="10725912" cy="0"/>
+          </a:xfrm>
+          <a:prstGeom prst="line">
+            <a:avLst/>
+          </a:prstGeom>
+          <a:noFill/>
+          <a:ln w="12700">
+            <a:solidFill>
+              <a:schemeClr val="accent3"/>
+            </a:solidFill>
+            <a:prstDash val="solid"/>
+          </a:ln>
+        </p:spPr>
       </p:sp>
       <p:sp>
         <p:nvSpPr>
@@ -3502,8 +3927,8 @@
         </p:nvSpPr>
         <p:spPr>
           <a:xfrm>
-            <a:off x="640080" y="868680"/>
-            <a:ext cx="10881360" cy="822960"/>
+            <a:off x="731520" y="777240"/>
+            <a:ext cx="10698480" cy="914400"/>
           </a:xfrm>
           <a:prstGeom prst="rect">
             <a:avLst/>
@@ -3519,17 +3944,17 @@
               <a:buNone/>
             </a:pPr>
             <a:r>
-              <a:rPr lang="en-US" sz="3200" spc="200" kern="0" dirty="0">
-                <a:solidFill>
-                  <a:schemeClr val="bg1"/>
-                </a:solidFill>
-                <a:latin typeface="Georgia" pitchFamily="34" charset="0"/>
-                <a:ea typeface="Georgia" pitchFamily="34" charset="-122"/>
-                <a:cs typeface="Georgia" pitchFamily="34" charset="-120"/>
+              <a:rPr lang="en-US" sz="4400" dirty="0">
+                <a:solidFill>
+                  <a:schemeClr val="accent1"/>
+                </a:solidFill>
+                <a:latin typeface="Garamond" pitchFamily="34" charset="0"/>
+                <a:ea typeface="Garamond" pitchFamily="34" charset="-122"/>
+                <a:cs typeface="Garamond" pitchFamily="34" charset="-120"/>
               </a:rPr>
-              <a:t>DA TEORIA À PRÁTICA</a:t>
-            </a:r>
-            <a:endParaRPr lang="en-US" sz="3200" dirty="0"/>
+              <a:t>Da teoria à prática</a:t>
+            </a:r>
+            <a:endParaRPr lang="en-US" sz="4400" dirty="0"/>
           </a:p>
         </p:txBody>
       </p:sp>
@@ -3541,18 +3966,18 @@
         </p:nvSpPr>
         <p:spPr>
           <a:xfrm>
-            <a:off x="640080" y="2103120"/>
-            <a:ext cx="5303520" cy="3566160"/>
+            <a:off x="731520" y="2011680"/>
+            <a:ext cx="5239512" cy="3840480"/>
           </a:xfrm>
           <a:prstGeom prst="rect">
             <a:avLst/>
           </a:prstGeom>
           <a:solidFill>
-            <a:schemeClr val="accent5"/>
+            <a:schemeClr val="bg1"/>
           </a:solidFill>
           <a:ln w="12700">
             <a:solidFill>
-              <a:schemeClr val="accent5"/>
+              <a:schemeClr val="accent3"/>
             </a:solidFill>
             <a:prstDash val="solid"/>
           </a:ln>
@@ -3566,8 +3991,8 @@
         </p:nvSpPr>
         <p:spPr>
           <a:xfrm>
-            <a:off x="1051560" y="2468880"/>
-            <a:ext cx="4480560" cy="685800"/>
+            <a:off x="1188720" y="2423160"/>
+            <a:ext cx="4389120" cy="822960"/>
           </a:xfrm>
           <a:prstGeom prst="rect">
             <a:avLst/>
@@ -3576,24 +4001,24 @@
           <a:ln/>
         </p:spPr>
         <p:txBody>
-          <a:bodyPr wrap="square" lIns="0" tIns="0" rIns="0" bIns="0" rtlCol="0" anchor="ctr"/>
+          <a:bodyPr wrap="square" lIns="0" tIns="0" rIns="0" bIns="0" rtlCol="0" anchor="t"/>
           <a:lstStyle/>
           <a:p>
             <a:pPr indent="0" marL="0">
               <a:buNone/>
             </a:pPr>
             <a:r>
-              <a:rPr lang="en-US" sz="3800" dirty="0">
-                <a:solidFill>
-                  <a:schemeClr val="bg1"/>
-                </a:solidFill>
-                <a:latin typeface="Georgia" pitchFamily="34" charset="0"/>
-                <a:ea typeface="Georgia" pitchFamily="34" charset="-122"/>
-                <a:cs typeface="Georgia" pitchFamily="34" charset="-120"/>
+              <a:rPr lang="en-US" sz="4800" dirty="0">
+                <a:solidFill>
+                  <a:schemeClr val="accent1"/>
+                </a:solidFill>
+                <a:latin typeface="Garamond" pitchFamily="34" charset="0"/>
+                <a:ea typeface="Garamond" pitchFamily="34" charset="-122"/>
+                <a:cs typeface="Garamond" pitchFamily="34" charset="-120"/>
               </a:rPr>
               <a:t>Boston</a:t>
             </a:r>
-            <a:endParaRPr lang="en-US" sz="3800" dirty="0"/>
+            <a:endParaRPr lang="en-US" sz="4800" dirty="0"/>
           </a:p>
         </p:txBody>
       </p:sp>
@@ -3605,8 +4030,8 @@
         </p:nvSpPr>
         <p:spPr>
           <a:xfrm>
-            <a:off x="1051560" y="3246120"/>
-            <a:ext cx="4480560" cy="457200"/>
+            <a:off x="1188720" y="3383280"/>
+            <a:ext cx="4389120" cy="457200"/>
           </a:xfrm>
           <a:prstGeom prst="rect">
             <a:avLst/>
@@ -3622,14 +4047,14 @@
               <a:buNone/>
             </a:pPr>
             <a:r>
-              <a:rPr lang="en-US" sz="1800" b="1" dirty="0">
-                <a:solidFill>
-                  <a:schemeClr val="bg1"/>
+              <a:rPr lang="en-US" sz="1600" b="1" dirty="0">
+                <a:solidFill>
+                  <a:schemeClr val="tx1"/>
                 </a:solidFill>
               </a:rPr>
               <a:t>Teoria e anatomia demonstrativa</a:t>
             </a:r>
-            <a:endParaRPr lang="en-US" sz="1800" dirty="0"/>
+            <a:endParaRPr lang="en-US" sz="1600" dirty="0"/>
           </a:p>
         </p:txBody>
       </p:sp>
@@ -3641,8 +4066,8 @@
         </p:nvSpPr>
         <p:spPr>
           <a:xfrm>
-            <a:off x="1051560" y="4160520"/>
-            <a:ext cx="4480560" cy="1188720"/>
+            <a:off x="1188720" y="3977640"/>
+            <a:ext cx="4389120" cy="1463040"/>
           </a:xfrm>
           <a:prstGeom prst="rect">
             <a:avLst/>
@@ -3655,17 +4080,20 @@
           <a:lstStyle/>
           <a:p>
             <a:pPr indent="0" marL="0">
-              <a:buNone/>
-            </a:pPr>
-            <a:r>
-              <a:rPr lang="en-US" sz="1500" dirty="0">
-                <a:solidFill>
-                  <a:schemeClr val="accent4"/>
+              <a:lnSpc>
+                <a:spcPct val="115000"/>
+              </a:lnSpc>
+              <a:buNone/>
+            </a:pPr>
+            <a:r>
+              <a:rPr lang="en-US" sz="1400" dirty="0">
+                <a:solidFill>
+                  <a:schemeClr val="tx2"/>
                 </a:solidFill>
               </a:rPr>
               <a:t>3 dias em ambiente acadêmico: aulas científicas, anatomy review com anatomista e demonstração de dissecação.</a:t>
             </a:r>
-            <a:endParaRPr lang="en-US" sz="1500" dirty="0"/>
+            <a:endParaRPr lang="en-US" sz="1400" dirty="0"/>
           </a:p>
         </p:txBody>
       </p:sp>
@@ -3677,8 +4105,8 @@
         </p:nvSpPr>
         <p:spPr>
           <a:xfrm>
-            <a:off x="6245352" y="2103120"/>
-            <a:ext cx="5303520" cy="3566160"/>
+            <a:off x="6217920" y="2011680"/>
+            <a:ext cx="5239512" cy="3840480"/>
           </a:xfrm>
           <a:prstGeom prst="rect">
             <a:avLst/>
@@ -3702,8 +4130,8 @@
         </p:nvSpPr>
         <p:spPr>
           <a:xfrm>
-            <a:off x="6656832" y="2468880"/>
-            <a:ext cx="4480560" cy="685800"/>
+            <a:off x="6675120" y="2423160"/>
+            <a:ext cx="4389120" cy="822960"/>
           </a:xfrm>
           <a:prstGeom prst="rect">
             <a:avLst/>
@@ -3712,24 +4140,24 @@
           <a:ln/>
         </p:spPr>
         <p:txBody>
-          <a:bodyPr wrap="square" lIns="0" tIns="0" rIns="0" bIns="0" rtlCol="0" anchor="ctr"/>
+          <a:bodyPr wrap="square" lIns="0" tIns="0" rIns="0" bIns="0" rtlCol="0" anchor="t"/>
           <a:lstStyle/>
           <a:p>
             <a:pPr indent="0" marL="0">
               <a:buNone/>
             </a:pPr>
             <a:r>
-              <a:rPr lang="en-US" sz="3800" dirty="0">
+              <a:rPr lang="en-US" sz="4800" dirty="0">
                 <a:solidFill>
                   <a:schemeClr val="bg1"/>
                 </a:solidFill>
-                <a:latin typeface="Georgia" pitchFamily="34" charset="0"/>
-                <a:ea typeface="Georgia" pitchFamily="34" charset="-122"/>
-                <a:cs typeface="Georgia" pitchFamily="34" charset="-120"/>
+                <a:latin typeface="Garamond" pitchFamily="34" charset="0"/>
+                <a:ea typeface="Garamond" pitchFamily="34" charset="-122"/>
+                <a:cs typeface="Garamond" pitchFamily="34" charset="-120"/>
               </a:rPr>
               <a:t>Miami</a:t>
             </a:r>
-            <a:endParaRPr lang="en-US" sz="3800" dirty="0"/>
+            <a:endParaRPr lang="en-US" sz="4800" dirty="0"/>
           </a:p>
         </p:txBody>
       </p:sp>
@@ -3741,8 +4169,8 @@
         </p:nvSpPr>
         <p:spPr>
           <a:xfrm>
-            <a:off x="6656832" y="3246120"/>
-            <a:ext cx="4480560" cy="457200"/>
+            <a:off x="6675120" y="3383280"/>
+            <a:ext cx="4389120" cy="457200"/>
           </a:xfrm>
           <a:prstGeom prst="rect">
             <a:avLst/>
@@ -3758,14 +4186,14 @@
               <a:buNone/>
             </a:pPr>
             <a:r>
-              <a:rPr lang="en-US" sz="1800" b="1" dirty="0">
+              <a:rPr lang="en-US" sz="1600" b="1" dirty="0">
                 <a:solidFill>
                   <a:schemeClr val="bg1"/>
                 </a:solidFill>
               </a:rPr>
               <a:t>Prática real e hands-on</a:t>
             </a:r>
-            <a:endParaRPr lang="en-US" sz="1800" dirty="0"/>
+            <a:endParaRPr lang="en-US" sz="1600" dirty="0"/>
           </a:p>
         </p:txBody>
       </p:sp>
@@ -3777,8 +4205,8 @@
         </p:nvSpPr>
         <p:spPr>
           <a:xfrm>
-            <a:off x="6656832" y="4160520"/>
-            <a:ext cx="4480560" cy="1188720"/>
+            <a:off x="6675120" y="3977640"/>
+            <a:ext cx="4389120" cy="1463040"/>
           </a:xfrm>
           <a:prstGeom prst="rect">
             <a:avLst/>
@@ -3791,17 +4219,20 @@
           <a:lstStyle/>
           <a:p>
             <a:pPr indent="0" marL="0">
-              <a:buNone/>
-            </a:pPr>
-            <a:r>
-              <a:rPr lang="en-US" sz="1500" dirty="0">
-                <a:solidFill>
-                  <a:schemeClr val="bg1"/>
+              <a:lnSpc>
+                <a:spcPct val="115000"/>
+              </a:lnSpc>
+              <a:buNone/>
+            </a:pPr>
+            <a:r>
+              <a:rPr lang="en-US" sz="1400" dirty="0">
+                <a:solidFill>
+                  <a:schemeClr val="accent4"/>
                 </a:solidFill>
               </a:rPr>
               <a:t>19, 20 e 21 de maio de 2027, em laboratório de specimen: anatomia aplicada e prática supervisionada dos procedimentos.</a:t>
             </a:r>
-            <a:endParaRPr lang="en-US" sz="1500" dirty="0"/>
+            <a:endParaRPr lang="en-US" sz="1400" dirty="0"/>
           </a:p>
         </p:txBody>
       </p:sp>
@@ -3894,24 +4325,31 @@
         </p:blipFill>
         <p:spPr>
           <a:xfrm>
-            <a:off x="8412480" y="548640"/>
+            <a:off x="8366760" y="685800"/>
             <a:ext cx="3182112" cy="5477256"/>
           </a:xfrm>
           <a:prstGeom prst="rect">
             <a:avLst/>
           </a:prstGeom>
+          <a:effectLst>
+            <a:outerShdw sx="100000" sy="100000" kx="0" ky="0" algn="bl" rotWithShape="0" blurRad="152400" dist="50800" dir="5400000">
+              <a:srgbClr val="2B2A29">
+                <a:alpha val="25000"/>
+              </a:srgbClr>
+            </a:outerShdw>
+          </a:effectLst>
         </p:spPr>
       </p:pic>
       <p:sp>
         <p:nvSpPr>
-          <p:cNvPr id="3" name="Pré-título"/>
+          <p:cNvPr id="3" name="Text 0"/>
           <p:cNvSpPr txBox="1"/>
           <p:nvPr/>
         </p:nvSpPr>
         <p:spPr>
           <a:xfrm>
-            <a:off x="640080" y="411480"/>
-            <a:ext cx="6035040" cy="411480"/>
+            <a:off x="731520" y="411480"/>
+            <a:ext cx="5486400" cy="411480"/>
           </a:xfrm>
           <a:prstGeom prst="rect">
             <a:avLst/>
@@ -3920,24 +4358,24 @@
           <a:ln/>
         </p:spPr>
         <p:txBody>
-          <a:bodyPr wrap="square" lIns="0" tIns="0" rIns="0" bIns="0" rtlCol="0" anchor="ctr"/>
+          <a:bodyPr wrap="square" lIns="0" tIns="0" rIns="0" bIns="0" rtlCol="0" anchor="t"/>
           <a:lstStyle/>
           <a:p>
             <a:pPr indent="0" marL="0">
               <a:buNone/>
             </a:pPr>
             <a:r>
-              <a:rPr lang="en-US" sz="2000" spc="300" kern="0" dirty="0">
-                <a:solidFill>
-                  <a:schemeClr val="accent4"/>
-                </a:solidFill>
-                <a:latin typeface="Georgia" pitchFamily="34" charset="0"/>
-                <a:ea typeface="Georgia" pitchFamily="34" charset="-122"/>
-                <a:cs typeface="Georgia" pitchFamily="34" charset="-120"/>
+              <a:rPr lang="en-US" sz="2200" i="1" dirty="0">
+                <a:solidFill>
+                  <a:schemeClr val="tx2"/>
+                </a:solidFill>
+                <a:latin typeface="Garamond" pitchFamily="34" charset="0"/>
+                <a:ea typeface="Garamond" pitchFamily="34" charset="-122"/>
+                <a:cs typeface="Garamond" pitchFamily="34" charset="-120"/>
               </a:rPr>
               <a:t>O poder do</a:t>
             </a:r>
-            <a:endParaRPr lang="en-US" sz="2000" dirty="0"/>
+            <a:endParaRPr lang="en-US" sz="2200" dirty="0"/>
           </a:p>
         </p:txBody>
       </p:sp>
@@ -3951,8 +4389,8 @@
         </p:nvSpPr>
         <p:spPr>
           <a:xfrm>
-            <a:off x="640080" y="868680"/>
-            <a:ext cx="10881360" cy="822960"/>
+            <a:off x="731520" y="777240"/>
+            <a:ext cx="10698480" cy="914400"/>
           </a:xfrm>
           <a:prstGeom prst="rect">
             <a:avLst/>
@@ -3968,29 +4406,29 @@
               <a:buNone/>
             </a:pPr>
             <a:r>
-              <a:rPr lang="en-US" sz="3200" spc="200" kern="0" dirty="0">
-                <a:solidFill>
-                  <a:schemeClr val="bg1"/>
-                </a:solidFill>
-                <a:latin typeface="Georgia" pitchFamily="34" charset="0"/>
-                <a:ea typeface="Georgia" pitchFamily="34" charset="-122"/>
-                <a:cs typeface="Georgia" pitchFamily="34" charset="-120"/>
+              <a:rPr lang="en-US" sz="4400" dirty="0">
+                <a:solidFill>
+                  <a:schemeClr val="accent1"/>
+                </a:solidFill>
+                <a:latin typeface="Garamond" pitchFamily="34" charset="0"/>
+                <a:ea typeface="Garamond" pitchFamily="34" charset="-122"/>
+                <a:cs typeface="Garamond" pitchFamily="34" charset="-120"/>
               </a:rPr>
-              <a:t>POSICIONAMENTO</a:t>
-            </a:r>
-            <a:endParaRPr lang="en-US" sz="3200" dirty="0"/>
-          </a:p>
-        </p:txBody>
-      </p:sp>
-      <p:sp>
-        <p:nvSpPr>
-          <p:cNvPr id="5" name="Introdução posicionamento"/>
+              <a:t>Posicionamento</a:t>
+            </a:r>
+            <a:endParaRPr lang="en-US" sz="4400" dirty="0"/>
+          </a:p>
+        </p:txBody>
+      </p:sp>
+      <p:sp>
+        <p:nvSpPr>
+          <p:cNvPr id="5" name="Text 2"/>
           <p:cNvSpPr txBox="1"/>
           <p:nvPr/>
         </p:nvSpPr>
         <p:spPr>
           <a:xfrm>
-            <a:off x="640080" y="1920240"/>
+            <a:off x="731520" y="1874520"/>
             <a:ext cx="6949440" cy="548640"/>
           </a:xfrm>
           <a:prstGeom prst="rect">
@@ -4007,27 +4445,50 @@
               <a:buNone/>
             </a:pPr>
             <a:r>
-              <a:rPr lang="en-US" sz="1600" dirty="0">
-                <a:solidFill>
-                  <a:schemeClr val="accent4"/>
+              <a:rPr lang="en-US" sz="1500" dirty="0">
+                <a:solidFill>
+                  <a:schemeClr val="tx2"/>
                 </a:solidFill>
               </a:rPr>
               <a:t>Um programa realizado em Boston e Miami reúne, além do conteúdo técnico:</a:t>
             </a:r>
-            <a:endParaRPr lang="en-US" sz="1600" dirty="0"/>
-          </a:p>
-        </p:txBody>
-      </p:sp>
-      <p:sp>
-        <p:nvSpPr>
-          <p:cNvPr id="6" name="Item 1 título"/>
+            <a:endParaRPr lang="en-US" sz="1500" dirty="0"/>
+          </a:p>
+        </p:txBody>
+      </p:sp>
+      <p:sp>
+        <p:nvSpPr>
+          <p:cNvPr id="6" name="Fio 1"/>
+          <p:cNvSpPr/>
+          <p:nvPr/>
+        </p:nvSpPr>
+        <p:spPr>
+          <a:xfrm>
+            <a:off x="731520" y="2651760"/>
+            <a:ext cx="6949440" cy="0"/>
+          </a:xfrm>
+          <a:prstGeom prst="line">
+            <a:avLst/>
+          </a:prstGeom>
+          <a:noFill/>
+          <a:ln w="12700">
+            <a:solidFill>
+              <a:schemeClr val="accent3"/>
+            </a:solidFill>
+            <a:prstDash val="solid"/>
+          </a:ln>
+        </p:spPr>
+      </p:sp>
+      <p:sp>
+        <p:nvSpPr>
+          <p:cNvPr id="7" name="Item 1 título"/>
           <p:cNvSpPr txBox="1"/>
           <p:nvPr/>
         </p:nvSpPr>
         <p:spPr>
           <a:xfrm>
-            <a:off x="640080" y="2697480"/>
-            <a:ext cx="6949440" cy="365760"/>
+            <a:off x="731520" y="2788920"/>
+            <a:ext cx="6949440" cy="411480"/>
           </a:xfrm>
           <a:prstGeom prst="rect">
             <a:avLst/>
@@ -4036,37 +4497,37 @@
           <a:ln/>
         </p:spPr>
         <p:txBody>
-          <a:bodyPr wrap="square" lIns="0" tIns="0" rIns="0" bIns="0" rtlCol="0" anchor="ctr"/>
+          <a:bodyPr wrap="square" lIns="0" tIns="0" rIns="0" bIns="0" rtlCol="0" anchor="t"/>
           <a:lstStyle/>
           <a:p>
             <a:pPr indent="0" marL="0">
               <a:buNone/>
             </a:pPr>
             <a:r>
-              <a:rPr lang="en-US" sz="2000" dirty="0">
-                <a:solidFill>
-                  <a:schemeClr val="bg1"/>
-                </a:solidFill>
-                <a:latin typeface="Georgia" pitchFamily="34" charset="0"/>
-                <a:ea typeface="Georgia" pitchFamily="34" charset="-122"/>
-                <a:cs typeface="Georgia" pitchFamily="34" charset="-120"/>
+              <a:rPr lang="en-US" sz="2400" dirty="0">
+                <a:solidFill>
+                  <a:schemeClr val="accent1"/>
+                </a:solidFill>
+                <a:latin typeface="Garamond" pitchFamily="34" charset="0"/>
+                <a:ea typeface="Garamond" pitchFamily="34" charset="-122"/>
+                <a:cs typeface="Garamond" pitchFamily="34" charset="-120"/>
               </a:rPr>
               <a:t>Doutores da estética</a:t>
             </a:r>
-            <a:endParaRPr lang="en-US" sz="2000" dirty="0"/>
-          </a:p>
-        </p:txBody>
-      </p:sp>
-      <p:sp>
-        <p:nvSpPr>
-          <p:cNvPr id="7" name="Item 1 texto"/>
+            <a:endParaRPr lang="en-US" sz="2400" dirty="0"/>
+          </a:p>
+        </p:txBody>
+      </p:sp>
+      <p:sp>
+        <p:nvSpPr>
+          <p:cNvPr id="8" name="Item 1 texto"/>
           <p:cNvSpPr txBox="1"/>
           <p:nvPr/>
         </p:nvSpPr>
         <p:spPr>
           <a:xfrm>
-            <a:off x="640080" y="3081528"/>
-            <a:ext cx="6949440" cy="411480"/>
+            <a:off x="731520" y="3200400"/>
+            <a:ext cx="6949440" cy="365760"/>
           </a:xfrm>
           <a:prstGeom prst="rect">
             <a:avLst/>
@@ -4075,34 +4536,57 @@
           <a:ln/>
         </p:spPr>
         <p:txBody>
-          <a:bodyPr wrap="square" lIns="0" tIns="0" rIns="0" bIns="0" rtlCol="0" anchor="ctr"/>
+          <a:bodyPr wrap="square" lIns="0" tIns="0" rIns="0" bIns="0" rtlCol="0" anchor="t"/>
           <a:lstStyle/>
           <a:p>
             <a:pPr indent="0" marL="0">
               <a:buNone/>
             </a:pPr>
             <a:r>
-              <a:rPr lang="en-US" sz="1500" dirty="0">
-                <a:solidFill>
-                  <a:schemeClr val="accent4"/>
+              <a:rPr lang="en-US" sz="1400" dirty="0">
+                <a:solidFill>
+                  <a:schemeClr val="tx2"/>
                 </a:solidFill>
               </a:rPr>
               <a:t>nacionais e internacionais</a:t>
             </a:r>
-            <a:endParaRPr lang="en-US" sz="1500" dirty="0"/>
-          </a:p>
-        </p:txBody>
-      </p:sp>
-      <p:sp>
-        <p:nvSpPr>
-          <p:cNvPr id="8" name="Item 2 título"/>
+            <a:endParaRPr lang="en-US" sz="1400" dirty="0"/>
+          </a:p>
+        </p:txBody>
+      </p:sp>
+      <p:sp>
+        <p:nvSpPr>
+          <p:cNvPr id="9" name="Fio 2"/>
+          <p:cNvSpPr/>
+          <p:nvPr/>
+        </p:nvSpPr>
+        <p:spPr>
+          <a:xfrm>
+            <a:off x="731520" y="3657600"/>
+            <a:ext cx="6949440" cy="0"/>
+          </a:xfrm>
+          <a:prstGeom prst="line">
+            <a:avLst/>
+          </a:prstGeom>
+          <a:noFill/>
+          <a:ln w="12700">
+            <a:solidFill>
+              <a:schemeClr val="accent3"/>
+            </a:solidFill>
+            <a:prstDash val="solid"/>
+          </a:ln>
+        </p:spPr>
+      </p:sp>
+      <p:sp>
+        <p:nvSpPr>
+          <p:cNvPr id="10" name="Item 2 título"/>
           <p:cNvSpPr txBox="1"/>
           <p:nvPr/>
         </p:nvSpPr>
         <p:spPr>
           <a:xfrm>
-            <a:off x="640080" y="3657600"/>
-            <a:ext cx="6949440" cy="365760"/>
+            <a:off x="731520" y="3794760"/>
+            <a:ext cx="6949440" cy="411480"/>
           </a:xfrm>
           <a:prstGeom prst="rect">
             <a:avLst/>
@@ -4111,37 +4595,37 @@
           <a:ln/>
         </p:spPr>
         <p:txBody>
-          <a:bodyPr wrap="square" lIns="0" tIns="0" rIns="0" bIns="0" rtlCol="0" anchor="ctr"/>
+          <a:bodyPr wrap="square" lIns="0" tIns="0" rIns="0" bIns="0" rtlCol="0" anchor="t"/>
           <a:lstStyle/>
           <a:p>
             <a:pPr indent="0" marL="0">
               <a:buNone/>
             </a:pPr>
             <a:r>
-              <a:rPr lang="en-US" sz="2000" dirty="0">
-                <a:solidFill>
-                  <a:schemeClr val="bg1"/>
-                </a:solidFill>
-                <a:latin typeface="Georgia" pitchFamily="34" charset="0"/>
-                <a:ea typeface="Georgia" pitchFamily="34" charset="-122"/>
-                <a:cs typeface="Georgia" pitchFamily="34" charset="-120"/>
+              <a:rPr lang="en-US" sz="2400" dirty="0">
+                <a:solidFill>
+                  <a:schemeClr val="accent1"/>
+                </a:solidFill>
+                <a:latin typeface="Garamond" pitchFamily="34" charset="0"/>
+                <a:ea typeface="Garamond" pitchFamily="34" charset="-122"/>
+                <a:cs typeface="Garamond" pitchFamily="34" charset="-120"/>
               </a:rPr>
               <a:t>Convidados</a:t>
             </a:r>
-            <a:endParaRPr lang="en-US" sz="2000" dirty="0"/>
-          </a:p>
-        </p:txBody>
-      </p:sp>
-      <p:sp>
-        <p:nvSpPr>
-          <p:cNvPr id="9" name="Item 2 texto"/>
+            <a:endParaRPr lang="en-US" sz="2400" dirty="0"/>
+          </a:p>
+        </p:txBody>
+      </p:sp>
+      <p:sp>
+        <p:nvSpPr>
+          <p:cNvPr id="11" name="Item 2 texto"/>
           <p:cNvSpPr txBox="1"/>
           <p:nvPr/>
         </p:nvSpPr>
         <p:spPr>
           <a:xfrm>
-            <a:off x="640080" y="4041648"/>
-            <a:ext cx="6949440" cy="411480"/>
+            <a:off x="731520" y="4206240"/>
+            <a:ext cx="6949440" cy="365760"/>
           </a:xfrm>
           <a:prstGeom prst="rect">
             <a:avLst/>
@@ -4150,34 +4634,57 @@
           <a:ln/>
         </p:spPr>
         <p:txBody>
-          <a:bodyPr wrap="square" lIns="0" tIns="0" rIns="0" bIns="0" rtlCol="0" anchor="ctr"/>
+          <a:bodyPr wrap="square" lIns="0" tIns="0" rIns="0" bIns="0" rtlCol="0" anchor="t"/>
           <a:lstStyle/>
           <a:p>
             <a:pPr indent="0" marL="0">
               <a:buNone/>
             </a:pPr>
             <a:r>
-              <a:rPr lang="en-US" sz="1500" dirty="0">
-                <a:solidFill>
-                  <a:schemeClr val="accent4"/>
+              <a:rPr lang="en-US" sz="1400" dirty="0">
+                <a:solidFill>
+                  <a:schemeClr val="tx2"/>
                 </a:solidFill>
               </a:rPr>
               <a:t>com cases reais de sucesso na estética e no empreendedorismo</a:t>
             </a:r>
-            <a:endParaRPr lang="en-US" sz="1500" dirty="0"/>
-          </a:p>
-        </p:txBody>
-      </p:sp>
-      <p:sp>
-        <p:nvSpPr>
-          <p:cNvPr id="10" name="Item 3 título"/>
+            <a:endParaRPr lang="en-US" sz="1400" dirty="0"/>
+          </a:p>
+        </p:txBody>
+      </p:sp>
+      <p:sp>
+        <p:nvSpPr>
+          <p:cNvPr id="12" name="Fio 3"/>
+          <p:cNvSpPr/>
+          <p:nvPr/>
+        </p:nvSpPr>
+        <p:spPr>
+          <a:xfrm>
+            <a:off x="731520" y="4663440"/>
+            <a:ext cx="6949440" cy="0"/>
+          </a:xfrm>
+          <a:prstGeom prst="line">
+            <a:avLst/>
+          </a:prstGeom>
+          <a:noFill/>
+          <a:ln w="12700">
+            <a:solidFill>
+              <a:schemeClr val="accent3"/>
+            </a:solidFill>
+            <a:prstDash val="solid"/>
+          </a:ln>
+        </p:spPr>
+      </p:sp>
+      <p:sp>
+        <p:nvSpPr>
+          <p:cNvPr id="13" name="Item 3 título"/>
           <p:cNvSpPr txBox="1"/>
           <p:nvPr/>
         </p:nvSpPr>
         <p:spPr>
           <a:xfrm>
-            <a:off x="640080" y="4617720"/>
-            <a:ext cx="6949440" cy="365760"/>
+            <a:off x="731520" y="4800600"/>
+            <a:ext cx="6949440" cy="411480"/>
           </a:xfrm>
           <a:prstGeom prst="rect">
             <a:avLst/>
@@ -4186,37 +4693,37 @@
           <a:ln/>
         </p:spPr>
         <p:txBody>
-          <a:bodyPr wrap="square" lIns="0" tIns="0" rIns="0" bIns="0" rtlCol="0" anchor="ctr"/>
+          <a:bodyPr wrap="square" lIns="0" tIns="0" rIns="0" bIns="0" rtlCol="0" anchor="t"/>
           <a:lstStyle/>
           <a:p>
             <a:pPr indent="0" marL="0">
               <a:buNone/>
             </a:pPr>
             <a:r>
-              <a:rPr lang="en-US" sz="2000" dirty="0">
-                <a:solidFill>
-                  <a:schemeClr val="bg1"/>
-                </a:solidFill>
-                <a:latin typeface="Georgia" pitchFamily="34" charset="0"/>
-                <a:ea typeface="Georgia" pitchFamily="34" charset="-122"/>
-                <a:cs typeface="Georgia" pitchFamily="34" charset="-120"/>
+              <a:rPr lang="en-US" sz="2400" dirty="0">
+                <a:solidFill>
+                  <a:schemeClr val="accent1"/>
+                </a:solidFill>
+                <a:latin typeface="Garamond" pitchFamily="34" charset="0"/>
+                <a:ea typeface="Garamond" pitchFamily="34" charset="-122"/>
+                <a:cs typeface="Garamond" pitchFamily="34" charset="-120"/>
               </a:rPr>
               <a:t>Palestrantes</a:t>
             </a:r>
-            <a:endParaRPr lang="en-US" sz="2000" dirty="0"/>
-          </a:p>
-        </p:txBody>
-      </p:sp>
-      <p:sp>
-        <p:nvSpPr>
-          <p:cNvPr id="11" name="Item 3 texto"/>
+            <a:endParaRPr lang="en-US" sz="2400" dirty="0"/>
+          </a:p>
+        </p:txBody>
+      </p:sp>
+      <p:sp>
+        <p:nvSpPr>
+          <p:cNvPr id="14" name="Item 3 texto"/>
           <p:cNvSpPr txBox="1"/>
           <p:nvPr/>
         </p:nvSpPr>
         <p:spPr>
           <a:xfrm>
-            <a:off x="640080" y="5001768"/>
-            <a:ext cx="6949440" cy="411480"/>
+            <a:off x="731520" y="5212080"/>
+            <a:ext cx="6949440" cy="365760"/>
           </a:xfrm>
           <a:prstGeom prst="rect">
             <a:avLst/>
@@ -4225,33 +4732,33 @@
           <a:ln/>
         </p:spPr>
         <p:txBody>
-          <a:bodyPr wrap="square" lIns="0" tIns="0" rIns="0" bIns="0" rtlCol="0" anchor="ctr"/>
+          <a:bodyPr wrap="square" lIns="0" tIns="0" rIns="0" bIns="0" rtlCol="0" anchor="t"/>
           <a:lstStyle/>
           <a:p>
             <a:pPr indent="0" marL="0">
               <a:buNone/>
             </a:pPr>
             <a:r>
-              <a:rPr lang="en-US" sz="1500" dirty="0">
-                <a:solidFill>
-                  <a:schemeClr val="accent4"/>
+              <a:rPr lang="en-US" sz="1400" dirty="0">
+                <a:solidFill>
+                  <a:schemeClr val="tx2"/>
                 </a:solidFill>
               </a:rPr>
               <a:t>que atuam com carreira, posicionamento e autoridade</a:t>
             </a:r>
-            <a:endParaRPr lang="en-US" sz="1500" dirty="0"/>
-          </a:p>
-        </p:txBody>
-      </p:sp>
-      <p:sp>
-        <p:nvSpPr>
-          <p:cNvPr id="12" name="Nota posicionamento"/>
+            <a:endParaRPr lang="en-US" sz="1400" dirty="0"/>
+          </a:p>
+        </p:txBody>
+      </p:sp>
+      <p:sp>
+        <p:nvSpPr>
+          <p:cNvPr id="15" name="Text 12"/>
           <p:cNvSpPr txBox="1"/>
           <p:nvPr/>
         </p:nvSpPr>
         <p:spPr>
           <a:xfrm>
-            <a:off x="640080" y="5623560"/>
+            <a:off x="731520" y="5760720"/>
             <a:ext cx="7132320" cy="457200"/>
           </a:xfrm>
           <a:prstGeom prst="rect">
@@ -4261,21 +4768,21 @@
           <a:ln/>
         </p:spPr>
         <p:txBody>
-          <a:bodyPr wrap="square" lIns="0" tIns="0" rIns="0" bIns="0" rtlCol="0" anchor="ctr"/>
+          <a:bodyPr wrap="square" lIns="0" tIns="0" rIns="0" bIns="0" rtlCol="0" anchor="t"/>
           <a:lstStyle/>
           <a:p>
             <a:pPr indent="0" marL="0">
               <a:buNone/>
             </a:pPr>
             <a:r>
-              <a:rPr lang="en-US" sz="1400" i="1" dirty="0">
+              <a:rPr lang="en-US" sz="1300" i="1" dirty="0">
                 <a:solidFill>
                   <a:schemeClr val="tx2"/>
                 </a:solidFill>
               </a:rPr>
               <a:t>Um momento desenhado para troca de experiências, visão de mercado e conexões profissionais relevantes.</a:t>
             </a:r>
-            <a:endParaRPr lang="en-US" sz="1400" dirty="0"/>
+            <a:endParaRPr lang="en-US" sz="1300" dirty="0"/>
           </a:p>
         </p:txBody>
       </p:sp>
@@ -4386,8 +4893,8 @@
         </p:nvSpPr>
         <p:spPr>
           <a:xfrm>
-            <a:off x="640080" y="868680"/>
-            <a:ext cx="10881360" cy="822960"/>
+            <a:off x="731520" y="777240"/>
+            <a:ext cx="10698480" cy="914400"/>
           </a:xfrm>
           <a:prstGeom prst="rect">
             <a:avLst/>
@@ -4403,30 +4910,30 @@
               <a:buNone/>
             </a:pPr>
             <a:r>
-              <a:rPr lang="en-US" sz="3200" spc="200" kern="0" dirty="0">
-                <a:solidFill>
-                  <a:schemeClr val="bg1"/>
-                </a:solidFill>
-                <a:latin typeface="Georgia" pitchFamily="34" charset="0"/>
-                <a:ea typeface="Georgia" pitchFamily="34" charset="-122"/>
-                <a:cs typeface="Georgia" pitchFamily="34" charset="-120"/>
+              <a:rPr lang="en-US" sz="4400" dirty="0">
+                <a:solidFill>
+                  <a:schemeClr val="accent1"/>
+                </a:solidFill>
+                <a:latin typeface="Garamond" pitchFamily="34" charset="0"/>
+                <a:ea typeface="Garamond" pitchFamily="34" charset="-122"/>
+                <a:cs typeface="Garamond" pitchFamily="34" charset="-120"/>
               </a:rPr>
-              <a:t>QUEM JÁ VIVEU</a:t>
-            </a:r>
-            <a:endParaRPr lang="en-US" sz="3200" dirty="0"/>
-          </a:p>
-        </p:txBody>
-      </p:sp>
-      <p:sp>
-        <p:nvSpPr>
-          <p:cNvPr id="4" name="Texto turma"/>
+              <a:t>Quem já viveu</a:t>
+            </a:r>
+            <a:endParaRPr lang="en-US" sz="4400" dirty="0"/>
+          </a:p>
+        </p:txBody>
+      </p:sp>
+      <p:sp>
+        <p:nvSpPr>
+          <p:cNvPr id="4" name="Text 1"/>
           <p:cNvSpPr txBox="1"/>
           <p:nvPr/>
         </p:nvSpPr>
         <p:spPr>
           <a:xfrm>
-            <a:off x="640080" y="1920240"/>
-            <a:ext cx="4480560" cy="1280160"/>
+            <a:off x="731520" y="1920240"/>
+            <a:ext cx="4297680" cy="1280160"/>
           </a:xfrm>
           <a:prstGeom prst="rect">
             <a:avLst/>
@@ -4439,29 +4946,55 @@
           <a:lstStyle/>
           <a:p>
             <a:pPr indent="0" marL="0">
-              <a:buNone/>
-            </a:pPr>
-            <a:r>
-              <a:rPr lang="en-US" sz="2000" dirty="0">
-                <a:solidFill>
-                  <a:schemeClr val="accent4"/>
+              <a:lnSpc>
+                <a:spcPct val="115000"/>
+              </a:lnSpc>
+              <a:buNone/>
+            </a:pPr>
+            <a:r>
+              <a:rPr lang="en-US" sz="1700" dirty="0">
+                <a:solidFill>
+                  <a:schemeClr val="tx2"/>
                 </a:solidFill>
               </a:rPr>
               <a:t>Turma da Formação Internacional na etapa de Boston, com os certificados em mãos.</a:t>
             </a:r>
-            <a:endParaRPr lang="en-US" sz="2000" dirty="0"/>
-          </a:p>
-        </p:txBody>
-      </p:sp>
-      <p:sp>
-        <p:nvSpPr>
-          <p:cNvPr id="5" name="Chamada turma"/>
+            <a:endParaRPr lang="en-US" sz="1700" dirty="0"/>
+          </a:p>
+        </p:txBody>
+      </p:sp>
+      <p:sp>
+        <p:nvSpPr>
+          <p:cNvPr id="5" name="Fio"/>
+          <p:cNvSpPr/>
+          <p:nvPr/>
+        </p:nvSpPr>
+        <p:spPr>
+          <a:xfrm>
+            <a:off x="731520" y="3977640"/>
+            <a:ext cx="822960" cy="0"/>
+          </a:xfrm>
+          <a:prstGeom prst="line">
+            <a:avLst/>
+          </a:prstGeom>
+          <a:noFill/>
+          <a:ln w="15875">
+            <a:solidFill>
+              <a:schemeClr val="accent2"/>
+            </a:solidFill>
+            <a:prstDash val="solid"/>
+          </a:ln>
+        </p:spPr>
+      </p:sp>
+      <p:sp>
+        <p:nvSpPr>
+          <p:cNvPr id="6" name="Text 3"/>
           <p:cNvSpPr txBox="1"/>
           <p:nvPr/>
         </p:nvSpPr>
         <p:spPr>
           <a:xfrm>
-            <a:off x="640080" y="4206240"/>
+            <a:off x="731520" y="4160520"/>
             <a:ext cx="4572000" cy="548640"/>
           </a:xfrm>
           <a:prstGeom prst="rect">
@@ -4471,37 +5004,37 @@
           <a:ln/>
         </p:spPr>
         <p:txBody>
-          <a:bodyPr wrap="square" lIns="0" tIns="0" rIns="0" bIns="0" rtlCol="0" anchor="ctr"/>
+          <a:bodyPr wrap="square" lIns="0" tIns="0" rIns="0" bIns="0" rtlCol="0" anchor="t"/>
           <a:lstStyle/>
           <a:p>
             <a:pPr indent="0" marL="0">
               <a:buNone/>
             </a:pPr>
             <a:r>
-              <a:rPr lang="en-US" sz="2600" dirty="0">
-                <a:solidFill>
-                  <a:schemeClr val="bg1"/>
-                </a:solidFill>
-                <a:latin typeface="Georgia" pitchFamily="34" charset="0"/>
-                <a:ea typeface="Georgia" pitchFamily="34" charset="-122"/>
-                <a:cs typeface="Georgia" pitchFamily="34" charset="-120"/>
+              <a:rPr lang="en-US" sz="2800" dirty="0">
+                <a:solidFill>
+                  <a:schemeClr val="accent1"/>
+                </a:solidFill>
+                <a:latin typeface="Garamond" pitchFamily="34" charset="0"/>
+                <a:ea typeface="Garamond" pitchFamily="34" charset="-122"/>
+                <a:cs typeface="Garamond" pitchFamily="34" charset="-120"/>
               </a:rPr>
               <a:t>A próxima etapa é em Miami.</a:t>
             </a:r>
-            <a:endParaRPr lang="en-US" sz="2600" dirty="0"/>
-          </a:p>
-        </p:txBody>
-      </p:sp>
-      <p:sp>
-        <p:nvSpPr>
-          <p:cNvPr id="6" name="Data turma"/>
+            <a:endParaRPr lang="en-US" sz="2800" dirty="0"/>
+          </a:p>
+        </p:txBody>
+      </p:sp>
+      <p:sp>
+        <p:nvSpPr>
+          <p:cNvPr id="7" name="Text 4"/>
           <p:cNvSpPr txBox="1"/>
           <p:nvPr/>
         </p:nvSpPr>
         <p:spPr>
           <a:xfrm>
-            <a:off x="640080" y="4800600"/>
-            <a:ext cx="5760720" cy="411480"/>
+            <a:off x="731520" y="4754880"/>
+            <a:ext cx="4572000" cy="411480"/>
           </a:xfrm>
           <a:prstGeom prst="rect">
             <a:avLst/>
@@ -4510,24 +5043,21 @@
           <a:ln/>
         </p:spPr>
         <p:txBody>
-          <a:bodyPr wrap="square" lIns="0" tIns="0" rIns="0" bIns="0" rtlCol="0" anchor="ctr"/>
+          <a:bodyPr wrap="square" lIns="0" tIns="0" rIns="0" bIns="0" rtlCol="0" anchor="t"/>
           <a:lstStyle/>
           <a:p>
             <a:pPr indent="0" marL="0">
               <a:buNone/>
             </a:pPr>
             <a:r>
-              <a:rPr lang="en-US" sz="2000" dirty="0">
-                <a:solidFill>
-                  <a:schemeClr val="accent4"/>
-                </a:solidFill>
-                <a:latin typeface="Georgia" pitchFamily="34" charset="0"/>
-                <a:ea typeface="Georgia" pitchFamily="34" charset="-122"/>
-                <a:cs typeface="Georgia" pitchFamily="34" charset="-120"/>
+              <a:rPr lang="en-US" sz="1500" dirty="0">
+                <a:solidFill>
+                  <a:schemeClr val="tx2"/>
+                </a:solidFill>
               </a:rPr>
               <a:t>19, 20 e 21 de maio de 2027</a:t>
             </a:r>
-            <a:endParaRPr lang="en-US" sz="2000" dirty="0"/>
+            <a:endParaRPr lang="en-US" sz="1500" dirty="0"/>
           </a:p>
         </p:txBody>
       </p:sp>
@@ -4614,8 +5144,8 @@
         </p:nvSpPr>
         <p:spPr>
           <a:xfrm>
-            <a:off x="640080" y="868680"/>
-            <a:ext cx="10881360" cy="822960"/>
+            <a:off x="731520" y="777240"/>
+            <a:ext cx="10698480" cy="914400"/>
           </a:xfrm>
           <a:prstGeom prst="rect">
             <a:avLst/>
@@ -4631,17 +5161,17 @@
               <a:buNone/>
             </a:pPr>
             <a:r>
-              <a:rPr lang="en-US" sz="3200" spc="200" kern="0" dirty="0">
+              <a:rPr lang="en-US" sz="4400" dirty="0">
                 <a:solidFill>
                   <a:schemeClr val="bg1"/>
                 </a:solidFill>
-                <a:latin typeface="Georgia" pitchFamily="34" charset="0"/>
-                <a:ea typeface="Georgia" pitchFamily="34" charset="-122"/>
-                <a:cs typeface="Georgia" pitchFamily="34" charset="-120"/>
+                <a:latin typeface="Garamond" pitchFamily="34" charset="0"/>
+                <a:ea typeface="Garamond" pitchFamily="34" charset="-122"/>
+                <a:cs typeface="Garamond" pitchFamily="34" charset="-120"/>
               </a:rPr>
-              <a:t>O RESULTADO NA PRÁTICA</a:t>
-            </a:r>
-            <a:endParaRPr lang="en-US" sz="3200" dirty="0"/>
+              <a:t>O resultado na prática</a:t>
+            </a:r>
+            <a:endParaRPr lang="en-US" sz="4400" dirty="0"/>
           </a:p>
         </p:txBody>
       </p:sp>
@@ -4661,23 +5191,30 @@
         </p:blipFill>
         <p:spPr>
           <a:xfrm>
-            <a:off x="1984248" y="2194560"/>
+            <a:off x="1984248" y="2057400"/>
             <a:ext cx="8229600" cy="2468880"/>
           </a:xfrm>
           <a:prstGeom prst="rect">
             <a:avLst/>
           </a:prstGeom>
+          <a:effectLst>
+            <a:outerShdw sx="100000" sy="100000" kx="0" ky="0" algn="bl" rotWithShape="0" blurRad="177800" dist="50800" dir="5400000">
+              <a:srgbClr val="000000">
+                <a:alpha val="35000"/>
+              </a:srgbClr>
+            </a:outerShdw>
+          </a:effectLst>
         </p:spPr>
       </p:pic>
       <p:sp>
         <p:nvSpPr>
-          <p:cNvPr id="4" name="Legenda depoimento"/>
+          <p:cNvPr id="4" name="Text 1"/>
           <p:cNvSpPr txBox="1"/>
           <p:nvPr/>
         </p:nvSpPr>
         <p:spPr>
           <a:xfrm>
-            <a:off x="1984248" y="4892040"/>
+            <a:off x="1984248" y="4846320"/>
             <a:ext cx="8229600" cy="365760"/>
           </a:xfrm>
           <a:prstGeom prst="rect">
@@ -4687,7 +5224,7 @@
           <a:ln/>
         </p:spPr>
         <p:txBody>
-          <a:bodyPr wrap="square" lIns="0" tIns="0" rIns="0" bIns="0" rtlCol="0" anchor="ctr"/>
+          <a:bodyPr wrap="square" lIns="0" tIns="0" rIns="0" bIns="0" rtlCol="0" anchor="t"/>
           <a:lstStyle/>
           <a:p>
             <a:pPr indent="0" marL="0">
@@ -4696,57 +5233,12 @@
             <a:r>
               <a:rPr lang="en-US" sz="1300" i="1" dirty="0">
                 <a:solidFill>
-                  <a:schemeClr val="tx2"/>
+                  <a:schemeClr val="accent4"/>
                 </a:solidFill>
               </a:rPr>
               <a:t>Relato de aluna da Formação Internacional, enviado no grupo da turma.</a:t>
             </a:r>
             <a:endParaRPr lang="en-US" sz="1300" dirty="0"/>
-          </a:p>
-        </p:txBody>
-      </p:sp>
-      <p:sp>
-        <p:nvSpPr>
-          <p:cNvPr id="25" name="Slide Number Placeholder 0"/>
-          <p:cNvSpPr>
-            <a:spLocks noGrp="1"/>
-          </p:cNvSpPr>
-          <p:nvPr>
-            <p:ph type="sldNum" sz="quarter" idx="4294967295"/>
-          </p:nvPr>
-        </p:nvSpPr>
-        <p:spPr>
-          <a:xfrm>
-            <a:off x="11155680" y="6355080"/>
-            <a:ext cx="411480" cy="274320"/>
-          </a:xfrm>
-          <a:prstGeom prst="rect">
-            <a:avLst/>
-          </a:prstGeom>
-          <a:extLst>
-            <a:ext uri="{C572A759-6A51-4108-AA02-DFA0A04FC94B}">
-              <ma14:wrappingTextBoxFlag xmlns:ma14="http://schemas.microsoft.com/office/mac/drawingml/2011/main" val="0"/>
-            </a:ext>
-          </a:extLst>
-        </p:spPr>
-        <p:txBody>
-          <a:bodyPr/>
-          <a:lstStyle>
-            <a:lvl1pPr>
-              <a:defRPr sz="900">
-                <a:solidFill>
-                  <a:schemeClr val="tx2"/>
-                </a:solidFill>
-              </a:defRPr>
-            </a:lvl1pPr>
-          </a:lstStyle>
-          <a:p>
-            <a:pPr algn="r"/>
-            <a:fld id="{F7021451-1387-4CA6-816F-3879F97B5CBC}" type="slidenum">
-              <a:rPr b="0" lang="en-US"/>
-              <a:t>9</a:t>
-            </a:fld>
-            <a:endParaRPr lang="en-US"/>
           </a:p>
         </p:txBody>
       </p:sp>
@@ -4766,45 +5258,45 @@
   <a:themeElements>
     <a:clrScheme name="Formação Internacional">
       <a:dk1>
-        <a:srgbClr val="0B0B0C"/>
+        <a:srgbClr val="2B2A29"/>
       </a:dk1>
       <a:lt1>
         <a:srgbClr val="FFFFFF"/>
       </a:lt1>
       <a:dk2>
-        <a:srgbClr val="8E8C88"/>
+        <a:srgbClr val="7D7771"/>
       </a:dk2>
       <a:lt2>
-        <a:srgbClr val="F2EFEA"/>
+        <a:srgbClr val="F6F3EE"/>
       </a:lt2>
       <a:accent1>
-        <a:srgbClr val="B3182F"/>
+        <a:srgbClr val="5E1A2A"/>
       </a:accent1>
       <a:accent2>
-        <a:srgbClr val="7E1222"/>
+        <a:srgbClr val="B49A74"/>
       </a:accent2>
       <a:accent3>
-        <a:srgbClr val="161618"/>
+        <a:srgbClr val="E7E1D8"/>
       </a:accent3>
       <a:accent4>
-        <a:srgbClr val="BDBAB4"/>
+        <a:srgbClr val="D9C9C3"/>
       </a:accent4>
       <a:accent5>
-        <a:srgbClr val="2A2A2D"/>
+        <a:srgbClr val="47131F"/>
       </a:accent5>
       <a:accent6>
-        <a:srgbClr val="E9E4DC"/>
+        <a:srgbClr val="FBF9F6"/>
       </a:accent6>
       <a:hlink>
-        <a:srgbClr val="B3182F"/>
+        <a:srgbClr val="5E1A2A"/>
       </a:hlink>
       <a:folHlink>
-        <a:srgbClr val="7E1222"/>
+        <a:srgbClr val="47131F"/>
       </a:folHlink>
     </a:clrScheme>
     <a:fontScheme name="Formação Internacional">
       <a:majorFont>
-        <a:latin typeface="Georgia"/>
+        <a:latin typeface="Garamond"/>
         <a:ea typeface=""/>
         <a:cs typeface=""/>
         <a:font script="Jpan" typeface="游ゴシック Light"/>
@@ -4856,7 +5348,7 @@
         <a:font script="Tfng" typeface="Ebrima"/>
       </a:majorFont>
       <a:minorFont>
-        <a:latin typeface="Arial"/>
+        <a:latin typeface="Century Gothic"/>
         <a:ea typeface=""/>
         <a:cs typeface=""/>
         <a:font script="Jpan" typeface="游ゴシック"/>

</xml_diff>

<commit_message>
Etapa Miami: slide Por que Miami vira comparação Brasil x Miami
Co-Authored-By: Claude Opus 5.5 <noreply@anthropic.com>
Claude-Session: https://claude.ai/code/session_01ETjDEHo1Y5Ziwi4pumEH8K
</commit_message>
<xml_diff>
--- a/entregas/Formacao-Internacional-Etapa-Miami.pptx
+++ b/entregas/Formacao-Internacional-Etapa-Miami.pptx
@@ -116,28 +116,28 @@
   <p:extLst>
     <p:ext uri="{521415D9-36F7-43E2-AB2F-B90AF26B5E84}">
       <p14:sectionLst xmlns:p14="http://schemas.microsoft.com/office/powerpoint/2010/main">
-        <p14:section name="Abertura" id="{0d560b6e-caf9-2d30-07b5-912f2486563e}">
+        <p14:section name="Abertura" id="{4756d23b-6741-176a-e8b4-d10942a608f8}">
           <p14:sldIdLst>
             <p14:sldId id="256"/>
             <p14:sldId id="257"/>
             <p14:sldId id="258"/>
           </p14:sldIdLst>
         </p14:section>
-        <p14:section name="A etapa" id="{5d01691f-ad47-f40b-ba83-8382f22766b9}">
+        <p14:section name="A etapa" id="{4cc62894-c225-0adf-25e4-15856f525158}">
           <p14:sldIdLst>
             <p14:sldId id="259"/>
             <p14:sldId id="260"/>
             <p14:sldId id="261"/>
           </p14:sldIdLst>
         </p14:section>
-        <p14:section name="Pessoas" id="{4dfaa058-7255-37e9-77eb-bf32afe1b12e}">
+        <p14:section name="Pessoas" id="{0fba5408-7641-fd2d-8b74-78aada5d27b4}">
           <p14:sldIdLst>
             <p14:sldId id="262"/>
             <p14:sldId id="263"/>
             <p14:sldId id="264"/>
           </p14:sldIdLst>
         </p14:section>
-        <p14:section name="Inscrição" id="{c35dbee8-1251-ea30-f51e-e104f0d56a1b}">
+        <p14:section name="Inscrição" id="{cc8a45af-2fa5-8924-7c45-594ee9587317}">
           <p14:sldIdLst>
             <p14:sldId id="265"/>
           </p14:sldIdLst>
@@ -898,7 +898,7 @@
           <a:p>
             <a:r>
               <a:rPr lang="en-US" dirty="0"/>
-              <a:t/>
+              <a:t>Fale da segurança: entender a anatomia na peça real antes de aplicar no paciente. Se tiver os dados, cite o nome do laboratório, o tipo de specimen e quantos alunos por peça.</a:t>
             </a:r>
             <a:endParaRPr lang="en-US" dirty="0"/>
           </a:p>
@@ -2963,33 +2963,9 @@
           <a:chExt cx="0" cy="0"/>
         </a:xfrm>
       </p:grpSpPr>
-      <p:pic>
-        <p:nvPicPr>
-          <p:cNvPr id="2" name="Foto Miami" descr="Prédios de Miami vistos da rua">    </p:cNvPr>
-          <p:cNvPicPr>
-            <a:picLocks noChangeAspect="1"/>
-          </p:cNvPicPr>
-          <p:nvPr/>
-        </p:nvPicPr>
-        <p:blipFill>
-          <a:blip r:embed="rId1"/>
-          <a:stretch>
-            <a:fillRect/>
-          </a:stretch>
-        </p:blipFill>
-        <p:spPr>
-          <a:xfrm>
-            <a:off x="7050024" y="0"/>
-            <a:ext cx="5143500" cy="6858000"/>
-          </a:xfrm>
-          <a:prstGeom prst="rect">
-            <a:avLst/>
-          </a:prstGeom>
-        </p:spPr>
-      </p:pic>
-      <p:sp>
-        <p:nvSpPr>
-          <p:cNvPr id="3" name="Text 0"/>
+      <p:sp>
+        <p:nvSpPr>
+          <p:cNvPr id="2" name="Text 0"/>
           <p:cNvSpPr/>
           <p:nvPr>
             <p:ph idx="100" type="title" hasCustomPrompt="1"/>
@@ -3030,14 +3006,14 @@
       </p:sp>
       <p:sp>
         <p:nvSpPr>
-          <p:cNvPr id="4" name="Text 1"/>
+          <p:cNvPr id="3" name="Text 1"/>
           <p:cNvSpPr txBox="1"/>
           <p:nvPr/>
         </p:nvSpPr>
         <p:spPr>
           <a:xfrm>
-            <a:off x="731520" y="1920240"/>
-            <a:ext cx="5669280" cy="1554480"/>
+            <a:off x="731520" y="1645920"/>
+            <a:ext cx="10698480" cy="457200"/>
           </a:xfrm>
           <a:prstGeom prst="rect">
             <a:avLst/>
@@ -3050,38 +3026,37 @@
           <a:lstStyle/>
           <a:p>
             <a:pPr indent="0" marL="0">
-              <a:lnSpc>
-                <a:spcPct val="115000"/>
-              </a:lnSpc>
-              <a:buNone/>
-            </a:pPr>
-            <a:r>
-              <a:rPr lang="en-US" sz="1600" dirty="0">
-                <a:solidFill>
-                  <a:schemeClr val="tx1"/>
+              <a:buNone/>
+            </a:pPr>
+            <a:r>
+              <a:rPr lang="en-US" sz="1800" dirty="0">
+                <a:solidFill>
+                  <a:schemeClr val="tx2"/>
                 </a:solidFill>
               </a:rPr>
-              <a:t>Nos Estados Unidos, laboratórios privados de anatomia oferecem estrutura para treinamento hands-on em specimen, a peça anatômica real. Em Miami, o conteúdo científico vira prática.</a:t>
-            </a:r>
-            <a:endParaRPr lang="en-US" sz="1600" dirty="0"/>
-          </a:p>
-        </p:txBody>
-      </p:sp>
-      <p:sp>
-        <p:nvSpPr>
-          <p:cNvPr id="5" name="Fio 1"/>
+              <a:t>Porque lá a anatomia sai do livro e vai para a peça anatômica real.</a:t>
+            </a:r>
+            <a:endParaRPr lang="en-US" sz="1800" dirty="0"/>
+          </a:p>
+        </p:txBody>
+      </p:sp>
+      <p:sp>
+        <p:nvSpPr>
+          <p:cNvPr id="4" name="Cartão No Brasil"/>
           <p:cNvSpPr/>
           <p:nvPr/>
         </p:nvSpPr>
         <p:spPr>
           <a:xfrm>
-            <a:off x="731520" y="3611880"/>
-            <a:ext cx="5669280" cy="0"/>
-          </a:xfrm>
-          <a:prstGeom prst="line">
-            <a:avLst/>
-          </a:prstGeom>
-          <a:noFill/>
+            <a:off x="731520" y="2423160"/>
+            <a:ext cx="5239512" cy="3749040"/>
+          </a:xfrm>
+          <a:prstGeom prst="rect">
+            <a:avLst/>
+          </a:prstGeom>
+          <a:solidFill>
+            <a:schemeClr val="bg1"/>
+          </a:solidFill>
           <a:ln w="12700">
             <a:solidFill>
               <a:schemeClr val="accent3"/>
@@ -3092,14 +3067,14 @@
       </p:sp>
       <p:sp>
         <p:nvSpPr>
-          <p:cNvPr id="6" name="Item 1 título"/>
+          <p:cNvPr id="5" name="No Brasil título"/>
           <p:cNvSpPr txBox="1"/>
           <p:nvPr/>
         </p:nvSpPr>
         <p:spPr>
           <a:xfrm>
-            <a:off x="731520" y="3721608"/>
-            <a:ext cx="5669280" cy="384048"/>
+            <a:off x="1188720" y="2743200"/>
+            <a:ext cx="4389120" cy="685800"/>
           </a:xfrm>
           <a:prstGeom prst="rect">
             <a:avLst/>
@@ -3115,7 +3090,7 @@
               <a:buNone/>
             </a:pPr>
             <a:r>
-              <a:rPr lang="en-US" sz="2200" dirty="0">
+              <a:rPr lang="en-US" sz="3600" dirty="0">
                 <a:solidFill>
                   <a:schemeClr val="accent1"/>
                 </a:solidFill>
@@ -3123,58 +3098,22 @@
                 <a:ea typeface="Garamond" pitchFamily="34" charset="-122"/>
                 <a:cs typeface="Garamond" pitchFamily="34" charset="-120"/>
               </a:rPr>
-              <a:t>Imersão de 3 dias</a:t>
-            </a:r>
-            <a:endParaRPr lang="en-US" sz="2200" dirty="0"/>
-          </a:p>
-        </p:txBody>
-      </p:sp>
-      <p:sp>
-        <p:nvSpPr>
-          <p:cNvPr id="7" name="Item 1 texto"/>
-          <p:cNvSpPr txBox="1"/>
-          <p:nvPr/>
-        </p:nvSpPr>
-        <p:spPr>
-          <a:xfrm>
-            <a:off x="731520" y="4096512"/>
-            <a:ext cx="5669280" cy="292608"/>
-          </a:xfrm>
-          <a:prstGeom prst="rect">
-            <a:avLst/>
-          </a:prstGeom>
-          <a:noFill/>
-          <a:ln/>
-        </p:spPr>
-        <p:txBody>
-          <a:bodyPr wrap="square" lIns="0" tIns="0" rIns="0" bIns="0" rtlCol="0" anchor="t"/>
-          <a:lstStyle/>
-          <a:p>
-            <a:pPr indent="0" marL="0">
-              <a:buNone/>
-            </a:pPr>
-            <a:r>
-              <a:rPr lang="en-US" sz="1400" dirty="0">
-                <a:solidFill>
-                  <a:schemeClr val="tx2"/>
-                </a:solidFill>
-              </a:rPr>
-              <a:t>com prática real</a:t>
-            </a:r>
-            <a:endParaRPr lang="en-US" sz="1400" dirty="0"/>
-          </a:p>
-        </p:txBody>
-      </p:sp>
-      <p:sp>
-        <p:nvSpPr>
-          <p:cNvPr id="8" name="Fio 2"/>
+              <a:t>No Brasil</a:t>
+            </a:r>
+            <a:endParaRPr lang="en-US" sz="3600" dirty="0"/>
+          </a:p>
+        </p:txBody>
+      </p:sp>
+      <p:sp>
+        <p:nvSpPr>
+          <p:cNvPr id="6" name="No Brasil fio 1"/>
           <p:cNvSpPr/>
           <p:nvPr/>
         </p:nvSpPr>
         <p:spPr>
           <a:xfrm>
-            <a:off x="731520" y="4480560"/>
-            <a:ext cx="5669280" cy="0"/>
+            <a:off x="1188720" y="3611880"/>
+            <a:ext cx="4325112" cy="0"/>
           </a:xfrm>
           <a:prstGeom prst="line">
             <a:avLst/>
@@ -3190,14 +3129,14 @@
       </p:sp>
       <p:sp>
         <p:nvSpPr>
-          <p:cNvPr id="9" name="Item 2 título"/>
+          <p:cNvPr id="7" name="No Brasil item 1"/>
           <p:cNvSpPr txBox="1"/>
           <p:nvPr/>
         </p:nvSpPr>
         <p:spPr>
           <a:xfrm>
-            <a:off x="731520" y="4590288"/>
-            <a:ext cx="5669280" cy="384048"/>
+            <a:off x="1188720" y="3703320"/>
+            <a:ext cx="4325112" cy="713232"/>
           </a:xfrm>
           <a:prstGeom prst="rect">
             <a:avLst/>
@@ -3210,69 +3149,33 @@
           <a:lstStyle/>
           <a:p>
             <a:pPr indent="0" marL="0">
-              <a:buNone/>
-            </a:pPr>
-            <a:r>
-              <a:rPr lang="en-US" sz="2200" dirty="0">
-                <a:solidFill>
-                  <a:schemeClr val="accent1"/>
-                </a:solidFill>
-                <a:latin typeface="Garamond" pitchFamily="34" charset="0"/>
-                <a:ea typeface="Garamond" pitchFamily="34" charset="-122"/>
-                <a:cs typeface="Garamond" pitchFamily="34" charset="-120"/>
+              <a:lnSpc>
+                <a:spcPct val="110000"/>
+              </a:lnSpc>
+              <a:buNone/>
+            </a:pPr>
+            <a:r>
+              <a:rPr lang="en-US" sz="1500" dirty="0">
+                <a:solidFill>
+                  <a:schemeClr val="tx1"/>
+                </a:solidFill>
               </a:rPr>
-              <a:t>Laboratórios privados</a:t>
-            </a:r>
-            <a:endParaRPr lang="en-US" sz="2200" dirty="0"/>
-          </a:p>
-        </p:txBody>
-      </p:sp>
-      <p:sp>
-        <p:nvSpPr>
-          <p:cNvPr id="10" name="Item 2 texto"/>
-          <p:cNvSpPr txBox="1"/>
-          <p:nvPr/>
-        </p:nvSpPr>
-        <p:spPr>
-          <a:xfrm>
-            <a:off x="731520" y="4965192"/>
-            <a:ext cx="5669280" cy="292608"/>
-          </a:xfrm>
-          <a:prstGeom prst="rect">
-            <a:avLst/>
-          </a:prstGeom>
-          <a:noFill/>
-          <a:ln/>
-        </p:spPr>
-        <p:txBody>
-          <a:bodyPr wrap="square" lIns="0" tIns="0" rIns="0" bIns="0" rtlCol="0" anchor="t"/>
-          <a:lstStyle/>
-          <a:p>
-            <a:pPr indent="0" marL="0">
-              <a:buNone/>
-            </a:pPr>
-            <a:r>
-              <a:rPr lang="en-US" sz="1400" dirty="0">
-                <a:solidFill>
-                  <a:schemeClr val="tx2"/>
-                </a:solidFill>
-              </a:rPr>
-              <a:t>preparados para hands-on avançado</a:t>
-            </a:r>
-            <a:endParaRPr lang="en-US" sz="1400" dirty="0"/>
-          </a:p>
-        </p:txBody>
-      </p:sp>
-      <p:sp>
-        <p:nvSpPr>
-          <p:cNvPr id="11" name="Fio 3"/>
+              <a:t>Anatomia estudada em atlas, vídeos e modelos sintéticos</a:t>
+            </a:r>
+            <a:endParaRPr lang="en-US" sz="1500" dirty="0"/>
+          </a:p>
+        </p:txBody>
+      </p:sp>
+      <p:sp>
+        <p:nvSpPr>
+          <p:cNvPr id="8" name="No Brasil fio 2"/>
           <p:cNvSpPr/>
           <p:nvPr/>
         </p:nvSpPr>
         <p:spPr>
           <a:xfrm>
-            <a:off x="731520" y="5349240"/>
-            <a:ext cx="5669280" cy="0"/>
+            <a:off x="1188720" y="4434840"/>
+            <a:ext cx="4325112" cy="0"/>
           </a:xfrm>
           <a:prstGeom prst="line">
             <a:avLst/>
@@ -3288,14 +3191,14 @@
       </p:sp>
       <p:sp>
         <p:nvSpPr>
-          <p:cNvPr id="12" name="Item 3 título"/>
+          <p:cNvPr id="9" name="No Brasil item 2"/>
           <p:cNvSpPr txBox="1"/>
           <p:nvPr/>
         </p:nvSpPr>
         <p:spPr>
           <a:xfrm>
-            <a:off x="731520" y="5458968"/>
-            <a:ext cx="5669280" cy="384048"/>
+            <a:off x="1188720" y="4526280"/>
+            <a:ext cx="4325112" cy="713232"/>
           </a:xfrm>
           <a:prstGeom prst="rect">
             <a:avLst/>
@@ -3308,33 +3211,182 @@
           <a:lstStyle/>
           <a:p>
             <a:pPr indent="0" marL="0">
-              <a:buNone/>
-            </a:pPr>
-            <a:r>
-              <a:rPr lang="en-US" sz="2200" dirty="0">
-                <a:solidFill>
-                  <a:schemeClr val="accent1"/>
+              <a:lnSpc>
+                <a:spcPct val="110000"/>
+              </a:lnSpc>
+              <a:buNone/>
+            </a:pPr>
+            <a:r>
+              <a:rPr lang="en-US" sz="1500" dirty="0">
+                <a:solidFill>
+                  <a:schemeClr val="tx1"/>
+                </a:solidFill>
+              </a:rPr>
+              <a:t>Acesso a peças anatômicas restrito, em geral, às universidades</a:t>
+            </a:r>
+            <a:endParaRPr lang="en-US" sz="1500" dirty="0"/>
+          </a:p>
+        </p:txBody>
+      </p:sp>
+      <p:sp>
+        <p:nvSpPr>
+          <p:cNvPr id="10" name="No Brasil fio 3"/>
+          <p:cNvSpPr/>
+          <p:nvPr/>
+        </p:nvSpPr>
+        <p:spPr>
+          <a:xfrm>
+            <a:off x="1188720" y="5257800"/>
+            <a:ext cx="4325112" cy="0"/>
+          </a:xfrm>
+          <a:prstGeom prst="line">
+            <a:avLst/>
+          </a:prstGeom>
+          <a:noFill/>
+          <a:ln w="12700">
+            <a:solidFill>
+              <a:schemeClr val="accent3"/>
+            </a:solidFill>
+            <a:prstDash val="solid"/>
+          </a:ln>
+        </p:spPr>
+      </p:sp>
+      <p:sp>
+        <p:nvSpPr>
+          <p:cNvPr id="11" name="No Brasil item 3"/>
+          <p:cNvSpPr txBox="1"/>
+          <p:nvPr/>
+        </p:nvSpPr>
+        <p:spPr>
+          <a:xfrm>
+            <a:off x="1188720" y="5349240"/>
+            <a:ext cx="4325112" cy="713232"/>
+          </a:xfrm>
+          <a:prstGeom prst="rect">
+            <a:avLst/>
+          </a:prstGeom>
+          <a:noFill/>
+          <a:ln/>
+        </p:spPr>
+        <p:txBody>
+          <a:bodyPr wrap="square" lIns="0" tIns="0" rIns="0" bIns="0" rtlCol="0" anchor="t"/>
+          <a:lstStyle/>
+          <a:p>
+            <a:pPr indent="0" marL="0">
+              <a:lnSpc>
+                <a:spcPct val="110000"/>
+              </a:lnSpc>
+              <a:buNone/>
+            </a:pPr>
+            <a:r>
+              <a:rPr lang="en-US" sz="1500" dirty="0">
+                <a:solidFill>
+                  <a:schemeClr val="tx1"/>
+                </a:solidFill>
+              </a:rPr>
+              <a:t>A primeira prática costuma ser direto no paciente</a:t>
+            </a:r>
+            <a:endParaRPr lang="en-US" sz="1500" dirty="0"/>
+          </a:p>
+        </p:txBody>
+      </p:sp>
+      <p:sp>
+        <p:nvSpPr>
+          <p:cNvPr id="12" name="Cartão Em Miami"/>
+          <p:cNvSpPr/>
+          <p:nvPr/>
+        </p:nvSpPr>
+        <p:spPr>
+          <a:xfrm>
+            <a:off x="6217920" y="2423160"/>
+            <a:ext cx="5239512" cy="3749040"/>
+          </a:xfrm>
+          <a:prstGeom prst="rect">
+            <a:avLst/>
+          </a:prstGeom>
+          <a:solidFill>
+            <a:schemeClr val="accent1"/>
+          </a:solidFill>
+          <a:ln w="12700">
+            <a:solidFill>
+              <a:schemeClr val="accent1"/>
+            </a:solidFill>
+            <a:prstDash val="solid"/>
+          </a:ln>
+        </p:spPr>
+      </p:sp>
+      <p:sp>
+        <p:nvSpPr>
+          <p:cNvPr id="13" name="Em Miami título"/>
+          <p:cNvSpPr txBox="1"/>
+          <p:nvPr/>
+        </p:nvSpPr>
+        <p:spPr>
+          <a:xfrm>
+            <a:off x="6675120" y="2743200"/>
+            <a:ext cx="4389120" cy="685800"/>
+          </a:xfrm>
+          <a:prstGeom prst="rect">
+            <a:avLst/>
+          </a:prstGeom>
+          <a:noFill/>
+          <a:ln/>
+        </p:spPr>
+        <p:txBody>
+          <a:bodyPr wrap="square" lIns="0" tIns="0" rIns="0" bIns="0" rtlCol="0" anchor="t"/>
+          <a:lstStyle/>
+          <a:p>
+            <a:pPr indent="0" marL="0">
+              <a:buNone/>
+            </a:pPr>
+            <a:r>
+              <a:rPr lang="en-US" sz="3600" dirty="0">
+                <a:solidFill>
+                  <a:schemeClr val="bg1"/>
                 </a:solidFill>
                 <a:latin typeface="Garamond" pitchFamily="34" charset="0"/>
                 <a:ea typeface="Garamond" pitchFamily="34" charset="-122"/>
                 <a:cs typeface="Garamond" pitchFamily="34" charset="-120"/>
               </a:rPr>
-              <a:t>Anatomia aplicada</a:t>
-            </a:r>
-            <a:endParaRPr lang="en-US" sz="2200" dirty="0"/>
-          </a:p>
-        </p:txBody>
-      </p:sp>
-      <p:sp>
-        <p:nvSpPr>
-          <p:cNvPr id="13" name="Item 3 texto"/>
+              <a:t>Em Miami</a:t>
+            </a:r>
+            <a:endParaRPr lang="en-US" sz="3600" dirty="0"/>
+          </a:p>
+        </p:txBody>
+      </p:sp>
+      <p:sp>
+        <p:nvSpPr>
+          <p:cNvPr id="14" name="Em Miami fio 1"/>
+          <p:cNvSpPr/>
+          <p:nvPr/>
+        </p:nvSpPr>
+        <p:spPr>
+          <a:xfrm>
+            <a:off x="6675120" y="3611880"/>
+            <a:ext cx="4325112" cy="0"/>
+          </a:xfrm>
+          <a:prstGeom prst="line">
+            <a:avLst/>
+          </a:prstGeom>
+          <a:noFill/>
+          <a:ln w="12700">
+            <a:solidFill>
+              <a:schemeClr val="accent5"/>
+            </a:solidFill>
+            <a:prstDash val="solid"/>
+          </a:ln>
+        </p:spPr>
+      </p:sp>
+      <p:sp>
+        <p:nvSpPr>
+          <p:cNvPr id="15" name="Em Miami item 1"/>
           <p:cNvSpPr txBox="1"/>
           <p:nvPr/>
         </p:nvSpPr>
         <p:spPr>
           <a:xfrm>
-            <a:off x="731520" y="5833872"/>
-            <a:ext cx="5669280" cy="292608"/>
+            <a:off x="6675120" y="3703320"/>
+            <a:ext cx="4325112" cy="713232"/>
           </a:xfrm>
           <a:prstGeom prst="rect">
             <a:avLst/>
@@ -3347,17 +3399,144 @@
           <a:lstStyle/>
           <a:p>
             <a:pPr indent="0" marL="0">
-              <a:buNone/>
-            </a:pPr>
-            <a:r>
-              <a:rPr lang="en-US" sz="1400" dirty="0">
-                <a:solidFill>
-                  <a:schemeClr val="tx2"/>
+              <a:lnSpc>
+                <a:spcPct val="110000"/>
+              </a:lnSpc>
+              <a:buNone/>
+            </a:pPr>
+            <a:r>
+              <a:rPr lang="en-US" sz="1500" dirty="0">
+                <a:solidFill>
+                  <a:schemeClr val="bg1"/>
                 </a:solidFill>
               </a:rPr>
-              <a:t>direto na peça anatômica</a:t>
-            </a:r>
-            <a:endParaRPr lang="en-US" sz="1400" dirty="0"/>
+              <a:t>Hands-on em specimen, a peça anatômica real</a:t>
+            </a:r>
+            <a:endParaRPr lang="en-US" sz="1500" dirty="0"/>
+          </a:p>
+        </p:txBody>
+      </p:sp>
+      <p:sp>
+        <p:nvSpPr>
+          <p:cNvPr id="16" name="Em Miami fio 2"/>
+          <p:cNvSpPr/>
+          <p:nvPr/>
+        </p:nvSpPr>
+        <p:spPr>
+          <a:xfrm>
+            <a:off x="6675120" y="4434840"/>
+            <a:ext cx="4325112" cy="0"/>
+          </a:xfrm>
+          <a:prstGeom prst="line">
+            <a:avLst/>
+          </a:prstGeom>
+          <a:noFill/>
+          <a:ln w="12700">
+            <a:solidFill>
+              <a:schemeClr val="accent5"/>
+            </a:solidFill>
+            <a:prstDash val="solid"/>
+          </a:ln>
+        </p:spPr>
+      </p:sp>
+      <p:sp>
+        <p:nvSpPr>
+          <p:cNvPr id="17" name="Em Miami item 2"/>
+          <p:cNvSpPr txBox="1"/>
+          <p:nvPr/>
+        </p:nvSpPr>
+        <p:spPr>
+          <a:xfrm>
+            <a:off x="6675120" y="4526280"/>
+            <a:ext cx="4325112" cy="713232"/>
+          </a:xfrm>
+          <a:prstGeom prst="rect">
+            <a:avLst/>
+          </a:prstGeom>
+          <a:noFill/>
+          <a:ln/>
+        </p:spPr>
+        <p:txBody>
+          <a:bodyPr wrap="square" lIns="0" tIns="0" rIns="0" bIns="0" rtlCol="0" anchor="t"/>
+          <a:lstStyle/>
+          <a:p>
+            <a:pPr indent="0" marL="0">
+              <a:lnSpc>
+                <a:spcPct val="110000"/>
+              </a:lnSpc>
+              <a:buNone/>
+            </a:pPr>
+            <a:r>
+              <a:rPr lang="en-US" sz="1500" dirty="0">
+                <a:solidFill>
+                  <a:schemeClr val="bg1"/>
+                </a:solidFill>
+              </a:rPr>
+              <a:t>Laboratório privado com estrutura para treinamento avançado</a:t>
+            </a:r>
+            <a:endParaRPr lang="en-US" sz="1500" dirty="0"/>
+          </a:p>
+        </p:txBody>
+      </p:sp>
+      <p:sp>
+        <p:nvSpPr>
+          <p:cNvPr id="18" name="Em Miami fio 3"/>
+          <p:cNvSpPr/>
+          <p:nvPr/>
+        </p:nvSpPr>
+        <p:spPr>
+          <a:xfrm>
+            <a:off x="6675120" y="5257800"/>
+            <a:ext cx="4325112" cy="0"/>
+          </a:xfrm>
+          <a:prstGeom prst="line">
+            <a:avLst/>
+          </a:prstGeom>
+          <a:noFill/>
+          <a:ln w="12700">
+            <a:solidFill>
+              <a:schemeClr val="accent5"/>
+            </a:solidFill>
+            <a:prstDash val="solid"/>
+          </a:ln>
+        </p:spPr>
+      </p:sp>
+      <p:sp>
+        <p:nvSpPr>
+          <p:cNvPr id="19" name="Em Miami item 3"/>
+          <p:cNvSpPr txBox="1"/>
+          <p:nvPr/>
+        </p:nvSpPr>
+        <p:spPr>
+          <a:xfrm>
+            <a:off x="6675120" y="5349240"/>
+            <a:ext cx="4325112" cy="713232"/>
+          </a:xfrm>
+          <a:prstGeom prst="rect">
+            <a:avLst/>
+          </a:prstGeom>
+          <a:noFill/>
+          <a:ln/>
+        </p:spPr>
+        <p:txBody>
+          <a:bodyPr wrap="square" lIns="0" tIns="0" rIns="0" bIns="0" rtlCol="0" anchor="t"/>
+          <a:lstStyle/>
+          <a:p>
+            <a:pPr indent="0" marL="0">
+              <a:lnSpc>
+                <a:spcPct val="110000"/>
+              </a:lnSpc>
+              <a:buNone/>
+            </a:pPr>
+            <a:r>
+              <a:rPr lang="en-US" sz="1500" dirty="0">
+                <a:solidFill>
+                  <a:schemeClr val="bg1"/>
+                </a:solidFill>
+              </a:rPr>
+              <a:t>Você vê planos, vasos e áreas de risco antes de tocar no paciente</a:t>
+            </a:r>
+            <a:endParaRPr lang="en-US" sz="1500" dirty="0"/>
           </a:p>
         </p:txBody>
       </p:sp>

</xml_diff>

<commit_message>
Etapa Miami: adiciona slide Visão do Projeto no estilo do material original
Co-Authored-By: Claude Opus 5.5 <noreply@anthropic.com>
Claude-Session: https://claude.ai/code/session_01ETjDEHo1Y5Ziwi4pumEH8K
</commit_message>
<xml_diff>
--- a/entregas/Formacao-Internacional-Etapa-Miami.pptx
+++ b/entregas/Formacao-Internacional-Etapa-Miami.pptx
@@ -15,9 +15,10 @@
     <p:sldId id="263" r:id="rId9"/>
     <p:sldId id="264" r:id="rId10"/>
     <p:sldId id="265" r:id="rId11"/>
+    <p:sldId id="266" r:id="rId12"/>
   </p:sldIdLst>
   <p:notesMasterIdLst>
-    <p:notesMasterId r:id="rId12"/>
+    <p:notesMasterId r:id="rId13"/>
   </p:notesMasterIdLst>
   <p:sldSz cx="12192000" cy="6858000"/>
   <p:notesSz cx="6858000" cy="12192000"/>
@@ -116,30 +117,31 @@
   <p:extLst>
     <p:ext uri="{521415D9-36F7-43E2-AB2F-B90AF26B5E84}">
       <p14:sectionLst xmlns:p14="http://schemas.microsoft.com/office/powerpoint/2010/main">
-        <p14:section name="Abertura" id="{4756d23b-6741-176a-e8b4-d10942a608f8}">
+        <p14:section name="Abertura" id="{27af0fbe-db16-bc55-2bd1-393f973e3b53}">
           <p14:sldIdLst>
             <p14:sldId id="256"/>
             <p14:sldId id="257"/>
             <p14:sldId id="258"/>
+            <p14:sldId id="259"/>
           </p14:sldIdLst>
         </p14:section>
-        <p14:section name="A etapa" id="{4cc62894-c225-0adf-25e4-15856f525158}">
+        <p14:section name="A etapa" id="{1f3ca47f-40b3-434c-bd82-3a9d11258bf6}">
           <p14:sldIdLst>
-            <p14:sldId id="259"/>
             <p14:sldId id="260"/>
             <p14:sldId id="261"/>
+            <p14:sldId id="262"/>
           </p14:sldIdLst>
         </p14:section>
-        <p14:section name="Pessoas" id="{0fba5408-7641-fd2d-8b74-78aada5d27b4}">
+        <p14:section name="Pessoas" id="{a7287e01-13cf-0921-6c86-504e4156c5d5}">
           <p14:sldIdLst>
-            <p14:sldId id="262"/>
             <p14:sldId id="263"/>
             <p14:sldId id="264"/>
+            <p14:sldId id="265"/>
           </p14:sldIdLst>
         </p14:section>
-        <p14:section name="Inscrição" id="{cc8a45af-2fa5-8924-7c45-594ee9587317}">
+        <p14:section name="Inscrição" id="{37d091c0-835b-f8f8-0222-65d507c432bd}">
           <p14:sldIdLst>
-            <p14:sldId id="265"/>
+            <p14:sldId id="266"/>
           </p14:sldIdLst>
         </p14:section>
       </p14:sectionLst>
@@ -634,7 +636,7 @@
           <a:p>
             <a:r>
               <a:rPr lang="en-US" dirty="0"/>
-              <a:t>O QR code e o número abrem o WhatsApp (62) 98515-0061 com a mensagem pronta: Olá, quero saber mais do Programa de Formação Internacional.</a:t>
+              <a:t/>
             </a:r>
             <a:endParaRPr lang="en-US" dirty="0"/>
           </a:p>
@@ -658,6 +660,94 @@
             <a:fld id="{F7021451-1387-4CA6-816F-3879F97B5CBC}" type="slidenum">
               <a:rPr lang="en-US"/>
               <a:t>10</a:t>
+            </a:fld>
+            <a:endParaRPr lang="en-US"/>
+          </a:p>
+        </p:txBody>
+      </p:sp>
+    </p:spTree>
+    <p:extLst>
+      <p:ext uri="{BB962C8B-B14F-4D97-AF65-F5344CB8AC3E}">
+        <p14:creationId xmlns:p14="http://schemas.microsoft.com/office/powerpoint/2010/main" val="1024086991"/>
+      </p:ext>
+    </p:extLst>
+  </p:cSld>
+  <p:clrMapOvr>
+    <a:masterClrMapping/>
+  </p:clrMapOvr>
+</p:notes>
+</file>
+
+<file path=ppt/notesSlides/notesSlide11.xml><?xml version="1.0" encoding="utf-8"?>
+<p:notes xmlns:a="http://schemas.openxmlformats.org/drawingml/2006/main" xmlns:r="http://schemas.openxmlformats.org/officeDocument/2006/relationships" xmlns:p="http://schemas.openxmlformats.org/presentationml/2006/main">
+  <p:cSld>
+    <p:spTree>
+      <p:nvGrpSpPr>
+        <p:cNvPr id="1" name=""/>
+        <p:cNvGrpSpPr/>
+        <p:nvPr/>
+      </p:nvGrpSpPr>
+      <p:grpSpPr>
+        <a:xfrm>
+          <a:off x="0" y="0"/>
+          <a:ext cx="0" cy="0"/>
+          <a:chOff x="0" y="0"/>
+          <a:chExt cx="0" cy="0"/>
+        </a:xfrm>
+      </p:grpSpPr>
+      <p:sp>
+        <p:nvSpPr>
+          <p:cNvPr id="2" name="Slide Image Placeholder 1"/>
+          <p:cNvSpPr>
+            <a:spLocks noGrp="1" noRot="1" noChangeAspect="1"/>
+          </p:cNvSpPr>
+          <p:nvPr>
+            <p:ph type="sldImg"/>
+          </p:nvPr>
+        </p:nvSpPr>
+        <p:spPr/>
+      </p:sp>
+      <p:sp>
+        <p:nvSpPr>
+          <p:cNvPr id="3" name="Notes Placeholder 2"/>
+          <p:cNvSpPr>
+            <a:spLocks noGrp="1"/>
+          </p:cNvSpPr>
+          <p:nvPr>
+            <p:ph type="body" idx="1"/>
+          </p:nvPr>
+        </p:nvSpPr>
+        <p:spPr/>
+        <p:txBody>
+          <a:bodyPr/>
+          <a:lstStyle/>
+          <a:p>
+            <a:r>
+              <a:rPr lang="en-US" dirty="0"/>
+              <a:t>O QR code e o número abrem o WhatsApp (62) 98515-0061 com a mensagem pronta: Olá, quero saber mais do Programa de Formação Internacional.</a:t>
+            </a:r>
+            <a:endParaRPr lang="en-US" dirty="0"/>
+          </a:p>
+        </p:txBody>
+      </p:sp>
+      <p:sp>
+        <p:nvSpPr>
+          <p:cNvPr id="4" name="Slide Number Placeholder 3"/>
+          <p:cNvSpPr>
+            <a:spLocks noGrp="1"/>
+          </p:cNvSpPr>
+          <p:nvPr>
+            <p:ph type="sldNum" sz="quarter" idx="10"/>
+          </p:nvPr>
+        </p:nvSpPr>
+        <p:spPr/>
+        <p:txBody>
+          <a:bodyPr/>
+          <a:lstStyle/>
+          <a:p>
+            <a:fld id="{F7021451-1387-4CA6-816F-3879F97B5CBC}" type="slidenum">
+              <a:rPr lang="en-US"/>
+              <a:t>11</a:t>
             </a:fld>
             <a:endParaRPr lang="en-US"/>
           </a:p>
@@ -810,7 +900,7 @@
           <a:p>
             <a:r>
               <a:rPr lang="en-US" dirty="0"/>
-              <a:t>Slide reservado para vídeo. Depois de inserir: aba Reprodução &gt; Iniciar: Automaticamente. Para vídeo de fundo sem som, marque 'Repetir até parar' e deixe o volume mudo.</a:t>
+              <a:t/>
             </a:r>
             <a:endParaRPr lang="en-US" dirty="0"/>
           </a:p>
@@ -898,7 +988,7 @@
           <a:p>
             <a:r>
               <a:rPr lang="en-US" dirty="0"/>
-              <a:t>Fale da segurança: entender a anatomia na peça real antes de aplicar no paciente. Se tiver os dados, cite o nome do laboratório, o tipo de specimen e quantos alunos por peça.</a:t>
+              <a:t>Slide reservado para vídeo. Depois de inserir: aba Reprodução &gt; Iniciar: Automaticamente. Para vídeo de fundo sem som, marque 'Repetir até parar' e deixe o volume mudo.</a:t>
             </a:r>
             <a:endParaRPr lang="en-US" dirty="0"/>
           </a:p>
@@ -986,7 +1076,7 @@
           <a:p>
             <a:r>
               <a:rPr lang="en-US" dirty="0"/>
-              <a:t/>
+              <a:t>Fale da segurança: entender a anatomia na peça real antes de aplicar no paciente. Se tiver os dados, cite o nome do laboratório, o tipo de specimen e quantos alunos por peça.</a:t>
             </a:r>
             <a:endParaRPr lang="en-US" dirty="0"/>
           </a:p>
@@ -2054,6 +2144,142 @@
       <p:sp>
         <p:nvSpPr>
           <p:cNvPr id="2" name="Text 0"/>
+          <p:cNvSpPr/>
+          <p:nvPr>
+            <p:ph idx="100" type="title" hasCustomPrompt="1"/>
+          </p:nvPr>
+        </p:nvSpPr>
+        <p:spPr>
+          <a:xfrm>
+            <a:off x="731520" y="777240"/>
+            <a:ext cx="10698480" cy="914400"/>
+          </a:xfrm>
+          <a:prstGeom prst="rect">
+            <a:avLst/>
+          </a:prstGeom>
+          <a:noFill/>
+          <a:ln/>
+        </p:spPr>
+        <p:txBody>
+          <a:bodyPr wrap="square" lIns="0" tIns="0" rIns="0" bIns="0" rtlCol="0" anchor="t"/>
+          <a:lstStyle/>
+          <a:p>
+            <a:pPr algn="l" indent="0" marL="0">
+              <a:buNone/>
+            </a:pPr>
+            <a:r>
+              <a:rPr lang="en-US" sz="4400" dirty="0">
+                <a:solidFill>
+                  <a:schemeClr val="bg1"/>
+                </a:solidFill>
+                <a:latin typeface="Garamond" pitchFamily="34" charset="0"/>
+                <a:ea typeface="Garamond" pitchFamily="34" charset="-122"/>
+                <a:cs typeface="Garamond" pitchFamily="34" charset="-120"/>
+              </a:rPr>
+              <a:t>O resultado na prática</a:t>
+            </a:r>
+            <a:endParaRPr lang="en-US" sz="4400" dirty="0"/>
+          </a:p>
+        </p:txBody>
+      </p:sp>
+      <p:pic>
+        <p:nvPicPr>
+          <p:cNvPr id="3" name="Depoimento" descr="Mensagem de aluna: depois da Formação Internacional, converteu o valor do curso em menos de 2 meses com 2 pacientes">    </p:cNvPr>
+          <p:cNvPicPr>
+            <a:picLocks noChangeAspect="1"/>
+          </p:cNvPicPr>
+          <p:nvPr/>
+        </p:nvPicPr>
+        <p:blipFill>
+          <a:blip r:embed="rId1"/>
+          <a:stretch>
+            <a:fillRect/>
+          </a:stretch>
+        </p:blipFill>
+        <p:spPr>
+          <a:xfrm>
+            <a:off x="1984248" y="2057400"/>
+            <a:ext cx="8229600" cy="2468880"/>
+          </a:xfrm>
+          <a:prstGeom prst="rect">
+            <a:avLst/>
+          </a:prstGeom>
+          <a:effectLst>
+            <a:outerShdw sx="100000" sy="100000" kx="0" ky="0" algn="bl" rotWithShape="0" blurRad="177800" dist="50800" dir="5400000">
+              <a:srgbClr val="000000">
+                <a:alpha val="35000"/>
+              </a:srgbClr>
+            </a:outerShdw>
+          </a:effectLst>
+        </p:spPr>
+      </p:pic>
+      <p:sp>
+        <p:nvSpPr>
+          <p:cNvPr id="4" name="Text 1"/>
+          <p:cNvSpPr txBox="1"/>
+          <p:nvPr/>
+        </p:nvSpPr>
+        <p:spPr>
+          <a:xfrm>
+            <a:off x="1984248" y="4846320"/>
+            <a:ext cx="8229600" cy="365760"/>
+          </a:xfrm>
+          <a:prstGeom prst="rect">
+            <a:avLst/>
+          </a:prstGeom>
+          <a:noFill/>
+          <a:ln/>
+        </p:spPr>
+        <p:txBody>
+          <a:bodyPr wrap="square" lIns="0" tIns="0" rIns="0" bIns="0" rtlCol="0" anchor="t"/>
+          <a:lstStyle/>
+          <a:p>
+            <a:pPr indent="0" marL="0">
+              <a:buNone/>
+            </a:pPr>
+            <a:r>
+              <a:rPr lang="en-US" sz="1300" i="1" dirty="0">
+                <a:solidFill>
+                  <a:schemeClr val="accent4"/>
+                </a:solidFill>
+              </a:rPr>
+              <a:t>Relato de aluna da Formação Internacional, enviado no grupo da turma.</a:t>
+            </a:r>
+            <a:endParaRPr lang="en-US" sz="1300" dirty="0"/>
+          </a:p>
+        </p:txBody>
+      </p:sp>
+    </p:spTree>
+  </p:cSld>
+  <p:clrMapOvr>
+    <a:masterClrMapping/>
+  </p:clrMapOvr>
+  <p:transition spd="slow">
+    <p:fade/>
+  </p:transition>
+</p:sld>
+</file>
+
+<file path=ppt/slides/slide11.xml><?xml version="1.0" encoding="utf-8"?>
+<p:sld xmlns:a="http://schemas.openxmlformats.org/drawingml/2006/main" xmlns:r="http://schemas.openxmlformats.org/officeDocument/2006/relationships" xmlns:p="http://schemas.openxmlformats.org/presentationml/2006/main">
+  <p:cSld name="Slide 11">
+    <p:spTree>
+      <p:nvGrpSpPr>
+        <p:cNvPr id="1" name=""/>
+        <p:cNvGrpSpPr/>
+        <p:nvPr/>
+      </p:nvGrpSpPr>
+      <p:grpSpPr>
+        <a:xfrm>
+          <a:off x="0" y="0"/>
+          <a:ext cx="0" cy="0"/>
+          <a:chOff x="0" y="0"/>
+          <a:chExt cx="0" cy="0"/>
+        </a:xfrm>
+      </p:grpSpPr>
+      <p:sp>
+        <p:nvSpPr>
+          <p:cNvPr id="2" name="Text 0"/>
           <p:cNvSpPr txBox="1"/>
           <p:nvPr/>
         </p:nvSpPr>
@@ -2540,7 +2766,7 @@
       </p:grpSpPr>
       <p:pic>
         <p:nvPicPr>
-          <p:cNvPr id="2" name="Foto laboratório" descr="Dra. Rosana em laboratório de anatomia, ao lado de uma mesa de specimen">    </p:cNvPr>
+          <p:cNvPr id="2" name="Fundo prédio" descr="Fachada de prédio com colunas, à noite">    </p:cNvPr>
           <p:cNvPicPr>
             <a:picLocks noChangeAspect="1"/>
           </p:cNvPicPr>
@@ -2554,8 +2780,8 @@
         </p:blipFill>
         <p:spPr>
           <a:xfrm>
-            <a:off x="7050024" y="0"/>
-            <a:ext cx="5143500" cy="6858000"/>
+            <a:off x="0" y="0"/>
+            <a:ext cx="12191695" cy="6858000"/>
           </a:xfrm>
           <a:prstGeom prst="rect">
             <a:avLst/>
@@ -2564,14 +2790,91 @@
       </p:pic>
       <p:sp>
         <p:nvSpPr>
-          <p:cNvPr id="3" name="Text 0"/>
+          <p:cNvPr id="3" name="Escurecer fundo"/>
+          <p:cNvSpPr/>
+          <p:nvPr/>
+        </p:nvSpPr>
+        <p:spPr>
+          <a:xfrm>
+            <a:off x="0" y="0"/>
+            <a:ext cx="12191695" cy="6858000"/>
+          </a:xfrm>
+          <a:prstGeom prst="rect">
+            <a:avLst/>
+          </a:prstGeom>
+          <a:solidFill>
+            <a:srgbClr val="000000">
+              <a:alpha val="78000"/>
+            </a:srgbClr>
+          </a:solidFill>
+          <a:ln w="12700">
+            <a:solidFill>
+              <a:srgbClr val="000000">
+                <a:alpha val="0"/>
+              </a:srgbClr>
+            </a:solidFill>
+            <a:prstDash val="solid"/>
+          </a:ln>
+        </p:spPr>
+      </p:sp>
+      <p:pic>
+        <p:nvPicPr>
+          <p:cNvPr id="4" name="Bandeira" descr="Bandeira dos Estados Unidos tremulando">    </p:cNvPr>
+          <p:cNvPicPr>
+            <a:picLocks noChangeAspect="1"/>
+          </p:cNvPicPr>
+          <p:nvPr/>
+        </p:nvPicPr>
+        <p:blipFill>
+          <a:blip r:embed="rId2"/>
+          <a:stretch>
+            <a:fillRect/>
+          </a:stretch>
+        </p:blipFill>
+        <p:spPr>
+          <a:xfrm>
+            <a:off x="7406640" y="-137160"/>
+            <a:ext cx="4937760" cy="3291840"/>
+          </a:xfrm>
+          <a:prstGeom prst="rect">
+            <a:avLst/>
+          </a:prstGeom>
+        </p:spPr>
+      </p:pic>
+      <p:pic>
+        <p:nvPicPr>
+          <p:cNvPr id="5" name="Foto prática" descr="Profissional de touca e avental durante prática em laboratório de anatomia">    </p:cNvPr>
+          <p:cNvPicPr>
+            <a:picLocks noChangeAspect="1"/>
+          </p:cNvPicPr>
+          <p:nvPr/>
+        </p:nvPicPr>
+        <p:blipFill>
+          <a:blip r:embed="rId3"/>
+          <a:stretch>
+            <a:fillRect/>
+          </a:stretch>
+        </p:blipFill>
+        <p:spPr>
+          <a:xfrm>
+            <a:off x="9098280" y="3246120"/>
+            <a:ext cx="3090672" cy="3611880"/>
+          </a:xfrm>
+          <a:prstGeom prst="rect">
+            <a:avLst/>
+          </a:prstGeom>
+        </p:spPr>
+      </p:pic>
+      <p:sp>
+        <p:nvSpPr>
+          <p:cNvPr id="6" name="Pré-título"/>
           <p:cNvSpPr txBox="1"/>
           <p:nvPr/>
         </p:nvSpPr>
         <p:spPr>
           <a:xfrm>
-            <a:off x="731520" y="1188720"/>
-            <a:ext cx="5852160" cy="365760"/>
+            <a:off x="731520" y="777240"/>
+            <a:ext cx="7863840" cy="457200"/>
           </a:xfrm>
           <a:prstGeom prst="rect">
             <a:avLst/>
@@ -2583,31 +2886,31 @@
           <a:bodyPr wrap="square" lIns="0" tIns="0" rIns="0" bIns="0" rtlCol="0" anchor="t"/>
           <a:lstStyle/>
           <a:p>
-            <a:pPr indent="0" marL="0">
-              <a:buNone/>
-            </a:pPr>
-            <a:r>
-              <a:rPr lang="en-US" sz="1400" dirty="0">
-                <a:solidFill>
-                  <a:schemeClr val="accent4"/>
-                </a:solidFill>
-              </a:rPr>
-              <a:t>Programa de Formação Internacional</a:t>
-            </a:r>
-            <a:endParaRPr lang="en-US" sz="1400" dirty="0"/>
-          </a:p>
-        </p:txBody>
-      </p:sp>
-      <p:sp>
-        <p:nvSpPr>
-          <p:cNvPr id="4" name="Text 1"/>
+            <a:pPr algn="ctr" indent="0" marL="0">
+              <a:buNone/>
+            </a:pPr>
+            <a:r>
+              <a:rPr lang="en-US" sz="2200" spc="600" kern="0" dirty="0">
+                <a:solidFill>
+                  <a:srgbClr val="F3EEE6"/>
+                </a:solidFill>
+              </a:rPr>
+              <a:t>Visão do Projeto</a:t>
+            </a:r>
+            <a:endParaRPr lang="en-US" sz="2200" dirty="0"/>
+          </a:p>
+        </p:txBody>
+      </p:sp>
+      <p:sp>
+        <p:nvSpPr>
+          <p:cNvPr id="7" name="Título"/>
           <p:cNvSpPr txBox="1"/>
           <p:nvPr/>
         </p:nvSpPr>
         <p:spPr>
           <a:xfrm>
-            <a:off x="731520" y="1874520"/>
-            <a:ext cx="5852160" cy="640080"/>
+            <a:off x="731520" y="1234440"/>
+            <a:ext cx="7863840" cy="1005840"/>
           </a:xfrm>
           <a:prstGeom prst="rect">
             <a:avLst/>
@@ -2619,34 +2922,34 @@
           <a:bodyPr wrap="square" lIns="0" tIns="0" rIns="0" bIns="0" rtlCol="0" anchor="t"/>
           <a:lstStyle/>
           <a:p>
-            <a:pPr indent="0" marL="0">
-              <a:buNone/>
-            </a:pPr>
-            <a:r>
-              <a:rPr lang="en-US" sz="3400" i="1" dirty="0">
-                <a:solidFill>
-                  <a:schemeClr val="accent4"/>
+            <a:pPr algn="ctr" indent="0" marL="0">
+              <a:buNone/>
+            </a:pPr>
+            <a:r>
+              <a:rPr lang="en-US" sz="6000" spc="200" kern="0" dirty="0">
+                <a:solidFill>
+                  <a:srgbClr val="F3EEE6"/>
                 </a:solidFill>
                 <a:latin typeface="Garamond" pitchFamily="34" charset="0"/>
                 <a:ea typeface="Garamond" pitchFamily="34" charset="-122"/>
                 <a:cs typeface="Garamond" pitchFamily="34" charset="-120"/>
               </a:rPr>
-              <a:t>Etapa de</a:t>
-            </a:r>
-            <a:endParaRPr lang="en-US" sz="3400" dirty="0"/>
-          </a:p>
-        </p:txBody>
-      </p:sp>
-      <p:sp>
-        <p:nvSpPr>
-          <p:cNvPr id="5" name="Título"/>
+              <a:t>INTERNACIONAL</a:t>
+            </a:r>
+            <a:endParaRPr lang="en-US" sz="6000" dirty="0"/>
+          </a:p>
+        </p:txBody>
+      </p:sp>
+      <p:sp>
+        <p:nvSpPr>
+          <p:cNvPr id="8" name="Objetivo"/>
           <p:cNvSpPr txBox="1"/>
           <p:nvPr/>
         </p:nvSpPr>
         <p:spPr>
           <a:xfrm>
-            <a:off x="685800" y="2377440"/>
-            <a:ext cx="6035040" cy="1463040"/>
+            <a:off x="731520" y="2697480"/>
+            <a:ext cx="7863840" cy="457200"/>
           </a:xfrm>
           <a:prstGeom prst="rect">
             <a:avLst/>
@@ -2658,34 +2961,31 @@
           <a:bodyPr wrap="square" lIns="0" tIns="0" rIns="0" bIns="0" rtlCol="0" anchor="t"/>
           <a:lstStyle/>
           <a:p>
-            <a:pPr indent="0" marL="0">
-              <a:buNone/>
-            </a:pPr>
-            <a:r>
-              <a:rPr lang="en-US" sz="10800" dirty="0">
+            <a:pPr algn="ctr" indent="0" marL="0">
+              <a:buNone/>
+            </a:pPr>
+            <a:r>
+              <a:rPr lang="en-US" sz="2000" b="1" dirty="0">
                 <a:solidFill>
                   <a:schemeClr val="bg1"/>
                 </a:solidFill>
-                <a:latin typeface="Garamond" pitchFamily="34" charset="0"/>
-                <a:ea typeface="Garamond" pitchFamily="34" charset="-122"/>
-                <a:cs typeface="Garamond" pitchFamily="34" charset="-120"/>
-              </a:rPr>
-              <a:t>Miami</a:t>
-            </a:r>
-            <a:endParaRPr lang="en-US" sz="10800" dirty="0"/>
-          </a:p>
-        </p:txBody>
-      </p:sp>
-      <p:sp>
-        <p:nvSpPr>
-          <p:cNvPr id="6" name="Text 3"/>
+              </a:rPr>
+              <a:t>Formar profissionais completos, capazes de:</a:t>
+            </a:r>
+            <a:endParaRPr lang="en-US" sz="2000" dirty="0"/>
+          </a:p>
+        </p:txBody>
+      </p:sp>
+      <p:sp>
+        <p:nvSpPr>
+          <p:cNvPr id="9" name="Lista visão"/>
           <p:cNvSpPr txBox="1"/>
           <p:nvPr/>
         </p:nvSpPr>
         <p:spPr>
           <a:xfrm>
-            <a:off x="731520" y="4069080"/>
-            <a:ext cx="5394960" cy="822960"/>
+            <a:off x="1005840" y="3429000"/>
+            <a:ext cx="7589520" cy="2651760"/>
           </a:xfrm>
           <a:prstGeom prst="rect">
             <a:avLst/>
@@ -2697,110 +2997,94 @@
           <a:bodyPr wrap="square" lIns="0" tIns="0" rIns="0" bIns="0" rtlCol="0" anchor="t"/>
           <a:lstStyle/>
           <a:p>
-            <a:pPr indent="0" marL="0">
-              <a:buNone/>
-            </a:pPr>
-            <a:r>
-              <a:rPr lang="en-US" sz="1700" dirty="0">
-                <a:solidFill>
-                  <a:schemeClr val="accent4"/>
-                </a:solidFill>
-              </a:rPr>
-              <a:t>Imersão de 3 dias com prática real em laboratório de specimen</a:t>
-            </a:r>
-            <a:endParaRPr lang="en-US" sz="1700" dirty="0"/>
-          </a:p>
-        </p:txBody>
-      </p:sp>
-      <p:sp>
-        <p:nvSpPr>
-          <p:cNvPr id="7" name="Fio"/>
-          <p:cNvSpPr/>
-          <p:nvPr/>
-        </p:nvSpPr>
-        <p:spPr>
-          <a:xfrm>
-            <a:off x="731520" y="5074920"/>
-            <a:ext cx="822960" cy="0"/>
-          </a:xfrm>
-          <a:prstGeom prst="line">
-            <a:avLst/>
-          </a:prstGeom>
-          <a:noFill/>
-          <a:ln w="15875">
-            <a:solidFill>
-              <a:schemeClr val="accent2"/>
-            </a:solidFill>
-            <a:prstDash val="solid"/>
-          </a:ln>
-        </p:spPr>
-      </p:sp>
-      <p:sp>
-        <p:nvSpPr>
-          <p:cNvPr id="8" name="Data"/>
-          <p:cNvSpPr txBox="1"/>
-          <p:nvPr/>
-        </p:nvSpPr>
-        <p:spPr>
-          <a:xfrm>
-            <a:off x="731520" y="5257800"/>
-            <a:ext cx="5852160" cy="457200"/>
-          </a:xfrm>
-          <a:prstGeom prst="rect">
-            <a:avLst/>
-          </a:prstGeom>
-          <a:noFill/>
-          <a:ln/>
-        </p:spPr>
-        <p:txBody>
-          <a:bodyPr wrap="square" lIns="0" tIns="0" rIns="0" bIns="0" rtlCol="0" anchor="t"/>
-          <a:lstStyle/>
-          <a:p>
-            <a:pPr indent="0" marL="0">
-              <a:buNone/>
-            </a:pPr>
-            <a:r>
-              <a:rPr lang="en-US" sz="2400" dirty="0">
+            <a:pPr marL="342900" indent="-342900">
+              <a:spcAft>
+                <a:spcPts val="800"/>
+              </a:spcAft>
+              <a:buSzPct val="100000"/>
+              <a:buChar char="•"/>
+            </a:pPr>
+            <a:r>
+              <a:rPr lang="en-US" sz="1800" dirty="0">
                 <a:solidFill>
                   <a:schemeClr val="bg1"/>
                 </a:solidFill>
-                <a:latin typeface="Garamond" pitchFamily="34" charset="0"/>
-                <a:ea typeface="Garamond" pitchFamily="34" charset="-122"/>
-                <a:cs typeface="Garamond" pitchFamily="34" charset="-120"/>
-              </a:rPr>
-              <a:t>19, 20 e 21 de maio de 2027</a:t>
-            </a:r>
-            <a:endParaRPr lang="en-US" sz="2400" dirty="0"/>
-          </a:p>
-        </p:txBody>
-      </p:sp>
-      <p:sp>
-        <p:nvSpPr>
-          <p:cNvPr id="9" name="Text 0"/>
-          <p:cNvSpPr/>
-          <p:nvPr>
-            <p:ph idx="100" type="title" hasCustomPrompt="1"/>
-          </p:nvPr>
-        </p:nvSpPr>
-        <p:spPr>
-          <a:xfrm>
-            <a:off x="731520" y="777240"/>
-            <a:ext cx="10698480" cy="914400"/>
-          </a:xfrm>
-          <a:prstGeom prst="rect">
-            <a:avLst/>
-          </a:prstGeom>
-          <a:noFill/>
-          <a:ln/>
-        </p:spPr>
-        <p:txBody>
-          <a:bodyPr wrap="square" lIns="0" tIns="0" rIns="0" bIns="0" rtlCol="0" anchor="t"/>
-          <a:lstStyle/>
-          <a:p>
-            <a:pPr algn="l" indent="0" marL="0">
-              <a:buNone/>
-            </a:pPr>
-            <a:endParaRPr lang="en-US" sz="4400" dirty="0"/>
+              </a:rPr>
+              <a:t>Compreender profundamente a anatomia aplicada à estética</a:t>
+            </a:r>
+            <a:endParaRPr lang="en-US" sz="1800" dirty="0"/>
+          </a:p>
+          <a:p>
+            <a:pPr marL="342900" indent="-342900">
+              <a:spcAft>
+                <a:spcPts val="800"/>
+              </a:spcAft>
+              <a:buSzPct val="100000"/>
+              <a:buChar char="•"/>
+            </a:pPr>
+            <a:r>
+              <a:rPr lang="en-US" sz="1800" dirty="0">
+                <a:solidFill>
+                  <a:schemeClr val="bg1"/>
+                </a:solidFill>
+              </a:rPr>
+              <a:t>Atuar com segurança em procedimentos avançados</a:t>
+            </a:r>
+            <a:endParaRPr lang="en-US" sz="1800" dirty="0"/>
+          </a:p>
+          <a:p>
+            <a:pPr marL="342900" indent="-342900">
+              <a:spcAft>
+                <a:spcPts val="800"/>
+              </a:spcAft>
+              <a:buSzPct val="100000"/>
+              <a:buChar char="•"/>
+            </a:pPr>
+            <a:r>
+              <a:rPr lang="en-US" sz="1800" dirty="0">
+                <a:solidFill>
+                  <a:schemeClr val="bg1"/>
+                </a:solidFill>
+              </a:rPr>
+              <a:t>Integrar ciência, técnica e raciocínio clínico</a:t>
+            </a:r>
+            <a:endParaRPr lang="en-US" sz="1800" dirty="0"/>
+          </a:p>
+          <a:p>
+            <a:pPr marL="342900" indent="-342900">
+              <a:spcAft>
+                <a:spcPts val="800"/>
+              </a:spcAft>
+              <a:buSzPct val="100000"/>
+              <a:buChar char="•"/>
+            </a:pPr>
+            <a:r>
+              <a:rPr lang="en-US" sz="1800" dirty="0">
+                <a:solidFill>
+                  <a:schemeClr val="bg1"/>
+                </a:solidFill>
+              </a:rPr>
+              <a:t>Desenvolver pensamento crítico e responsabilidade estética</a:t>
+            </a:r>
+            <a:endParaRPr lang="en-US" sz="1800" dirty="0"/>
+          </a:p>
+          <a:p>
+            <a:pPr marL="342900" indent="-342900">
+              <a:spcAft>
+                <a:spcPts val="800"/>
+              </a:spcAft>
+              <a:buSzPct val="100000"/>
+              <a:buChar char="•"/>
+            </a:pPr>
+            <a:r>
+              <a:rPr lang="en-US" sz="1800" dirty="0">
+                <a:solidFill>
+                  <a:schemeClr val="bg1"/>
+                </a:solidFill>
+              </a:rPr>
+              <a:t>Ampliar sua visão profissional em um contexto internacional</a:t>
+            </a:r>
+            <a:endParaRPr lang="en-US" sz="1800" dirty="0"/>
           </a:p>
         </p:txBody>
       </p:sp>
@@ -2832,26 +3116,198 @@
           <a:chExt cx="0" cy="0"/>
         </a:xfrm>
       </p:grpSpPr>
-      <p:sp>
-        <p:nvSpPr>
-          <p:cNvPr id="2" name="Fundo"/>
+      <p:pic>
+        <p:nvPicPr>
+          <p:cNvPr id="2" name="Foto laboratório" descr="Dra. Rosana em laboratório de anatomia, ao lado de uma mesa de specimen">    </p:cNvPr>
+          <p:cNvPicPr>
+            <a:picLocks noChangeAspect="1"/>
+          </p:cNvPicPr>
+          <p:nvPr/>
+        </p:nvPicPr>
+        <p:blipFill>
+          <a:blip r:embed="rId1"/>
+          <a:stretch>
+            <a:fillRect/>
+          </a:stretch>
+        </p:blipFill>
+        <p:spPr>
+          <a:xfrm>
+            <a:off x="7050024" y="0"/>
+            <a:ext cx="5143500" cy="6858000"/>
+          </a:xfrm>
+          <a:prstGeom prst="rect">
+            <a:avLst/>
+          </a:prstGeom>
+        </p:spPr>
+      </p:pic>
+      <p:sp>
+        <p:nvSpPr>
+          <p:cNvPr id="3" name="Text 0"/>
+          <p:cNvSpPr txBox="1"/>
+          <p:nvPr/>
+        </p:nvSpPr>
+        <p:spPr>
+          <a:xfrm>
+            <a:off x="731520" y="1188720"/>
+            <a:ext cx="5852160" cy="365760"/>
+          </a:xfrm>
+          <a:prstGeom prst="rect">
+            <a:avLst/>
+          </a:prstGeom>
+          <a:noFill/>
+          <a:ln/>
+        </p:spPr>
+        <p:txBody>
+          <a:bodyPr wrap="square" lIns="0" tIns="0" rIns="0" bIns="0" rtlCol="0" anchor="t"/>
+          <a:lstStyle/>
+          <a:p>
+            <a:pPr indent="0" marL="0">
+              <a:buNone/>
+            </a:pPr>
+            <a:r>
+              <a:rPr lang="en-US" sz="1400" dirty="0">
+                <a:solidFill>
+                  <a:schemeClr val="accent4"/>
+                </a:solidFill>
+              </a:rPr>
+              <a:t>Programa de Formação Internacional</a:t>
+            </a:r>
+            <a:endParaRPr lang="en-US" sz="1400" dirty="0"/>
+          </a:p>
+        </p:txBody>
+      </p:sp>
+      <p:sp>
+        <p:nvSpPr>
+          <p:cNvPr id="4" name="Text 1"/>
+          <p:cNvSpPr txBox="1"/>
+          <p:nvPr/>
+        </p:nvSpPr>
+        <p:spPr>
+          <a:xfrm>
+            <a:off x="731520" y="1874520"/>
+            <a:ext cx="5852160" cy="640080"/>
+          </a:xfrm>
+          <a:prstGeom prst="rect">
+            <a:avLst/>
+          </a:prstGeom>
+          <a:noFill/>
+          <a:ln/>
+        </p:spPr>
+        <p:txBody>
+          <a:bodyPr wrap="square" lIns="0" tIns="0" rIns="0" bIns="0" rtlCol="0" anchor="t"/>
+          <a:lstStyle/>
+          <a:p>
+            <a:pPr indent="0" marL="0">
+              <a:buNone/>
+            </a:pPr>
+            <a:r>
+              <a:rPr lang="en-US" sz="3400" i="1" dirty="0">
+                <a:solidFill>
+                  <a:schemeClr val="accent4"/>
+                </a:solidFill>
+                <a:latin typeface="Garamond" pitchFamily="34" charset="0"/>
+                <a:ea typeface="Garamond" pitchFamily="34" charset="-122"/>
+                <a:cs typeface="Garamond" pitchFamily="34" charset="-120"/>
+              </a:rPr>
+              <a:t>Etapa de</a:t>
+            </a:r>
+            <a:endParaRPr lang="en-US" sz="3400" dirty="0"/>
+          </a:p>
+        </p:txBody>
+      </p:sp>
+      <p:sp>
+        <p:nvSpPr>
+          <p:cNvPr id="5" name="Título"/>
+          <p:cNvSpPr txBox="1"/>
+          <p:nvPr/>
+        </p:nvSpPr>
+        <p:spPr>
+          <a:xfrm>
+            <a:off x="685800" y="2377440"/>
+            <a:ext cx="6035040" cy="1463040"/>
+          </a:xfrm>
+          <a:prstGeom prst="rect">
+            <a:avLst/>
+          </a:prstGeom>
+          <a:noFill/>
+          <a:ln/>
+        </p:spPr>
+        <p:txBody>
+          <a:bodyPr wrap="square" lIns="0" tIns="0" rIns="0" bIns="0" rtlCol="0" anchor="t"/>
+          <a:lstStyle/>
+          <a:p>
+            <a:pPr indent="0" marL="0">
+              <a:buNone/>
+            </a:pPr>
+            <a:r>
+              <a:rPr lang="en-US" sz="10800" dirty="0">
+                <a:solidFill>
+                  <a:schemeClr val="bg1"/>
+                </a:solidFill>
+                <a:latin typeface="Garamond" pitchFamily="34" charset="0"/>
+                <a:ea typeface="Garamond" pitchFamily="34" charset="-122"/>
+                <a:cs typeface="Garamond" pitchFamily="34" charset="-120"/>
+              </a:rPr>
+              <a:t>Miami</a:t>
+            </a:r>
+            <a:endParaRPr lang="en-US" sz="10800" dirty="0"/>
+          </a:p>
+        </p:txBody>
+      </p:sp>
+      <p:sp>
+        <p:nvSpPr>
+          <p:cNvPr id="6" name="Text 3"/>
+          <p:cNvSpPr txBox="1"/>
+          <p:nvPr/>
+        </p:nvSpPr>
+        <p:spPr>
+          <a:xfrm>
+            <a:off x="731520" y="4069080"/>
+            <a:ext cx="5394960" cy="822960"/>
+          </a:xfrm>
+          <a:prstGeom prst="rect">
+            <a:avLst/>
+          </a:prstGeom>
+          <a:noFill/>
+          <a:ln/>
+        </p:spPr>
+        <p:txBody>
+          <a:bodyPr wrap="square" lIns="0" tIns="0" rIns="0" bIns="0" rtlCol="0" anchor="t"/>
+          <a:lstStyle/>
+          <a:p>
+            <a:pPr indent="0" marL="0">
+              <a:buNone/>
+            </a:pPr>
+            <a:r>
+              <a:rPr lang="en-US" sz="1700" dirty="0">
+                <a:solidFill>
+                  <a:schemeClr val="accent4"/>
+                </a:solidFill>
+              </a:rPr>
+              <a:t>Imersão de 3 dias com prática real em laboratório de specimen</a:t>
+            </a:r>
+            <a:endParaRPr lang="en-US" sz="1700" dirty="0"/>
+          </a:p>
+        </p:txBody>
+      </p:sp>
+      <p:sp>
+        <p:nvSpPr>
+          <p:cNvPr id="7" name="Fio"/>
           <p:cNvSpPr/>
           <p:nvPr/>
         </p:nvSpPr>
         <p:spPr>
           <a:xfrm>
-            <a:off x="0" y="0"/>
-            <a:ext cx="12191695" cy="6858000"/>
-          </a:xfrm>
-          <a:prstGeom prst="rect">
-            <a:avLst/>
-          </a:prstGeom>
-          <a:solidFill>
-            <a:schemeClr val="accent5"/>
-          </a:solidFill>
-          <a:ln w="12700">
+            <a:off x="731520" y="5074920"/>
+            <a:ext cx="822960" cy="0"/>
+          </a:xfrm>
+          <a:prstGeom prst="line">
+            <a:avLst/>
+          </a:prstGeom>
+          <a:noFill/>
+          <a:ln w="15875">
             <a:solidFill>
-              <a:schemeClr val="accent5"/>
+              <a:schemeClr val="accent2"/>
             </a:solidFill>
             <a:prstDash val="solid"/>
           </a:ln>
@@ -2859,39 +3315,14 @@
       </p:sp>
       <p:sp>
         <p:nvSpPr>
-          <p:cNvPr id="3" name="Área do vídeo"/>
-          <p:cNvSpPr/>
-          <p:nvPr/>
-        </p:nvSpPr>
-        <p:spPr>
-          <a:xfrm>
-            <a:off x="731520" y="640080"/>
-            <a:ext cx="10725912" cy="5577840"/>
-          </a:xfrm>
-          <a:prstGeom prst="rect">
-            <a:avLst/>
-          </a:prstGeom>
-          <a:solidFill>
-            <a:schemeClr val="accent1"/>
-          </a:solidFill>
-          <a:ln w="12700">
-            <a:solidFill>
-              <a:schemeClr val="accent2"/>
-            </a:solidFill>
-            <a:prstDash val="dash"/>
-          </a:ln>
-        </p:spPr>
-      </p:sp>
-      <p:sp>
-        <p:nvSpPr>
-          <p:cNvPr id="4" name="Instrução do vídeo"/>
+          <p:cNvPr id="8" name="Data"/>
           <p:cNvSpPr txBox="1"/>
           <p:nvPr/>
         </p:nvSpPr>
         <p:spPr>
           <a:xfrm>
-            <a:off x="731520" y="640080"/>
-            <a:ext cx="10725912" cy="5577840"/>
+            <a:off x="731520" y="5257800"/>
+            <a:ext cx="5852160" cy="457200"/>
           </a:xfrm>
           <a:prstGeom prst="rect">
             <a:avLst/>
@@ -2900,14 +3331,14 @@
           <a:ln/>
         </p:spPr>
         <p:txBody>
-          <a:bodyPr wrap="square" lIns="0" tIns="0" rIns="0" bIns="0" rtlCol="0" anchor="ctr"/>
-          <a:lstStyle/>
-          <a:p>
-            <a:pPr algn="ctr" indent="0" marL="0">
-              <a:buNone/>
-            </a:pPr>
-            <a:r>
-              <a:rPr lang="en-US" sz="3400" dirty="0">
+          <a:bodyPr wrap="square" lIns="0" tIns="0" rIns="0" bIns="0" rtlCol="0" anchor="t"/>
+          <a:lstStyle/>
+          <a:p>
+            <a:pPr indent="0" marL="0">
+              <a:buNone/>
+            </a:pPr>
+            <a:r>
+              <a:rPr lang="en-US" sz="2400" dirty="0">
                 <a:solidFill>
                   <a:schemeClr val="bg1"/>
                 </a:solidFill>
@@ -2915,23 +3346,39 @@
                 <a:ea typeface="Garamond" pitchFamily="34" charset="-122"/>
                 <a:cs typeface="Garamond" pitchFamily="34" charset="-120"/>
               </a:rPr>
-              <a:t>Insira aqui o vídeo</a:t>
-            </a:r>
-            <a:endParaRPr lang="en-US" sz="3400" dirty="0"/>
-          </a:p>
-          <a:p>
-            <a:pPr algn="ctr" indent="0" marL="0">
-              <a:buNone/>
-            </a:pPr>
-            <a:r>
-              <a:rPr lang="en-US" sz="1400" dirty="0">
-                <a:solidFill>
-                  <a:schemeClr val="accent4"/>
-                </a:solidFill>
-              </a:rPr>
-              <a:t>Inserir  ›  Vídeo  ›  Este dispositivo. Depois apague esta caixa e o retângulo.</a:t>
-            </a:r>
-            <a:endParaRPr lang="en-US" sz="3400" dirty="0"/>
+              <a:t>19, 20 e 21 de maio de 2027</a:t>
+            </a:r>
+            <a:endParaRPr lang="en-US" sz="2400" dirty="0"/>
+          </a:p>
+        </p:txBody>
+      </p:sp>
+      <p:sp>
+        <p:nvSpPr>
+          <p:cNvPr id="9" name="Text 0"/>
+          <p:cNvSpPr/>
+          <p:nvPr>
+            <p:ph idx="100" type="title" hasCustomPrompt="1"/>
+          </p:nvPr>
+        </p:nvSpPr>
+        <p:spPr>
+          <a:xfrm>
+            <a:off x="731520" y="777240"/>
+            <a:ext cx="10698480" cy="914400"/>
+          </a:xfrm>
+          <a:prstGeom prst="rect">
+            <a:avLst/>
+          </a:prstGeom>
+          <a:noFill/>
+          <a:ln/>
+        </p:spPr>
+        <p:txBody>
+          <a:bodyPr wrap="square" lIns="0" tIns="0" rIns="0" bIns="0" rtlCol="0" anchor="t"/>
+          <a:lstStyle/>
+          <a:p>
+            <a:pPr algn="l" indent="0" marL="0">
+              <a:buNone/>
+            </a:pPr>
+            <a:endParaRPr lang="en-US" sz="4400" dirty="0"/>
           </a:p>
         </p:txBody>
       </p:sp>
@@ -2965,410 +3412,21 @@
       </p:grpSpPr>
       <p:sp>
         <p:nvSpPr>
-          <p:cNvPr id="2" name="Text 0"/>
+          <p:cNvPr id="2" name="Fundo"/>
           <p:cNvSpPr/>
-          <p:nvPr>
-            <p:ph idx="100" type="title" hasCustomPrompt="1"/>
-          </p:nvPr>
-        </p:nvSpPr>
-        <p:spPr>
-          <a:xfrm>
-            <a:off x="731520" y="777240"/>
-            <a:ext cx="10698480" cy="914400"/>
-          </a:xfrm>
-          <a:prstGeom prst="rect">
-            <a:avLst/>
-          </a:prstGeom>
-          <a:noFill/>
-          <a:ln/>
-        </p:spPr>
-        <p:txBody>
-          <a:bodyPr wrap="square" lIns="0" tIns="0" rIns="0" bIns="0" rtlCol="0" anchor="t"/>
-          <a:lstStyle/>
-          <a:p>
-            <a:pPr algn="l" indent="0" marL="0">
-              <a:buNone/>
-            </a:pPr>
-            <a:r>
-              <a:rPr lang="en-US" sz="4400" dirty="0">
-                <a:solidFill>
-                  <a:schemeClr val="accent1"/>
-                </a:solidFill>
-                <a:latin typeface="Garamond" pitchFamily="34" charset="0"/>
-                <a:ea typeface="Garamond" pitchFamily="34" charset="-122"/>
-                <a:cs typeface="Garamond" pitchFamily="34" charset="-120"/>
-              </a:rPr>
-              <a:t>Por que Miami?</a:t>
-            </a:r>
-            <a:endParaRPr lang="en-US" sz="4400" dirty="0"/>
-          </a:p>
-        </p:txBody>
-      </p:sp>
-      <p:sp>
-        <p:nvSpPr>
-          <p:cNvPr id="3" name="Text 1"/>
-          <p:cNvSpPr txBox="1"/>
-          <p:nvPr/>
-        </p:nvSpPr>
-        <p:spPr>
-          <a:xfrm>
-            <a:off x="731520" y="1645920"/>
-            <a:ext cx="10698480" cy="457200"/>
-          </a:xfrm>
-          <a:prstGeom prst="rect">
-            <a:avLst/>
-          </a:prstGeom>
-          <a:noFill/>
-          <a:ln/>
-        </p:spPr>
-        <p:txBody>
-          <a:bodyPr wrap="square" lIns="0" tIns="0" rIns="0" bIns="0" rtlCol="0" anchor="t"/>
-          <a:lstStyle/>
-          <a:p>
-            <a:pPr indent="0" marL="0">
-              <a:buNone/>
-            </a:pPr>
-            <a:r>
-              <a:rPr lang="en-US" sz="1800" dirty="0">
-                <a:solidFill>
-                  <a:schemeClr val="tx2"/>
-                </a:solidFill>
-              </a:rPr>
-              <a:t>Porque lá a anatomia sai do livro e vai para a peça anatômica real.</a:t>
-            </a:r>
-            <a:endParaRPr lang="en-US" sz="1800" dirty="0"/>
-          </a:p>
-        </p:txBody>
-      </p:sp>
-      <p:sp>
-        <p:nvSpPr>
-          <p:cNvPr id="4" name="Cartão No Brasil"/>
-          <p:cNvSpPr/>
-          <p:nvPr/>
-        </p:nvSpPr>
-        <p:spPr>
-          <a:xfrm>
-            <a:off x="731520" y="2423160"/>
-            <a:ext cx="5239512" cy="3749040"/>
+          <p:nvPr/>
+        </p:nvSpPr>
+        <p:spPr>
+          <a:xfrm>
+            <a:off x="0" y="0"/>
+            <a:ext cx="12191695" cy="6858000"/>
           </a:xfrm>
           <a:prstGeom prst="rect">
             <a:avLst/>
           </a:prstGeom>
           <a:solidFill>
-            <a:schemeClr val="bg1"/>
+            <a:schemeClr val="accent5"/>
           </a:solidFill>
-          <a:ln w="12700">
-            <a:solidFill>
-              <a:schemeClr val="accent3"/>
-            </a:solidFill>
-            <a:prstDash val="solid"/>
-          </a:ln>
-        </p:spPr>
-      </p:sp>
-      <p:sp>
-        <p:nvSpPr>
-          <p:cNvPr id="5" name="No Brasil título"/>
-          <p:cNvSpPr txBox="1"/>
-          <p:nvPr/>
-        </p:nvSpPr>
-        <p:spPr>
-          <a:xfrm>
-            <a:off x="1188720" y="2743200"/>
-            <a:ext cx="4389120" cy="685800"/>
-          </a:xfrm>
-          <a:prstGeom prst="rect">
-            <a:avLst/>
-          </a:prstGeom>
-          <a:noFill/>
-          <a:ln/>
-        </p:spPr>
-        <p:txBody>
-          <a:bodyPr wrap="square" lIns="0" tIns="0" rIns="0" bIns="0" rtlCol="0" anchor="t"/>
-          <a:lstStyle/>
-          <a:p>
-            <a:pPr indent="0" marL="0">
-              <a:buNone/>
-            </a:pPr>
-            <a:r>
-              <a:rPr lang="en-US" sz="3600" dirty="0">
-                <a:solidFill>
-                  <a:schemeClr val="accent1"/>
-                </a:solidFill>
-                <a:latin typeface="Garamond" pitchFamily="34" charset="0"/>
-                <a:ea typeface="Garamond" pitchFamily="34" charset="-122"/>
-                <a:cs typeface="Garamond" pitchFamily="34" charset="-120"/>
-              </a:rPr>
-              <a:t>No Brasil</a:t>
-            </a:r>
-            <a:endParaRPr lang="en-US" sz="3600" dirty="0"/>
-          </a:p>
-        </p:txBody>
-      </p:sp>
-      <p:sp>
-        <p:nvSpPr>
-          <p:cNvPr id="6" name="No Brasil fio 1"/>
-          <p:cNvSpPr/>
-          <p:nvPr/>
-        </p:nvSpPr>
-        <p:spPr>
-          <a:xfrm>
-            <a:off x="1188720" y="3611880"/>
-            <a:ext cx="4325112" cy="0"/>
-          </a:xfrm>
-          <a:prstGeom prst="line">
-            <a:avLst/>
-          </a:prstGeom>
-          <a:noFill/>
-          <a:ln w="12700">
-            <a:solidFill>
-              <a:schemeClr val="accent3"/>
-            </a:solidFill>
-            <a:prstDash val="solid"/>
-          </a:ln>
-        </p:spPr>
-      </p:sp>
-      <p:sp>
-        <p:nvSpPr>
-          <p:cNvPr id="7" name="No Brasil item 1"/>
-          <p:cNvSpPr txBox="1"/>
-          <p:nvPr/>
-        </p:nvSpPr>
-        <p:spPr>
-          <a:xfrm>
-            <a:off x="1188720" y="3703320"/>
-            <a:ext cx="4325112" cy="713232"/>
-          </a:xfrm>
-          <a:prstGeom prst="rect">
-            <a:avLst/>
-          </a:prstGeom>
-          <a:noFill/>
-          <a:ln/>
-        </p:spPr>
-        <p:txBody>
-          <a:bodyPr wrap="square" lIns="0" tIns="0" rIns="0" bIns="0" rtlCol="0" anchor="t"/>
-          <a:lstStyle/>
-          <a:p>
-            <a:pPr indent="0" marL="0">
-              <a:lnSpc>
-                <a:spcPct val="110000"/>
-              </a:lnSpc>
-              <a:buNone/>
-            </a:pPr>
-            <a:r>
-              <a:rPr lang="en-US" sz="1500" dirty="0">
-                <a:solidFill>
-                  <a:schemeClr val="tx1"/>
-                </a:solidFill>
-              </a:rPr>
-              <a:t>Anatomia estudada em atlas, vídeos e modelos sintéticos</a:t>
-            </a:r>
-            <a:endParaRPr lang="en-US" sz="1500" dirty="0"/>
-          </a:p>
-        </p:txBody>
-      </p:sp>
-      <p:sp>
-        <p:nvSpPr>
-          <p:cNvPr id="8" name="No Brasil fio 2"/>
-          <p:cNvSpPr/>
-          <p:nvPr/>
-        </p:nvSpPr>
-        <p:spPr>
-          <a:xfrm>
-            <a:off x="1188720" y="4434840"/>
-            <a:ext cx="4325112" cy="0"/>
-          </a:xfrm>
-          <a:prstGeom prst="line">
-            <a:avLst/>
-          </a:prstGeom>
-          <a:noFill/>
-          <a:ln w="12700">
-            <a:solidFill>
-              <a:schemeClr val="accent3"/>
-            </a:solidFill>
-            <a:prstDash val="solid"/>
-          </a:ln>
-        </p:spPr>
-      </p:sp>
-      <p:sp>
-        <p:nvSpPr>
-          <p:cNvPr id="9" name="No Brasil item 2"/>
-          <p:cNvSpPr txBox="1"/>
-          <p:nvPr/>
-        </p:nvSpPr>
-        <p:spPr>
-          <a:xfrm>
-            <a:off x="1188720" y="4526280"/>
-            <a:ext cx="4325112" cy="713232"/>
-          </a:xfrm>
-          <a:prstGeom prst="rect">
-            <a:avLst/>
-          </a:prstGeom>
-          <a:noFill/>
-          <a:ln/>
-        </p:spPr>
-        <p:txBody>
-          <a:bodyPr wrap="square" lIns="0" tIns="0" rIns="0" bIns="0" rtlCol="0" anchor="t"/>
-          <a:lstStyle/>
-          <a:p>
-            <a:pPr indent="0" marL="0">
-              <a:lnSpc>
-                <a:spcPct val="110000"/>
-              </a:lnSpc>
-              <a:buNone/>
-            </a:pPr>
-            <a:r>
-              <a:rPr lang="en-US" sz="1500" dirty="0">
-                <a:solidFill>
-                  <a:schemeClr val="tx1"/>
-                </a:solidFill>
-              </a:rPr>
-              <a:t>Acesso a peças anatômicas restrito, em geral, às universidades</a:t>
-            </a:r>
-            <a:endParaRPr lang="en-US" sz="1500" dirty="0"/>
-          </a:p>
-        </p:txBody>
-      </p:sp>
-      <p:sp>
-        <p:nvSpPr>
-          <p:cNvPr id="10" name="No Brasil fio 3"/>
-          <p:cNvSpPr/>
-          <p:nvPr/>
-        </p:nvSpPr>
-        <p:spPr>
-          <a:xfrm>
-            <a:off x="1188720" y="5257800"/>
-            <a:ext cx="4325112" cy="0"/>
-          </a:xfrm>
-          <a:prstGeom prst="line">
-            <a:avLst/>
-          </a:prstGeom>
-          <a:noFill/>
-          <a:ln w="12700">
-            <a:solidFill>
-              <a:schemeClr val="accent3"/>
-            </a:solidFill>
-            <a:prstDash val="solid"/>
-          </a:ln>
-        </p:spPr>
-      </p:sp>
-      <p:sp>
-        <p:nvSpPr>
-          <p:cNvPr id="11" name="No Brasil item 3"/>
-          <p:cNvSpPr txBox="1"/>
-          <p:nvPr/>
-        </p:nvSpPr>
-        <p:spPr>
-          <a:xfrm>
-            <a:off x="1188720" y="5349240"/>
-            <a:ext cx="4325112" cy="713232"/>
-          </a:xfrm>
-          <a:prstGeom prst="rect">
-            <a:avLst/>
-          </a:prstGeom>
-          <a:noFill/>
-          <a:ln/>
-        </p:spPr>
-        <p:txBody>
-          <a:bodyPr wrap="square" lIns="0" tIns="0" rIns="0" bIns="0" rtlCol="0" anchor="t"/>
-          <a:lstStyle/>
-          <a:p>
-            <a:pPr indent="0" marL="0">
-              <a:lnSpc>
-                <a:spcPct val="110000"/>
-              </a:lnSpc>
-              <a:buNone/>
-            </a:pPr>
-            <a:r>
-              <a:rPr lang="en-US" sz="1500" dirty="0">
-                <a:solidFill>
-                  <a:schemeClr val="tx1"/>
-                </a:solidFill>
-              </a:rPr>
-              <a:t>A primeira prática costuma ser direto no paciente</a:t>
-            </a:r>
-            <a:endParaRPr lang="en-US" sz="1500" dirty="0"/>
-          </a:p>
-        </p:txBody>
-      </p:sp>
-      <p:sp>
-        <p:nvSpPr>
-          <p:cNvPr id="12" name="Cartão Em Miami"/>
-          <p:cNvSpPr/>
-          <p:nvPr/>
-        </p:nvSpPr>
-        <p:spPr>
-          <a:xfrm>
-            <a:off x="6217920" y="2423160"/>
-            <a:ext cx="5239512" cy="3749040"/>
-          </a:xfrm>
-          <a:prstGeom prst="rect">
-            <a:avLst/>
-          </a:prstGeom>
-          <a:solidFill>
-            <a:schemeClr val="accent1"/>
-          </a:solidFill>
-          <a:ln w="12700">
-            <a:solidFill>
-              <a:schemeClr val="accent1"/>
-            </a:solidFill>
-            <a:prstDash val="solid"/>
-          </a:ln>
-        </p:spPr>
-      </p:sp>
-      <p:sp>
-        <p:nvSpPr>
-          <p:cNvPr id="13" name="Em Miami título"/>
-          <p:cNvSpPr txBox="1"/>
-          <p:nvPr/>
-        </p:nvSpPr>
-        <p:spPr>
-          <a:xfrm>
-            <a:off x="6675120" y="2743200"/>
-            <a:ext cx="4389120" cy="685800"/>
-          </a:xfrm>
-          <a:prstGeom prst="rect">
-            <a:avLst/>
-          </a:prstGeom>
-          <a:noFill/>
-          <a:ln/>
-        </p:spPr>
-        <p:txBody>
-          <a:bodyPr wrap="square" lIns="0" tIns="0" rIns="0" bIns="0" rtlCol="0" anchor="t"/>
-          <a:lstStyle/>
-          <a:p>
-            <a:pPr indent="0" marL="0">
-              <a:buNone/>
-            </a:pPr>
-            <a:r>
-              <a:rPr lang="en-US" sz="3600" dirty="0">
-                <a:solidFill>
-                  <a:schemeClr val="bg1"/>
-                </a:solidFill>
-                <a:latin typeface="Garamond" pitchFamily="34" charset="0"/>
-                <a:ea typeface="Garamond" pitchFamily="34" charset="-122"/>
-                <a:cs typeface="Garamond" pitchFamily="34" charset="-120"/>
-              </a:rPr>
-              <a:t>Em Miami</a:t>
-            </a:r>
-            <a:endParaRPr lang="en-US" sz="3600" dirty="0"/>
-          </a:p>
-        </p:txBody>
-      </p:sp>
-      <p:sp>
-        <p:nvSpPr>
-          <p:cNvPr id="14" name="Em Miami fio 1"/>
-          <p:cNvSpPr/>
-          <p:nvPr/>
-        </p:nvSpPr>
-        <p:spPr>
-          <a:xfrm>
-            <a:off x="6675120" y="3611880"/>
-            <a:ext cx="4325112" cy="0"/>
-          </a:xfrm>
-          <a:prstGeom prst="line">
-            <a:avLst/>
-          </a:prstGeom>
-          <a:noFill/>
           <a:ln w="12700">
             <a:solidFill>
               <a:schemeClr val="accent5"/>
@@ -3379,76 +3437,39 @@
       </p:sp>
       <p:sp>
         <p:nvSpPr>
-          <p:cNvPr id="15" name="Em Miami item 1"/>
-          <p:cNvSpPr txBox="1"/>
-          <p:nvPr/>
-        </p:nvSpPr>
-        <p:spPr>
-          <a:xfrm>
-            <a:off x="6675120" y="3703320"/>
-            <a:ext cx="4325112" cy="713232"/>
-          </a:xfrm>
-          <a:prstGeom prst="rect">
-            <a:avLst/>
-          </a:prstGeom>
-          <a:noFill/>
-          <a:ln/>
-        </p:spPr>
-        <p:txBody>
-          <a:bodyPr wrap="square" lIns="0" tIns="0" rIns="0" bIns="0" rtlCol="0" anchor="t"/>
-          <a:lstStyle/>
-          <a:p>
-            <a:pPr indent="0" marL="0">
-              <a:lnSpc>
-                <a:spcPct val="110000"/>
-              </a:lnSpc>
-              <a:buNone/>
-            </a:pPr>
-            <a:r>
-              <a:rPr lang="en-US" sz="1500" dirty="0">
-                <a:solidFill>
-                  <a:schemeClr val="bg1"/>
-                </a:solidFill>
-              </a:rPr>
-              <a:t>Hands-on em specimen, a peça anatômica real</a:t>
-            </a:r>
-            <a:endParaRPr lang="en-US" sz="1500" dirty="0"/>
-          </a:p>
-        </p:txBody>
-      </p:sp>
-      <p:sp>
-        <p:nvSpPr>
-          <p:cNvPr id="16" name="Em Miami fio 2"/>
+          <p:cNvPr id="3" name="Área do vídeo"/>
           <p:cNvSpPr/>
           <p:nvPr/>
         </p:nvSpPr>
         <p:spPr>
           <a:xfrm>
-            <a:off x="6675120" y="4434840"/>
-            <a:ext cx="4325112" cy="0"/>
-          </a:xfrm>
-          <a:prstGeom prst="line">
-            <a:avLst/>
-          </a:prstGeom>
-          <a:noFill/>
+            <a:off x="731520" y="640080"/>
+            <a:ext cx="10725912" cy="5577840"/>
+          </a:xfrm>
+          <a:prstGeom prst="rect">
+            <a:avLst/>
+          </a:prstGeom>
+          <a:solidFill>
+            <a:schemeClr val="accent1"/>
+          </a:solidFill>
           <a:ln w="12700">
             <a:solidFill>
-              <a:schemeClr val="accent5"/>
+              <a:schemeClr val="accent2"/>
             </a:solidFill>
-            <a:prstDash val="solid"/>
+            <a:prstDash val="dash"/>
           </a:ln>
         </p:spPr>
       </p:sp>
       <p:sp>
         <p:nvSpPr>
-          <p:cNvPr id="17" name="Em Miami item 2"/>
+          <p:cNvPr id="4" name="Instrução do vídeo"/>
           <p:cNvSpPr txBox="1"/>
           <p:nvPr/>
         </p:nvSpPr>
         <p:spPr>
           <a:xfrm>
-            <a:off x="6675120" y="4526280"/>
-            <a:ext cx="4325112" cy="713232"/>
+            <a:off x="731520" y="640080"/>
+            <a:ext cx="10725912" cy="5577840"/>
           </a:xfrm>
           <a:prstGeom prst="rect">
             <a:avLst/>
@@ -3457,131 +3478,38 @@
           <a:ln/>
         </p:spPr>
         <p:txBody>
-          <a:bodyPr wrap="square" lIns="0" tIns="0" rIns="0" bIns="0" rtlCol="0" anchor="t"/>
-          <a:lstStyle/>
-          <a:p>
-            <a:pPr indent="0" marL="0">
-              <a:lnSpc>
-                <a:spcPct val="110000"/>
-              </a:lnSpc>
-              <a:buNone/>
-            </a:pPr>
-            <a:r>
-              <a:rPr lang="en-US" sz="1500" dirty="0">
+          <a:bodyPr wrap="square" lIns="0" tIns="0" rIns="0" bIns="0" rtlCol="0" anchor="ctr"/>
+          <a:lstStyle/>
+          <a:p>
+            <a:pPr algn="ctr" indent="0" marL="0">
+              <a:buNone/>
+            </a:pPr>
+            <a:r>
+              <a:rPr lang="en-US" sz="3400" dirty="0">
                 <a:solidFill>
                   <a:schemeClr val="bg1"/>
                 </a:solidFill>
-              </a:rPr>
-              <a:t>Laboratório privado com estrutura para treinamento avançado</a:t>
-            </a:r>
-            <a:endParaRPr lang="en-US" sz="1500" dirty="0"/>
-          </a:p>
-        </p:txBody>
-      </p:sp>
-      <p:sp>
-        <p:nvSpPr>
-          <p:cNvPr id="18" name="Em Miami fio 3"/>
-          <p:cNvSpPr/>
-          <p:nvPr/>
-        </p:nvSpPr>
-        <p:spPr>
-          <a:xfrm>
-            <a:off x="6675120" y="5257800"/>
-            <a:ext cx="4325112" cy="0"/>
-          </a:xfrm>
-          <a:prstGeom prst="line">
-            <a:avLst/>
-          </a:prstGeom>
-          <a:noFill/>
-          <a:ln w="12700">
-            <a:solidFill>
-              <a:schemeClr val="accent5"/>
-            </a:solidFill>
-            <a:prstDash val="solid"/>
-          </a:ln>
-        </p:spPr>
-      </p:sp>
-      <p:sp>
-        <p:nvSpPr>
-          <p:cNvPr id="19" name="Em Miami item 3"/>
-          <p:cNvSpPr txBox="1"/>
-          <p:nvPr/>
-        </p:nvSpPr>
-        <p:spPr>
-          <a:xfrm>
-            <a:off x="6675120" y="5349240"/>
-            <a:ext cx="4325112" cy="713232"/>
-          </a:xfrm>
-          <a:prstGeom prst="rect">
-            <a:avLst/>
-          </a:prstGeom>
-          <a:noFill/>
-          <a:ln/>
-        </p:spPr>
-        <p:txBody>
-          <a:bodyPr wrap="square" lIns="0" tIns="0" rIns="0" bIns="0" rtlCol="0" anchor="t"/>
-          <a:lstStyle/>
-          <a:p>
-            <a:pPr indent="0" marL="0">
-              <a:lnSpc>
-                <a:spcPct val="110000"/>
-              </a:lnSpc>
-              <a:buNone/>
-            </a:pPr>
-            <a:r>
-              <a:rPr lang="en-US" sz="1500" dirty="0">
-                <a:solidFill>
-                  <a:schemeClr val="bg1"/>
-                </a:solidFill>
-              </a:rPr>
-              <a:t>Você vê planos, vasos e áreas de risco antes de tocar no paciente</a:t>
-            </a:r>
-            <a:endParaRPr lang="en-US" sz="1500" dirty="0"/>
-          </a:p>
-        </p:txBody>
-      </p:sp>
-      <p:sp>
-        <p:nvSpPr>
-          <p:cNvPr id="25" name="Slide Number Placeholder 0"/>
-          <p:cNvSpPr>
-            <a:spLocks noGrp="1"/>
-          </p:cNvSpPr>
-          <p:nvPr>
-            <p:ph type="sldNum" sz="quarter" idx="4294967295"/>
-          </p:nvPr>
-        </p:nvSpPr>
-        <p:spPr>
-          <a:xfrm>
-            <a:off x="11155680" y="6355080"/>
-            <a:ext cx="411480" cy="274320"/>
-          </a:xfrm>
-          <a:prstGeom prst="rect">
-            <a:avLst/>
-          </a:prstGeom>
-          <a:extLst>
-            <a:ext uri="{C572A759-6A51-4108-AA02-DFA0A04FC94B}">
-              <ma14:wrappingTextBoxFlag xmlns:ma14="http://schemas.microsoft.com/office/mac/drawingml/2011/main" val="0"/>
-            </a:ext>
-          </a:extLst>
-        </p:spPr>
-        <p:txBody>
-          <a:bodyPr/>
-          <a:lstStyle>
-            <a:lvl1pPr>
-              <a:defRPr sz="900">
-                <a:solidFill>
-                  <a:schemeClr val="tx2"/>
-                </a:solidFill>
-              </a:defRPr>
-            </a:lvl1pPr>
-          </a:lstStyle>
-          <a:p>
-            <a:pPr algn="r"/>
-            <a:fld id="{F7021451-1387-4CA6-816F-3879F97B5CBC}" type="slidenum">
-              <a:rPr b="0" lang="en-US"/>
-              <a:t>4</a:t>
-            </a:fld>
-            <a:endParaRPr lang="en-US"/>
+                <a:latin typeface="Garamond" pitchFamily="34" charset="0"/>
+                <a:ea typeface="Garamond" pitchFamily="34" charset="-122"/>
+                <a:cs typeface="Garamond" pitchFamily="34" charset="-120"/>
+              </a:rPr>
+              <a:t>Insira aqui o vídeo</a:t>
+            </a:r>
+            <a:endParaRPr lang="en-US" sz="3400" dirty="0"/>
+          </a:p>
+          <a:p>
+            <a:pPr algn="ctr" indent="0" marL="0">
+              <a:buNone/>
+            </a:pPr>
+            <a:r>
+              <a:rPr lang="en-US" sz="1400" dirty="0">
+                <a:solidFill>
+                  <a:schemeClr val="accent4"/>
+                </a:solidFill>
+              </a:rPr>
+              <a:t>Inserir  ›  Vídeo  ›  Este dispositivo. Depois apague esta caixa e o retângulo.</a:t>
+            </a:r>
+            <a:endParaRPr lang="en-US" sz="3400" dirty="0"/>
           </a:p>
         </p:txBody>
       </p:sp>
@@ -3648,7 +3576,7 @@
                 <a:ea typeface="Garamond" pitchFamily="34" charset="-122"/>
                 <a:cs typeface="Garamond" pitchFamily="34" charset="-120"/>
               </a:rPr>
-              <a:t>Programação prática</a:t>
+              <a:t>Por que Miami?</a:t>
             </a:r>
             <a:endParaRPr lang="en-US" sz="4400" dirty="0"/>
           </a:p>
@@ -3662,8 +3590,8 @@
         </p:nvSpPr>
         <p:spPr>
           <a:xfrm>
-            <a:off x="731520" y="1600200"/>
-            <a:ext cx="7315200" cy="365760"/>
+            <a:off x="731520" y="1645920"/>
+            <a:ext cx="10698480" cy="457200"/>
           </a:xfrm>
           <a:prstGeom prst="rect">
             <a:avLst/>
@@ -3679,32 +3607,34 @@
               <a:buNone/>
             </a:pPr>
             <a:r>
-              <a:rPr lang="en-US" sz="1600" dirty="0">
+              <a:rPr lang="en-US" sz="1800" dirty="0">
                 <a:solidFill>
                   <a:schemeClr val="tx2"/>
                 </a:solidFill>
               </a:rPr>
-              <a:t>Anatomia aplicada e hands-on</a:t>
-            </a:r>
-            <a:endParaRPr lang="en-US" sz="1600" dirty="0"/>
-          </a:p>
-        </p:txBody>
-      </p:sp>
-      <p:sp>
-        <p:nvSpPr>
-          <p:cNvPr id="4" name="Fio 1"/>
+              <a:t>Porque lá a anatomia sai do livro e vai para a peça anatômica real.</a:t>
+            </a:r>
+            <a:endParaRPr lang="en-US" sz="1800" dirty="0"/>
+          </a:p>
+        </p:txBody>
+      </p:sp>
+      <p:sp>
+        <p:nvSpPr>
+          <p:cNvPr id="4" name="Cartão No Brasil"/>
           <p:cNvSpPr/>
           <p:nvPr/>
         </p:nvSpPr>
         <p:spPr>
           <a:xfrm>
-            <a:off x="731520" y="2331720"/>
-            <a:ext cx="10725912" cy="0"/>
-          </a:xfrm>
-          <a:prstGeom prst="line">
-            <a:avLst/>
-          </a:prstGeom>
-          <a:noFill/>
+            <a:off x="731520" y="2423160"/>
+            <a:ext cx="5239512" cy="3749040"/>
+          </a:xfrm>
+          <a:prstGeom prst="rect">
+            <a:avLst/>
+          </a:prstGeom>
+          <a:solidFill>
+            <a:schemeClr val="bg1"/>
+          </a:solidFill>
           <a:ln w="12700">
             <a:solidFill>
               <a:schemeClr val="accent3"/>
@@ -3715,14 +3645,14 @@
       </p:sp>
       <p:sp>
         <p:nvSpPr>
-          <p:cNvPr id="5" name="Módulo 1"/>
+          <p:cNvPr id="5" name="No Brasil título"/>
           <p:cNvSpPr txBox="1"/>
           <p:nvPr/>
         </p:nvSpPr>
         <p:spPr>
           <a:xfrm>
-            <a:off x="731520" y="2459736"/>
-            <a:ext cx="10698480" cy="548640"/>
+            <a:off x="1188720" y="2743200"/>
+            <a:ext cx="4389120" cy="685800"/>
           </a:xfrm>
           <a:prstGeom prst="rect">
             <a:avLst/>
@@ -3731,37 +3661,37 @@
           <a:ln/>
         </p:spPr>
         <p:txBody>
-          <a:bodyPr wrap="square" lIns="0" tIns="0" rIns="0" bIns="0" rtlCol="0" anchor="ctr"/>
+          <a:bodyPr wrap="square" lIns="0" tIns="0" rIns="0" bIns="0" rtlCol="0" anchor="t"/>
           <a:lstStyle/>
           <a:p>
             <a:pPr indent="0" marL="0">
               <a:buNone/>
             </a:pPr>
             <a:r>
-              <a:rPr lang="en-US" sz="2400" dirty="0">
-                <a:solidFill>
-                  <a:schemeClr val="tx1"/>
+              <a:rPr lang="en-US" sz="3600" dirty="0">
+                <a:solidFill>
+                  <a:schemeClr val="accent1"/>
                 </a:solidFill>
                 <a:latin typeface="Garamond" pitchFamily="34" charset="0"/>
                 <a:ea typeface="Garamond" pitchFamily="34" charset="-122"/>
                 <a:cs typeface="Garamond" pitchFamily="34" charset="-120"/>
               </a:rPr>
-              <a:t>Anatomia avançada de cabeça e pescoço aplicada a injetáveis</a:t>
-            </a:r>
-            <a:endParaRPr lang="en-US" sz="2400" dirty="0"/>
-          </a:p>
-        </p:txBody>
-      </p:sp>
-      <p:sp>
-        <p:nvSpPr>
-          <p:cNvPr id="6" name="Fio 2"/>
+              <a:t>No Brasil</a:t>
+            </a:r>
+            <a:endParaRPr lang="en-US" sz="3600" dirty="0"/>
+          </a:p>
+        </p:txBody>
+      </p:sp>
+      <p:sp>
+        <p:nvSpPr>
+          <p:cNvPr id="6" name="No Brasil fio 1"/>
           <p:cNvSpPr/>
           <p:nvPr/>
         </p:nvSpPr>
         <p:spPr>
           <a:xfrm>
-            <a:off x="731520" y="3118104"/>
-            <a:ext cx="10725912" cy="0"/>
+            <a:off x="1188720" y="3611880"/>
+            <a:ext cx="4325112" cy="0"/>
           </a:xfrm>
           <a:prstGeom prst="line">
             <a:avLst/>
@@ -3777,14 +3707,14 @@
       </p:sp>
       <p:sp>
         <p:nvSpPr>
-          <p:cNvPr id="7" name="Módulo 2"/>
+          <p:cNvPr id="7" name="No Brasil item 1"/>
           <p:cNvSpPr txBox="1"/>
           <p:nvPr/>
         </p:nvSpPr>
         <p:spPr>
           <a:xfrm>
-            <a:off x="731520" y="3246120"/>
-            <a:ext cx="10698480" cy="548640"/>
+            <a:off x="1188720" y="3703320"/>
+            <a:ext cx="4325112" cy="713232"/>
           </a:xfrm>
           <a:prstGeom prst="rect">
             <a:avLst/>
@@ -3793,37 +3723,37 @@
           <a:ln/>
         </p:spPr>
         <p:txBody>
-          <a:bodyPr wrap="square" lIns="0" tIns="0" rIns="0" bIns="0" rtlCol="0" anchor="ctr"/>
+          <a:bodyPr wrap="square" lIns="0" tIns="0" rIns="0" bIns="0" rtlCol="0" anchor="t"/>
           <a:lstStyle/>
           <a:p>
             <a:pPr indent="0" marL="0">
-              <a:buNone/>
-            </a:pPr>
-            <a:r>
-              <a:rPr lang="en-US" sz="2400" dirty="0">
+              <a:lnSpc>
+                <a:spcPct val="110000"/>
+              </a:lnSpc>
+              <a:buNone/>
+            </a:pPr>
+            <a:r>
+              <a:rPr lang="en-US" sz="1500" dirty="0">
                 <a:solidFill>
                   <a:schemeClr val="tx1"/>
                 </a:solidFill>
-                <a:latin typeface="Garamond" pitchFamily="34" charset="0"/>
-                <a:ea typeface="Garamond" pitchFamily="34" charset="-122"/>
-                <a:cs typeface="Garamond" pitchFamily="34" charset="-120"/>
-              </a:rPr>
-              <a:t>Anatomia avançada de cabeça e pescoço aplicada a fios faciais</a:t>
-            </a:r>
-            <a:endParaRPr lang="en-US" sz="2400" dirty="0"/>
-          </a:p>
-        </p:txBody>
-      </p:sp>
-      <p:sp>
-        <p:nvSpPr>
-          <p:cNvPr id="8" name="Fio 3"/>
+              </a:rPr>
+              <a:t>Anatomia estudada em atlas, vídeos e modelos sintéticos</a:t>
+            </a:r>
+            <a:endParaRPr lang="en-US" sz="1500" dirty="0"/>
+          </a:p>
+        </p:txBody>
+      </p:sp>
+      <p:sp>
+        <p:nvSpPr>
+          <p:cNvPr id="8" name="No Brasil fio 2"/>
           <p:cNvSpPr/>
           <p:nvPr/>
         </p:nvSpPr>
         <p:spPr>
           <a:xfrm>
-            <a:off x="731520" y="3904488"/>
-            <a:ext cx="10725912" cy="0"/>
+            <a:off x="1188720" y="4434840"/>
+            <a:ext cx="4325112" cy="0"/>
           </a:xfrm>
           <a:prstGeom prst="line">
             <a:avLst/>
@@ -3839,14 +3769,14 @@
       </p:sp>
       <p:sp>
         <p:nvSpPr>
-          <p:cNvPr id="9" name="Módulo 3"/>
+          <p:cNvPr id="9" name="No Brasil item 2"/>
           <p:cNvSpPr txBox="1"/>
           <p:nvPr/>
         </p:nvSpPr>
         <p:spPr>
           <a:xfrm>
-            <a:off x="731520" y="4032504"/>
-            <a:ext cx="10698480" cy="548640"/>
+            <a:off x="1188720" y="4526280"/>
+            <a:ext cx="4325112" cy="713232"/>
           </a:xfrm>
           <a:prstGeom prst="rect">
             <a:avLst/>
@@ -3855,37 +3785,37 @@
           <a:ln/>
         </p:spPr>
         <p:txBody>
-          <a:bodyPr wrap="square" lIns="0" tIns="0" rIns="0" bIns="0" rtlCol="0" anchor="ctr"/>
+          <a:bodyPr wrap="square" lIns="0" tIns="0" rIns="0" bIns="0" rtlCol="0" anchor="t"/>
           <a:lstStyle/>
           <a:p>
             <a:pPr indent="0" marL="0">
-              <a:buNone/>
-            </a:pPr>
-            <a:r>
-              <a:rPr lang="en-US" sz="2400" dirty="0">
+              <a:lnSpc>
+                <a:spcPct val="110000"/>
+              </a:lnSpc>
+              <a:buNone/>
+            </a:pPr>
+            <a:r>
+              <a:rPr lang="en-US" sz="1500" dirty="0">
                 <a:solidFill>
                   <a:schemeClr val="tx1"/>
                 </a:solidFill>
-                <a:latin typeface="Garamond" pitchFamily="34" charset="0"/>
-                <a:ea typeface="Garamond" pitchFamily="34" charset="-122"/>
-                <a:cs typeface="Garamond" pitchFamily="34" charset="-120"/>
-              </a:rPr>
-              <a:t>Bioestimuladores faciais e corporais: fundamentos, indicações e limites</a:t>
-            </a:r>
-            <a:endParaRPr lang="en-US" sz="2400" dirty="0"/>
-          </a:p>
-        </p:txBody>
-      </p:sp>
-      <p:sp>
-        <p:nvSpPr>
-          <p:cNvPr id="10" name="Fio 4"/>
+              </a:rPr>
+              <a:t>Acesso a peças anatômicas restrito, em geral, às universidades</a:t>
+            </a:r>
+            <a:endParaRPr lang="en-US" sz="1500" dirty="0"/>
+          </a:p>
+        </p:txBody>
+      </p:sp>
+      <p:sp>
+        <p:nvSpPr>
+          <p:cNvPr id="10" name="No Brasil fio 3"/>
           <p:cNvSpPr/>
           <p:nvPr/>
         </p:nvSpPr>
         <p:spPr>
           <a:xfrm>
-            <a:off x="731520" y="4690872"/>
-            <a:ext cx="10725912" cy="0"/>
+            <a:off x="1188720" y="5257800"/>
+            <a:ext cx="4325112" cy="0"/>
           </a:xfrm>
           <a:prstGeom prst="line">
             <a:avLst/>
@@ -3901,14 +3831,14 @@
       </p:sp>
       <p:sp>
         <p:nvSpPr>
-          <p:cNvPr id="11" name="Módulo 4"/>
+          <p:cNvPr id="11" name="No Brasil item 3"/>
           <p:cNvSpPr txBox="1"/>
           <p:nvPr/>
         </p:nvSpPr>
         <p:spPr>
           <a:xfrm>
-            <a:off x="731520" y="4818888"/>
-            <a:ext cx="10698480" cy="548640"/>
+            <a:off x="1188720" y="5349240"/>
+            <a:ext cx="4325112" cy="713232"/>
           </a:xfrm>
           <a:prstGeom prst="rect">
             <a:avLst/>
@@ -3917,37 +3847,101 @@
           <a:ln/>
         </p:spPr>
         <p:txBody>
-          <a:bodyPr wrap="square" lIns="0" tIns="0" rIns="0" bIns="0" rtlCol="0" anchor="ctr"/>
+          <a:bodyPr wrap="square" lIns="0" tIns="0" rIns="0" bIns="0" rtlCol="0" anchor="t"/>
           <a:lstStyle/>
           <a:p>
             <a:pPr indent="0" marL="0">
-              <a:buNone/>
-            </a:pPr>
-            <a:r>
-              <a:rPr lang="en-US" sz="2400" dirty="0">
+              <a:lnSpc>
+                <a:spcPct val="110000"/>
+              </a:lnSpc>
+              <a:buNone/>
+            </a:pPr>
+            <a:r>
+              <a:rPr lang="en-US" sz="1500" dirty="0">
                 <a:solidFill>
                   <a:schemeClr val="tx1"/>
+                </a:solidFill>
+              </a:rPr>
+              <a:t>A primeira prática costuma ser direto no paciente</a:t>
+            </a:r>
+            <a:endParaRPr lang="en-US" sz="1500" dirty="0"/>
+          </a:p>
+        </p:txBody>
+      </p:sp>
+      <p:sp>
+        <p:nvSpPr>
+          <p:cNvPr id="12" name="Cartão Em Miami"/>
+          <p:cNvSpPr/>
+          <p:nvPr/>
+        </p:nvSpPr>
+        <p:spPr>
+          <a:xfrm>
+            <a:off x="6217920" y="2423160"/>
+            <a:ext cx="5239512" cy="3749040"/>
+          </a:xfrm>
+          <a:prstGeom prst="rect">
+            <a:avLst/>
+          </a:prstGeom>
+          <a:solidFill>
+            <a:schemeClr val="accent1"/>
+          </a:solidFill>
+          <a:ln w="12700">
+            <a:solidFill>
+              <a:schemeClr val="accent1"/>
+            </a:solidFill>
+            <a:prstDash val="solid"/>
+          </a:ln>
+        </p:spPr>
+      </p:sp>
+      <p:sp>
+        <p:nvSpPr>
+          <p:cNvPr id="13" name="Em Miami título"/>
+          <p:cNvSpPr txBox="1"/>
+          <p:nvPr/>
+        </p:nvSpPr>
+        <p:spPr>
+          <a:xfrm>
+            <a:off x="6675120" y="2743200"/>
+            <a:ext cx="4389120" cy="685800"/>
+          </a:xfrm>
+          <a:prstGeom prst="rect">
+            <a:avLst/>
+          </a:prstGeom>
+          <a:noFill/>
+          <a:ln/>
+        </p:spPr>
+        <p:txBody>
+          <a:bodyPr wrap="square" lIns="0" tIns="0" rIns="0" bIns="0" rtlCol="0" anchor="t"/>
+          <a:lstStyle/>
+          <a:p>
+            <a:pPr indent="0" marL="0">
+              <a:buNone/>
+            </a:pPr>
+            <a:r>
+              <a:rPr lang="en-US" sz="3600" dirty="0">
+                <a:solidFill>
+                  <a:schemeClr val="bg1"/>
                 </a:solidFill>
                 <a:latin typeface="Garamond" pitchFamily="34" charset="0"/>
                 <a:ea typeface="Garamond" pitchFamily="34" charset="-122"/>
                 <a:cs typeface="Garamond" pitchFamily="34" charset="-120"/>
               </a:rPr>
-              <a:t>Lifting facial com preenchedores: raciocínio anatômico e estrutural</a:t>
-            </a:r>
-            <a:endParaRPr lang="en-US" sz="2400" dirty="0"/>
-          </a:p>
-        </p:txBody>
-      </p:sp>
-      <p:sp>
-        <p:nvSpPr>
-          <p:cNvPr id="12" name="Fio 5"/>
+              <a:t>Em Miami</a:t>
+            </a:r>
+            <a:endParaRPr lang="en-US" sz="3600" dirty="0"/>
+          </a:p>
+        </p:txBody>
+      </p:sp>
+      <p:sp>
+        <p:nvSpPr>
+          <p:cNvPr id="14" name="Em Miami fio 1"/>
           <p:cNvSpPr/>
           <p:nvPr/>
         </p:nvSpPr>
         <p:spPr>
           <a:xfrm>
-            <a:off x="731520" y="5477256"/>
-            <a:ext cx="10725912" cy="0"/>
+            <a:off x="6675120" y="3611880"/>
+            <a:ext cx="4325112" cy="0"/>
           </a:xfrm>
           <a:prstGeom prst="line">
             <a:avLst/>
@@ -3955,7 +3949,7 @@
           <a:noFill/>
           <a:ln w="12700">
             <a:solidFill>
-              <a:schemeClr val="accent3"/>
+              <a:schemeClr val="accent5"/>
             </a:solidFill>
             <a:prstDash val="solid"/>
           </a:ln>
@@ -3963,14 +3957,14 @@
       </p:sp>
       <p:sp>
         <p:nvSpPr>
-          <p:cNvPr id="13" name="Módulo 5"/>
+          <p:cNvPr id="15" name="Em Miami item 1"/>
           <p:cNvSpPr txBox="1"/>
           <p:nvPr/>
         </p:nvSpPr>
         <p:spPr>
           <a:xfrm>
-            <a:off x="731520" y="5605272"/>
-            <a:ext cx="10698480" cy="548640"/>
+            <a:off x="6675120" y="3703320"/>
+            <a:ext cx="4325112" cy="713232"/>
           </a:xfrm>
           <a:prstGeom prst="rect">
             <a:avLst/>
@@ -3979,37 +3973,37 @@
           <a:ln/>
         </p:spPr>
         <p:txBody>
-          <a:bodyPr wrap="square" lIns="0" tIns="0" rIns="0" bIns="0" rtlCol="0" anchor="ctr"/>
+          <a:bodyPr wrap="square" lIns="0" tIns="0" rIns="0" bIns="0" rtlCol="0" anchor="t"/>
           <a:lstStyle/>
           <a:p>
             <a:pPr indent="0" marL="0">
-              <a:buNone/>
-            </a:pPr>
-            <a:r>
-              <a:rPr lang="en-US" sz="2400" dirty="0">
-                <a:solidFill>
-                  <a:schemeClr val="tx1"/>
-                </a:solidFill>
-                <a:latin typeface="Garamond" pitchFamily="34" charset="0"/>
-                <a:ea typeface="Garamond" pitchFamily="34" charset="-122"/>
-                <a:cs typeface="Garamond" pitchFamily="34" charset="-120"/>
-              </a:rPr>
-              <a:t>Full face: planejamento anatômico, segurança e naturalidade</a:t>
-            </a:r>
-            <a:endParaRPr lang="en-US" sz="2400" dirty="0"/>
-          </a:p>
-        </p:txBody>
-      </p:sp>
-      <p:sp>
-        <p:nvSpPr>
-          <p:cNvPr id="14" name="Fio final"/>
+              <a:lnSpc>
+                <a:spcPct val="110000"/>
+              </a:lnSpc>
+              <a:buNone/>
+            </a:pPr>
+            <a:r>
+              <a:rPr lang="en-US" sz="1500" dirty="0">
+                <a:solidFill>
+                  <a:schemeClr val="bg1"/>
+                </a:solidFill>
+              </a:rPr>
+              <a:t>Hands-on em specimen, a peça anatômica real</a:t>
+            </a:r>
+            <a:endParaRPr lang="en-US" sz="1500" dirty="0"/>
+          </a:p>
+        </p:txBody>
+      </p:sp>
+      <p:sp>
+        <p:nvSpPr>
+          <p:cNvPr id="16" name="Em Miami fio 2"/>
           <p:cNvSpPr/>
           <p:nvPr/>
         </p:nvSpPr>
         <p:spPr>
           <a:xfrm>
-            <a:off x="731520" y="6263640"/>
-            <a:ext cx="10725912" cy="0"/>
+            <a:off x="6675120" y="4434840"/>
+            <a:ext cx="4325112" cy="0"/>
           </a:xfrm>
           <a:prstGeom prst="line">
             <a:avLst/>
@@ -4017,11 +4011,112 @@
           <a:noFill/>
           <a:ln w="12700">
             <a:solidFill>
-              <a:schemeClr val="accent3"/>
+              <a:schemeClr val="accent5"/>
             </a:solidFill>
             <a:prstDash val="solid"/>
           </a:ln>
         </p:spPr>
+      </p:sp>
+      <p:sp>
+        <p:nvSpPr>
+          <p:cNvPr id="17" name="Em Miami item 2"/>
+          <p:cNvSpPr txBox="1"/>
+          <p:nvPr/>
+        </p:nvSpPr>
+        <p:spPr>
+          <a:xfrm>
+            <a:off x="6675120" y="4526280"/>
+            <a:ext cx="4325112" cy="713232"/>
+          </a:xfrm>
+          <a:prstGeom prst="rect">
+            <a:avLst/>
+          </a:prstGeom>
+          <a:noFill/>
+          <a:ln/>
+        </p:spPr>
+        <p:txBody>
+          <a:bodyPr wrap="square" lIns="0" tIns="0" rIns="0" bIns="0" rtlCol="0" anchor="t"/>
+          <a:lstStyle/>
+          <a:p>
+            <a:pPr indent="0" marL="0">
+              <a:lnSpc>
+                <a:spcPct val="110000"/>
+              </a:lnSpc>
+              <a:buNone/>
+            </a:pPr>
+            <a:r>
+              <a:rPr lang="en-US" sz="1500" dirty="0">
+                <a:solidFill>
+                  <a:schemeClr val="bg1"/>
+                </a:solidFill>
+              </a:rPr>
+              <a:t>Laboratório privado com estrutura para treinamento avançado</a:t>
+            </a:r>
+            <a:endParaRPr lang="en-US" sz="1500" dirty="0"/>
+          </a:p>
+        </p:txBody>
+      </p:sp>
+      <p:sp>
+        <p:nvSpPr>
+          <p:cNvPr id="18" name="Em Miami fio 3"/>
+          <p:cNvSpPr/>
+          <p:nvPr/>
+        </p:nvSpPr>
+        <p:spPr>
+          <a:xfrm>
+            <a:off x="6675120" y="5257800"/>
+            <a:ext cx="4325112" cy="0"/>
+          </a:xfrm>
+          <a:prstGeom prst="line">
+            <a:avLst/>
+          </a:prstGeom>
+          <a:noFill/>
+          <a:ln w="12700">
+            <a:solidFill>
+              <a:schemeClr val="accent5"/>
+            </a:solidFill>
+            <a:prstDash val="solid"/>
+          </a:ln>
+        </p:spPr>
+      </p:sp>
+      <p:sp>
+        <p:nvSpPr>
+          <p:cNvPr id="19" name="Em Miami item 3"/>
+          <p:cNvSpPr txBox="1"/>
+          <p:nvPr/>
+        </p:nvSpPr>
+        <p:spPr>
+          <a:xfrm>
+            <a:off x="6675120" y="5349240"/>
+            <a:ext cx="4325112" cy="713232"/>
+          </a:xfrm>
+          <a:prstGeom prst="rect">
+            <a:avLst/>
+          </a:prstGeom>
+          <a:noFill/>
+          <a:ln/>
+        </p:spPr>
+        <p:txBody>
+          <a:bodyPr wrap="square" lIns="0" tIns="0" rIns="0" bIns="0" rtlCol="0" anchor="t"/>
+          <a:lstStyle/>
+          <a:p>
+            <a:pPr indent="0" marL="0">
+              <a:lnSpc>
+                <a:spcPct val="110000"/>
+              </a:lnSpc>
+              <a:buNone/>
+            </a:pPr>
+            <a:r>
+              <a:rPr lang="en-US" sz="1500" dirty="0">
+                <a:solidFill>
+                  <a:schemeClr val="bg1"/>
+                </a:solidFill>
+              </a:rPr>
+              <a:t>Você vê planos, vasos e áreas de risco antes de tocar no paciente</a:t>
+            </a:r>
+            <a:endParaRPr lang="en-US" sz="1500" dirty="0"/>
+          </a:p>
+        </p:txBody>
       </p:sp>
       <p:sp>
         <p:nvSpPr>
@@ -4131,7 +4226,7 @@
                 <a:ea typeface="Garamond" pitchFamily="34" charset="-122"/>
                 <a:cs typeface="Garamond" pitchFamily="34" charset="-120"/>
               </a:rPr>
-              <a:t>Da teoria à prática</a:t>
+              <a:t>Programação prática</a:t>
             </a:r>
             <a:endParaRPr lang="en-US" sz="4400" dirty="0"/>
           </a:p>
@@ -4139,21 +4234,55 @@
       </p:sp>
       <p:sp>
         <p:nvSpPr>
-          <p:cNvPr id="3" name="Cartão Boston"/>
+          <p:cNvPr id="3" name="Text 1"/>
+          <p:cNvSpPr txBox="1"/>
+          <p:nvPr/>
+        </p:nvSpPr>
+        <p:spPr>
+          <a:xfrm>
+            <a:off x="731520" y="1600200"/>
+            <a:ext cx="7315200" cy="365760"/>
+          </a:xfrm>
+          <a:prstGeom prst="rect">
+            <a:avLst/>
+          </a:prstGeom>
+          <a:noFill/>
+          <a:ln/>
+        </p:spPr>
+        <p:txBody>
+          <a:bodyPr wrap="square" lIns="0" tIns="0" rIns="0" bIns="0" rtlCol="0" anchor="t"/>
+          <a:lstStyle/>
+          <a:p>
+            <a:pPr indent="0" marL="0">
+              <a:buNone/>
+            </a:pPr>
+            <a:r>
+              <a:rPr lang="en-US" sz="1600" dirty="0">
+                <a:solidFill>
+                  <a:schemeClr val="tx2"/>
+                </a:solidFill>
+              </a:rPr>
+              <a:t>Anatomia aplicada e hands-on</a:t>
+            </a:r>
+            <a:endParaRPr lang="en-US" sz="1600" dirty="0"/>
+          </a:p>
+        </p:txBody>
+      </p:sp>
+      <p:sp>
+        <p:nvSpPr>
+          <p:cNvPr id="4" name="Fio 1"/>
           <p:cNvSpPr/>
           <p:nvPr/>
         </p:nvSpPr>
         <p:spPr>
           <a:xfrm>
-            <a:off x="731520" y="2011680"/>
-            <a:ext cx="5239512" cy="3840480"/>
-          </a:xfrm>
-          <a:prstGeom prst="rect">
-            <a:avLst/>
-          </a:prstGeom>
-          <a:solidFill>
-            <a:schemeClr val="bg1"/>
-          </a:solidFill>
+            <a:off x="731520" y="2331720"/>
+            <a:ext cx="10725912" cy="0"/>
+          </a:xfrm>
+          <a:prstGeom prst="line">
+            <a:avLst/>
+          </a:prstGeom>
+          <a:noFill/>
           <a:ln w="12700">
             <a:solidFill>
               <a:schemeClr val="accent3"/>
@@ -4164,14 +4293,14 @@
       </p:sp>
       <p:sp>
         <p:nvSpPr>
-          <p:cNvPr id="4" name="Boston título"/>
+          <p:cNvPr id="5" name="Módulo 1"/>
           <p:cNvSpPr txBox="1"/>
           <p:nvPr/>
         </p:nvSpPr>
         <p:spPr>
           <a:xfrm>
-            <a:off x="1188720" y="2423160"/>
-            <a:ext cx="4389120" cy="822960"/>
+            <a:off x="731520" y="2459736"/>
+            <a:ext cx="10698480" cy="548640"/>
           </a:xfrm>
           <a:prstGeom prst="rect">
             <a:avLst/>
@@ -4180,122 +4309,45 @@
           <a:ln/>
         </p:spPr>
         <p:txBody>
-          <a:bodyPr wrap="square" lIns="0" tIns="0" rIns="0" bIns="0" rtlCol="0" anchor="t"/>
+          <a:bodyPr wrap="square" lIns="0" tIns="0" rIns="0" bIns="0" rtlCol="0" anchor="ctr"/>
           <a:lstStyle/>
           <a:p>
             <a:pPr indent="0" marL="0">
               <a:buNone/>
             </a:pPr>
             <a:r>
-              <a:rPr lang="en-US" sz="4800" dirty="0">
-                <a:solidFill>
-                  <a:schemeClr val="accent1"/>
+              <a:rPr lang="en-US" sz="2400" dirty="0">
+                <a:solidFill>
+                  <a:schemeClr val="tx1"/>
                 </a:solidFill>
                 <a:latin typeface="Garamond" pitchFamily="34" charset="0"/>
                 <a:ea typeface="Garamond" pitchFamily="34" charset="-122"/>
                 <a:cs typeface="Garamond" pitchFamily="34" charset="-120"/>
               </a:rPr>
-              <a:t>Boston</a:t>
-            </a:r>
-            <a:endParaRPr lang="en-US" sz="4800" dirty="0"/>
-          </a:p>
-        </p:txBody>
-      </p:sp>
-      <p:sp>
-        <p:nvSpPr>
-          <p:cNvPr id="5" name="Boston subtítulo"/>
-          <p:cNvSpPr txBox="1"/>
-          <p:nvPr/>
-        </p:nvSpPr>
-        <p:spPr>
-          <a:xfrm>
-            <a:off x="1188720" y="3383280"/>
-            <a:ext cx="4389120" cy="457200"/>
-          </a:xfrm>
-          <a:prstGeom prst="rect">
-            <a:avLst/>
-          </a:prstGeom>
-          <a:noFill/>
-          <a:ln/>
-        </p:spPr>
-        <p:txBody>
-          <a:bodyPr wrap="square" lIns="0" tIns="0" rIns="0" bIns="0" rtlCol="0" anchor="t"/>
-          <a:lstStyle/>
-          <a:p>
-            <a:pPr indent="0" marL="0">
-              <a:buNone/>
-            </a:pPr>
-            <a:r>
-              <a:rPr lang="en-US" sz="1600" b="1" dirty="0">
-                <a:solidFill>
-                  <a:schemeClr val="tx1"/>
-                </a:solidFill>
-              </a:rPr>
-              <a:t>Teoria e anatomia demonstrativa</a:t>
-            </a:r>
-            <a:endParaRPr lang="en-US" sz="1600" dirty="0"/>
-          </a:p>
-        </p:txBody>
-      </p:sp>
-      <p:sp>
-        <p:nvSpPr>
-          <p:cNvPr id="6" name="Boston texto"/>
-          <p:cNvSpPr txBox="1"/>
-          <p:nvPr/>
-        </p:nvSpPr>
-        <p:spPr>
-          <a:xfrm>
-            <a:off x="1188720" y="3977640"/>
-            <a:ext cx="4389120" cy="1463040"/>
-          </a:xfrm>
-          <a:prstGeom prst="rect">
-            <a:avLst/>
-          </a:prstGeom>
-          <a:noFill/>
-          <a:ln/>
-        </p:spPr>
-        <p:txBody>
-          <a:bodyPr wrap="square" lIns="0" tIns="0" rIns="0" bIns="0" rtlCol="0" anchor="t"/>
-          <a:lstStyle/>
-          <a:p>
-            <a:pPr indent="0" marL="0">
-              <a:lnSpc>
-                <a:spcPct val="115000"/>
-              </a:lnSpc>
-              <a:buNone/>
-            </a:pPr>
-            <a:r>
-              <a:rPr lang="en-US" sz="1400" dirty="0">
-                <a:solidFill>
-                  <a:schemeClr val="tx2"/>
-                </a:solidFill>
-              </a:rPr>
-              <a:t>3 dias em ambiente acadêmico: aulas científicas, anatomy review com anatomista e demonstração de dissecação.</a:t>
-            </a:r>
-            <a:endParaRPr lang="en-US" sz="1400" dirty="0"/>
-          </a:p>
-        </p:txBody>
-      </p:sp>
-      <p:sp>
-        <p:nvSpPr>
-          <p:cNvPr id="7" name="Cartão Miami"/>
+              <a:t>Anatomia avançada de cabeça e pescoço aplicada a injetáveis</a:t>
+            </a:r>
+            <a:endParaRPr lang="en-US" sz="2400" dirty="0"/>
+          </a:p>
+        </p:txBody>
+      </p:sp>
+      <p:sp>
+        <p:nvSpPr>
+          <p:cNvPr id="6" name="Fio 2"/>
           <p:cNvSpPr/>
           <p:nvPr/>
         </p:nvSpPr>
         <p:spPr>
           <a:xfrm>
-            <a:off x="6217920" y="2011680"/>
-            <a:ext cx="5239512" cy="3840480"/>
-          </a:xfrm>
-          <a:prstGeom prst="rect">
-            <a:avLst/>
-          </a:prstGeom>
-          <a:solidFill>
-            <a:schemeClr val="accent1"/>
-          </a:solidFill>
+            <a:off x="731520" y="3118104"/>
+            <a:ext cx="10725912" cy="0"/>
+          </a:xfrm>
+          <a:prstGeom prst="line">
+            <a:avLst/>
+          </a:prstGeom>
+          <a:noFill/>
           <a:ln w="12700">
             <a:solidFill>
-              <a:schemeClr val="accent1"/>
+              <a:schemeClr val="accent3"/>
             </a:solidFill>
             <a:prstDash val="solid"/>
           </a:ln>
@@ -4303,14 +4355,14 @@
       </p:sp>
       <p:sp>
         <p:nvSpPr>
-          <p:cNvPr id="8" name="Miami título"/>
+          <p:cNvPr id="7" name="Módulo 2"/>
           <p:cNvSpPr txBox="1"/>
           <p:nvPr/>
         </p:nvSpPr>
         <p:spPr>
           <a:xfrm>
-            <a:off x="6675120" y="2423160"/>
-            <a:ext cx="4389120" cy="822960"/>
+            <a:off x="731520" y="3246120"/>
+            <a:ext cx="10698480" cy="548640"/>
           </a:xfrm>
           <a:prstGeom prst="rect">
             <a:avLst/>
@@ -4319,37 +4371,60 @@
           <a:ln/>
         </p:spPr>
         <p:txBody>
-          <a:bodyPr wrap="square" lIns="0" tIns="0" rIns="0" bIns="0" rtlCol="0" anchor="t"/>
+          <a:bodyPr wrap="square" lIns="0" tIns="0" rIns="0" bIns="0" rtlCol="0" anchor="ctr"/>
           <a:lstStyle/>
           <a:p>
             <a:pPr indent="0" marL="0">
               <a:buNone/>
             </a:pPr>
             <a:r>
-              <a:rPr lang="en-US" sz="4800" dirty="0">
-                <a:solidFill>
-                  <a:schemeClr val="bg1"/>
+              <a:rPr lang="en-US" sz="2400" dirty="0">
+                <a:solidFill>
+                  <a:schemeClr val="tx1"/>
                 </a:solidFill>
                 <a:latin typeface="Garamond" pitchFamily="34" charset="0"/>
                 <a:ea typeface="Garamond" pitchFamily="34" charset="-122"/>
                 <a:cs typeface="Garamond" pitchFamily="34" charset="-120"/>
               </a:rPr>
-              <a:t>Miami</a:t>
-            </a:r>
-            <a:endParaRPr lang="en-US" sz="4800" dirty="0"/>
-          </a:p>
-        </p:txBody>
-      </p:sp>
-      <p:sp>
-        <p:nvSpPr>
-          <p:cNvPr id="9" name="Miami subtítulo"/>
+              <a:t>Anatomia avançada de cabeça e pescoço aplicada a fios faciais</a:t>
+            </a:r>
+            <a:endParaRPr lang="en-US" sz="2400" dirty="0"/>
+          </a:p>
+        </p:txBody>
+      </p:sp>
+      <p:sp>
+        <p:nvSpPr>
+          <p:cNvPr id="8" name="Fio 3"/>
+          <p:cNvSpPr/>
+          <p:nvPr/>
+        </p:nvSpPr>
+        <p:spPr>
+          <a:xfrm>
+            <a:off x="731520" y="3904488"/>
+            <a:ext cx="10725912" cy="0"/>
+          </a:xfrm>
+          <a:prstGeom prst="line">
+            <a:avLst/>
+          </a:prstGeom>
+          <a:noFill/>
+          <a:ln w="12700">
+            <a:solidFill>
+              <a:schemeClr val="accent3"/>
+            </a:solidFill>
+            <a:prstDash val="solid"/>
+          </a:ln>
+        </p:spPr>
+      </p:sp>
+      <p:sp>
+        <p:nvSpPr>
+          <p:cNvPr id="9" name="Módulo 3"/>
           <p:cNvSpPr txBox="1"/>
           <p:nvPr/>
         </p:nvSpPr>
         <p:spPr>
           <a:xfrm>
-            <a:off x="6675120" y="3383280"/>
-            <a:ext cx="4389120" cy="457200"/>
+            <a:off x="731520" y="4032504"/>
+            <a:ext cx="10698480" cy="548640"/>
           </a:xfrm>
           <a:prstGeom prst="rect">
             <a:avLst/>
@@ -4358,34 +4433,60 @@
           <a:ln/>
         </p:spPr>
         <p:txBody>
-          <a:bodyPr wrap="square" lIns="0" tIns="0" rIns="0" bIns="0" rtlCol="0" anchor="t"/>
+          <a:bodyPr wrap="square" lIns="0" tIns="0" rIns="0" bIns="0" rtlCol="0" anchor="ctr"/>
           <a:lstStyle/>
           <a:p>
             <a:pPr indent="0" marL="0">
               <a:buNone/>
             </a:pPr>
             <a:r>
-              <a:rPr lang="en-US" sz="1600" b="1" dirty="0">
-                <a:solidFill>
-                  <a:schemeClr val="bg1"/>
-                </a:solidFill>
-              </a:rPr>
-              <a:t>Prática real e hands-on</a:t>
-            </a:r>
-            <a:endParaRPr lang="en-US" sz="1600" dirty="0"/>
-          </a:p>
-        </p:txBody>
-      </p:sp>
-      <p:sp>
-        <p:nvSpPr>
-          <p:cNvPr id="10" name="Miami texto"/>
+              <a:rPr lang="en-US" sz="2400" dirty="0">
+                <a:solidFill>
+                  <a:schemeClr val="tx1"/>
+                </a:solidFill>
+                <a:latin typeface="Garamond" pitchFamily="34" charset="0"/>
+                <a:ea typeface="Garamond" pitchFamily="34" charset="-122"/>
+                <a:cs typeface="Garamond" pitchFamily="34" charset="-120"/>
+              </a:rPr>
+              <a:t>Bioestimuladores faciais e corporais: fundamentos, indicações e limites</a:t>
+            </a:r>
+            <a:endParaRPr lang="en-US" sz="2400" dirty="0"/>
+          </a:p>
+        </p:txBody>
+      </p:sp>
+      <p:sp>
+        <p:nvSpPr>
+          <p:cNvPr id="10" name="Fio 4"/>
+          <p:cNvSpPr/>
+          <p:nvPr/>
+        </p:nvSpPr>
+        <p:spPr>
+          <a:xfrm>
+            <a:off x="731520" y="4690872"/>
+            <a:ext cx="10725912" cy="0"/>
+          </a:xfrm>
+          <a:prstGeom prst="line">
+            <a:avLst/>
+          </a:prstGeom>
+          <a:noFill/>
+          <a:ln w="12700">
+            <a:solidFill>
+              <a:schemeClr val="accent3"/>
+            </a:solidFill>
+            <a:prstDash val="solid"/>
+          </a:ln>
+        </p:spPr>
+      </p:sp>
+      <p:sp>
+        <p:nvSpPr>
+          <p:cNvPr id="11" name="Módulo 4"/>
           <p:cNvSpPr txBox="1"/>
           <p:nvPr/>
         </p:nvSpPr>
         <p:spPr>
           <a:xfrm>
-            <a:off x="6675120" y="3977640"/>
-            <a:ext cx="4389120" cy="1463040"/>
+            <a:off x="731520" y="4818888"/>
+            <a:ext cx="10698480" cy="548640"/>
           </a:xfrm>
           <a:prstGeom prst="rect">
             <a:avLst/>
@@ -4394,26 +4495,111 @@
           <a:ln/>
         </p:spPr>
         <p:txBody>
-          <a:bodyPr wrap="square" lIns="0" tIns="0" rIns="0" bIns="0" rtlCol="0" anchor="t"/>
+          <a:bodyPr wrap="square" lIns="0" tIns="0" rIns="0" bIns="0" rtlCol="0" anchor="ctr"/>
           <a:lstStyle/>
           <a:p>
             <a:pPr indent="0" marL="0">
-              <a:lnSpc>
-                <a:spcPct val="115000"/>
-              </a:lnSpc>
-              <a:buNone/>
-            </a:pPr>
-            <a:r>
-              <a:rPr lang="en-US" sz="1400" dirty="0">
-                <a:solidFill>
-                  <a:schemeClr val="accent4"/>
-                </a:solidFill>
-              </a:rPr>
-              <a:t>19, 20 e 21 de maio de 2027, em laboratório de specimen: anatomia aplicada e prática supervisionada dos procedimentos.</a:t>
-            </a:r>
-            <a:endParaRPr lang="en-US" sz="1400" dirty="0"/>
-          </a:p>
-        </p:txBody>
+              <a:buNone/>
+            </a:pPr>
+            <a:r>
+              <a:rPr lang="en-US" sz="2400" dirty="0">
+                <a:solidFill>
+                  <a:schemeClr val="tx1"/>
+                </a:solidFill>
+                <a:latin typeface="Garamond" pitchFamily="34" charset="0"/>
+                <a:ea typeface="Garamond" pitchFamily="34" charset="-122"/>
+                <a:cs typeface="Garamond" pitchFamily="34" charset="-120"/>
+              </a:rPr>
+              <a:t>Lifting facial com preenchedores: raciocínio anatômico e estrutural</a:t>
+            </a:r>
+            <a:endParaRPr lang="en-US" sz="2400" dirty="0"/>
+          </a:p>
+        </p:txBody>
+      </p:sp>
+      <p:sp>
+        <p:nvSpPr>
+          <p:cNvPr id="12" name="Fio 5"/>
+          <p:cNvSpPr/>
+          <p:nvPr/>
+        </p:nvSpPr>
+        <p:spPr>
+          <a:xfrm>
+            <a:off x="731520" y="5477256"/>
+            <a:ext cx="10725912" cy="0"/>
+          </a:xfrm>
+          <a:prstGeom prst="line">
+            <a:avLst/>
+          </a:prstGeom>
+          <a:noFill/>
+          <a:ln w="12700">
+            <a:solidFill>
+              <a:schemeClr val="accent3"/>
+            </a:solidFill>
+            <a:prstDash val="solid"/>
+          </a:ln>
+        </p:spPr>
+      </p:sp>
+      <p:sp>
+        <p:nvSpPr>
+          <p:cNvPr id="13" name="Módulo 5"/>
+          <p:cNvSpPr txBox="1"/>
+          <p:nvPr/>
+        </p:nvSpPr>
+        <p:spPr>
+          <a:xfrm>
+            <a:off x="731520" y="5605272"/>
+            <a:ext cx="10698480" cy="548640"/>
+          </a:xfrm>
+          <a:prstGeom prst="rect">
+            <a:avLst/>
+          </a:prstGeom>
+          <a:noFill/>
+          <a:ln/>
+        </p:spPr>
+        <p:txBody>
+          <a:bodyPr wrap="square" lIns="0" tIns="0" rIns="0" bIns="0" rtlCol="0" anchor="ctr"/>
+          <a:lstStyle/>
+          <a:p>
+            <a:pPr indent="0" marL="0">
+              <a:buNone/>
+            </a:pPr>
+            <a:r>
+              <a:rPr lang="en-US" sz="2400" dirty="0">
+                <a:solidFill>
+                  <a:schemeClr val="tx1"/>
+                </a:solidFill>
+                <a:latin typeface="Garamond" pitchFamily="34" charset="0"/>
+                <a:ea typeface="Garamond" pitchFamily="34" charset="-122"/>
+                <a:cs typeface="Garamond" pitchFamily="34" charset="-120"/>
+              </a:rPr>
+              <a:t>Full face: planejamento anatômico, segurança e naturalidade</a:t>
+            </a:r>
+            <a:endParaRPr lang="en-US" sz="2400" dirty="0"/>
+          </a:p>
+        </p:txBody>
+      </p:sp>
+      <p:sp>
+        <p:nvSpPr>
+          <p:cNvPr id="14" name="Fio final"/>
+          <p:cNvSpPr/>
+          <p:nvPr/>
+        </p:nvSpPr>
+        <p:spPr>
+          <a:xfrm>
+            <a:off x="731520" y="6263640"/>
+            <a:ext cx="10725912" cy="0"/>
+          </a:xfrm>
+          <a:prstGeom prst="line">
+            <a:avLst/>
+          </a:prstGeom>
+          <a:noFill/>
+          <a:ln w="12700">
+            <a:solidFill>
+              <a:schemeClr val="accent3"/>
+            </a:solidFill>
+            <a:prstDash val="solid"/>
+          </a:ln>
+        </p:spPr>
       </p:sp>
       <p:sp>
         <p:nvSpPr>
@@ -4488,79 +4674,9 @@
           <a:chExt cx="0" cy="0"/>
         </a:xfrm>
       </p:grpSpPr>
-      <p:pic>
-        <p:nvPicPr>
-          <p:cNvPr id="2" name="Print Instagram" descr="Perfil @dra.rosanaa no Instagram, com 339 mil seguidores">    </p:cNvPr>
-          <p:cNvPicPr>
-            <a:picLocks noChangeAspect="1"/>
-          </p:cNvPicPr>
-          <p:nvPr/>
-        </p:nvPicPr>
-        <p:blipFill>
-          <a:blip r:embed="rId1"/>
-          <a:stretch>
-            <a:fillRect/>
-          </a:stretch>
-        </p:blipFill>
-        <p:spPr>
-          <a:xfrm>
-            <a:off x="8366760" y="685800"/>
-            <a:ext cx="3182112" cy="5477256"/>
-          </a:xfrm>
-          <a:prstGeom prst="rect">
-            <a:avLst/>
-          </a:prstGeom>
-          <a:effectLst>
-            <a:outerShdw sx="100000" sy="100000" kx="0" ky="0" algn="bl" rotWithShape="0" blurRad="152400" dist="50800" dir="5400000">
-              <a:srgbClr val="2B2A29">
-                <a:alpha val="25000"/>
-              </a:srgbClr>
-            </a:outerShdw>
-          </a:effectLst>
-        </p:spPr>
-      </p:pic>
-      <p:sp>
-        <p:nvSpPr>
-          <p:cNvPr id="3" name="Text 0"/>
-          <p:cNvSpPr txBox="1"/>
-          <p:nvPr/>
-        </p:nvSpPr>
-        <p:spPr>
-          <a:xfrm>
-            <a:off x="731520" y="411480"/>
-            <a:ext cx="5486400" cy="411480"/>
-          </a:xfrm>
-          <a:prstGeom prst="rect">
-            <a:avLst/>
-          </a:prstGeom>
-          <a:noFill/>
-          <a:ln/>
-        </p:spPr>
-        <p:txBody>
-          <a:bodyPr wrap="square" lIns="0" tIns="0" rIns="0" bIns="0" rtlCol="0" anchor="t"/>
-          <a:lstStyle/>
-          <a:p>
-            <a:pPr indent="0" marL="0">
-              <a:buNone/>
-            </a:pPr>
-            <a:r>
-              <a:rPr lang="en-US" sz="2200" i="1" dirty="0">
-                <a:solidFill>
-                  <a:schemeClr val="tx2"/>
-                </a:solidFill>
-                <a:latin typeface="Garamond" pitchFamily="34" charset="0"/>
-                <a:ea typeface="Garamond" pitchFamily="34" charset="-122"/>
-                <a:cs typeface="Garamond" pitchFamily="34" charset="-120"/>
-              </a:rPr>
-              <a:t>O poder do</a:t>
-            </a:r>
-            <a:endParaRPr lang="en-US" sz="2200" dirty="0"/>
-          </a:p>
-        </p:txBody>
-      </p:sp>
-      <p:sp>
-        <p:nvSpPr>
-          <p:cNvPr id="4" name="Text 0"/>
+      <p:sp>
+        <p:nvSpPr>
+          <p:cNvPr id="2" name="Text 0"/>
           <p:cNvSpPr/>
           <p:nvPr>
             <p:ph idx="100" type="title" hasCustomPrompt="1"/>
@@ -4593,7 +4709,7 @@
                 <a:ea typeface="Garamond" pitchFamily="34" charset="-122"/>
                 <a:cs typeface="Garamond" pitchFamily="34" charset="-120"/>
               </a:rPr>
-              <a:t>Posicionamento</a:t>
+              <a:t>Da teoria à prática</a:t>
             </a:r>
             <a:endParaRPr lang="en-US" sz="4400" dirty="0"/>
           </a:p>
@@ -4601,55 +4717,21 @@
       </p:sp>
       <p:sp>
         <p:nvSpPr>
-          <p:cNvPr id="5" name="Text 2"/>
-          <p:cNvSpPr txBox="1"/>
-          <p:nvPr/>
-        </p:nvSpPr>
-        <p:spPr>
-          <a:xfrm>
-            <a:off x="731520" y="1874520"/>
-            <a:ext cx="6949440" cy="548640"/>
-          </a:xfrm>
-          <a:prstGeom prst="rect">
-            <a:avLst/>
-          </a:prstGeom>
-          <a:noFill/>
-          <a:ln/>
-        </p:spPr>
-        <p:txBody>
-          <a:bodyPr wrap="square" lIns="0" tIns="0" rIns="0" bIns="0" rtlCol="0" anchor="t"/>
-          <a:lstStyle/>
-          <a:p>
-            <a:pPr indent="0" marL="0">
-              <a:buNone/>
-            </a:pPr>
-            <a:r>
-              <a:rPr lang="en-US" sz="1500" dirty="0">
-                <a:solidFill>
-                  <a:schemeClr val="tx2"/>
-                </a:solidFill>
-              </a:rPr>
-              <a:t>Um programa realizado em Boston e Miami reúne, além do conteúdo técnico:</a:t>
-            </a:r>
-            <a:endParaRPr lang="en-US" sz="1500" dirty="0"/>
-          </a:p>
-        </p:txBody>
-      </p:sp>
-      <p:sp>
-        <p:nvSpPr>
-          <p:cNvPr id="6" name="Fio 1"/>
+          <p:cNvPr id="3" name="Cartão Boston"/>
           <p:cNvSpPr/>
           <p:nvPr/>
         </p:nvSpPr>
         <p:spPr>
           <a:xfrm>
-            <a:off x="731520" y="2651760"/>
-            <a:ext cx="6949440" cy="0"/>
-          </a:xfrm>
-          <a:prstGeom prst="line">
-            <a:avLst/>
-          </a:prstGeom>
-          <a:noFill/>
+            <a:off x="731520" y="2011680"/>
+            <a:ext cx="5239512" cy="3840480"/>
+          </a:xfrm>
+          <a:prstGeom prst="rect">
+            <a:avLst/>
+          </a:prstGeom>
+          <a:solidFill>
+            <a:schemeClr val="bg1"/>
+          </a:solidFill>
           <a:ln w="12700">
             <a:solidFill>
               <a:schemeClr val="accent3"/>
@@ -4660,14 +4742,14 @@
       </p:sp>
       <p:sp>
         <p:nvSpPr>
-          <p:cNvPr id="7" name="Item 1 título"/>
+          <p:cNvPr id="4" name="Boston título"/>
           <p:cNvSpPr txBox="1"/>
           <p:nvPr/>
         </p:nvSpPr>
         <p:spPr>
           <a:xfrm>
-            <a:off x="731520" y="2788920"/>
-            <a:ext cx="6949440" cy="411480"/>
+            <a:off x="1188720" y="2423160"/>
+            <a:ext cx="4389120" cy="822960"/>
           </a:xfrm>
           <a:prstGeom prst="rect">
             <a:avLst/>
@@ -4683,7 +4765,7 @@
               <a:buNone/>
             </a:pPr>
             <a:r>
-              <a:rPr lang="en-US" sz="2400" dirty="0">
+              <a:rPr lang="en-US" sz="4800" dirty="0">
                 <a:solidFill>
                   <a:schemeClr val="accent1"/>
                 </a:solidFill>
@@ -4691,22 +4773,22 @@
                 <a:ea typeface="Garamond" pitchFamily="34" charset="-122"/>
                 <a:cs typeface="Garamond" pitchFamily="34" charset="-120"/>
               </a:rPr>
-              <a:t>Doutores da estética</a:t>
-            </a:r>
-            <a:endParaRPr lang="en-US" sz="2400" dirty="0"/>
-          </a:p>
-        </p:txBody>
-      </p:sp>
-      <p:sp>
-        <p:nvSpPr>
-          <p:cNvPr id="8" name="Item 1 texto"/>
+              <a:t>Boston</a:t>
+            </a:r>
+            <a:endParaRPr lang="en-US" sz="4800" dirty="0"/>
+          </a:p>
+        </p:txBody>
+      </p:sp>
+      <p:sp>
+        <p:nvSpPr>
+          <p:cNvPr id="5" name="Boston subtítulo"/>
           <p:cNvSpPr txBox="1"/>
           <p:nvPr/>
         </p:nvSpPr>
         <p:spPr>
           <a:xfrm>
-            <a:off x="731520" y="3200400"/>
-            <a:ext cx="6949440" cy="365760"/>
+            <a:off x="1188720" y="3383280"/>
+            <a:ext cx="4389120" cy="457200"/>
           </a:xfrm>
           <a:prstGeom prst="rect">
             <a:avLst/>
@@ -4722,12 +4804,51 @@
               <a:buNone/>
             </a:pPr>
             <a:r>
+              <a:rPr lang="en-US" sz="1600" b="1" dirty="0">
+                <a:solidFill>
+                  <a:schemeClr val="tx1"/>
+                </a:solidFill>
+              </a:rPr>
+              <a:t>Teoria e anatomia demonstrativa</a:t>
+            </a:r>
+            <a:endParaRPr lang="en-US" sz="1600" dirty="0"/>
+          </a:p>
+        </p:txBody>
+      </p:sp>
+      <p:sp>
+        <p:nvSpPr>
+          <p:cNvPr id="6" name="Boston texto"/>
+          <p:cNvSpPr txBox="1"/>
+          <p:nvPr/>
+        </p:nvSpPr>
+        <p:spPr>
+          <a:xfrm>
+            <a:off x="1188720" y="3977640"/>
+            <a:ext cx="4389120" cy="1463040"/>
+          </a:xfrm>
+          <a:prstGeom prst="rect">
+            <a:avLst/>
+          </a:prstGeom>
+          <a:noFill/>
+          <a:ln/>
+        </p:spPr>
+        <p:txBody>
+          <a:bodyPr wrap="square" lIns="0" tIns="0" rIns="0" bIns="0" rtlCol="0" anchor="t"/>
+          <a:lstStyle/>
+          <a:p>
+            <a:pPr indent="0" marL="0">
+              <a:lnSpc>
+                <a:spcPct val="115000"/>
+              </a:lnSpc>
+              <a:buNone/>
+            </a:pPr>
+            <a:r>
               <a:rPr lang="en-US" sz="1400" dirty="0">
                 <a:solidFill>
                   <a:schemeClr val="tx2"/>
                 </a:solidFill>
               </a:rPr>
-              <a:t>nacionais e internacionais</a:t>
+              <a:t>3 dias em ambiente acadêmico: aulas científicas, anatomy review com anatomista e demonstração de dissecação.</a:t>
             </a:r>
             <a:endParaRPr lang="en-US" sz="1400" dirty="0"/>
           </a:p>
@@ -4735,22 +4856,24 @@
       </p:sp>
       <p:sp>
         <p:nvSpPr>
-          <p:cNvPr id="9" name="Fio 2"/>
+          <p:cNvPr id="7" name="Cartão Miami"/>
           <p:cNvSpPr/>
           <p:nvPr/>
         </p:nvSpPr>
         <p:spPr>
           <a:xfrm>
-            <a:off x="731520" y="3657600"/>
-            <a:ext cx="6949440" cy="0"/>
-          </a:xfrm>
-          <a:prstGeom prst="line">
-            <a:avLst/>
-          </a:prstGeom>
-          <a:noFill/>
+            <a:off x="6217920" y="2011680"/>
+            <a:ext cx="5239512" cy="3840480"/>
+          </a:xfrm>
+          <a:prstGeom prst="rect">
+            <a:avLst/>
+          </a:prstGeom>
+          <a:solidFill>
+            <a:schemeClr val="accent1"/>
+          </a:solidFill>
           <a:ln w="12700">
             <a:solidFill>
-              <a:schemeClr val="accent3"/>
+              <a:schemeClr val="accent1"/>
             </a:solidFill>
             <a:prstDash val="solid"/>
           </a:ln>
@@ -4758,14 +4881,14 @@
       </p:sp>
       <p:sp>
         <p:nvSpPr>
-          <p:cNvPr id="10" name="Item 2 título"/>
+          <p:cNvPr id="8" name="Miami título"/>
           <p:cNvSpPr txBox="1"/>
           <p:nvPr/>
         </p:nvSpPr>
         <p:spPr>
           <a:xfrm>
-            <a:off x="731520" y="3794760"/>
-            <a:ext cx="6949440" cy="411480"/>
+            <a:off x="6675120" y="2423160"/>
+            <a:ext cx="4389120" cy="822960"/>
           </a:xfrm>
           <a:prstGeom prst="rect">
             <a:avLst/>
@@ -4781,30 +4904,30 @@
               <a:buNone/>
             </a:pPr>
             <a:r>
-              <a:rPr lang="en-US" sz="2400" dirty="0">
-                <a:solidFill>
-                  <a:schemeClr val="accent1"/>
+              <a:rPr lang="en-US" sz="4800" dirty="0">
+                <a:solidFill>
+                  <a:schemeClr val="bg1"/>
                 </a:solidFill>
                 <a:latin typeface="Garamond" pitchFamily="34" charset="0"/>
                 <a:ea typeface="Garamond" pitchFamily="34" charset="-122"/>
                 <a:cs typeface="Garamond" pitchFamily="34" charset="-120"/>
               </a:rPr>
-              <a:t>Convidados</a:t>
-            </a:r>
-            <a:endParaRPr lang="en-US" sz="2400" dirty="0"/>
-          </a:p>
-        </p:txBody>
-      </p:sp>
-      <p:sp>
-        <p:nvSpPr>
-          <p:cNvPr id="11" name="Item 2 texto"/>
+              <a:t>Miami</a:t>
+            </a:r>
+            <a:endParaRPr lang="en-US" sz="4800" dirty="0"/>
+          </a:p>
+        </p:txBody>
+      </p:sp>
+      <p:sp>
+        <p:nvSpPr>
+          <p:cNvPr id="9" name="Miami subtítulo"/>
           <p:cNvSpPr txBox="1"/>
           <p:nvPr/>
         </p:nvSpPr>
         <p:spPr>
           <a:xfrm>
-            <a:off x="731520" y="4206240"/>
-            <a:ext cx="6949440" cy="365760"/>
+            <a:off x="6675120" y="3383280"/>
+            <a:ext cx="4389120" cy="457200"/>
           </a:xfrm>
           <a:prstGeom prst="rect">
             <a:avLst/>
@@ -4820,148 +4943,53 @@
               <a:buNone/>
             </a:pPr>
             <a:r>
+              <a:rPr lang="en-US" sz="1600" b="1" dirty="0">
+                <a:solidFill>
+                  <a:schemeClr val="bg1"/>
+                </a:solidFill>
+              </a:rPr>
+              <a:t>Prática real e hands-on</a:t>
+            </a:r>
+            <a:endParaRPr lang="en-US" sz="1600" dirty="0"/>
+          </a:p>
+        </p:txBody>
+      </p:sp>
+      <p:sp>
+        <p:nvSpPr>
+          <p:cNvPr id="10" name="Miami texto"/>
+          <p:cNvSpPr txBox="1"/>
+          <p:nvPr/>
+        </p:nvSpPr>
+        <p:spPr>
+          <a:xfrm>
+            <a:off x="6675120" y="3977640"/>
+            <a:ext cx="4389120" cy="1463040"/>
+          </a:xfrm>
+          <a:prstGeom prst="rect">
+            <a:avLst/>
+          </a:prstGeom>
+          <a:noFill/>
+          <a:ln/>
+        </p:spPr>
+        <p:txBody>
+          <a:bodyPr wrap="square" lIns="0" tIns="0" rIns="0" bIns="0" rtlCol="0" anchor="t"/>
+          <a:lstStyle/>
+          <a:p>
+            <a:pPr indent="0" marL="0">
+              <a:lnSpc>
+                <a:spcPct val="115000"/>
+              </a:lnSpc>
+              <a:buNone/>
+            </a:pPr>
+            <a:r>
               <a:rPr lang="en-US" sz="1400" dirty="0">
                 <a:solidFill>
-                  <a:schemeClr val="tx2"/>
-                </a:solidFill>
-              </a:rPr>
-              <a:t>com cases reais de sucesso na estética e no empreendedorismo</a:t>
+                  <a:schemeClr val="accent4"/>
+                </a:solidFill>
+              </a:rPr>
+              <a:t>19, 20 e 21 de maio de 2027, em laboratório de specimen: anatomia aplicada e prática supervisionada dos procedimentos.</a:t>
             </a:r>
             <a:endParaRPr lang="en-US" sz="1400" dirty="0"/>
-          </a:p>
-        </p:txBody>
-      </p:sp>
-      <p:sp>
-        <p:nvSpPr>
-          <p:cNvPr id="12" name="Fio 3"/>
-          <p:cNvSpPr/>
-          <p:nvPr/>
-        </p:nvSpPr>
-        <p:spPr>
-          <a:xfrm>
-            <a:off x="731520" y="4663440"/>
-            <a:ext cx="6949440" cy="0"/>
-          </a:xfrm>
-          <a:prstGeom prst="line">
-            <a:avLst/>
-          </a:prstGeom>
-          <a:noFill/>
-          <a:ln w="12700">
-            <a:solidFill>
-              <a:schemeClr val="accent3"/>
-            </a:solidFill>
-            <a:prstDash val="solid"/>
-          </a:ln>
-        </p:spPr>
-      </p:sp>
-      <p:sp>
-        <p:nvSpPr>
-          <p:cNvPr id="13" name="Item 3 título"/>
-          <p:cNvSpPr txBox="1"/>
-          <p:nvPr/>
-        </p:nvSpPr>
-        <p:spPr>
-          <a:xfrm>
-            <a:off x="731520" y="4800600"/>
-            <a:ext cx="6949440" cy="411480"/>
-          </a:xfrm>
-          <a:prstGeom prst="rect">
-            <a:avLst/>
-          </a:prstGeom>
-          <a:noFill/>
-          <a:ln/>
-        </p:spPr>
-        <p:txBody>
-          <a:bodyPr wrap="square" lIns="0" tIns="0" rIns="0" bIns="0" rtlCol="0" anchor="t"/>
-          <a:lstStyle/>
-          <a:p>
-            <a:pPr indent="0" marL="0">
-              <a:buNone/>
-            </a:pPr>
-            <a:r>
-              <a:rPr lang="en-US" sz="2400" dirty="0">
-                <a:solidFill>
-                  <a:schemeClr val="accent1"/>
-                </a:solidFill>
-                <a:latin typeface="Garamond" pitchFamily="34" charset="0"/>
-                <a:ea typeface="Garamond" pitchFamily="34" charset="-122"/>
-                <a:cs typeface="Garamond" pitchFamily="34" charset="-120"/>
-              </a:rPr>
-              <a:t>Palestrantes</a:t>
-            </a:r>
-            <a:endParaRPr lang="en-US" sz="2400" dirty="0"/>
-          </a:p>
-        </p:txBody>
-      </p:sp>
-      <p:sp>
-        <p:nvSpPr>
-          <p:cNvPr id="14" name="Item 3 texto"/>
-          <p:cNvSpPr txBox="1"/>
-          <p:nvPr/>
-        </p:nvSpPr>
-        <p:spPr>
-          <a:xfrm>
-            <a:off x="731520" y="5212080"/>
-            <a:ext cx="6949440" cy="365760"/>
-          </a:xfrm>
-          <a:prstGeom prst="rect">
-            <a:avLst/>
-          </a:prstGeom>
-          <a:noFill/>
-          <a:ln/>
-        </p:spPr>
-        <p:txBody>
-          <a:bodyPr wrap="square" lIns="0" tIns="0" rIns="0" bIns="0" rtlCol="0" anchor="t"/>
-          <a:lstStyle/>
-          <a:p>
-            <a:pPr indent="0" marL="0">
-              <a:buNone/>
-            </a:pPr>
-            <a:r>
-              <a:rPr lang="en-US" sz="1400" dirty="0">
-                <a:solidFill>
-                  <a:schemeClr val="tx2"/>
-                </a:solidFill>
-              </a:rPr>
-              <a:t>que atuam com carreira, posicionamento e autoridade</a:t>
-            </a:r>
-            <a:endParaRPr lang="en-US" sz="1400" dirty="0"/>
-          </a:p>
-        </p:txBody>
-      </p:sp>
-      <p:sp>
-        <p:nvSpPr>
-          <p:cNvPr id="15" name="Text 12"/>
-          <p:cNvSpPr txBox="1"/>
-          <p:nvPr/>
-        </p:nvSpPr>
-        <p:spPr>
-          <a:xfrm>
-            <a:off x="731520" y="5760720"/>
-            <a:ext cx="7132320" cy="457200"/>
-          </a:xfrm>
-          <a:prstGeom prst="rect">
-            <a:avLst/>
-          </a:prstGeom>
-          <a:noFill/>
-          <a:ln/>
-        </p:spPr>
-        <p:txBody>
-          <a:bodyPr wrap="square" lIns="0" tIns="0" rIns="0" bIns="0" rtlCol="0" anchor="t"/>
-          <a:lstStyle/>
-          <a:p>
-            <a:pPr indent="0" marL="0">
-              <a:buNone/>
-            </a:pPr>
-            <a:r>
-              <a:rPr lang="en-US" sz="1300" i="1" dirty="0">
-                <a:solidFill>
-                  <a:schemeClr val="tx2"/>
-                </a:solidFill>
-              </a:rPr>
-              <a:t>Um momento desenhado para troca de experiências, visão de mercado e conexões profissionais relevantes.</a:t>
-            </a:r>
-            <a:endParaRPr lang="en-US" sz="1300" dirty="0"/>
           </a:p>
         </p:txBody>
       </p:sp>
@@ -5040,7 +5068,7 @@
       </p:grpSpPr>
       <p:pic>
         <p:nvPicPr>
-          <p:cNvPr id="2" name="Foto da turma" descr="Turma da Formação Internacional reunida em uma escadaria, de uniforme vinho, segurando certificados e uma bandeira de Harvard">    </p:cNvPr>
+          <p:cNvPr id="2" name="Print Instagram" descr="Perfil @dra.rosanaa no Instagram, com 339 mil seguidores">    </p:cNvPr>
           <p:cNvPicPr>
             <a:picLocks noChangeAspect="1"/>
           </p:cNvPicPr>
@@ -5054,17 +5082,63 @@
         </p:blipFill>
         <p:spPr>
           <a:xfrm>
-            <a:off x="5486400" y="0"/>
-            <a:ext cx="6705295" cy="6858000"/>
-          </a:xfrm>
-          <a:prstGeom prst="rect">
-            <a:avLst/>
-          </a:prstGeom>
+            <a:off x="8366760" y="685800"/>
+            <a:ext cx="3182112" cy="5477256"/>
+          </a:xfrm>
+          <a:prstGeom prst="rect">
+            <a:avLst/>
+          </a:prstGeom>
+          <a:effectLst>
+            <a:outerShdw sx="100000" sy="100000" kx="0" ky="0" algn="bl" rotWithShape="0" blurRad="152400" dist="50800" dir="5400000">
+              <a:srgbClr val="2B2A29">
+                <a:alpha val="25000"/>
+              </a:srgbClr>
+            </a:outerShdw>
+          </a:effectLst>
         </p:spPr>
       </p:pic>
       <p:sp>
         <p:nvSpPr>
           <p:cNvPr id="3" name="Text 0"/>
+          <p:cNvSpPr txBox="1"/>
+          <p:nvPr/>
+        </p:nvSpPr>
+        <p:spPr>
+          <a:xfrm>
+            <a:off x="731520" y="411480"/>
+            <a:ext cx="5486400" cy="411480"/>
+          </a:xfrm>
+          <a:prstGeom prst="rect">
+            <a:avLst/>
+          </a:prstGeom>
+          <a:noFill/>
+          <a:ln/>
+        </p:spPr>
+        <p:txBody>
+          <a:bodyPr wrap="square" lIns="0" tIns="0" rIns="0" bIns="0" rtlCol="0" anchor="t"/>
+          <a:lstStyle/>
+          <a:p>
+            <a:pPr indent="0" marL="0">
+              <a:buNone/>
+            </a:pPr>
+            <a:r>
+              <a:rPr lang="en-US" sz="2200" i="1" dirty="0">
+                <a:solidFill>
+                  <a:schemeClr val="tx2"/>
+                </a:solidFill>
+                <a:latin typeface="Garamond" pitchFamily="34" charset="0"/>
+                <a:ea typeface="Garamond" pitchFamily="34" charset="-122"/>
+                <a:cs typeface="Garamond" pitchFamily="34" charset="-120"/>
+              </a:rPr>
+              <a:t>O poder do</a:t>
+            </a:r>
+            <a:endParaRPr lang="en-US" sz="2200" dirty="0"/>
+          </a:p>
+        </p:txBody>
+      </p:sp>
+      <p:sp>
+        <p:nvSpPr>
+          <p:cNvPr id="4" name="Text 0"/>
           <p:cNvSpPr/>
           <p:nvPr>
             <p:ph idx="100" type="title" hasCustomPrompt="1"/>
@@ -5097,7 +5171,7 @@
                 <a:ea typeface="Garamond" pitchFamily="34" charset="-122"/>
                 <a:cs typeface="Garamond" pitchFamily="34" charset="-120"/>
               </a:rPr>
-              <a:t>Quem já viveu</a:t>
+              <a:t>Posicionamento</a:t>
             </a:r>
             <a:endParaRPr lang="en-US" sz="4400" dirty="0"/>
           </a:p>
@@ -5105,14 +5179,14 @@
       </p:sp>
       <p:sp>
         <p:nvSpPr>
-          <p:cNvPr id="4" name="Text 1"/>
+          <p:cNvPr id="5" name="Text 2"/>
           <p:cNvSpPr txBox="1"/>
           <p:nvPr/>
         </p:nvSpPr>
         <p:spPr>
           <a:xfrm>
-            <a:off x="731520" y="1920240"/>
-            <a:ext cx="4297680" cy="1280160"/>
+            <a:off x="731520" y="1874520"/>
+            <a:ext cx="6949440" cy="548640"/>
           </a:xfrm>
           <a:prstGeom prst="rect">
             <a:avLst/>
@@ -5125,41 +5199,38 @@
           <a:lstStyle/>
           <a:p>
             <a:pPr indent="0" marL="0">
-              <a:lnSpc>
-                <a:spcPct val="115000"/>
-              </a:lnSpc>
-              <a:buNone/>
-            </a:pPr>
-            <a:r>
-              <a:rPr lang="en-US" sz="1700" dirty="0">
+              <a:buNone/>
+            </a:pPr>
+            <a:r>
+              <a:rPr lang="en-US" sz="1500" dirty="0">
                 <a:solidFill>
                   <a:schemeClr val="tx2"/>
                 </a:solidFill>
               </a:rPr>
-              <a:t>Turma da Formação Internacional na etapa de Boston, com os certificados em mãos.</a:t>
-            </a:r>
-            <a:endParaRPr lang="en-US" sz="1700" dirty="0"/>
-          </a:p>
-        </p:txBody>
-      </p:sp>
-      <p:sp>
-        <p:nvSpPr>
-          <p:cNvPr id="5" name="Fio"/>
+              <a:t>Um programa realizado em Boston e Miami reúne, além do conteúdo técnico:</a:t>
+            </a:r>
+            <a:endParaRPr lang="en-US" sz="1500" dirty="0"/>
+          </a:p>
+        </p:txBody>
+      </p:sp>
+      <p:sp>
+        <p:nvSpPr>
+          <p:cNvPr id="6" name="Fio 1"/>
           <p:cNvSpPr/>
           <p:nvPr/>
         </p:nvSpPr>
         <p:spPr>
           <a:xfrm>
-            <a:off x="731520" y="3977640"/>
-            <a:ext cx="822960" cy="0"/>
+            <a:off x="731520" y="2651760"/>
+            <a:ext cx="6949440" cy="0"/>
           </a:xfrm>
           <a:prstGeom prst="line">
             <a:avLst/>
           </a:prstGeom>
           <a:noFill/>
-          <a:ln w="15875">
+          <a:ln w="12700">
             <a:solidFill>
-              <a:schemeClr val="accent2"/>
+              <a:schemeClr val="accent3"/>
             </a:solidFill>
             <a:prstDash val="solid"/>
           </a:ln>
@@ -5167,14 +5238,14 @@
       </p:sp>
       <p:sp>
         <p:nvSpPr>
-          <p:cNvPr id="6" name="Text 3"/>
+          <p:cNvPr id="7" name="Item 1 título"/>
           <p:cNvSpPr txBox="1"/>
           <p:nvPr/>
         </p:nvSpPr>
         <p:spPr>
           <a:xfrm>
-            <a:off x="731520" y="4160520"/>
-            <a:ext cx="4572000" cy="548640"/>
+            <a:off x="731520" y="2788920"/>
+            <a:ext cx="6949440" cy="411480"/>
           </a:xfrm>
           <a:prstGeom prst="rect">
             <a:avLst/>
@@ -5190,7 +5261,7 @@
               <a:buNone/>
             </a:pPr>
             <a:r>
-              <a:rPr lang="en-US" sz="2800" dirty="0">
+              <a:rPr lang="en-US" sz="2400" dirty="0">
                 <a:solidFill>
                   <a:schemeClr val="accent1"/>
                 </a:solidFill>
@@ -5198,22 +5269,22 @@
                 <a:ea typeface="Garamond" pitchFamily="34" charset="-122"/>
                 <a:cs typeface="Garamond" pitchFamily="34" charset="-120"/>
               </a:rPr>
-              <a:t>A próxima etapa é em Miami.</a:t>
-            </a:r>
-            <a:endParaRPr lang="en-US" sz="2800" dirty="0"/>
-          </a:p>
-        </p:txBody>
-      </p:sp>
-      <p:sp>
-        <p:nvSpPr>
-          <p:cNvPr id="7" name="Text 4"/>
+              <a:t>Doutores da estética</a:t>
+            </a:r>
+            <a:endParaRPr lang="en-US" sz="2400" dirty="0"/>
+          </a:p>
+        </p:txBody>
+      </p:sp>
+      <p:sp>
+        <p:nvSpPr>
+          <p:cNvPr id="8" name="Item 1 texto"/>
           <p:cNvSpPr txBox="1"/>
           <p:nvPr/>
         </p:nvSpPr>
         <p:spPr>
           <a:xfrm>
-            <a:off x="731520" y="4754880"/>
-            <a:ext cx="4572000" cy="411480"/>
+            <a:off x="731520" y="3200400"/>
+            <a:ext cx="6949440" cy="365760"/>
           </a:xfrm>
           <a:prstGeom prst="rect">
             <a:avLst/>
@@ -5229,14 +5300,246 @@
               <a:buNone/>
             </a:pPr>
             <a:r>
-              <a:rPr lang="en-US" sz="1500" dirty="0">
+              <a:rPr lang="en-US" sz="1400" dirty="0">
                 <a:solidFill>
                   <a:schemeClr val="tx2"/>
                 </a:solidFill>
               </a:rPr>
-              <a:t>19, 20 e 21 de maio de 2027</a:t>
-            </a:r>
-            <a:endParaRPr lang="en-US" sz="1500" dirty="0"/>
+              <a:t>nacionais e internacionais</a:t>
+            </a:r>
+            <a:endParaRPr lang="en-US" sz="1400" dirty="0"/>
+          </a:p>
+        </p:txBody>
+      </p:sp>
+      <p:sp>
+        <p:nvSpPr>
+          <p:cNvPr id="9" name="Fio 2"/>
+          <p:cNvSpPr/>
+          <p:nvPr/>
+        </p:nvSpPr>
+        <p:spPr>
+          <a:xfrm>
+            <a:off x="731520" y="3657600"/>
+            <a:ext cx="6949440" cy="0"/>
+          </a:xfrm>
+          <a:prstGeom prst="line">
+            <a:avLst/>
+          </a:prstGeom>
+          <a:noFill/>
+          <a:ln w="12700">
+            <a:solidFill>
+              <a:schemeClr val="accent3"/>
+            </a:solidFill>
+            <a:prstDash val="solid"/>
+          </a:ln>
+        </p:spPr>
+      </p:sp>
+      <p:sp>
+        <p:nvSpPr>
+          <p:cNvPr id="10" name="Item 2 título"/>
+          <p:cNvSpPr txBox="1"/>
+          <p:nvPr/>
+        </p:nvSpPr>
+        <p:spPr>
+          <a:xfrm>
+            <a:off x="731520" y="3794760"/>
+            <a:ext cx="6949440" cy="411480"/>
+          </a:xfrm>
+          <a:prstGeom prst="rect">
+            <a:avLst/>
+          </a:prstGeom>
+          <a:noFill/>
+          <a:ln/>
+        </p:spPr>
+        <p:txBody>
+          <a:bodyPr wrap="square" lIns="0" tIns="0" rIns="0" bIns="0" rtlCol="0" anchor="t"/>
+          <a:lstStyle/>
+          <a:p>
+            <a:pPr indent="0" marL="0">
+              <a:buNone/>
+            </a:pPr>
+            <a:r>
+              <a:rPr lang="en-US" sz="2400" dirty="0">
+                <a:solidFill>
+                  <a:schemeClr val="accent1"/>
+                </a:solidFill>
+                <a:latin typeface="Garamond" pitchFamily="34" charset="0"/>
+                <a:ea typeface="Garamond" pitchFamily="34" charset="-122"/>
+                <a:cs typeface="Garamond" pitchFamily="34" charset="-120"/>
+              </a:rPr>
+              <a:t>Convidados</a:t>
+            </a:r>
+            <a:endParaRPr lang="en-US" sz="2400" dirty="0"/>
+          </a:p>
+        </p:txBody>
+      </p:sp>
+      <p:sp>
+        <p:nvSpPr>
+          <p:cNvPr id="11" name="Item 2 texto"/>
+          <p:cNvSpPr txBox="1"/>
+          <p:nvPr/>
+        </p:nvSpPr>
+        <p:spPr>
+          <a:xfrm>
+            <a:off x="731520" y="4206240"/>
+            <a:ext cx="6949440" cy="365760"/>
+          </a:xfrm>
+          <a:prstGeom prst="rect">
+            <a:avLst/>
+          </a:prstGeom>
+          <a:noFill/>
+          <a:ln/>
+        </p:spPr>
+        <p:txBody>
+          <a:bodyPr wrap="square" lIns="0" tIns="0" rIns="0" bIns="0" rtlCol="0" anchor="t"/>
+          <a:lstStyle/>
+          <a:p>
+            <a:pPr indent="0" marL="0">
+              <a:buNone/>
+            </a:pPr>
+            <a:r>
+              <a:rPr lang="en-US" sz="1400" dirty="0">
+                <a:solidFill>
+                  <a:schemeClr val="tx2"/>
+                </a:solidFill>
+              </a:rPr>
+              <a:t>com cases reais de sucesso na estética e no empreendedorismo</a:t>
+            </a:r>
+            <a:endParaRPr lang="en-US" sz="1400" dirty="0"/>
+          </a:p>
+        </p:txBody>
+      </p:sp>
+      <p:sp>
+        <p:nvSpPr>
+          <p:cNvPr id="12" name="Fio 3"/>
+          <p:cNvSpPr/>
+          <p:nvPr/>
+        </p:nvSpPr>
+        <p:spPr>
+          <a:xfrm>
+            <a:off x="731520" y="4663440"/>
+            <a:ext cx="6949440" cy="0"/>
+          </a:xfrm>
+          <a:prstGeom prst="line">
+            <a:avLst/>
+          </a:prstGeom>
+          <a:noFill/>
+          <a:ln w="12700">
+            <a:solidFill>
+              <a:schemeClr val="accent3"/>
+            </a:solidFill>
+            <a:prstDash val="solid"/>
+          </a:ln>
+        </p:spPr>
+      </p:sp>
+      <p:sp>
+        <p:nvSpPr>
+          <p:cNvPr id="13" name="Item 3 título"/>
+          <p:cNvSpPr txBox="1"/>
+          <p:nvPr/>
+        </p:nvSpPr>
+        <p:spPr>
+          <a:xfrm>
+            <a:off x="731520" y="4800600"/>
+            <a:ext cx="6949440" cy="411480"/>
+          </a:xfrm>
+          <a:prstGeom prst="rect">
+            <a:avLst/>
+          </a:prstGeom>
+          <a:noFill/>
+          <a:ln/>
+        </p:spPr>
+        <p:txBody>
+          <a:bodyPr wrap="square" lIns="0" tIns="0" rIns="0" bIns="0" rtlCol="0" anchor="t"/>
+          <a:lstStyle/>
+          <a:p>
+            <a:pPr indent="0" marL="0">
+              <a:buNone/>
+            </a:pPr>
+            <a:r>
+              <a:rPr lang="en-US" sz="2400" dirty="0">
+                <a:solidFill>
+                  <a:schemeClr val="accent1"/>
+                </a:solidFill>
+                <a:latin typeface="Garamond" pitchFamily="34" charset="0"/>
+                <a:ea typeface="Garamond" pitchFamily="34" charset="-122"/>
+                <a:cs typeface="Garamond" pitchFamily="34" charset="-120"/>
+              </a:rPr>
+              <a:t>Palestrantes</a:t>
+            </a:r>
+            <a:endParaRPr lang="en-US" sz="2400" dirty="0"/>
+          </a:p>
+        </p:txBody>
+      </p:sp>
+      <p:sp>
+        <p:nvSpPr>
+          <p:cNvPr id="14" name="Item 3 texto"/>
+          <p:cNvSpPr txBox="1"/>
+          <p:nvPr/>
+        </p:nvSpPr>
+        <p:spPr>
+          <a:xfrm>
+            <a:off x="731520" y="5212080"/>
+            <a:ext cx="6949440" cy="365760"/>
+          </a:xfrm>
+          <a:prstGeom prst="rect">
+            <a:avLst/>
+          </a:prstGeom>
+          <a:noFill/>
+          <a:ln/>
+        </p:spPr>
+        <p:txBody>
+          <a:bodyPr wrap="square" lIns="0" tIns="0" rIns="0" bIns="0" rtlCol="0" anchor="t"/>
+          <a:lstStyle/>
+          <a:p>
+            <a:pPr indent="0" marL="0">
+              <a:buNone/>
+            </a:pPr>
+            <a:r>
+              <a:rPr lang="en-US" sz="1400" dirty="0">
+                <a:solidFill>
+                  <a:schemeClr val="tx2"/>
+                </a:solidFill>
+              </a:rPr>
+              <a:t>que atuam com carreira, posicionamento e autoridade</a:t>
+            </a:r>
+            <a:endParaRPr lang="en-US" sz="1400" dirty="0"/>
+          </a:p>
+        </p:txBody>
+      </p:sp>
+      <p:sp>
+        <p:nvSpPr>
+          <p:cNvPr id="15" name="Text 12"/>
+          <p:cNvSpPr txBox="1"/>
+          <p:nvPr/>
+        </p:nvSpPr>
+        <p:spPr>
+          <a:xfrm>
+            <a:off x="731520" y="5760720"/>
+            <a:ext cx="7132320" cy="457200"/>
+          </a:xfrm>
+          <a:prstGeom prst="rect">
+            <a:avLst/>
+          </a:prstGeom>
+          <a:noFill/>
+          <a:ln/>
+        </p:spPr>
+        <p:txBody>
+          <a:bodyPr wrap="square" lIns="0" tIns="0" rIns="0" bIns="0" rtlCol="0" anchor="t"/>
+          <a:lstStyle/>
+          <a:p>
+            <a:pPr indent="0" marL="0">
+              <a:buNone/>
+            </a:pPr>
+            <a:r>
+              <a:rPr lang="en-US" sz="1300" i="1" dirty="0">
+                <a:solidFill>
+                  <a:schemeClr val="tx2"/>
+                </a:solidFill>
+              </a:rPr>
+              <a:t>Um momento desenhado para troca de experiências, visão de mercado e conexões profissionais relevantes.</a:t>
+            </a:r>
+            <a:endParaRPr lang="en-US" sz="1300" dirty="0"/>
           </a:p>
         </p:txBody>
       </p:sp>
@@ -5313,50 +5616,9 @@
           <a:chExt cx="0" cy="0"/>
         </a:xfrm>
       </p:grpSpPr>
-      <p:sp>
-        <p:nvSpPr>
-          <p:cNvPr id="2" name="Text 0"/>
-          <p:cNvSpPr/>
-          <p:nvPr>
-            <p:ph idx="100" type="title" hasCustomPrompt="1"/>
-          </p:nvPr>
-        </p:nvSpPr>
-        <p:spPr>
-          <a:xfrm>
-            <a:off x="731520" y="777240"/>
-            <a:ext cx="10698480" cy="914400"/>
-          </a:xfrm>
-          <a:prstGeom prst="rect">
-            <a:avLst/>
-          </a:prstGeom>
-          <a:noFill/>
-          <a:ln/>
-        </p:spPr>
-        <p:txBody>
-          <a:bodyPr wrap="square" lIns="0" tIns="0" rIns="0" bIns="0" rtlCol="0" anchor="t"/>
-          <a:lstStyle/>
-          <a:p>
-            <a:pPr algn="l" indent="0" marL="0">
-              <a:buNone/>
-            </a:pPr>
-            <a:r>
-              <a:rPr lang="en-US" sz="4400" dirty="0">
-                <a:solidFill>
-                  <a:schemeClr val="bg1"/>
-                </a:solidFill>
-                <a:latin typeface="Garamond" pitchFamily="34" charset="0"/>
-                <a:ea typeface="Garamond" pitchFamily="34" charset="-122"/>
-                <a:cs typeface="Garamond" pitchFamily="34" charset="-120"/>
-              </a:rPr>
-              <a:t>O resultado na prática</a:t>
-            </a:r>
-            <a:endParaRPr lang="en-US" sz="4400" dirty="0"/>
-          </a:p>
-        </p:txBody>
-      </p:sp>
       <p:pic>
         <p:nvPicPr>
-          <p:cNvPr id="3" name="Depoimento" descr="Mensagem de aluna: depois da Formação Internacional, converteu o valor do curso em menos de 2 meses com 2 pacientes">    </p:cNvPr>
+          <p:cNvPr id="2" name="Foto da turma" descr="Turma da Formação Internacional reunida em uma escadaria, de uniforme vinho, segurando certificados e uma bandeira de Harvard">    </p:cNvPr>
           <p:cNvPicPr>
             <a:picLocks noChangeAspect="1"/>
           </p:cNvPicPr>
@@ -5370,21 +5632,55 @@
         </p:blipFill>
         <p:spPr>
           <a:xfrm>
-            <a:off x="1984248" y="2057400"/>
-            <a:ext cx="8229600" cy="2468880"/>
-          </a:xfrm>
-          <a:prstGeom prst="rect">
-            <a:avLst/>
-          </a:prstGeom>
-          <a:effectLst>
-            <a:outerShdw sx="100000" sy="100000" kx="0" ky="0" algn="bl" rotWithShape="0" blurRad="177800" dist="50800" dir="5400000">
-              <a:srgbClr val="000000">
-                <a:alpha val="35000"/>
-              </a:srgbClr>
-            </a:outerShdw>
-          </a:effectLst>
+            <a:off x="5486400" y="0"/>
+            <a:ext cx="6705295" cy="6858000"/>
+          </a:xfrm>
+          <a:prstGeom prst="rect">
+            <a:avLst/>
+          </a:prstGeom>
         </p:spPr>
       </p:pic>
+      <p:sp>
+        <p:nvSpPr>
+          <p:cNvPr id="3" name="Text 0"/>
+          <p:cNvSpPr/>
+          <p:nvPr>
+            <p:ph idx="100" type="title" hasCustomPrompt="1"/>
+          </p:nvPr>
+        </p:nvSpPr>
+        <p:spPr>
+          <a:xfrm>
+            <a:off x="731520" y="777240"/>
+            <a:ext cx="10698480" cy="914400"/>
+          </a:xfrm>
+          <a:prstGeom prst="rect">
+            <a:avLst/>
+          </a:prstGeom>
+          <a:noFill/>
+          <a:ln/>
+        </p:spPr>
+        <p:txBody>
+          <a:bodyPr wrap="square" lIns="0" tIns="0" rIns="0" bIns="0" rtlCol="0" anchor="t"/>
+          <a:lstStyle/>
+          <a:p>
+            <a:pPr algn="l" indent="0" marL="0">
+              <a:buNone/>
+            </a:pPr>
+            <a:r>
+              <a:rPr lang="en-US" sz="4400" dirty="0">
+                <a:solidFill>
+                  <a:schemeClr val="accent1"/>
+                </a:solidFill>
+                <a:latin typeface="Garamond" pitchFamily="34" charset="0"/>
+                <a:ea typeface="Garamond" pitchFamily="34" charset="-122"/>
+                <a:cs typeface="Garamond" pitchFamily="34" charset="-120"/>
+              </a:rPr>
+              <a:t>Quem já viveu</a:t>
+            </a:r>
+            <a:endParaRPr lang="en-US" sz="4400" dirty="0"/>
+          </a:p>
+        </p:txBody>
+      </p:sp>
       <p:sp>
         <p:nvSpPr>
           <p:cNvPr id="4" name="Text 1"/>
@@ -5393,8 +5689,8 @@
         </p:nvSpPr>
         <p:spPr>
           <a:xfrm>
-            <a:off x="1984248" y="4846320"/>
-            <a:ext cx="8229600" cy="365760"/>
+            <a:off x="731520" y="1920240"/>
+            <a:ext cx="4297680" cy="1280160"/>
           </a:xfrm>
           <a:prstGeom prst="rect">
             <a:avLst/>
@@ -5407,17 +5703,163 @@
           <a:lstStyle/>
           <a:p>
             <a:pPr indent="0" marL="0">
-              <a:buNone/>
-            </a:pPr>
-            <a:r>
-              <a:rPr lang="en-US" sz="1300" i="1" dirty="0">
-                <a:solidFill>
-                  <a:schemeClr val="accent4"/>
-                </a:solidFill>
-              </a:rPr>
-              <a:t>Relato de aluna da Formação Internacional, enviado no grupo da turma.</a:t>
-            </a:r>
-            <a:endParaRPr lang="en-US" sz="1300" dirty="0"/>
+              <a:lnSpc>
+                <a:spcPct val="115000"/>
+              </a:lnSpc>
+              <a:buNone/>
+            </a:pPr>
+            <a:r>
+              <a:rPr lang="en-US" sz="1700" dirty="0">
+                <a:solidFill>
+                  <a:schemeClr val="tx2"/>
+                </a:solidFill>
+              </a:rPr>
+              <a:t>Turma da Formação Internacional na etapa de Boston, com os certificados em mãos.</a:t>
+            </a:r>
+            <a:endParaRPr lang="en-US" sz="1700" dirty="0"/>
+          </a:p>
+        </p:txBody>
+      </p:sp>
+      <p:sp>
+        <p:nvSpPr>
+          <p:cNvPr id="5" name="Fio"/>
+          <p:cNvSpPr/>
+          <p:nvPr/>
+        </p:nvSpPr>
+        <p:spPr>
+          <a:xfrm>
+            <a:off x="731520" y="3977640"/>
+            <a:ext cx="822960" cy="0"/>
+          </a:xfrm>
+          <a:prstGeom prst="line">
+            <a:avLst/>
+          </a:prstGeom>
+          <a:noFill/>
+          <a:ln w="15875">
+            <a:solidFill>
+              <a:schemeClr val="accent2"/>
+            </a:solidFill>
+            <a:prstDash val="solid"/>
+          </a:ln>
+        </p:spPr>
+      </p:sp>
+      <p:sp>
+        <p:nvSpPr>
+          <p:cNvPr id="6" name="Text 3"/>
+          <p:cNvSpPr txBox="1"/>
+          <p:nvPr/>
+        </p:nvSpPr>
+        <p:spPr>
+          <a:xfrm>
+            <a:off x="731520" y="4160520"/>
+            <a:ext cx="4572000" cy="548640"/>
+          </a:xfrm>
+          <a:prstGeom prst="rect">
+            <a:avLst/>
+          </a:prstGeom>
+          <a:noFill/>
+          <a:ln/>
+        </p:spPr>
+        <p:txBody>
+          <a:bodyPr wrap="square" lIns="0" tIns="0" rIns="0" bIns="0" rtlCol="0" anchor="t"/>
+          <a:lstStyle/>
+          <a:p>
+            <a:pPr indent="0" marL="0">
+              <a:buNone/>
+            </a:pPr>
+            <a:r>
+              <a:rPr lang="en-US" sz="2800" dirty="0">
+                <a:solidFill>
+                  <a:schemeClr val="accent1"/>
+                </a:solidFill>
+                <a:latin typeface="Garamond" pitchFamily="34" charset="0"/>
+                <a:ea typeface="Garamond" pitchFamily="34" charset="-122"/>
+                <a:cs typeface="Garamond" pitchFamily="34" charset="-120"/>
+              </a:rPr>
+              <a:t>A próxima etapa é em Miami.</a:t>
+            </a:r>
+            <a:endParaRPr lang="en-US" sz="2800" dirty="0"/>
+          </a:p>
+        </p:txBody>
+      </p:sp>
+      <p:sp>
+        <p:nvSpPr>
+          <p:cNvPr id="7" name="Text 4"/>
+          <p:cNvSpPr txBox="1"/>
+          <p:nvPr/>
+        </p:nvSpPr>
+        <p:spPr>
+          <a:xfrm>
+            <a:off x="731520" y="4754880"/>
+            <a:ext cx="4572000" cy="411480"/>
+          </a:xfrm>
+          <a:prstGeom prst="rect">
+            <a:avLst/>
+          </a:prstGeom>
+          <a:noFill/>
+          <a:ln/>
+        </p:spPr>
+        <p:txBody>
+          <a:bodyPr wrap="square" lIns="0" tIns="0" rIns="0" bIns="0" rtlCol="0" anchor="t"/>
+          <a:lstStyle/>
+          <a:p>
+            <a:pPr indent="0" marL="0">
+              <a:buNone/>
+            </a:pPr>
+            <a:r>
+              <a:rPr lang="en-US" sz="1500" dirty="0">
+                <a:solidFill>
+                  <a:schemeClr val="tx2"/>
+                </a:solidFill>
+              </a:rPr>
+              <a:t>19, 20 e 21 de maio de 2027</a:t>
+            </a:r>
+            <a:endParaRPr lang="en-US" sz="1500" dirty="0"/>
+          </a:p>
+        </p:txBody>
+      </p:sp>
+      <p:sp>
+        <p:nvSpPr>
+          <p:cNvPr id="25" name="Slide Number Placeholder 0"/>
+          <p:cNvSpPr>
+            <a:spLocks noGrp="1"/>
+          </p:cNvSpPr>
+          <p:nvPr>
+            <p:ph type="sldNum" sz="quarter" idx="4294967295"/>
+          </p:nvPr>
+        </p:nvSpPr>
+        <p:spPr>
+          <a:xfrm>
+            <a:off x="11155680" y="6355080"/>
+            <a:ext cx="411480" cy="274320"/>
+          </a:xfrm>
+          <a:prstGeom prst="rect">
+            <a:avLst/>
+          </a:prstGeom>
+          <a:extLst>
+            <a:ext uri="{C572A759-6A51-4108-AA02-DFA0A04FC94B}">
+              <ma14:wrappingTextBoxFlag xmlns:ma14="http://schemas.microsoft.com/office/mac/drawingml/2011/main" val="0"/>
+            </a:ext>
+          </a:extLst>
+        </p:spPr>
+        <p:txBody>
+          <a:bodyPr/>
+          <a:lstStyle>
+            <a:lvl1pPr>
+              <a:defRPr sz="900">
+                <a:solidFill>
+                  <a:schemeClr val="tx2"/>
+                </a:solidFill>
+              </a:defRPr>
+            </a:lvl1pPr>
+          </a:lstStyle>
+          <a:p>
+            <a:pPr algn="r"/>
+            <a:fld id="{F7021451-1387-4CA6-816F-3879F97B5CBC}" type="slidenum">
+              <a:rPr b="0" lang="en-US"/>
+              <a:t>9</a:t>
+            </a:fld>
+            <a:endParaRPr lang="en-US"/>
           </a:p>
         </p:txBody>
       </p:sp>

</xml_diff>

<commit_message>
Etapa Miami: bandeira inteira no slide 2
Co-Authored-By: Claude Opus 5.5 <noreply@anthropic.com>
Claude-Session: https://claude.ai/code/session_01ETjDEHo1Y5Ziwi4pumEH8K
</commit_message>
<xml_diff>
--- a/entregas/Formacao-Internacional-Etapa-Miami.pptx
+++ b/entregas/Formacao-Internacional-Etapa-Miami.pptx
@@ -117,7 +117,7 @@
   <p:extLst>
     <p:ext uri="{521415D9-36F7-43E2-AB2F-B90AF26B5E84}">
       <p14:sectionLst xmlns:p14="http://schemas.microsoft.com/office/powerpoint/2010/main">
-        <p14:section name="Abertura" id="{27af0fbe-db16-bc55-2bd1-393f973e3b53}">
+        <p14:section name="Abertura" id="{adc64d61-c334-54ea-c45d-e094de30581a}">
           <p14:sldIdLst>
             <p14:sldId id="256"/>
             <p14:sldId id="257"/>
@@ -125,21 +125,21 @@
             <p14:sldId id="259"/>
           </p14:sldIdLst>
         </p14:section>
-        <p14:section name="A etapa" id="{1f3ca47f-40b3-434c-bd82-3a9d11258bf6}">
+        <p14:section name="A etapa" id="{120944f2-25e6-b333-fff5-daeef0ab5ce0}">
           <p14:sldIdLst>
             <p14:sldId id="260"/>
             <p14:sldId id="261"/>
             <p14:sldId id="262"/>
           </p14:sldIdLst>
         </p14:section>
-        <p14:section name="Pessoas" id="{a7287e01-13cf-0921-6c86-504e4156c5d5}">
+        <p14:section name="Pessoas" id="{ab62d7ff-c270-1613-e5ad-6a3a71bde697}">
           <p14:sldIdLst>
             <p14:sldId id="263"/>
             <p14:sldId id="264"/>
             <p14:sldId id="265"/>
           </p14:sldIdLst>
         </p14:section>
-        <p14:section name="Inscrição" id="{37d091c0-835b-f8f8-0222-65d507c432bd}">
+        <p14:section name="Inscrição" id="{324fae44-5482-928d-138d-3ddd7929beba}">
           <p14:sldIdLst>
             <p14:sldId id="266"/>
           </p14:sldIdLst>
@@ -2833,8 +2833,8 @@
         </p:blipFill>
         <p:spPr>
           <a:xfrm>
-            <a:off x="7406640" y="-137160"/>
-            <a:ext cx="4937760" cy="3291840"/>
+            <a:off x="7360920" y="274320"/>
+            <a:ext cx="4480560" cy="2990088"/>
           </a:xfrm>
           <a:prstGeom prst="rect">
             <a:avLst/>

</xml_diff>

<commit_message>
Etapa Miami: mastro da bandeira encaixado atrás da foto no slide 2
Co-Authored-By: Claude Opus 5.5 <noreply@anthropic.com>
Claude-Session: https://claude.ai/code/session_01ETjDEHo1Y5Ziwi4pumEH8K
</commit_message>
<xml_diff>
--- a/entregas/Formacao-Internacional-Etapa-Miami.pptx
+++ b/entregas/Formacao-Internacional-Etapa-Miami.pptx
@@ -117,7 +117,7 @@
   <p:extLst>
     <p:ext uri="{521415D9-36F7-43E2-AB2F-B90AF26B5E84}">
       <p14:sectionLst xmlns:p14="http://schemas.microsoft.com/office/powerpoint/2010/main">
-        <p14:section name="Abertura" id="{adc64d61-c334-54ea-c45d-e094de30581a}">
+        <p14:section name="Abertura" id="{f703f527-249d-9391-5757-e5811d98b017}">
           <p14:sldIdLst>
             <p14:sldId id="256"/>
             <p14:sldId id="257"/>
@@ -125,21 +125,21 @@
             <p14:sldId id="259"/>
           </p14:sldIdLst>
         </p14:section>
-        <p14:section name="A etapa" id="{120944f2-25e6-b333-fff5-daeef0ab5ce0}">
+        <p14:section name="A etapa" id="{1cff00fc-4305-e9bb-f7a6-fc5450c1ffb7}">
           <p14:sldIdLst>
             <p14:sldId id="260"/>
             <p14:sldId id="261"/>
             <p14:sldId id="262"/>
           </p14:sldIdLst>
         </p14:section>
-        <p14:section name="Pessoas" id="{ab62d7ff-c270-1613-e5ad-6a3a71bde697}">
+        <p14:section name="Pessoas" id="{b75e1110-f20d-69b0-258f-8455dc3c4e00}">
           <p14:sldIdLst>
             <p14:sldId id="263"/>
             <p14:sldId id="264"/>
             <p14:sldId id="265"/>
           </p14:sldIdLst>
         </p14:section>
-        <p14:section name="Inscrição" id="{324fae44-5482-928d-138d-3ddd7929beba}">
+        <p14:section name="Inscrição" id="{24ab5d15-e239-1560-0baf-17a010b17d51}">
           <p14:sldIdLst>
             <p14:sldId id="266"/>
           </p14:sldIdLst>
@@ -2833,7 +2833,7 @@
         </p:blipFill>
         <p:spPr>
           <a:xfrm>
-            <a:off x="7360920" y="274320"/>
+            <a:off x="7360920" y="1234440"/>
             <a:ext cx="4480560" cy="2990088"/>
           </a:xfrm>
           <a:prstGeom prst="rect">

</xml_diff>

<commit_message>
Etapa Miami: bandeira no canto superior direito como no original
Co-Authored-By: Claude Opus 5.5 <noreply@anthropic.com>
Claude-Session: https://claude.ai/code/session_01ETjDEHo1Y5Ziwi4pumEH8K
</commit_message>
<xml_diff>
--- a/entregas/Formacao-Internacional-Etapa-Miami.pptx
+++ b/entregas/Formacao-Internacional-Etapa-Miami.pptx
@@ -117,7 +117,7 @@
   <p:extLst>
     <p:ext uri="{521415D9-36F7-43E2-AB2F-B90AF26B5E84}">
       <p14:sectionLst xmlns:p14="http://schemas.microsoft.com/office/powerpoint/2010/main">
-        <p14:section name="Abertura" id="{f703f527-249d-9391-5757-e5811d98b017}">
+        <p14:section name="Abertura" id="{c45bf658-2f2b-3e08-5c7d-dfffdd3b7ff2}">
           <p14:sldIdLst>
             <p14:sldId id="256"/>
             <p14:sldId id="257"/>
@@ -125,21 +125,21 @@
             <p14:sldId id="259"/>
           </p14:sldIdLst>
         </p14:section>
-        <p14:section name="A etapa" id="{1cff00fc-4305-e9bb-f7a6-fc5450c1ffb7}">
+        <p14:section name="A etapa" id="{11aaaa24-d881-a34d-180b-6e3c2acec52b}">
           <p14:sldIdLst>
             <p14:sldId id="260"/>
             <p14:sldId id="261"/>
             <p14:sldId id="262"/>
           </p14:sldIdLst>
         </p14:section>
-        <p14:section name="Pessoas" id="{b75e1110-f20d-69b0-258f-8455dc3c4e00}">
+        <p14:section name="Pessoas" id="{769bbdad-b6cd-60eb-0f73-5cdf15fa26c4}">
           <p14:sldIdLst>
             <p14:sldId id="263"/>
             <p14:sldId id="264"/>
             <p14:sldId id="265"/>
           </p14:sldIdLst>
         </p14:section>
-        <p14:section name="Inscrição" id="{24ab5d15-e239-1560-0baf-17a010b17d51}">
+        <p14:section name="Inscrição" id="{e3bf77d4-946a-de6a-f06b-b280b06778d2}">
           <p14:sldIdLst>
             <p14:sldId id="266"/>
           </p14:sldIdLst>
@@ -2833,8 +2833,8 @@
         </p:blipFill>
         <p:spPr>
           <a:xfrm>
-            <a:off x="7360920" y="1234440"/>
-            <a:ext cx="4480560" cy="2990088"/>
+            <a:off x="5852160" y="-777240"/>
+            <a:ext cx="9692640" cy="6464808"/>
           </a:xfrm>
           <a:prstGeom prst="rect">
             <a:avLst/>

</xml_diff>

<commit_message>
Etapa Miami: programação prática após Quem já viveu, com foto de Miami ao fundo
Co-Authored-By: Claude Opus 5.5 <noreply@anthropic.com>
Claude-Session: https://claude.ai/code/session_01ETjDEHo1Y5Ziwi4pumEH8K
</commit_message>
<xml_diff>
--- a/entregas/Formacao-Internacional-Etapa-Miami.pptx
+++ b/entregas/Formacao-Internacional-Etapa-Miami.pptx
@@ -117,7 +117,7 @@
   <p:extLst>
     <p:ext uri="{521415D9-36F7-43E2-AB2F-B90AF26B5E84}">
       <p14:sectionLst xmlns:p14="http://schemas.microsoft.com/office/powerpoint/2010/main">
-        <p14:section name="Abertura" id="{c45bf658-2f2b-3e08-5c7d-dfffdd3b7ff2}">
+        <p14:section name="Abertura" id="{30f2e697-24d7-cc94-0b01-27f1a7b8ef3f}">
           <p14:sldIdLst>
             <p14:sldId id="256"/>
             <p14:sldId id="257"/>
@@ -125,21 +125,21 @@
             <p14:sldId id="259"/>
           </p14:sldIdLst>
         </p14:section>
-        <p14:section name="A etapa" id="{11aaaa24-d881-a34d-180b-6e3c2acec52b}">
+        <p14:section name="A etapa" id="{a73b45c2-af94-56cb-a9fc-5b687dd87a15}">
           <p14:sldIdLst>
             <p14:sldId id="260"/>
             <p14:sldId id="261"/>
-            <p14:sldId id="262"/>
           </p14:sldIdLst>
         </p14:section>
-        <p14:section name="Pessoas" id="{769bbdad-b6cd-60eb-0f73-5cdf15fa26c4}">
+        <p14:section name="Pessoas" id="{caf6166f-443d-4d2f-8b19-36407cc2f1dc}">
           <p14:sldIdLst>
+            <p14:sldId id="262"/>
             <p14:sldId id="263"/>
             <p14:sldId id="264"/>
             <p14:sldId id="265"/>
           </p14:sldIdLst>
         </p14:section>
-        <p14:section name="Inscrição" id="{e3bf77d4-946a-de6a-f06b-b280b06778d2}">
+        <p14:section name="Inscrição" id="{93c638d8-99ed-6a97-3ed7-a7bdf7451e59}">
           <p14:sldIdLst>
             <p14:sldId id="266"/>
           </p14:sldIdLst>
@@ -4226,7 +4226,7 @@
                 <a:ea typeface="Garamond" pitchFamily="34" charset="-122"/>
                 <a:cs typeface="Garamond" pitchFamily="34" charset="-120"/>
               </a:rPr>
-              <a:t>Programação prática</a:t>
+              <a:t>Da teoria à prática</a:t>
             </a:r>
             <a:endParaRPr lang="en-US" sz="4400" dirty="0"/>
           </a:p>
@@ -4234,55 +4234,21 @@
       </p:sp>
       <p:sp>
         <p:nvSpPr>
-          <p:cNvPr id="3" name="Text 1"/>
-          <p:cNvSpPr txBox="1"/>
-          <p:nvPr/>
-        </p:nvSpPr>
-        <p:spPr>
-          <a:xfrm>
-            <a:off x="731520" y="1600200"/>
-            <a:ext cx="7315200" cy="365760"/>
-          </a:xfrm>
-          <a:prstGeom prst="rect">
-            <a:avLst/>
-          </a:prstGeom>
-          <a:noFill/>
-          <a:ln/>
-        </p:spPr>
-        <p:txBody>
-          <a:bodyPr wrap="square" lIns="0" tIns="0" rIns="0" bIns="0" rtlCol="0" anchor="t"/>
-          <a:lstStyle/>
-          <a:p>
-            <a:pPr indent="0" marL="0">
-              <a:buNone/>
-            </a:pPr>
-            <a:r>
-              <a:rPr lang="en-US" sz="1600" dirty="0">
-                <a:solidFill>
-                  <a:schemeClr val="tx2"/>
-                </a:solidFill>
-              </a:rPr>
-              <a:t>Anatomia aplicada e hands-on</a:t>
-            </a:r>
-            <a:endParaRPr lang="en-US" sz="1600" dirty="0"/>
-          </a:p>
-        </p:txBody>
-      </p:sp>
-      <p:sp>
-        <p:nvSpPr>
-          <p:cNvPr id="4" name="Fio 1"/>
+          <p:cNvPr id="3" name="Cartão Boston"/>
           <p:cNvSpPr/>
           <p:nvPr/>
         </p:nvSpPr>
         <p:spPr>
           <a:xfrm>
-            <a:off x="731520" y="2331720"/>
-            <a:ext cx="10725912" cy="0"/>
-          </a:xfrm>
-          <a:prstGeom prst="line">
-            <a:avLst/>
-          </a:prstGeom>
-          <a:noFill/>
+            <a:off x="731520" y="2011680"/>
+            <a:ext cx="5239512" cy="3840480"/>
+          </a:xfrm>
+          <a:prstGeom prst="rect">
+            <a:avLst/>
+          </a:prstGeom>
+          <a:solidFill>
+            <a:schemeClr val="bg1"/>
+          </a:solidFill>
           <a:ln w="12700">
             <a:solidFill>
               <a:schemeClr val="accent3"/>
@@ -4293,14 +4259,14 @@
       </p:sp>
       <p:sp>
         <p:nvSpPr>
-          <p:cNvPr id="5" name="Módulo 1"/>
+          <p:cNvPr id="4" name="Boston título"/>
           <p:cNvSpPr txBox="1"/>
           <p:nvPr/>
         </p:nvSpPr>
         <p:spPr>
           <a:xfrm>
-            <a:off x="731520" y="2459736"/>
-            <a:ext cx="10698480" cy="548640"/>
+            <a:off x="1188720" y="2423160"/>
+            <a:ext cx="4389120" cy="822960"/>
           </a:xfrm>
           <a:prstGeom prst="rect">
             <a:avLst/>
@@ -4309,45 +4275,122 @@
           <a:ln/>
         </p:spPr>
         <p:txBody>
-          <a:bodyPr wrap="square" lIns="0" tIns="0" rIns="0" bIns="0" rtlCol="0" anchor="ctr"/>
+          <a:bodyPr wrap="square" lIns="0" tIns="0" rIns="0" bIns="0" rtlCol="0" anchor="t"/>
           <a:lstStyle/>
           <a:p>
             <a:pPr indent="0" marL="0">
               <a:buNone/>
             </a:pPr>
             <a:r>
-              <a:rPr lang="en-US" sz="2400" dirty="0">
-                <a:solidFill>
-                  <a:schemeClr val="tx1"/>
+              <a:rPr lang="en-US" sz="4800" dirty="0">
+                <a:solidFill>
+                  <a:schemeClr val="accent1"/>
                 </a:solidFill>
                 <a:latin typeface="Garamond" pitchFamily="34" charset="0"/>
                 <a:ea typeface="Garamond" pitchFamily="34" charset="-122"/>
                 <a:cs typeface="Garamond" pitchFamily="34" charset="-120"/>
               </a:rPr>
-              <a:t>Anatomia avançada de cabeça e pescoço aplicada a injetáveis</a:t>
-            </a:r>
-            <a:endParaRPr lang="en-US" sz="2400" dirty="0"/>
-          </a:p>
-        </p:txBody>
-      </p:sp>
-      <p:sp>
-        <p:nvSpPr>
-          <p:cNvPr id="6" name="Fio 2"/>
+              <a:t>Boston</a:t>
+            </a:r>
+            <a:endParaRPr lang="en-US" sz="4800" dirty="0"/>
+          </a:p>
+        </p:txBody>
+      </p:sp>
+      <p:sp>
+        <p:nvSpPr>
+          <p:cNvPr id="5" name="Boston subtítulo"/>
+          <p:cNvSpPr txBox="1"/>
+          <p:nvPr/>
+        </p:nvSpPr>
+        <p:spPr>
+          <a:xfrm>
+            <a:off x="1188720" y="3383280"/>
+            <a:ext cx="4389120" cy="457200"/>
+          </a:xfrm>
+          <a:prstGeom prst="rect">
+            <a:avLst/>
+          </a:prstGeom>
+          <a:noFill/>
+          <a:ln/>
+        </p:spPr>
+        <p:txBody>
+          <a:bodyPr wrap="square" lIns="0" tIns="0" rIns="0" bIns="0" rtlCol="0" anchor="t"/>
+          <a:lstStyle/>
+          <a:p>
+            <a:pPr indent="0" marL="0">
+              <a:buNone/>
+            </a:pPr>
+            <a:r>
+              <a:rPr lang="en-US" sz="1600" b="1" dirty="0">
+                <a:solidFill>
+                  <a:schemeClr val="tx1"/>
+                </a:solidFill>
+              </a:rPr>
+              <a:t>Teoria e anatomia demonstrativa</a:t>
+            </a:r>
+            <a:endParaRPr lang="en-US" sz="1600" dirty="0"/>
+          </a:p>
+        </p:txBody>
+      </p:sp>
+      <p:sp>
+        <p:nvSpPr>
+          <p:cNvPr id="6" name="Boston texto"/>
+          <p:cNvSpPr txBox="1"/>
+          <p:nvPr/>
+        </p:nvSpPr>
+        <p:spPr>
+          <a:xfrm>
+            <a:off x="1188720" y="3977640"/>
+            <a:ext cx="4389120" cy="1463040"/>
+          </a:xfrm>
+          <a:prstGeom prst="rect">
+            <a:avLst/>
+          </a:prstGeom>
+          <a:noFill/>
+          <a:ln/>
+        </p:spPr>
+        <p:txBody>
+          <a:bodyPr wrap="square" lIns="0" tIns="0" rIns="0" bIns="0" rtlCol="0" anchor="t"/>
+          <a:lstStyle/>
+          <a:p>
+            <a:pPr indent="0" marL="0">
+              <a:lnSpc>
+                <a:spcPct val="115000"/>
+              </a:lnSpc>
+              <a:buNone/>
+            </a:pPr>
+            <a:r>
+              <a:rPr lang="en-US" sz="1400" dirty="0">
+                <a:solidFill>
+                  <a:schemeClr val="tx2"/>
+                </a:solidFill>
+              </a:rPr>
+              <a:t>3 dias em ambiente acadêmico: aulas científicas, anatomy review com anatomista e demonstração de dissecação.</a:t>
+            </a:r>
+            <a:endParaRPr lang="en-US" sz="1400" dirty="0"/>
+          </a:p>
+        </p:txBody>
+      </p:sp>
+      <p:sp>
+        <p:nvSpPr>
+          <p:cNvPr id="7" name="Cartão Miami"/>
           <p:cNvSpPr/>
           <p:nvPr/>
         </p:nvSpPr>
         <p:spPr>
           <a:xfrm>
-            <a:off x="731520" y="3118104"/>
-            <a:ext cx="10725912" cy="0"/>
-          </a:xfrm>
-          <a:prstGeom prst="line">
-            <a:avLst/>
-          </a:prstGeom>
-          <a:noFill/>
+            <a:off x="6217920" y="2011680"/>
+            <a:ext cx="5239512" cy="3840480"/>
+          </a:xfrm>
+          <a:prstGeom prst="rect">
+            <a:avLst/>
+          </a:prstGeom>
+          <a:solidFill>
+            <a:schemeClr val="accent1"/>
+          </a:solidFill>
           <a:ln w="12700">
             <a:solidFill>
-              <a:schemeClr val="accent3"/>
+              <a:schemeClr val="accent1"/>
             </a:solidFill>
             <a:prstDash val="solid"/>
           </a:ln>
@@ -4355,14 +4398,14 @@
       </p:sp>
       <p:sp>
         <p:nvSpPr>
-          <p:cNvPr id="7" name="Módulo 2"/>
+          <p:cNvPr id="8" name="Miami título"/>
           <p:cNvSpPr txBox="1"/>
           <p:nvPr/>
         </p:nvSpPr>
         <p:spPr>
           <a:xfrm>
-            <a:off x="731520" y="3246120"/>
-            <a:ext cx="10698480" cy="548640"/>
+            <a:off x="6675120" y="2423160"/>
+            <a:ext cx="4389120" cy="822960"/>
           </a:xfrm>
           <a:prstGeom prst="rect">
             <a:avLst/>
@@ -4371,60 +4414,37 @@
           <a:ln/>
         </p:spPr>
         <p:txBody>
-          <a:bodyPr wrap="square" lIns="0" tIns="0" rIns="0" bIns="0" rtlCol="0" anchor="ctr"/>
+          <a:bodyPr wrap="square" lIns="0" tIns="0" rIns="0" bIns="0" rtlCol="0" anchor="t"/>
           <a:lstStyle/>
           <a:p>
             <a:pPr indent="0" marL="0">
               <a:buNone/>
             </a:pPr>
             <a:r>
-              <a:rPr lang="en-US" sz="2400" dirty="0">
-                <a:solidFill>
-                  <a:schemeClr val="tx1"/>
+              <a:rPr lang="en-US" sz="4800" dirty="0">
+                <a:solidFill>
+                  <a:schemeClr val="bg1"/>
                 </a:solidFill>
                 <a:latin typeface="Garamond" pitchFamily="34" charset="0"/>
                 <a:ea typeface="Garamond" pitchFamily="34" charset="-122"/>
                 <a:cs typeface="Garamond" pitchFamily="34" charset="-120"/>
               </a:rPr>
-              <a:t>Anatomia avançada de cabeça e pescoço aplicada a fios faciais</a:t>
-            </a:r>
-            <a:endParaRPr lang="en-US" sz="2400" dirty="0"/>
-          </a:p>
-        </p:txBody>
-      </p:sp>
-      <p:sp>
-        <p:nvSpPr>
-          <p:cNvPr id="8" name="Fio 3"/>
-          <p:cNvSpPr/>
-          <p:nvPr/>
-        </p:nvSpPr>
-        <p:spPr>
-          <a:xfrm>
-            <a:off x="731520" y="3904488"/>
-            <a:ext cx="10725912" cy="0"/>
-          </a:xfrm>
-          <a:prstGeom prst="line">
-            <a:avLst/>
-          </a:prstGeom>
-          <a:noFill/>
-          <a:ln w="12700">
-            <a:solidFill>
-              <a:schemeClr val="accent3"/>
-            </a:solidFill>
-            <a:prstDash val="solid"/>
-          </a:ln>
-        </p:spPr>
-      </p:sp>
-      <p:sp>
-        <p:nvSpPr>
-          <p:cNvPr id="9" name="Módulo 3"/>
+              <a:t>Miami</a:t>
+            </a:r>
+            <a:endParaRPr lang="en-US" sz="4800" dirty="0"/>
+          </a:p>
+        </p:txBody>
+      </p:sp>
+      <p:sp>
+        <p:nvSpPr>
+          <p:cNvPr id="9" name="Miami subtítulo"/>
           <p:cNvSpPr txBox="1"/>
           <p:nvPr/>
         </p:nvSpPr>
         <p:spPr>
           <a:xfrm>
-            <a:off x="731520" y="4032504"/>
-            <a:ext cx="10698480" cy="548640"/>
+            <a:off x="6675120" y="3383280"/>
+            <a:ext cx="4389120" cy="457200"/>
           </a:xfrm>
           <a:prstGeom prst="rect">
             <a:avLst/>
@@ -4433,60 +4453,34 @@
           <a:ln/>
         </p:spPr>
         <p:txBody>
-          <a:bodyPr wrap="square" lIns="0" tIns="0" rIns="0" bIns="0" rtlCol="0" anchor="ctr"/>
+          <a:bodyPr wrap="square" lIns="0" tIns="0" rIns="0" bIns="0" rtlCol="0" anchor="t"/>
           <a:lstStyle/>
           <a:p>
             <a:pPr indent="0" marL="0">
               <a:buNone/>
             </a:pPr>
             <a:r>
-              <a:rPr lang="en-US" sz="2400" dirty="0">
-                <a:solidFill>
-                  <a:schemeClr val="tx1"/>
-                </a:solidFill>
-                <a:latin typeface="Garamond" pitchFamily="34" charset="0"/>
-                <a:ea typeface="Garamond" pitchFamily="34" charset="-122"/>
-                <a:cs typeface="Garamond" pitchFamily="34" charset="-120"/>
-              </a:rPr>
-              <a:t>Bioestimuladores faciais e corporais: fundamentos, indicações e limites</a:t>
-            </a:r>
-            <a:endParaRPr lang="en-US" sz="2400" dirty="0"/>
-          </a:p>
-        </p:txBody>
-      </p:sp>
-      <p:sp>
-        <p:nvSpPr>
-          <p:cNvPr id="10" name="Fio 4"/>
-          <p:cNvSpPr/>
-          <p:nvPr/>
-        </p:nvSpPr>
-        <p:spPr>
-          <a:xfrm>
-            <a:off x="731520" y="4690872"/>
-            <a:ext cx="10725912" cy="0"/>
-          </a:xfrm>
-          <a:prstGeom prst="line">
-            <a:avLst/>
-          </a:prstGeom>
-          <a:noFill/>
-          <a:ln w="12700">
-            <a:solidFill>
-              <a:schemeClr val="accent3"/>
-            </a:solidFill>
-            <a:prstDash val="solid"/>
-          </a:ln>
-        </p:spPr>
-      </p:sp>
-      <p:sp>
-        <p:nvSpPr>
-          <p:cNvPr id="11" name="Módulo 4"/>
+              <a:rPr lang="en-US" sz="1600" b="1" dirty="0">
+                <a:solidFill>
+                  <a:schemeClr val="bg1"/>
+                </a:solidFill>
+              </a:rPr>
+              <a:t>Prática real e hands-on</a:t>
+            </a:r>
+            <a:endParaRPr lang="en-US" sz="1600" dirty="0"/>
+          </a:p>
+        </p:txBody>
+      </p:sp>
+      <p:sp>
+        <p:nvSpPr>
+          <p:cNvPr id="10" name="Miami texto"/>
           <p:cNvSpPr txBox="1"/>
           <p:nvPr/>
         </p:nvSpPr>
         <p:spPr>
           <a:xfrm>
-            <a:off x="731520" y="4818888"/>
-            <a:ext cx="10698480" cy="548640"/>
+            <a:off x="6675120" y="3977640"/>
+            <a:ext cx="4389120" cy="1463040"/>
           </a:xfrm>
           <a:prstGeom prst="rect">
             <a:avLst/>
@@ -4495,111 +4489,26 @@
           <a:ln/>
         </p:spPr>
         <p:txBody>
-          <a:bodyPr wrap="square" lIns="0" tIns="0" rIns="0" bIns="0" rtlCol="0" anchor="ctr"/>
+          <a:bodyPr wrap="square" lIns="0" tIns="0" rIns="0" bIns="0" rtlCol="0" anchor="t"/>
           <a:lstStyle/>
           <a:p>
             <a:pPr indent="0" marL="0">
-              <a:buNone/>
-            </a:pPr>
-            <a:r>
-              <a:rPr lang="en-US" sz="2400" dirty="0">
-                <a:solidFill>
-                  <a:schemeClr val="tx1"/>
-                </a:solidFill>
-                <a:latin typeface="Garamond" pitchFamily="34" charset="0"/>
-                <a:ea typeface="Garamond" pitchFamily="34" charset="-122"/>
-                <a:cs typeface="Garamond" pitchFamily="34" charset="-120"/>
-              </a:rPr>
-              <a:t>Lifting facial com preenchedores: raciocínio anatômico e estrutural</a:t>
-            </a:r>
-            <a:endParaRPr lang="en-US" sz="2400" dirty="0"/>
-          </a:p>
-        </p:txBody>
-      </p:sp>
-      <p:sp>
-        <p:nvSpPr>
-          <p:cNvPr id="12" name="Fio 5"/>
-          <p:cNvSpPr/>
-          <p:nvPr/>
-        </p:nvSpPr>
-        <p:spPr>
-          <a:xfrm>
-            <a:off x="731520" y="5477256"/>
-            <a:ext cx="10725912" cy="0"/>
-          </a:xfrm>
-          <a:prstGeom prst="line">
-            <a:avLst/>
-          </a:prstGeom>
-          <a:noFill/>
-          <a:ln w="12700">
-            <a:solidFill>
-              <a:schemeClr val="accent3"/>
-            </a:solidFill>
-            <a:prstDash val="solid"/>
-          </a:ln>
-        </p:spPr>
-      </p:sp>
-      <p:sp>
-        <p:nvSpPr>
-          <p:cNvPr id="13" name="Módulo 5"/>
-          <p:cNvSpPr txBox="1"/>
-          <p:nvPr/>
-        </p:nvSpPr>
-        <p:spPr>
-          <a:xfrm>
-            <a:off x="731520" y="5605272"/>
-            <a:ext cx="10698480" cy="548640"/>
-          </a:xfrm>
-          <a:prstGeom prst="rect">
-            <a:avLst/>
-          </a:prstGeom>
-          <a:noFill/>
-          <a:ln/>
-        </p:spPr>
-        <p:txBody>
-          <a:bodyPr wrap="square" lIns="0" tIns="0" rIns="0" bIns="0" rtlCol="0" anchor="ctr"/>
-          <a:lstStyle/>
-          <a:p>
-            <a:pPr indent="0" marL="0">
-              <a:buNone/>
-            </a:pPr>
-            <a:r>
-              <a:rPr lang="en-US" sz="2400" dirty="0">
-                <a:solidFill>
-                  <a:schemeClr val="tx1"/>
-                </a:solidFill>
-                <a:latin typeface="Garamond" pitchFamily="34" charset="0"/>
-                <a:ea typeface="Garamond" pitchFamily="34" charset="-122"/>
-                <a:cs typeface="Garamond" pitchFamily="34" charset="-120"/>
-              </a:rPr>
-              <a:t>Full face: planejamento anatômico, segurança e naturalidade</a:t>
-            </a:r>
-            <a:endParaRPr lang="en-US" sz="2400" dirty="0"/>
-          </a:p>
-        </p:txBody>
-      </p:sp>
-      <p:sp>
-        <p:nvSpPr>
-          <p:cNvPr id="14" name="Fio final"/>
-          <p:cNvSpPr/>
-          <p:nvPr/>
-        </p:nvSpPr>
-        <p:spPr>
-          <a:xfrm>
-            <a:off x="731520" y="6263640"/>
-            <a:ext cx="10725912" cy="0"/>
-          </a:xfrm>
-          <a:prstGeom prst="line">
-            <a:avLst/>
-          </a:prstGeom>
-          <a:noFill/>
-          <a:ln w="12700">
-            <a:solidFill>
-              <a:schemeClr val="accent3"/>
-            </a:solidFill>
-            <a:prstDash val="solid"/>
-          </a:ln>
-        </p:spPr>
+              <a:lnSpc>
+                <a:spcPct val="115000"/>
+              </a:lnSpc>
+              <a:buNone/>
+            </a:pPr>
+            <a:r>
+              <a:rPr lang="en-US" sz="1400" dirty="0">
+                <a:solidFill>
+                  <a:schemeClr val="accent4"/>
+                </a:solidFill>
+              </a:rPr>
+              <a:t>19, 20 e 21 de maio de 2027, em laboratório de specimen: anatomia aplicada e prática supervisionada dos procedimentos.</a:t>
+            </a:r>
+            <a:endParaRPr lang="en-US" sz="1400" dirty="0"/>
+          </a:p>
+        </p:txBody>
       </p:sp>
       <p:sp>
         <p:nvSpPr>
@@ -4674,9 +4583,79 @@
           <a:chExt cx="0" cy="0"/>
         </a:xfrm>
       </p:grpSpPr>
-      <p:sp>
-        <p:nvSpPr>
-          <p:cNvPr id="2" name="Text 0"/>
+      <p:pic>
+        <p:nvPicPr>
+          <p:cNvPr id="2" name="Print Instagram" descr="Perfil @dra.rosanaa no Instagram, com 339 mil seguidores">    </p:cNvPr>
+          <p:cNvPicPr>
+            <a:picLocks noChangeAspect="1"/>
+          </p:cNvPicPr>
+          <p:nvPr/>
+        </p:nvPicPr>
+        <p:blipFill>
+          <a:blip r:embed="rId1"/>
+          <a:stretch>
+            <a:fillRect/>
+          </a:stretch>
+        </p:blipFill>
+        <p:spPr>
+          <a:xfrm>
+            <a:off x="8366760" y="685800"/>
+            <a:ext cx="3182112" cy="5477256"/>
+          </a:xfrm>
+          <a:prstGeom prst="rect">
+            <a:avLst/>
+          </a:prstGeom>
+          <a:effectLst>
+            <a:outerShdw sx="100000" sy="100000" kx="0" ky="0" algn="bl" rotWithShape="0" blurRad="152400" dist="50800" dir="5400000">
+              <a:srgbClr val="2B2A29">
+                <a:alpha val="25000"/>
+              </a:srgbClr>
+            </a:outerShdw>
+          </a:effectLst>
+        </p:spPr>
+      </p:pic>
+      <p:sp>
+        <p:nvSpPr>
+          <p:cNvPr id="3" name="Text 0"/>
+          <p:cNvSpPr txBox="1"/>
+          <p:nvPr/>
+        </p:nvSpPr>
+        <p:spPr>
+          <a:xfrm>
+            <a:off x="731520" y="411480"/>
+            <a:ext cx="5486400" cy="411480"/>
+          </a:xfrm>
+          <a:prstGeom prst="rect">
+            <a:avLst/>
+          </a:prstGeom>
+          <a:noFill/>
+          <a:ln/>
+        </p:spPr>
+        <p:txBody>
+          <a:bodyPr wrap="square" lIns="0" tIns="0" rIns="0" bIns="0" rtlCol="0" anchor="t"/>
+          <a:lstStyle/>
+          <a:p>
+            <a:pPr indent="0" marL="0">
+              <a:buNone/>
+            </a:pPr>
+            <a:r>
+              <a:rPr lang="en-US" sz="2200" i="1" dirty="0">
+                <a:solidFill>
+                  <a:schemeClr val="tx2"/>
+                </a:solidFill>
+                <a:latin typeface="Garamond" pitchFamily="34" charset="0"/>
+                <a:ea typeface="Garamond" pitchFamily="34" charset="-122"/>
+                <a:cs typeface="Garamond" pitchFamily="34" charset="-120"/>
+              </a:rPr>
+              <a:t>O poder do</a:t>
+            </a:r>
+            <a:endParaRPr lang="en-US" sz="2200" dirty="0"/>
+          </a:p>
+        </p:txBody>
+      </p:sp>
+      <p:sp>
+        <p:nvSpPr>
+          <p:cNvPr id="4" name="Text 0"/>
           <p:cNvSpPr/>
           <p:nvPr>
             <p:ph idx="100" type="title" hasCustomPrompt="1"/>
@@ -4709,7 +4688,7 @@
                 <a:ea typeface="Garamond" pitchFamily="34" charset="-122"/>
                 <a:cs typeface="Garamond" pitchFamily="34" charset="-120"/>
               </a:rPr>
-              <a:t>Da teoria à prática</a:t>
+              <a:t>Posicionamento</a:t>
             </a:r>
             <a:endParaRPr lang="en-US" sz="4400" dirty="0"/>
           </a:p>
@@ -4717,21 +4696,55 @@
       </p:sp>
       <p:sp>
         <p:nvSpPr>
-          <p:cNvPr id="3" name="Cartão Boston"/>
+          <p:cNvPr id="5" name="Text 2"/>
+          <p:cNvSpPr txBox="1"/>
+          <p:nvPr/>
+        </p:nvSpPr>
+        <p:spPr>
+          <a:xfrm>
+            <a:off x="731520" y="1874520"/>
+            <a:ext cx="6949440" cy="548640"/>
+          </a:xfrm>
+          <a:prstGeom prst="rect">
+            <a:avLst/>
+          </a:prstGeom>
+          <a:noFill/>
+          <a:ln/>
+        </p:spPr>
+        <p:txBody>
+          <a:bodyPr wrap="square" lIns="0" tIns="0" rIns="0" bIns="0" rtlCol="0" anchor="t"/>
+          <a:lstStyle/>
+          <a:p>
+            <a:pPr indent="0" marL="0">
+              <a:buNone/>
+            </a:pPr>
+            <a:r>
+              <a:rPr lang="en-US" sz="1500" dirty="0">
+                <a:solidFill>
+                  <a:schemeClr val="tx2"/>
+                </a:solidFill>
+              </a:rPr>
+              <a:t>Um programa realizado em Boston e Miami reúne, além do conteúdo técnico:</a:t>
+            </a:r>
+            <a:endParaRPr lang="en-US" sz="1500" dirty="0"/>
+          </a:p>
+        </p:txBody>
+      </p:sp>
+      <p:sp>
+        <p:nvSpPr>
+          <p:cNvPr id="6" name="Fio 1"/>
           <p:cNvSpPr/>
           <p:nvPr/>
         </p:nvSpPr>
         <p:spPr>
           <a:xfrm>
-            <a:off x="731520" y="2011680"/>
-            <a:ext cx="5239512" cy="3840480"/>
-          </a:xfrm>
-          <a:prstGeom prst="rect">
-            <a:avLst/>
-          </a:prstGeom>
-          <a:solidFill>
-            <a:schemeClr val="bg1"/>
-          </a:solidFill>
+            <a:off x="731520" y="2651760"/>
+            <a:ext cx="6949440" cy="0"/>
+          </a:xfrm>
+          <a:prstGeom prst="line">
+            <a:avLst/>
+          </a:prstGeom>
+          <a:noFill/>
           <a:ln w="12700">
             <a:solidFill>
               <a:schemeClr val="accent3"/>
@@ -4742,14 +4755,14 @@
       </p:sp>
       <p:sp>
         <p:nvSpPr>
-          <p:cNvPr id="4" name="Boston título"/>
+          <p:cNvPr id="7" name="Item 1 título"/>
           <p:cNvSpPr txBox="1"/>
           <p:nvPr/>
         </p:nvSpPr>
         <p:spPr>
           <a:xfrm>
-            <a:off x="1188720" y="2423160"/>
-            <a:ext cx="4389120" cy="822960"/>
+            <a:off x="731520" y="2788920"/>
+            <a:ext cx="6949440" cy="411480"/>
           </a:xfrm>
           <a:prstGeom prst="rect">
             <a:avLst/>
@@ -4765,7 +4778,7 @@
               <a:buNone/>
             </a:pPr>
             <a:r>
-              <a:rPr lang="en-US" sz="4800" dirty="0">
+              <a:rPr lang="en-US" sz="2400" dirty="0">
                 <a:solidFill>
                   <a:schemeClr val="accent1"/>
                 </a:solidFill>
@@ -4773,22 +4786,22 @@
                 <a:ea typeface="Garamond" pitchFamily="34" charset="-122"/>
                 <a:cs typeface="Garamond" pitchFamily="34" charset="-120"/>
               </a:rPr>
-              <a:t>Boston</a:t>
-            </a:r>
-            <a:endParaRPr lang="en-US" sz="4800" dirty="0"/>
-          </a:p>
-        </p:txBody>
-      </p:sp>
-      <p:sp>
-        <p:nvSpPr>
-          <p:cNvPr id="5" name="Boston subtítulo"/>
+              <a:t>Doutores da estética</a:t>
+            </a:r>
+            <a:endParaRPr lang="en-US" sz="2400" dirty="0"/>
+          </a:p>
+        </p:txBody>
+      </p:sp>
+      <p:sp>
+        <p:nvSpPr>
+          <p:cNvPr id="8" name="Item 1 texto"/>
           <p:cNvSpPr txBox="1"/>
           <p:nvPr/>
         </p:nvSpPr>
         <p:spPr>
           <a:xfrm>
-            <a:off x="1188720" y="3383280"/>
-            <a:ext cx="4389120" cy="457200"/>
+            <a:off x="731520" y="3200400"/>
+            <a:ext cx="6949440" cy="365760"/>
           </a:xfrm>
           <a:prstGeom prst="rect">
             <a:avLst/>
@@ -4804,51 +4817,12 @@
               <a:buNone/>
             </a:pPr>
             <a:r>
-              <a:rPr lang="en-US" sz="1600" b="1" dirty="0">
-                <a:solidFill>
-                  <a:schemeClr val="tx1"/>
-                </a:solidFill>
-              </a:rPr>
-              <a:t>Teoria e anatomia demonstrativa</a:t>
-            </a:r>
-            <a:endParaRPr lang="en-US" sz="1600" dirty="0"/>
-          </a:p>
-        </p:txBody>
-      </p:sp>
-      <p:sp>
-        <p:nvSpPr>
-          <p:cNvPr id="6" name="Boston texto"/>
-          <p:cNvSpPr txBox="1"/>
-          <p:nvPr/>
-        </p:nvSpPr>
-        <p:spPr>
-          <a:xfrm>
-            <a:off x="1188720" y="3977640"/>
-            <a:ext cx="4389120" cy="1463040"/>
-          </a:xfrm>
-          <a:prstGeom prst="rect">
-            <a:avLst/>
-          </a:prstGeom>
-          <a:noFill/>
-          <a:ln/>
-        </p:spPr>
-        <p:txBody>
-          <a:bodyPr wrap="square" lIns="0" tIns="0" rIns="0" bIns="0" rtlCol="0" anchor="t"/>
-          <a:lstStyle/>
-          <a:p>
-            <a:pPr indent="0" marL="0">
-              <a:lnSpc>
-                <a:spcPct val="115000"/>
-              </a:lnSpc>
-              <a:buNone/>
-            </a:pPr>
-            <a:r>
               <a:rPr lang="en-US" sz="1400" dirty="0">
                 <a:solidFill>
                   <a:schemeClr val="tx2"/>
                 </a:solidFill>
               </a:rPr>
-              <a:t>3 dias em ambiente acadêmico: aulas científicas, anatomy review com anatomista e demonstração de dissecação.</a:t>
+              <a:t>nacionais e internacionais</a:t>
             </a:r>
             <a:endParaRPr lang="en-US" sz="1400" dirty="0"/>
           </a:p>
@@ -4856,24 +4830,22 @@
       </p:sp>
       <p:sp>
         <p:nvSpPr>
-          <p:cNvPr id="7" name="Cartão Miami"/>
+          <p:cNvPr id="9" name="Fio 2"/>
           <p:cNvSpPr/>
           <p:nvPr/>
         </p:nvSpPr>
         <p:spPr>
           <a:xfrm>
-            <a:off x="6217920" y="2011680"/>
-            <a:ext cx="5239512" cy="3840480"/>
-          </a:xfrm>
-          <a:prstGeom prst="rect">
-            <a:avLst/>
-          </a:prstGeom>
-          <a:solidFill>
-            <a:schemeClr val="accent1"/>
-          </a:solidFill>
+            <a:off x="731520" y="3657600"/>
+            <a:ext cx="6949440" cy="0"/>
+          </a:xfrm>
+          <a:prstGeom prst="line">
+            <a:avLst/>
+          </a:prstGeom>
+          <a:noFill/>
           <a:ln w="12700">
             <a:solidFill>
-              <a:schemeClr val="accent1"/>
+              <a:schemeClr val="accent3"/>
             </a:solidFill>
             <a:prstDash val="solid"/>
           </a:ln>
@@ -4881,14 +4853,14 @@
       </p:sp>
       <p:sp>
         <p:nvSpPr>
-          <p:cNvPr id="8" name="Miami título"/>
+          <p:cNvPr id="10" name="Item 2 título"/>
           <p:cNvSpPr txBox="1"/>
           <p:nvPr/>
         </p:nvSpPr>
         <p:spPr>
           <a:xfrm>
-            <a:off x="6675120" y="2423160"/>
-            <a:ext cx="4389120" cy="822960"/>
+            <a:off x="731520" y="3794760"/>
+            <a:ext cx="6949440" cy="411480"/>
           </a:xfrm>
           <a:prstGeom prst="rect">
             <a:avLst/>
@@ -4904,30 +4876,30 @@
               <a:buNone/>
             </a:pPr>
             <a:r>
-              <a:rPr lang="en-US" sz="4800" dirty="0">
-                <a:solidFill>
-                  <a:schemeClr val="bg1"/>
+              <a:rPr lang="en-US" sz="2400" dirty="0">
+                <a:solidFill>
+                  <a:schemeClr val="accent1"/>
                 </a:solidFill>
                 <a:latin typeface="Garamond" pitchFamily="34" charset="0"/>
                 <a:ea typeface="Garamond" pitchFamily="34" charset="-122"/>
                 <a:cs typeface="Garamond" pitchFamily="34" charset="-120"/>
               </a:rPr>
-              <a:t>Miami</a:t>
-            </a:r>
-            <a:endParaRPr lang="en-US" sz="4800" dirty="0"/>
-          </a:p>
-        </p:txBody>
-      </p:sp>
-      <p:sp>
-        <p:nvSpPr>
-          <p:cNvPr id="9" name="Miami subtítulo"/>
+              <a:t>Convidados</a:t>
+            </a:r>
+            <a:endParaRPr lang="en-US" sz="2400" dirty="0"/>
+          </a:p>
+        </p:txBody>
+      </p:sp>
+      <p:sp>
+        <p:nvSpPr>
+          <p:cNvPr id="11" name="Item 2 texto"/>
           <p:cNvSpPr txBox="1"/>
           <p:nvPr/>
         </p:nvSpPr>
         <p:spPr>
           <a:xfrm>
-            <a:off x="6675120" y="3383280"/>
-            <a:ext cx="4389120" cy="457200"/>
+            <a:off x="731520" y="4206240"/>
+            <a:ext cx="6949440" cy="365760"/>
           </a:xfrm>
           <a:prstGeom prst="rect">
             <a:avLst/>
@@ -4943,27 +4915,50 @@
               <a:buNone/>
             </a:pPr>
             <a:r>
-              <a:rPr lang="en-US" sz="1600" b="1" dirty="0">
-                <a:solidFill>
-                  <a:schemeClr val="bg1"/>
-                </a:solidFill>
-              </a:rPr>
-              <a:t>Prática real e hands-on</a:t>
-            </a:r>
-            <a:endParaRPr lang="en-US" sz="1600" dirty="0"/>
-          </a:p>
-        </p:txBody>
-      </p:sp>
-      <p:sp>
-        <p:nvSpPr>
-          <p:cNvPr id="10" name="Miami texto"/>
+              <a:rPr lang="en-US" sz="1400" dirty="0">
+                <a:solidFill>
+                  <a:schemeClr val="tx2"/>
+                </a:solidFill>
+              </a:rPr>
+              <a:t>com cases reais de sucesso na estética e no empreendedorismo</a:t>
+            </a:r>
+            <a:endParaRPr lang="en-US" sz="1400" dirty="0"/>
+          </a:p>
+        </p:txBody>
+      </p:sp>
+      <p:sp>
+        <p:nvSpPr>
+          <p:cNvPr id="12" name="Fio 3"/>
+          <p:cNvSpPr/>
+          <p:nvPr/>
+        </p:nvSpPr>
+        <p:spPr>
+          <a:xfrm>
+            <a:off x="731520" y="4663440"/>
+            <a:ext cx="6949440" cy="0"/>
+          </a:xfrm>
+          <a:prstGeom prst="line">
+            <a:avLst/>
+          </a:prstGeom>
+          <a:noFill/>
+          <a:ln w="12700">
+            <a:solidFill>
+              <a:schemeClr val="accent3"/>
+            </a:solidFill>
+            <a:prstDash val="solid"/>
+          </a:ln>
+        </p:spPr>
+      </p:sp>
+      <p:sp>
+        <p:nvSpPr>
+          <p:cNvPr id="13" name="Item 3 título"/>
           <p:cNvSpPr txBox="1"/>
           <p:nvPr/>
         </p:nvSpPr>
         <p:spPr>
           <a:xfrm>
-            <a:off x="6675120" y="3977640"/>
-            <a:ext cx="4389120" cy="1463040"/>
+            <a:off x="731520" y="4800600"/>
+            <a:ext cx="6949440" cy="411480"/>
           </a:xfrm>
           <a:prstGeom prst="rect">
             <a:avLst/>
@@ -4976,20 +4971,92 @@
           <a:lstStyle/>
           <a:p>
             <a:pPr indent="0" marL="0">
-              <a:lnSpc>
-                <a:spcPct val="115000"/>
-              </a:lnSpc>
+              <a:buNone/>
+            </a:pPr>
+            <a:r>
+              <a:rPr lang="en-US" sz="2400" dirty="0">
+                <a:solidFill>
+                  <a:schemeClr val="accent1"/>
+                </a:solidFill>
+                <a:latin typeface="Garamond" pitchFamily="34" charset="0"/>
+                <a:ea typeface="Garamond" pitchFamily="34" charset="-122"/>
+                <a:cs typeface="Garamond" pitchFamily="34" charset="-120"/>
+              </a:rPr>
+              <a:t>Palestrantes</a:t>
+            </a:r>
+            <a:endParaRPr lang="en-US" sz="2400" dirty="0"/>
+          </a:p>
+        </p:txBody>
+      </p:sp>
+      <p:sp>
+        <p:nvSpPr>
+          <p:cNvPr id="14" name="Item 3 texto"/>
+          <p:cNvSpPr txBox="1"/>
+          <p:nvPr/>
+        </p:nvSpPr>
+        <p:spPr>
+          <a:xfrm>
+            <a:off x="731520" y="5212080"/>
+            <a:ext cx="6949440" cy="365760"/>
+          </a:xfrm>
+          <a:prstGeom prst="rect">
+            <a:avLst/>
+          </a:prstGeom>
+          <a:noFill/>
+          <a:ln/>
+        </p:spPr>
+        <p:txBody>
+          <a:bodyPr wrap="square" lIns="0" tIns="0" rIns="0" bIns="0" rtlCol="0" anchor="t"/>
+          <a:lstStyle/>
+          <a:p>
+            <a:pPr indent="0" marL="0">
               <a:buNone/>
             </a:pPr>
             <a:r>
               <a:rPr lang="en-US" sz="1400" dirty="0">
                 <a:solidFill>
-                  <a:schemeClr val="accent4"/>
-                </a:solidFill>
-              </a:rPr>
-              <a:t>19, 20 e 21 de maio de 2027, em laboratório de specimen: anatomia aplicada e prática supervisionada dos procedimentos.</a:t>
+                  <a:schemeClr val="tx2"/>
+                </a:solidFill>
+              </a:rPr>
+              <a:t>que atuam com carreira, posicionamento e autoridade</a:t>
             </a:r>
             <a:endParaRPr lang="en-US" sz="1400" dirty="0"/>
+          </a:p>
+        </p:txBody>
+      </p:sp>
+      <p:sp>
+        <p:nvSpPr>
+          <p:cNvPr id="15" name="Text 12"/>
+          <p:cNvSpPr txBox="1"/>
+          <p:nvPr/>
+        </p:nvSpPr>
+        <p:spPr>
+          <a:xfrm>
+            <a:off x="731520" y="5760720"/>
+            <a:ext cx="7132320" cy="457200"/>
+          </a:xfrm>
+          <a:prstGeom prst="rect">
+            <a:avLst/>
+          </a:prstGeom>
+          <a:noFill/>
+          <a:ln/>
+        </p:spPr>
+        <p:txBody>
+          <a:bodyPr wrap="square" lIns="0" tIns="0" rIns="0" bIns="0" rtlCol="0" anchor="t"/>
+          <a:lstStyle/>
+          <a:p>
+            <a:pPr indent="0" marL="0">
+              <a:buNone/>
+            </a:pPr>
+            <a:r>
+              <a:rPr lang="en-US" sz="1300" i="1" dirty="0">
+                <a:solidFill>
+                  <a:schemeClr val="tx2"/>
+                </a:solidFill>
+              </a:rPr>
+              <a:t>Um momento desenhado para troca de experiências, visão de mercado e conexões profissionais relevantes.</a:t>
+            </a:r>
+            <a:endParaRPr lang="en-US" sz="1300" dirty="0"/>
           </a:p>
         </p:txBody>
       </p:sp>
@@ -5068,7 +5135,7 @@
       </p:grpSpPr>
       <p:pic>
         <p:nvPicPr>
-          <p:cNvPr id="2" name="Print Instagram" descr="Perfil @dra.rosanaa no Instagram, com 339 mil seguidores">    </p:cNvPr>
+          <p:cNvPr id="2" name="Foto da turma" descr="Turma da Formação Internacional reunida em uma escadaria, de uniforme vinho, segurando certificados e uma bandeira de Harvard">    </p:cNvPr>
           <p:cNvPicPr>
             <a:picLocks noChangeAspect="1"/>
           </p:cNvPicPr>
@@ -5082,63 +5149,17 @@
         </p:blipFill>
         <p:spPr>
           <a:xfrm>
-            <a:off x="8366760" y="685800"/>
-            <a:ext cx="3182112" cy="5477256"/>
-          </a:xfrm>
-          <a:prstGeom prst="rect">
-            <a:avLst/>
-          </a:prstGeom>
-          <a:effectLst>
-            <a:outerShdw sx="100000" sy="100000" kx="0" ky="0" algn="bl" rotWithShape="0" blurRad="152400" dist="50800" dir="5400000">
-              <a:srgbClr val="2B2A29">
-                <a:alpha val="25000"/>
-              </a:srgbClr>
-            </a:outerShdw>
-          </a:effectLst>
+            <a:off x="5486400" y="0"/>
+            <a:ext cx="6705295" cy="6858000"/>
+          </a:xfrm>
+          <a:prstGeom prst="rect">
+            <a:avLst/>
+          </a:prstGeom>
         </p:spPr>
       </p:pic>
       <p:sp>
         <p:nvSpPr>
           <p:cNvPr id="3" name="Text 0"/>
-          <p:cNvSpPr txBox="1"/>
-          <p:nvPr/>
-        </p:nvSpPr>
-        <p:spPr>
-          <a:xfrm>
-            <a:off x="731520" y="411480"/>
-            <a:ext cx="5486400" cy="411480"/>
-          </a:xfrm>
-          <a:prstGeom prst="rect">
-            <a:avLst/>
-          </a:prstGeom>
-          <a:noFill/>
-          <a:ln/>
-        </p:spPr>
-        <p:txBody>
-          <a:bodyPr wrap="square" lIns="0" tIns="0" rIns="0" bIns="0" rtlCol="0" anchor="t"/>
-          <a:lstStyle/>
-          <a:p>
-            <a:pPr indent="0" marL="0">
-              <a:buNone/>
-            </a:pPr>
-            <a:r>
-              <a:rPr lang="en-US" sz="2200" i="1" dirty="0">
-                <a:solidFill>
-                  <a:schemeClr val="tx2"/>
-                </a:solidFill>
-                <a:latin typeface="Garamond" pitchFamily="34" charset="0"/>
-                <a:ea typeface="Garamond" pitchFamily="34" charset="-122"/>
-                <a:cs typeface="Garamond" pitchFamily="34" charset="-120"/>
-              </a:rPr>
-              <a:t>O poder do</a:t>
-            </a:r>
-            <a:endParaRPr lang="en-US" sz="2200" dirty="0"/>
-          </a:p>
-        </p:txBody>
-      </p:sp>
-      <p:sp>
-        <p:nvSpPr>
-          <p:cNvPr id="4" name="Text 0"/>
           <p:cNvSpPr/>
           <p:nvPr>
             <p:ph idx="100" type="title" hasCustomPrompt="1"/>
@@ -5171,7 +5192,7 @@
                 <a:ea typeface="Garamond" pitchFamily="34" charset="-122"/>
                 <a:cs typeface="Garamond" pitchFamily="34" charset="-120"/>
               </a:rPr>
-              <a:t>Posicionamento</a:t>
+              <a:t>Quem já viveu</a:t>
             </a:r>
             <a:endParaRPr lang="en-US" sz="4400" dirty="0"/>
           </a:p>
@@ -5179,14 +5200,14 @@
       </p:sp>
       <p:sp>
         <p:nvSpPr>
-          <p:cNvPr id="5" name="Text 2"/>
+          <p:cNvPr id="4" name="Text 1"/>
           <p:cNvSpPr txBox="1"/>
           <p:nvPr/>
         </p:nvSpPr>
         <p:spPr>
           <a:xfrm>
-            <a:off x="731520" y="1874520"/>
-            <a:ext cx="6949440" cy="548640"/>
+            <a:off x="731520" y="1920240"/>
+            <a:ext cx="4297680" cy="1280160"/>
           </a:xfrm>
           <a:prstGeom prst="rect">
             <a:avLst/>
@@ -5199,38 +5220,41 @@
           <a:lstStyle/>
           <a:p>
             <a:pPr indent="0" marL="0">
-              <a:buNone/>
-            </a:pPr>
-            <a:r>
-              <a:rPr lang="en-US" sz="1500" dirty="0">
+              <a:lnSpc>
+                <a:spcPct val="115000"/>
+              </a:lnSpc>
+              <a:buNone/>
+            </a:pPr>
+            <a:r>
+              <a:rPr lang="en-US" sz="1700" dirty="0">
                 <a:solidFill>
                   <a:schemeClr val="tx2"/>
                 </a:solidFill>
               </a:rPr>
-              <a:t>Um programa realizado em Boston e Miami reúne, além do conteúdo técnico:</a:t>
-            </a:r>
-            <a:endParaRPr lang="en-US" sz="1500" dirty="0"/>
-          </a:p>
-        </p:txBody>
-      </p:sp>
-      <p:sp>
-        <p:nvSpPr>
-          <p:cNvPr id="6" name="Fio 1"/>
+              <a:t>Turma da Formação Internacional na etapa de Boston, com os certificados em mãos.</a:t>
+            </a:r>
+            <a:endParaRPr lang="en-US" sz="1700" dirty="0"/>
+          </a:p>
+        </p:txBody>
+      </p:sp>
+      <p:sp>
+        <p:nvSpPr>
+          <p:cNvPr id="5" name="Fio"/>
           <p:cNvSpPr/>
           <p:nvPr/>
         </p:nvSpPr>
         <p:spPr>
           <a:xfrm>
-            <a:off x="731520" y="2651760"/>
-            <a:ext cx="6949440" cy="0"/>
+            <a:off x="731520" y="3977640"/>
+            <a:ext cx="822960" cy="0"/>
           </a:xfrm>
           <a:prstGeom prst="line">
             <a:avLst/>
           </a:prstGeom>
           <a:noFill/>
-          <a:ln w="12700">
+          <a:ln w="15875">
             <a:solidFill>
-              <a:schemeClr val="accent3"/>
+              <a:schemeClr val="accent2"/>
             </a:solidFill>
             <a:prstDash val="solid"/>
           </a:ln>
@@ -5238,14 +5262,14 @@
       </p:sp>
       <p:sp>
         <p:nvSpPr>
-          <p:cNvPr id="7" name="Item 1 título"/>
+          <p:cNvPr id="6" name="Text 3"/>
           <p:cNvSpPr txBox="1"/>
           <p:nvPr/>
         </p:nvSpPr>
         <p:spPr>
           <a:xfrm>
-            <a:off x="731520" y="2788920"/>
-            <a:ext cx="6949440" cy="411480"/>
+            <a:off x="731520" y="4160520"/>
+            <a:ext cx="4572000" cy="548640"/>
           </a:xfrm>
           <a:prstGeom prst="rect">
             <a:avLst/>
@@ -5261,7 +5285,7 @@
               <a:buNone/>
             </a:pPr>
             <a:r>
-              <a:rPr lang="en-US" sz="2400" dirty="0">
+              <a:rPr lang="en-US" sz="2800" dirty="0">
                 <a:solidFill>
                   <a:schemeClr val="accent1"/>
                 </a:solidFill>
@@ -5269,22 +5293,22 @@
                 <a:ea typeface="Garamond" pitchFamily="34" charset="-122"/>
                 <a:cs typeface="Garamond" pitchFamily="34" charset="-120"/>
               </a:rPr>
-              <a:t>Doutores da estética</a:t>
-            </a:r>
-            <a:endParaRPr lang="en-US" sz="2400" dirty="0"/>
-          </a:p>
-        </p:txBody>
-      </p:sp>
-      <p:sp>
-        <p:nvSpPr>
-          <p:cNvPr id="8" name="Item 1 texto"/>
+              <a:t>A próxima etapa é em Miami.</a:t>
+            </a:r>
+            <a:endParaRPr lang="en-US" sz="2800" dirty="0"/>
+          </a:p>
+        </p:txBody>
+      </p:sp>
+      <p:sp>
+        <p:nvSpPr>
+          <p:cNvPr id="7" name="Text 4"/>
           <p:cNvSpPr txBox="1"/>
           <p:nvPr/>
         </p:nvSpPr>
         <p:spPr>
           <a:xfrm>
-            <a:off x="731520" y="3200400"/>
-            <a:ext cx="6949440" cy="365760"/>
+            <a:off x="731520" y="4754880"/>
+            <a:ext cx="4572000" cy="411480"/>
           </a:xfrm>
           <a:prstGeom prst="rect">
             <a:avLst/>
@@ -5300,246 +5324,14 @@
               <a:buNone/>
             </a:pPr>
             <a:r>
-              <a:rPr lang="en-US" sz="1400" dirty="0">
+              <a:rPr lang="en-US" sz="1500" dirty="0">
                 <a:solidFill>
                   <a:schemeClr val="tx2"/>
                 </a:solidFill>
               </a:rPr>
-              <a:t>nacionais e internacionais</a:t>
-            </a:r>
-            <a:endParaRPr lang="en-US" sz="1400" dirty="0"/>
-          </a:p>
-        </p:txBody>
-      </p:sp>
-      <p:sp>
-        <p:nvSpPr>
-          <p:cNvPr id="9" name="Fio 2"/>
-          <p:cNvSpPr/>
-          <p:nvPr/>
-        </p:nvSpPr>
-        <p:spPr>
-          <a:xfrm>
-            <a:off x="731520" y="3657600"/>
-            <a:ext cx="6949440" cy="0"/>
-          </a:xfrm>
-          <a:prstGeom prst="line">
-            <a:avLst/>
-          </a:prstGeom>
-          <a:noFill/>
-          <a:ln w="12700">
-            <a:solidFill>
-              <a:schemeClr val="accent3"/>
-            </a:solidFill>
-            <a:prstDash val="solid"/>
-          </a:ln>
-        </p:spPr>
-      </p:sp>
-      <p:sp>
-        <p:nvSpPr>
-          <p:cNvPr id="10" name="Item 2 título"/>
-          <p:cNvSpPr txBox="1"/>
-          <p:nvPr/>
-        </p:nvSpPr>
-        <p:spPr>
-          <a:xfrm>
-            <a:off x="731520" y="3794760"/>
-            <a:ext cx="6949440" cy="411480"/>
-          </a:xfrm>
-          <a:prstGeom prst="rect">
-            <a:avLst/>
-          </a:prstGeom>
-          <a:noFill/>
-          <a:ln/>
-        </p:spPr>
-        <p:txBody>
-          <a:bodyPr wrap="square" lIns="0" tIns="0" rIns="0" bIns="0" rtlCol="0" anchor="t"/>
-          <a:lstStyle/>
-          <a:p>
-            <a:pPr indent="0" marL="0">
-              <a:buNone/>
-            </a:pPr>
-            <a:r>
-              <a:rPr lang="en-US" sz="2400" dirty="0">
-                <a:solidFill>
-                  <a:schemeClr val="accent1"/>
-                </a:solidFill>
-                <a:latin typeface="Garamond" pitchFamily="34" charset="0"/>
-                <a:ea typeface="Garamond" pitchFamily="34" charset="-122"/>
-                <a:cs typeface="Garamond" pitchFamily="34" charset="-120"/>
-              </a:rPr>
-              <a:t>Convidados</a:t>
-            </a:r>
-            <a:endParaRPr lang="en-US" sz="2400" dirty="0"/>
-          </a:p>
-        </p:txBody>
-      </p:sp>
-      <p:sp>
-        <p:nvSpPr>
-          <p:cNvPr id="11" name="Item 2 texto"/>
-          <p:cNvSpPr txBox="1"/>
-          <p:nvPr/>
-        </p:nvSpPr>
-        <p:spPr>
-          <a:xfrm>
-            <a:off x="731520" y="4206240"/>
-            <a:ext cx="6949440" cy="365760"/>
-          </a:xfrm>
-          <a:prstGeom prst="rect">
-            <a:avLst/>
-          </a:prstGeom>
-          <a:noFill/>
-          <a:ln/>
-        </p:spPr>
-        <p:txBody>
-          <a:bodyPr wrap="square" lIns="0" tIns="0" rIns="0" bIns="0" rtlCol="0" anchor="t"/>
-          <a:lstStyle/>
-          <a:p>
-            <a:pPr indent="0" marL="0">
-              <a:buNone/>
-            </a:pPr>
-            <a:r>
-              <a:rPr lang="en-US" sz="1400" dirty="0">
-                <a:solidFill>
-                  <a:schemeClr val="tx2"/>
-                </a:solidFill>
-              </a:rPr>
-              <a:t>com cases reais de sucesso na estética e no empreendedorismo</a:t>
-            </a:r>
-            <a:endParaRPr lang="en-US" sz="1400" dirty="0"/>
-          </a:p>
-        </p:txBody>
-      </p:sp>
-      <p:sp>
-        <p:nvSpPr>
-          <p:cNvPr id="12" name="Fio 3"/>
-          <p:cNvSpPr/>
-          <p:nvPr/>
-        </p:nvSpPr>
-        <p:spPr>
-          <a:xfrm>
-            <a:off x="731520" y="4663440"/>
-            <a:ext cx="6949440" cy="0"/>
-          </a:xfrm>
-          <a:prstGeom prst="line">
-            <a:avLst/>
-          </a:prstGeom>
-          <a:noFill/>
-          <a:ln w="12700">
-            <a:solidFill>
-              <a:schemeClr val="accent3"/>
-            </a:solidFill>
-            <a:prstDash val="solid"/>
-          </a:ln>
-        </p:spPr>
-      </p:sp>
-      <p:sp>
-        <p:nvSpPr>
-          <p:cNvPr id="13" name="Item 3 título"/>
-          <p:cNvSpPr txBox="1"/>
-          <p:nvPr/>
-        </p:nvSpPr>
-        <p:spPr>
-          <a:xfrm>
-            <a:off x="731520" y="4800600"/>
-            <a:ext cx="6949440" cy="411480"/>
-          </a:xfrm>
-          <a:prstGeom prst="rect">
-            <a:avLst/>
-          </a:prstGeom>
-          <a:noFill/>
-          <a:ln/>
-        </p:spPr>
-        <p:txBody>
-          <a:bodyPr wrap="square" lIns="0" tIns="0" rIns="0" bIns="0" rtlCol="0" anchor="t"/>
-          <a:lstStyle/>
-          <a:p>
-            <a:pPr indent="0" marL="0">
-              <a:buNone/>
-            </a:pPr>
-            <a:r>
-              <a:rPr lang="en-US" sz="2400" dirty="0">
-                <a:solidFill>
-                  <a:schemeClr val="accent1"/>
-                </a:solidFill>
-                <a:latin typeface="Garamond" pitchFamily="34" charset="0"/>
-                <a:ea typeface="Garamond" pitchFamily="34" charset="-122"/>
-                <a:cs typeface="Garamond" pitchFamily="34" charset="-120"/>
-              </a:rPr>
-              <a:t>Palestrantes</a:t>
-            </a:r>
-            <a:endParaRPr lang="en-US" sz="2400" dirty="0"/>
-          </a:p>
-        </p:txBody>
-      </p:sp>
-      <p:sp>
-        <p:nvSpPr>
-          <p:cNvPr id="14" name="Item 3 texto"/>
-          <p:cNvSpPr txBox="1"/>
-          <p:nvPr/>
-        </p:nvSpPr>
-        <p:spPr>
-          <a:xfrm>
-            <a:off x="731520" y="5212080"/>
-            <a:ext cx="6949440" cy="365760"/>
-          </a:xfrm>
-          <a:prstGeom prst="rect">
-            <a:avLst/>
-          </a:prstGeom>
-          <a:noFill/>
-          <a:ln/>
-        </p:spPr>
-        <p:txBody>
-          <a:bodyPr wrap="square" lIns="0" tIns="0" rIns="0" bIns="0" rtlCol="0" anchor="t"/>
-          <a:lstStyle/>
-          <a:p>
-            <a:pPr indent="0" marL="0">
-              <a:buNone/>
-            </a:pPr>
-            <a:r>
-              <a:rPr lang="en-US" sz="1400" dirty="0">
-                <a:solidFill>
-                  <a:schemeClr val="tx2"/>
-                </a:solidFill>
-              </a:rPr>
-              <a:t>que atuam com carreira, posicionamento e autoridade</a:t>
-            </a:r>
-            <a:endParaRPr lang="en-US" sz="1400" dirty="0"/>
-          </a:p>
-        </p:txBody>
-      </p:sp>
-      <p:sp>
-        <p:nvSpPr>
-          <p:cNvPr id="15" name="Text 12"/>
-          <p:cNvSpPr txBox="1"/>
-          <p:nvPr/>
-        </p:nvSpPr>
-        <p:spPr>
-          <a:xfrm>
-            <a:off x="731520" y="5760720"/>
-            <a:ext cx="7132320" cy="457200"/>
-          </a:xfrm>
-          <a:prstGeom prst="rect">
-            <a:avLst/>
-          </a:prstGeom>
-          <a:noFill/>
-          <a:ln/>
-        </p:spPr>
-        <p:txBody>
-          <a:bodyPr wrap="square" lIns="0" tIns="0" rIns="0" bIns="0" rtlCol="0" anchor="t"/>
-          <a:lstStyle/>
-          <a:p>
-            <a:pPr indent="0" marL="0">
-              <a:buNone/>
-            </a:pPr>
-            <a:r>
-              <a:rPr lang="en-US" sz="1300" i="1" dirty="0">
-                <a:solidFill>
-                  <a:schemeClr val="tx2"/>
-                </a:solidFill>
-              </a:rPr>
-              <a:t>Um momento desenhado para troca de experiências, visão de mercado e conexões profissionais relevantes.</a:t>
-            </a:r>
-            <a:endParaRPr lang="en-US" sz="1300" dirty="0"/>
+              <a:t>19, 20 e 21 de maio de 2027</a:t>
+            </a:r>
+            <a:endParaRPr lang="en-US" sz="1500" dirty="0"/>
           </a:p>
         </p:txBody>
       </p:sp>
@@ -5618,7 +5410,7 @@
       </p:grpSpPr>
       <p:pic>
         <p:nvPicPr>
-          <p:cNvPr id="2" name="Foto da turma" descr="Turma da Formação Internacional reunida em uma escadaria, de uniforme vinho, segurando certificados e uma bandeira de Harvard">    </p:cNvPr>
+          <p:cNvPr id="2" name="Foto Miami" descr="Vista aérea de um campus universitário e hospitalar em Miami, com palmeiras">    </p:cNvPr>
           <p:cNvPicPr>
             <a:picLocks noChangeAspect="1"/>
           </p:cNvPicPr>
@@ -5632,8 +5424,8 @@
         </p:blipFill>
         <p:spPr>
           <a:xfrm>
-            <a:off x="5486400" y="0"/>
-            <a:ext cx="6705295" cy="6858000"/>
+            <a:off x="0" y="0"/>
+            <a:ext cx="12191695" cy="6858000"/>
           </a:xfrm>
           <a:prstGeom prst="rect">
             <a:avLst/>
@@ -5642,11 +5434,38 @@
       </p:pic>
       <p:sp>
         <p:nvSpPr>
-          <p:cNvPr id="3" name="Text 0"/>
+          <p:cNvPr id="3" name="Véu vinho"/>
           <p:cNvSpPr/>
-          <p:nvPr>
-            <p:ph idx="100" type="title" hasCustomPrompt="1"/>
-          </p:nvPr>
+          <p:nvPr/>
+        </p:nvSpPr>
+        <p:spPr>
+          <a:xfrm>
+            <a:off x="0" y="0"/>
+            <a:ext cx="12191695" cy="6858000"/>
+          </a:xfrm>
+          <a:prstGeom prst="rect">
+            <a:avLst/>
+          </a:prstGeom>
+          <a:solidFill>
+            <a:schemeClr val="accent5">
+              <a:alpha val="62000"/>
+            </a:schemeClr>
+          </a:solidFill>
+          <a:ln w="12700">
+            <a:solidFill>
+              <a:schemeClr val="accent5">
+                <a:alpha val="0"/>
+              </a:schemeClr>
+            </a:solidFill>
+            <a:prstDash val="solid"/>
+          </a:ln>
+        </p:spPr>
+      </p:sp>
+      <p:sp>
+        <p:nvSpPr>
+          <p:cNvPr id="4" name="Título"/>
+          <p:cNvSpPr txBox="1"/>
+          <p:nvPr/>
         </p:nvSpPr>
         <p:spPr>
           <a:xfrm>
@@ -5663,19 +5482,19 @@
           <a:bodyPr wrap="square" lIns="0" tIns="0" rIns="0" bIns="0" rtlCol="0" anchor="t"/>
           <a:lstStyle/>
           <a:p>
-            <a:pPr algn="l" indent="0" marL="0">
+            <a:pPr indent="0" marL="0">
               <a:buNone/>
             </a:pPr>
             <a:r>
               <a:rPr lang="en-US" sz="4400" dirty="0">
                 <a:solidFill>
-                  <a:schemeClr val="accent1"/>
+                  <a:schemeClr val="bg1"/>
                 </a:solidFill>
                 <a:latin typeface="Garamond" pitchFamily="34" charset="0"/>
                 <a:ea typeface="Garamond" pitchFamily="34" charset="-122"/>
                 <a:cs typeface="Garamond" pitchFamily="34" charset="-120"/>
               </a:rPr>
-              <a:t>Quem já viveu</a:t>
+              <a:t>Programação prática</a:t>
             </a:r>
             <a:endParaRPr lang="en-US" sz="4400" dirty="0"/>
           </a:p>
@@ -5683,14 +5502,14 @@
       </p:sp>
       <p:sp>
         <p:nvSpPr>
-          <p:cNvPr id="4" name="Text 1"/>
+          <p:cNvPr id="5" name="Text 2"/>
           <p:cNvSpPr txBox="1"/>
           <p:nvPr/>
         </p:nvSpPr>
         <p:spPr>
           <a:xfrm>
-            <a:off x="731520" y="1920240"/>
-            <a:ext cx="4297680" cy="1280160"/>
+            <a:off x="731520" y="1600200"/>
+            <a:ext cx="10698480" cy="365760"/>
           </a:xfrm>
           <a:prstGeom prst="rect">
             <a:avLst/>
@@ -5703,39 +5522,36 @@
           <a:lstStyle/>
           <a:p>
             <a:pPr indent="0" marL="0">
-              <a:lnSpc>
-                <a:spcPct val="115000"/>
-              </a:lnSpc>
-              <a:buNone/>
-            </a:pPr>
-            <a:r>
-              <a:rPr lang="en-US" sz="1700" dirty="0">
-                <a:solidFill>
-                  <a:schemeClr val="tx2"/>
-                </a:solidFill>
-              </a:rPr>
-              <a:t>Turma da Formação Internacional na etapa de Boston, com os certificados em mãos.</a:t>
-            </a:r>
-            <a:endParaRPr lang="en-US" sz="1700" dirty="0"/>
-          </a:p>
-        </p:txBody>
-      </p:sp>
-      <p:sp>
-        <p:nvSpPr>
-          <p:cNvPr id="5" name="Fio"/>
+              <a:buNone/>
+            </a:pPr>
+            <a:r>
+              <a:rPr lang="en-US" sz="1600" dirty="0">
+                <a:solidFill>
+                  <a:schemeClr val="accent4"/>
+                </a:solidFill>
+              </a:rPr>
+              <a:t>Anatomia aplicada e hands-on  ·  19, 20 e 21 de maio de 2027</a:t>
+            </a:r>
+            <a:endParaRPr lang="en-US" sz="1600" dirty="0"/>
+          </a:p>
+        </p:txBody>
+      </p:sp>
+      <p:sp>
+        <p:nvSpPr>
+          <p:cNvPr id="6" name="Fio 1"/>
           <p:cNvSpPr/>
           <p:nvPr/>
         </p:nvSpPr>
         <p:spPr>
           <a:xfrm>
-            <a:off x="731520" y="3977640"/>
-            <a:ext cx="822960" cy="0"/>
+            <a:off x="731520" y="2331720"/>
+            <a:ext cx="10725912" cy="0"/>
           </a:xfrm>
           <a:prstGeom prst="line">
             <a:avLst/>
           </a:prstGeom>
           <a:noFill/>
-          <a:ln w="15875">
+          <a:ln w="9525">
             <a:solidFill>
               <a:schemeClr val="accent2"/>
             </a:solidFill>
@@ -5745,14 +5561,14 @@
       </p:sp>
       <p:sp>
         <p:nvSpPr>
-          <p:cNvPr id="6" name="Text 3"/>
+          <p:cNvPr id="7" name="Módulo 1"/>
           <p:cNvSpPr txBox="1"/>
           <p:nvPr/>
         </p:nvSpPr>
         <p:spPr>
           <a:xfrm>
-            <a:off x="731520" y="4160520"/>
-            <a:ext cx="4572000" cy="548640"/>
+            <a:off x="731520" y="2459736"/>
+            <a:ext cx="10698480" cy="548640"/>
           </a:xfrm>
           <a:prstGeom prst="rect">
             <a:avLst/>
@@ -5761,37 +5577,60 @@
           <a:ln/>
         </p:spPr>
         <p:txBody>
-          <a:bodyPr wrap="square" lIns="0" tIns="0" rIns="0" bIns="0" rtlCol="0" anchor="t"/>
+          <a:bodyPr wrap="square" lIns="0" tIns="0" rIns="0" bIns="0" rtlCol="0" anchor="ctr"/>
           <a:lstStyle/>
           <a:p>
             <a:pPr indent="0" marL="0">
               <a:buNone/>
             </a:pPr>
             <a:r>
-              <a:rPr lang="en-US" sz="2800" dirty="0">
-                <a:solidFill>
-                  <a:schemeClr val="accent1"/>
+              <a:rPr lang="en-US" sz="2400" dirty="0">
+                <a:solidFill>
+                  <a:schemeClr val="bg1"/>
                 </a:solidFill>
                 <a:latin typeface="Garamond" pitchFamily="34" charset="0"/>
                 <a:ea typeface="Garamond" pitchFamily="34" charset="-122"/>
                 <a:cs typeface="Garamond" pitchFamily="34" charset="-120"/>
               </a:rPr>
-              <a:t>A próxima etapa é em Miami.</a:t>
-            </a:r>
-            <a:endParaRPr lang="en-US" sz="2800" dirty="0"/>
-          </a:p>
-        </p:txBody>
-      </p:sp>
-      <p:sp>
-        <p:nvSpPr>
-          <p:cNvPr id="7" name="Text 4"/>
+              <a:t>Anatomia avançada de cabeça e pescoço aplicada a injetáveis</a:t>
+            </a:r>
+            <a:endParaRPr lang="en-US" sz="2400" dirty="0"/>
+          </a:p>
+        </p:txBody>
+      </p:sp>
+      <p:sp>
+        <p:nvSpPr>
+          <p:cNvPr id="8" name="Fio 2"/>
+          <p:cNvSpPr/>
+          <p:nvPr/>
+        </p:nvSpPr>
+        <p:spPr>
+          <a:xfrm>
+            <a:off x="731520" y="3118104"/>
+            <a:ext cx="10725912" cy="0"/>
+          </a:xfrm>
+          <a:prstGeom prst="line">
+            <a:avLst/>
+          </a:prstGeom>
+          <a:noFill/>
+          <a:ln w="9525">
+            <a:solidFill>
+              <a:schemeClr val="accent2"/>
+            </a:solidFill>
+            <a:prstDash val="solid"/>
+          </a:ln>
+        </p:spPr>
+      </p:sp>
+      <p:sp>
+        <p:nvSpPr>
+          <p:cNvPr id="9" name="Módulo 2"/>
           <p:cNvSpPr txBox="1"/>
           <p:nvPr/>
         </p:nvSpPr>
         <p:spPr>
           <a:xfrm>
-            <a:off x="731520" y="4754880"/>
-            <a:ext cx="4572000" cy="411480"/>
+            <a:off x="731520" y="3246120"/>
+            <a:ext cx="10698480" cy="548640"/>
           </a:xfrm>
           <a:prstGeom prst="rect">
             <a:avLst/>
@@ -5800,68 +5639,235 @@
           <a:ln/>
         </p:spPr>
         <p:txBody>
-          <a:bodyPr wrap="square" lIns="0" tIns="0" rIns="0" bIns="0" rtlCol="0" anchor="t"/>
+          <a:bodyPr wrap="square" lIns="0" tIns="0" rIns="0" bIns="0" rtlCol="0" anchor="ctr"/>
           <a:lstStyle/>
           <a:p>
             <a:pPr indent="0" marL="0">
               <a:buNone/>
             </a:pPr>
             <a:r>
-              <a:rPr lang="en-US" sz="1500" dirty="0">
-                <a:solidFill>
-                  <a:schemeClr val="tx2"/>
-                </a:solidFill>
-              </a:rPr>
-              <a:t>19, 20 e 21 de maio de 2027</a:t>
-            </a:r>
-            <a:endParaRPr lang="en-US" sz="1500" dirty="0"/>
-          </a:p>
-        </p:txBody>
-      </p:sp>
-      <p:sp>
-        <p:nvSpPr>
-          <p:cNvPr id="25" name="Slide Number Placeholder 0"/>
-          <p:cNvSpPr>
-            <a:spLocks noGrp="1"/>
-          </p:cNvSpPr>
-          <p:nvPr>
-            <p:ph type="sldNum" sz="quarter" idx="4294967295"/>
-          </p:nvPr>
-        </p:nvSpPr>
-        <p:spPr>
-          <a:xfrm>
-            <a:off x="11155680" y="6355080"/>
-            <a:ext cx="411480" cy="274320"/>
-          </a:xfrm>
-          <a:prstGeom prst="rect">
-            <a:avLst/>
-          </a:prstGeom>
-          <a:extLst>
-            <a:ext uri="{C572A759-6A51-4108-AA02-DFA0A04FC94B}">
-              <ma14:wrappingTextBoxFlag xmlns:ma14="http://schemas.microsoft.com/office/mac/drawingml/2011/main" val="0"/>
-            </a:ext>
-          </a:extLst>
-        </p:spPr>
-        <p:txBody>
-          <a:bodyPr/>
-          <a:lstStyle>
-            <a:lvl1pPr>
-              <a:defRPr sz="900">
-                <a:solidFill>
-                  <a:schemeClr val="tx2"/>
-                </a:solidFill>
-              </a:defRPr>
-            </a:lvl1pPr>
-          </a:lstStyle>
-          <a:p>
-            <a:pPr algn="r"/>
-            <a:fld id="{F7021451-1387-4CA6-816F-3879F97B5CBC}" type="slidenum">
-              <a:rPr b="0" lang="en-US"/>
-              <a:t>9</a:t>
-            </a:fld>
-            <a:endParaRPr lang="en-US"/>
-          </a:p>
-        </p:txBody>
+              <a:rPr lang="en-US" sz="2400" dirty="0">
+                <a:solidFill>
+                  <a:schemeClr val="bg1"/>
+                </a:solidFill>
+                <a:latin typeface="Garamond" pitchFamily="34" charset="0"/>
+                <a:ea typeface="Garamond" pitchFamily="34" charset="-122"/>
+                <a:cs typeface="Garamond" pitchFamily="34" charset="-120"/>
+              </a:rPr>
+              <a:t>Anatomia avançada de cabeça e pescoço aplicada a fios faciais</a:t>
+            </a:r>
+            <a:endParaRPr lang="en-US" sz="2400" dirty="0"/>
+          </a:p>
+        </p:txBody>
+      </p:sp>
+      <p:sp>
+        <p:nvSpPr>
+          <p:cNvPr id="10" name="Fio 3"/>
+          <p:cNvSpPr/>
+          <p:nvPr/>
+        </p:nvSpPr>
+        <p:spPr>
+          <a:xfrm>
+            <a:off x="731520" y="3904488"/>
+            <a:ext cx="10725912" cy="0"/>
+          </a:xfrm>
+          <a:prstGeom prst="line">
+            <a:avLst/>
+          </a:prstGeom>
+          <a:noFill/>
+          <a:ln w="9525">
+            <a:solidFill>
+              <a:schemeClr val="accent2"/>
+            </a:solidFill>
+            <a:prstDash val="solid"/>
+          </a:ln>
+        </p:spPr>
+      </p:sp>
+      <p:sp>
+        <p:nvSpPr>
+          <p:cNvPr id="11" name="Módulo 3"/>
+          <p:cNvSpPr txBox="1"/>
+          <p:nvPr/>
+        </p:nvSpPr>
+        <p:spPr>
+          <a:xfrm>
+            <a:off x="731520" y="4032504"/>
+            <a:ext cx="10698480" cy="548640"/>
+          </a:xfrm>
+          <a:prstGeom prst="rect">
+            <a:avLst/>
+          </a:prstGeom>
+          <a:noFill/>
+          <a:ln/>
+        </p:spPr>
+        <p:txBody>
+          <a:bodyPr wrap="square" lIns="0" tIns="0" rIns="0" bIns="0" rtlCol="0" anchor="ctr"/>
+          <a:lstStyle/>
+          <a:p>
+            <a:pPr indent="0" marL="0">
+              <a:buNone/>
+            </a:pPr>
+            <a:r>
+              <a:rPr lang="en-US" sz="2400" dirty="0">
+                <a:solidFill>
+                  <a:schemeClr val="bg1"/>
+                </a:solidFill>
+                <a:latin typeface="Garamond" pitchFamily="34" charset="0"/>
+                <a:ea typeface="Garamond" pitchFamily="34" charset="-122"/>
+                <a:cs typeface="Garamond" pitchFamily="34" charset="-120"/>
+              </a:rPr>
+              <a:t>Bioestimuladores faciais e corporais: fundamentos, indicações e limites</a:t>
+            </a:r>
+            <a:endParaRPr lang="en-US" sz="2400" dirty="0"/>
+          </a:p>
+        </p:txBody>
+      </p:sp>
+      <p:sp>
+        <p:nvSpPr>
+          <p:cNvPr id="12" name="Fio 4"/>
+          <p:cNvSpPr/>
+          <p:nvPr/>
+        </p:nvSpPr>
+        <p:spPr>
+          <a:xfrm>
+            <a:off x="731520" y="4690872"/>
+            <a:ext cx="10725912" cy="0"/>
+          </a:xfrm>
+          <a:prstGeom prst="line">
+            <a:avLst/>
+          </a:prstGeom>
+          <a:noFill/>
+          <a:ln w="9525">
+            <a:solidFill>
+              <a:schemeClr val="accent2"/>
+            </a:solidFill>
+            <a:prstDash val="solid"/>
+          </a:ln>
+        </p:spPr>
+      </p:sp>
+      <p:sp>
+        <p:nvSpPr>
+          <p:cNvPr id="13" name="Módulo 4"/>
+          <p:cNvSpPr txBox="1"/>
+          <p:nvPr/>
+        </p:nvSpPr>
+        <p:spPr>
+          <a:xfrm>
+            <a:off x="731520" y="4818888"/>
+            <a:ext cx="10698480" cy="548640"/>
+          </a:xfrm>
+          <a:prstGeom prst="rect">
+            <a:avLst/>
+          </a:prstGeom>
+          <a:noFill/>
+          <a:ln/>
+        </p:spPr>
+        <p:txBody>
+          <a:bodyPr wrap="square" lIns="0" tIns="0" rIns="0" bIns="0" rtlCol="0" anchor="ctr"/>
+          <a:lstStyle/>
+          <a:p>
+            <a:pPr indent="0" marL="0">
+              <a:buNone/>
+            </a:pPr>
+            <a:r>
+              <a:rPr lang="en-US" sz="2400" dirty="0">
+                <a:solidFill>
+                  <a:schemeClr val="bg1"/>
+                </a:solidFill>
+                <a:latin typeface="Garamond" pitchFamily="34" charset="0"/>
+                <a:ea typeface="Garamond" pitchFamily="34" charset="-122"/>
+                <a:cs typeface="Garamond" pitchFamily="34" charset="-120"/>
+              </a:rPr>
+              <a:t>Lifting facial com preenchedores: raciocínio anatômico e estrutural</a:t>
+            </a:r>
+            <a:endParaRPr lang="en-US" sz="2400" dirty="0"/>
+          </a:p>
+        </p:txBody>
+      </p:sp>
+      <p:sp>
+        <p:nvSpPr>
+          <p:cNvPr id="14" name="Fio 5"/>
+          <p:cNvSpPr/>
+          <p:nvPr/>
+        </p:nvSpPr>
+        <p:spPr>
+          <a:xfrm>
+            <a:off x="731520" y="5477256"/>
+            <a:ext cx="10725912" cy="0"/>
+          </a:xfrm>
+          <a:prstGeom prst="line">
+            <a:avLst/>
+          </a:prstGeom>
+          <a:noFill/>
+          <a:ln w="9525">
+            <a:solidFill>
+              <a:schemeClr val="accent2"/>
+            </a:solidFill>
+            <a:prstDash val="solid"/>
+          </a:ln>
+        </p:spPr>
+      </p:sp>
+      <p:sp>
+        <p:nvSpPr>
+          <p:cNvPr id="15" name="Módulo 5"/>
+          <p:cNvSpPr txBox="1"/>
+          <p:nvPr/>
+        </p:nvSpPr>
+        <p:spPr>
+          <a:xfrm>
+            <a:off x="731520" y="5605272"/>
+            <a:ext cx="10698480" cy="548640"/>
+          </a:xfrm>
+          <a:prstGeom prst="rect">
+            <a:avLst/>
+          </a:prstGeom>
+          <a:noFill/>
+          <a:ln/>
+        </p:spPr>
+        <p:txBody>
+          <a:bodyPr wrap="square" lIns="0" tIns="0" rIns="0" bIns="0" rtlCol="0" anchor="ctr"/>
+          <a:lstStyle/>
+          <a:p>
+            <a:pPr indent="0" marL="0">
+              <a:buNone/>
+            </a:pPr>
+            <a:r>
+              <a:rPr lang="en-US" sz="2400" dirty="0">
+                <a:solidFill>
+                  <a:schemeClr val="bg1"/>
+                </a:solidFill>
+                <a:latin typeface="Garamond" pitchFamily="34" charset="0"/>
+                <a:ea typeface="Garamond" pitchFamily="34" charset="-122"/>
+                <a:cs typeface="Garamond" pitchFamily="34" charset="-120"/>
+              </a:rPr>
+              <a:t>Full face: planejamento anatômico, segurança e naturalidade</a:t>
+            </a:r>
+            <a:endParaRPr lang="en-US" sz="2400" dirty="0"/>
+          </a:p>
+        </p:txBody>
+      </p:sp>
+      <p:sp>
+        <p:nvSpPr>
+          <p:cNvPr id="16" name="Fio final"/>
+          <p:cNvSpPr/>
+          <p:nvPr/>
+        </p:nvSpPr>
+        <p:spPr>
+          <a:xfrm>
+            <a:off x="731520" y="6263640"/>
+            <a:ext cx="10725912" cy="0"/>
+          </a:xfrm>
+          <a:prstGeom prst="line">
+            <a:avLst/>
+          </a:prstGeom>
+          <a:noFill/>
+          <a:ln w="9525">
+            <a:solidFill>
+              <a:schemeClr val="accent2"/>
+            </a:solidFill>
+            <a:prstDash val="solid"/>
+          </a:ln>
+        </p:spPr>
       </p:sp>
     </p:spTree>
   </p:cSld>

</xml_diff>

<commit_message>
Etapa Miami: depoimento da aluna dentro do slide de Posicionamento
Co-Authored-By: Claude Opus 5.5 <noreply@anthropic.com>
Claude-Session: https://claude.ai/code/session_01ETjDEHo1Y5Ziwi4pumEH8K
</commit_message>
<xml_diff>
--- a/entregas/Formacao-Internacional-Etapa-Miami.pptx
+++ b/entregas/Formacao-Internacional-Etapa-Miami.pptx
@@ -15,10 +15,9 @@
     <p:sldId id="263" r:id="rId9"/>
     <p:sldId id="264" r:id="rId10"/>
     <p:sldId id="265" r:id="rId11"/>
-    <p:sldId id="266" r:id="rId12"/>
   </p:sldIdLst>
   <p:notesMasterIdLst>
-    <p:notesMasterId r:id="rId13"/>
+    <p:notesMasterId r:id="rId12"/>
   </p:notesMasterIdLst>
   <p:sldSz cx="12192000" cy="6858000"/>
   <p:notesSz cx="6858000" cy="12192000"/>
@@ -117,7 +116,7 @@
   <p:extLst>
     <p:ext uri="{521415D9-36F7-43E2-AB2F-B90AF26B5E84}">
       <p14:sectionLst xmlns:p14="http://schemas.microsoft.com/office/powerpoint/2010/main">
-        <p14:section name="Abertura" id="{30f2e697-24d7-cc94-0b01-27f1a7b8ef3f}">
+        <p14:section name="Abertura" id="{33c09f5b-796e-e80f-620b-ef1043deead3}">
           <p14:sldIdLst>
             <p14:sldId id="256"/>
             <p14:sldId id="257"/>
@@ -125,23 +124,22 @@
             <p14:sldId id="259"/>
           </p14:sldIdLst>
         </p14:section>
-        <p14:section name="A etapa" id="{a73b45c2-af94-56cb-a9fc-5b687dd87a15}">
+        <p14:section name="A etapa" id="{ee230bea-e478-b65f-3cff-daf6af3e2330}">
           <p14:sldIdLst>
             <p14:sldId id="260"/>
             <p14:sldId id="261"/>
           </p14:sldIdLst>
         </p14:section>
-        <p14:section name="Pessoas" id="{caf6166f-443d-4d2f-8b19-36407cc2f1dc}">
+        <p14:section name="Pessoas" id="{f38a9533-7147-5417-34ad-7d5b9bdfffea}">
           <p14:sldIdLst>
             <p14:sldId id="262"/>
             <p14:sldId id="263"/>
             <p14:sldId id="264"/>
-            <p14:sldId id="265"/>
           </p14:sldIdLst>
         </p14:section>
-        <p14:section name="Inscrição" id="{93c638d8-99ed-6a97-3ed7-a7bdf7451e59}">
+        <p14:section name="Inscrição" id="{cc07784d-411b-606c-c609-91a79f56c495}">
           <p14:sldIdLst>
-            <p14:sldId id="266"/>
+            <p14:sldId id="265"/>
           </p14:sldIdLst>
         </p14:section>
       </p14:sectionLst>
@@ -636,7 +634,7 @@
           <a:p>
             <a:r>
               <a:rPr lang="en-US" dirty="0"/>
-              <a:t/>
+              <a:t>O QR code e o número abrem o WhatsApp (62) 98515-0061 com a mensagem pronta: Olá, quero saber mais do Programa de Formação Internacional.</a:t>
             </a:r>
             <a:endParaRPr lang="en-US" dirty="0"/>
           </a:p>
@@ -660,94 +658,6 @@
             <a:fld id="{F7021451-1387-4CA6-816F-3879F97B5CBC}" type="slidenum">
               <a:rPr lang="en-US"/>
               <a:t>10</a:t>
-            </a:fld>
-            <a:endParaRPr lang="en-US"/>
-          </a:p>
-        </p:txBody>
-      </p:sp>
-    </p:spTree>
-    <p:extLst>
-      <p:ext uri="{BB962C8B-B14F-4D97-AF65-F5344CB8AC3E}">
-        <p14:creationId xmlns:p14="http://schemas.microsoft.com/office/powerpoint/2010/main" val="1024086991"/>
-      </p:ext>
-    </p:extLst>
-  </p:cSld>
-  <p:clrMapOvr>
-    <a:masterClrMapping/>
-  </p:clrMapOvr>
-</p:notes>
-</file>
-
-<file path=ppt/notesSlides/notesSlide11.xml><?xml version="1.0" encoding="utf-8"?>
-<p:notes xmlns:a="http://schemas.openxmlformats.org/drawingml/2006/main" xmlns:r="http://schemas.openxmlformats.org/officeDocument/2006/relationships" xmlns:p="http://schemas.openxmlformats.org/presentationml/2006/main">
-  <p:cSld>
-    <p:spTree>
-      <p:nvGrpSpPr>
-        <p:cNvPr id="1" name=""/>
-        <p:cNvGrpSpPr/>
-        <p:nvPr/>
-      </p:nvGrpSpPr>
-      <p:grpSpPr>
-        <a:xfrm>
-          <a:off x="0" y="0"/>
-          <a:ext cx="0" cy="0"/>
-          <a:chOff x="0" y="0"/>
-          <a:chExt cx="0" cy="0"/>
-        </a:xfrm>
-      </p:grpSpPr>
-      <p:sp>
-        <p:nvSpPr>
-          <p:cNvPr id="2" name="Slide Image Placeholder 1"/>
-          <p:cNvSpPr>
-            <a:spLocks noGrp="1" noRot="1" noChangeAspect="1"/>
-          </p:cNvSpPr>
-          <p:nvPr>
-            <p:ph type="sldImg"/>
-          </p:nvPr>
-        </p:nvSpPr>
-        <p:spPr/>
-      </p:sp>
-      <p:sp>
-        <p:nvSpPr>
-          <p:cNvPr id="3" name="Notes Placeholder 2"/>
-          <p:cNvSpPr>
-            <a:spLocks noGrp="1"/>
-          </p:cNvSpPr>
-          <p:nvPr>
-            <p:ph type="body" idx="1"/>
-          </p:nvPr>
-        </p:nvSpPr>
-        <p:spPr/>
-        <p:txBody>
-          <a:bodyPr/>
-          <a:lstStyle/>
-          <a:p>
-            <a:r>
-              <a:rPr lang="en-US" dirty="0"/>
-              <a:t>O QR code e o número abrem o WhatsApp (62) 98515-0061 com a mensagem pronta: Olá, quero saber mais do Programa de Formação Internacional.</a:t>
-            </a:r>
-            <a:endParaRPr lang="en-US" dirty="0"/>
-          </a:p>
-        </p:txBody>
-      </p:sp>
-      <p:sp>
-        <p:nvSpPr>
-          <p:cNvPr id="4" name="Slide Number Placeholder 3"/>
-          <p:cNvSpPr>
-            <a:spLocks noGrp="1"/>
-          </p:cNvSpPr>
-          <p:nvPr>
-            <p:ph type="sldNum" sz="quarter" idx="10"/>
-          </p:nvPr>
-        </p:nvSpPr>
-        <p:spPr/>
-        <p:txBody>
-          <a:bodyPr/>
-          <a:lstStyle/>
-          <a:p>
-            <a:fld id="{F7021451-1387-4CA6-816F-3879F97B5CBC}" type="slidenum">
-              <a:rPr lang="en-US"/>
-              <a:t>11</a:t>
             </a:fld>
             <a:endParaRPr lang="en-US"/>
           </a:p>
@@ -2144,142 +2054,6 @@
       <p:sp>
         <p:nvSpPr>
           <p:cNvPr id="2" name="Text 0"/>
-          <p:cNvSpPr/>
-          <p:nvPr>
-            <p:ph idx="100" type="title" hasCustomPrompt="1"/>
-          </p:nvPr>
-        </p:nvSpPr>
-        <p:spPr>
-          <a:xfrm>
-            <a:off x="731520" y="777240"/>
-            <a:ext cx="10698480" cy="914400"/>
-          </a:xfrm>
-          <a:prstGeom prst="rect">
-            <a:avLst/>
-          </a:prstGeom>
-          <a:noFill/>
-          <a:ln/>
-        </p:spPr>
-        <p:txBody>
-          <a:bodyPr wrap="square" lIns="0" tIns="0" rIns="0" bIns="0" rtlCol="0" anchor="t"/>
-          <a:lstStyle/>
-          <a:p>
-            <a:pPr algn="l" indent="0" marL="0">
-              <a:buNone/>
-            </a:pPr>
-            <a:r>
-              <a:rPr lang="en-US" sz="4400" dirty="0">
-                <a:solidFill>
-                  <a:schemeClr val="bg1"/>
-                </a:solidFill>
-                <a:latin typeface="Garamond" pitchFamily="34" charset="0"/>
-                <a:ea typeface="Garamond" pitchFamily="34" charset="-122"/>
-                <a:cs typeface="Garamond" pitchFamily="34" charset="-120"/>
-              </a:rPr>
-              <a:t>O resultado na prática</a:t>
-            </a:r>
-            <a:endParaRPr lang="en-US" sz="4400" dirty="0"/>
-          </a:p>
-        </p:txBody>
-      </p:sp>
-      <p:pic>
-        <p:nvPicPr>
-          <p:cNvPr id="3" name="Depoimento" descr="Mensagem de aluna: depois da Formação Internacional, converteu o valor do curso em menos de 2 meses com 2 pacientes">    </p:cNvPr>
-          <p:cNvPicPr>
-            <a:picLocks noChangeAspect="1"/>
-          </p:cNvPicPr>
-          <p:nvPr/>
-        </p:nvPicPr>
-        <p:blipFill>
-          <a:blip r:embed="rId1"/>
-          <a:stretch>
-            <a:fillRect/>
-          </a:stretch>
-        </p:blipFill>
-        <p:spPr>
-          <a:xfrm>
-            <a:off x="1984248" y="2057400"/>
-            <a:ext cx="8229600" cy="2468880"/>
-          </a:xfrm>
-          <a:prstGeom prst="rect">
-            <a:avLst/>
-          </a:prstGeom>
-          <a:effectLst>
-            <a:outerShdw sx="100000" sy="100000" kx="0" ky="0" algn="bl" rotWithShape="0" blurRad="177800" dist="50800" dir="5400000">
-              <a:srgbClr val="000000">
-                <a:alpha val="35000"/>
-              </a:srgbClr>
-            </a:outerShdw>
-          </a:effectLst>
-        </p:spPr>
-      </p:pic>
-      <p:sp>
-        <p:nvSpPr>
-          <p:cNvPr id="4" name="Text 1"/>
-          <p:cNvSpPr txBox="1"/>
-          <p:nvPr/>
-        </p:nvSpPr>
-        <p:spPr>
-          <a:xfrm>
-            <a:off x="1984248" y="4846320"/>
-            <a:ext cx="8229600" cy="365760"/>
-          </a:xfrm>
-          <a:prstGeom prst="rect">
-            <a:avLst/>
-          </a:prstGeom>
-          <a:noFill/>
-          <a:ln/>
-        </p:spPr>
-        <p:txBody>
-          <a:bodyPr wrap="square" lIns="0" tIns="0" rIns="0" bIns="0" rtlCol="0" anchor="t"/>
-          <a:lstStyle/>
-          <a:p>
-            <a:pPr indent="0" marL="0">
-              <a:buNone/>
-            </a:pPr>
-            <a:r>
-              <a:rPr lang="en-US" sz="1300" i="1" dirty="0">
-                <a:solidFill>
-                  <a:schemeClr val="accent4"/>
-                </a:solidFill>
-              </a:rPr>
-              <a:t>Relato de aluna da Formação Internacional, enviado no grupo da turma.</a:t>
-            </a:r>
-            <a:endParaRPr lang="en-US" sz="1300" dirty="0"/>
-          </a:p>
-        </p:txBody>
-      </p:sp>
-    </p:spTree>
-  </p:cSld>
-  <p:clrMapOvr>
-    <a:masterClrMapping/>
-  </p:clrMapOvr>
-  <p:transition spd="slow">
-    <p:fade/>
-  </p:transition>
-</p:sld>
-</file>
-
-<file path=ppt/slides/slide11.xml><?xml version="1.0" encoding="utf-8"?>
-<p:sld xmlns:a="http://schemas.openxmlformats.org/drawingml/2006/main" xmlns:r="http://schemas.openxmlformats.org/officeDocument/2006/relationships" xmlns:p="http://schemas.openxmlformats.org/presentationml/2006/main">
-  <p:cSld name="Slide 11">
-    <p:spTree>
-      <p:nvGrpSpPr>
-        <p:cNvPr id="1" name=""/>
-        <p:cNvGrpSpPr/>
-        <p:nvPr/>
-      </p:nvGrpSpPr>
-      <p:grpSpPr>
-        <a:xfrm>
-          <a:off x="0" y="0"/>
-          <a:ext cx="0" cy="0"/>
-          <a:chOff x="0" y="0"/>
-          <a:chExt cx="0" cy="0"/>
-        </a:xfrm>
-      </p:grpSpPr>
-      <p:sp>
-        <p:nvSpPr>
-          <p:cNvPr id="2" name="Text 0"/>
           <p:cNvSpPr txBox="1"/>
           <p:nvPr/>
         </p:nvSpPr>
@@ -4599,8 +4373,8 @@
         </p:blipFill>
         <p:spPr>
           <a:xfrm>
-            <a:off x="8366760" y="685800"/>
-            <a:ext cx="3182112" cy="5477256"/>
+            <a:off x="9189720" y="1984248"/>
+            <a:ext cx="2450592" cy="4215384"/>
           </a:xfrm>
           <a:prstGeom prst="rect">
             <a:avLst/>
@@ -4702,8 +4476,8 @@
         </p:nvSpPr>
         <p:spPr>
           <a:xfrm>
-            <a:off x="731520" y="1874520"/>
-            <a:ext cx="6949440" cy="548640"/>
+            <a:off x="731520" y="1783080"/>
+            <a:ext cx="7863840" cy="365760"/>
           </a:xfrm>
           <a:prstGeom prst="rect">
             <a:avLst/>
@@ -4738,8 +4512,8 @@
         </p:nvSpPr>
         <p:spPr>
           <a:xfrm>
-            <a:off x="731520" y="2651760"/>
-            <a:ext cx="6949440" cy="0"/>
+            <a:off x="731520" y="2331720"/>
+            <a:ext cx="2468880" cy="0"/>
           </a:xfrm>
           <a:prstGeom prst="line">
             <a:avLst/>
@@ -4761,8 +4535,8 @@
         </p:nvSpPr>
         <p:spPr>
           <a:xfrm>
-            <a:off x="731520" y="2788920"/>
-            <a:ext cx="6949440" cy="411480"/>
+            <a:off x="731520" y="2468880"/>
+            <a:ext cx="2468880" cy="411480"/>
           </a:xfrm>
           <a:prstGeom prst="rect">
             <a:avLst/>
@@ -4778,7 +4552,7 @@
               <a:buNone/>
             </a:pPr>
             <a:r>
-              <a:rPr lang="en-US" sz="2400" dirty="0">
+              <a:rPr lang="en-US" sz="2100" dirty="0">
                 <a:solidFill>
                   <a:schemeClr val="accent1"/>
                 </a:solidFill>
@@ -4788,7 +4562,7 @@
               </a:rPr>
               <a:t>Doutores da estética</a:t>
             </a:r>
-            <a:endParaRPr lang="en-US" sz="2400" dirty="0"/>
+            <a:endParaRPr lang="en-US" sz="2100" dirty="0"/>
           </a:p>
         </p:txBody>
       </p:sp>
@@ -4800,8 +4574,8 @@
         </p:nvSpPr>
         <p:spPr>
           <a:xfrm>
-            <a:off x="731520" y="3200400"/>
-            <a:ext cx="6949440" cy="365760"/>
+            <a:off x="731520" y="2880360"/>
+            <a:ext cx="2468880" cy="685800"/>
           </a:xfrm>
           <a:prstGeom prst="rect">
             <a:avLst/>
@@ -4817,14 +4591,14 @@
               <a:buNone/>
             </a:pPr>
             <a:r>
-              <a:rPr lang="en-US" sz="1400" dirty="0">
+              <a:rPr lang="en-US" sz="1300" dirty="0">
                 <a:solidFill>
                   <a:schemeClr val="tx2"/>
                 </a:solidFill>
               </a:rPr>
               <a:t>nacionais e internacionais</a:t>
             </a:r>
-            <a:endParaRPr lang="en-US" sz="1400" dirty="0"/>
+            <a:endParaRPr lang="en-US" sz="1300" dirty="0"/>
           </a:p>
         </p:txBody>
       </p:sp>
@@ -4836,8 +4610,8 @@
         </p:nvSpPr>
         <p:spPr>
           <a:xfrm>
-            <a:off x="731520" y="3657600"/>
-            <a:ext cx="6949440" cy="0"/>
+            <a:off x="3429000" y="2331720"/>
+            <a:ext cx="2468880" cy="0"/>
           </a:xfrm>
           <a:prstGeom prst="line">
             <a:avLst/>
@@ -4859,8 +4633,8 @@
         </p:nvSpPr>
         <p:spPr>
           <a:xfrm>
-            <a:off x="731520" y="3794760"/>
-            <a:ext cx="6949440" cy="411480"/>
+            <a:off x="3429000" y="2468880"/>
+            <a:ext cx="2468880" cy="411480"/>
           </a:xfrm>
           <a:prstGeom prst="rect">
             <a:avLst/>
@@ -4876,7 +4650,7 @@
               <a:buNone/>
             </a:pPr>
             <a:r>
-              <a:rPr lang="en-US" sz="2400" dirty="0">
+              <a:rPr lang="en-US" sz="2100" dirty="0">
                 <a:solidFill>
                   <a:schemeClr val="accent1"/>
                 </a:solidFill>
@@ -4886,7 +4660,7 @@
               </a:rPr>
               <a:t>Convidados</a:t>
             </a:r>
-            <a:endParaRPr lang="en-US" sz="2400" dirty="0"/>
+            <a:endParaRPr lang="en-US" sz="2100" dirty="0"/>
           </a:p>
         </p:txBody>
       </p:sp>
@@ -4898,8 +4672,8 @@
         </p:nvSpPr>
         <p:spPr>
           <a:xfrm>
-            <a:off x="731520" y="4206240"/>
-            <a:ext cx="6949440" cy="365760"/>
+            <a:off x="3429000" y="2880360"/>
+            <a:ext cx="2468880" cy="685800"/>
           </a:xfrm>
           <a:prstGeom prst="rect">
             <a:avLst/>
@@ -4915,14 +4689,14 @@
               <a:buNone/>
             </a:pPr>
             <a:r>
-              <a:rPr lang="en-US" sz="1400" dirty="0">
+              <a:rPr lang="en-US" sz="1300" dirty="0">
                 <a:solidFill>
                   <a:schemeClr val="tx2"/>
                 </a:solidFill>
               </a:rPr>
               <a:t>com cases reais de sucesso na estética e no empreendedorismo</a:t>
             </a:r>
-            <a:endParaRPr lang="en-US" sz="1400" dirty="0"/>
+            <a:endParaRPr lang="en-US" sz="1300" dirty="0"/>
           </a:p>
         </p:txBody>
       </p:sp>
@@ -4934,8 +4708,8 @@
         </p:nvSpPr>
         <p:spPr>
           <a:xfrm>
-            <a:off x="731520" y="4663440"/>
-            <a:ext cx="6949440" cy="0"/>
+            <a:off x="6126480" y="2331720"/>
+            <a:ext cx="2468880" cy="0"/>
           </a:xfrm>
           <a:prstGeom prst="line">
             <a:avLst/>
@@ -4957,8 +4731,8 @@
         </p:nvSpPr>
         <p:spPr>
           <a:xfrm>
-            <a:off x="731520" y="4800600"/>
-            <a:ext cx="6949440" cy="411480"/>
+            <a:off x="6126480" y="2468880"/>
+            <a:ext cx="2468880" cy="411480"/>
           </a:xfrm>
           <a:prstGeom prst="rect">
             <a:avLst/>
@@ -4974,7 +4748,7 @@
               <a:buNone/>
             </a:pPr>
             <a:r>
-              <a:rPr lang="en-US" sz="2400" dirty="0">
+              <a:rPr lang="en-US" sz="2100" dirty="0">
                 <a:solidFill>
                   <a:schemeClr val="accent1"/>
                 </a:solidFill>
@@ -4984,7 +4758,7 @@
               </a:rPr>
               <a:t>Palestrantes</a:t>
             </a:r>
-            <a:endParaRPr lang="en-US" sz="2400" dirty="0"/>
+            <a:endParaRPr lang="en-US" sz="2100" dirty="0"/>
           </a:p>
         </p:txBody>
       </p:sp>
@@ -4996,8 +4770,8 @@
         </p:nvSpPr>
         <p:spPr>
           <a:xfrm>
-            <a:off x="731520" y="5212080"/>
-            <a:ext cx="6949440" cy="365760"/>
+            <a:off x="6126480" y="2880360"/>
+            <a:ext cx="2468880" cy="685800"/>
           </a:xfrm>
           <a:prstGeom prst="rect">
             <a:avLst/>
@@ -5013,27 +4787,58 @@
               <a:buNone/>
             </a:pPr>
             <a:r>
-              <a:rPr lang="en-US" sz="1400" dirty="0">
+              <a:rPr lang="en-US" sz="1300" dirty="0">
                 <a:solidFill>
                   <a:schemeClr val="tx2"/>
                 </a:solidFill>
               </a:rPr>
               <a:t>que atuam com carreira, posicionamento e autoridade</a:t>
             </a:r>
-            <a:endParaRPr lang="en-US" sz="1400" dirty="0"/>
-          </a:p>
-        </p:txBody>
-      </p:sp>
-      <p:sp>
-        <p:nvSpPr>
-          <p:cNvPr id="15" name="Text 12"/>
+            <a:endParaRPr lang="en-US" sz="1300" dirty="0"/>
+          </a:p>
+        </p:txBody>
+      </p:sp>
+      <p:pic>
+        <p:nvPicPr>
+          <p:cNvPr id="15" name="Depoimento" descr="Mensagem de aluna: depois da aula de Posicionamento e da Formação Internacional, converteu o valor do curso em menos de 2 meses com 2 pacientes">    </p:cNvPr>
+          <p:cNvPicPr>
+            <a:picLocks noChangeAspect="1"/>
+          </p:cNvPicPr>
+          <p:nvPr/>
+        </p:nvPicPr>
+        <p:blipFill>
+          <a:blip r:embed="rId2"/>
+          <a:stretch>
+            <a:fillRect/>
+          </a:stretch>
+        </p:blipFill>
+        <p:spPr>
+          <a:xfrm>
+            <a:off x="731520" y="3840480"/>
+            <a:ext cx="7863840" cy="2359152"/>
+          </a:xfrm>
+          <a:prstGeom prst="rect">
+            <a:avLst/>
+          </a:prstGeom>
+          <a:effectLst>
+            <a:outerShdw sx="100000" sy="100000" kx="0" ky="0" algn="bl" rotWithShape="0" blurRad="152400" dist="50800" dir="5400000">
+              <a:srgbClr val="2B2A29">
+                <a:alpha val="30000"/>
+              </a:srgbClr>
+            </a:outerShdw>
+          </a:effectLst>
+        </p:spPr>
+      </p:pic>
+      <p:sp>
+        <p:nvSpPr>
+          <p:cNvPr id="16" name="Text 12"/>
           <p:cNvSpPr txBox="1"/>
           <p:nvPr/>
         </p:nvSpPr>
         <p:spPr>
           <a:xfrm>
-            <a:off x="731520" y="5760720"/>
-            <a:ext cx="7132320" cy="457200"/>
+            <a:off x="731520" y="6309360"/>
+            <a:ext cx="7863840" cy="274320"/>
           </a:xfrm>
           <a:prstGeom prst="rect">
             <a:avLst/>
@@ -5049,14 +4854,14 @@
               <a:buNone/>
             </a:pPr>
             <a:r>
-              <a:rPr lang="en-US" sz="1300" i="1" dirty="0">
+              <a:rPr lang="en-US" sz="1200" i="1" dirty="0">
                 <a:solidFill>
                   <a:schemeClr val="tx2"/>
                 </a:solidFill>
               </a:rPr>
-              <a:t>Um momento desenhado para troca de experiências, visão de mercado e conexões profissionais relevantes.</a:t>
-            </a:r>
-            <a:endParaRPr lang="en-US" sz="1300" dirty="0"/>
+              <a:t>Relato de aluna depois da aula de Posicionamento.</a:t>
+            </a:r>
+            <a:endParaRPr lang="en-US" sz="1200" dirty="0"/>
           </a:p>
         </p:txBody>
       </p:sp>

</xml_diff>